<commit_message>
Week 1 fully graded: SMU 27-24 at FSU (market closer; machine 50.5 vs market 49.0); Tue refresh outputs (51 rated games)
Co-Authored-By: Claude Fable 5.1 <noreply@anthropic.com>
</commit_message>
<xml_diff>
--- a/decks/2026_Week2_Episode3.pptx
+++ b/decks/2026_Week2_Episode3.pptx
@@ -3214,7 +3214,7 @@
                 </a:solidFill>
                 <a:latin typeface="Arial"/>
               </a:rPr>
-              <a:t>our in-season rating after 50 rated games · Δ = move vs ESPN's preseason FPI (0.0 = no rated game yet) · AP = week 1 poll · NR = not ranked</a:t>
+              <a:t>our in-season rating after 51 rated games · Δ = move vs ESPN's preseason FPI (0.0 = no rated game yet) · AP = week 1 poll · NR = not ranked</a:t>
             </a:r>
           </a:p>
         </p:txBody>
@@ -9141,7 +9141,7 @@
       </p:sp>
       <p:pic>
         <p:nvPicPr>
-          <p:cNvPr id="172" name="Picture 171" descr="auburn.png"/>
+          <p:cNvPr id="172" name="Picture 171" descr="smu.png"/>
           <p:cNvPicPr>
             <a:picLocks noChangeAspect="1"/>
           </p:cNvPicPr>
@@ -9193,7 +9193,7 @@
                 </a:solidFill>
                 <a:latin typeface="Arial"/>
               </a:rPr>
-              <a:t>Auburn</a:t>
+              <a:t>SMU</a:t>
             </a:r>
           </a:p>
         </p:txBody>
@@ -9228,7 +9228,7 @@
                 </a:solidFill>
                 <a:latin typeface="Arial"/>
               </a:rPr>
-              <a:t>11.1</a:t>
+              <a:t>11.4</a:t>
             </a:r>
           </a:p>
         </p:txBody>
@@ -9259,11 +9259,11 @@
             <a:r>
               <a:rPr sz="1100" b="1" i="0">
                 <a:solidFill>
-                  <a:srgbClr val="FF7A7A"/>
-                </a:solidFill>
-                <a:latin typeface="Arial"/>
-              </a:rPr>
-              <a:t>-0.9</a:t>
+                  <a:srgbClr val="5CD68A"/>
+                </a:solidFill>
+                <a:latin typeface="Arial"/>
+              </a:rPr>
+              <a:t>+0.3</a:t>
             </a:r>
           </a:p>
         </p:txBody>
@@ -9298,7 +9298,7 @@
                 </a:solidFill>
                 <a:latin typeface="Arial"/>
               </a:rPr>
-              <a:t>NR</a:t>
+              <a:t>AP 19</a:t>
             </a:r>
           </a:p>
         </p:txBody>
@@ -9384,7 +9384,7 @@
       </p:sp>
       <p:pic>
         <p:nvPicPr>
-          <p:cNvPr id="179" name="Picture 178" descr="smu.png"/>
+          <p:cNvPr id="179" name="Picture 178" descr="auburn.png"/>
           <p:cNvPicPr>
             <a:picLocks noChangeAspect="1"/>
           </p:cNvPicPr>
@@ -9436,7 +9436,7 @@
                 </a:solidFill>
                 <a:latin typeface="Arial"/>
               </a:rPr>
-              <a:t>SMU</a:t>
+              <a:t>Auburn</a:t>
             </a:r>
           </a:p>
         </p:txBody>
@@ -9500,13 +9500,13 @@
           <a:p>
             <a:pPr algn="r"/>
             <a:r>
-              <a:rPr sz="1100" b="0" i="0">
-                <a:solidFill>
-                  <a:srgbClr val="CADCFC"/>
-                </a:solidFill>
-                <a:latin typeface="Arial"/>
-              </a:rPr>
-              <a:t>0.0</a:t>
+              <a:rPr sz="1100" b="1" i="0">
+                <a:solidFill>
+                  <a:srgbClr val="FF7A7A"/>
+                </a:solidFill>
+                <a:latin typeface="Arial"/>
+              </a:rPr>
+              <a:t>-0.9</a:t>
             </a:r>
           </a:p>
         </p:txBody>
@@ -9541,7 +9541,7 @@
                 </a:solidFill>
                 <a:latin typeface="Arial"/>
               </a:rPr>
-              <a:t>AP 19</a:t>
+              <a:t>NR</a:t>
             </a:r>
           </a:p>
         </p:txBody>
@@ -19828,7 +19828,7 @@
                 </a:solidFill>
                 <a:latin typeface="Arial"/>
               </a:rPr>
-              <a:t>Arkansas +13.5 at #21 Utah · ML +400</a:t>
+              <a:t>Arkansas +12.5 at #21 Utah · ML +360</a:t>
             </a:r>
           </a:p>
         </p:txBody>
@@ -21594,7 +21594,7 @@
                 </a:solidFill>
                 <a:latin typeface="Arial"/>
               </a:rPr>
-              <a:t>Machine = our in-season rating (ESPN preseason FPI prior + 2026 results, λ 3, cap ±28) + 2.5 HFA · empirical margin curve (σ 15.9) · lines as of Sep 7 · model plays graded vs first-seen lines</a:t>
+              <a:t>Machine = our in-season rating (ESPN preseason FPI prior + 2026 results, λ 3, cap ±28) + 2.5 HFA · empirical margin curve (σ 15.9) · lines as of Sep 8 · model plays graded vs first-seen lines</a:t>
             </a:r>
           </a:p>
         </p:txBody>
@@ -22780,7 +22780,7 @@
                 </a:solidFill>
                 <a:latin typeface="Arial"/>
               </a:rPr>
-              <a:t>we called FSU 27–26 · FINAL pending</a:t>
+              <a:t>we called FSU 27–26 · FINAL SMU 27–24</a:t>
             </a:r>
           </a:p>
         </p:txBody>
@@ -22846,11 +22846,11 @@
             <a:r>
               <a:rPr sz="1000" b="1" i="0">
                 <a:solidFill>
-                  <a:srgbClr val="5C6B7E"/>
-                </a:solidFill>
-                <a:latin typeface="Arial"/>
-              </a:rPr>
-              <a:t>graded before air — see the notes</a:t>
+                  <a:srgbClr val="B5121B"/>
+                </a:solidFill>
+                <a:latin typeface="Arial"/>
+              </a:rPr>
+              <a:t>machine off by 3.5 · market off by 0.5 — market closer</a:t>
             </a:r>
           </a:p>
         </p:txBody>
@@ -22929,7 +22929,7 @@
                 </a:solidFill>
                 <a:latin typeface="Arial"/>
               </a:rPr>
-              <a:t>Total miss across 4 graded games: machine 47.0 points, closing market 48.5 — machine closer in 2, market in 1, 1 tie. Stated positions 2–0: Baylor +7.5 covered and the MONSTER UNDER on 59.5 cashed (33 total). Two weeks in: machine 117.0 vs market 118.5 across 9 games — still a coin flip with Vegas. Stated leans 3–2 on the season.</a:t>
+              <a:t>Total miss across 5 graded games: machine 50.5 points, closing market 49.0 — machine closer in 2, market in 2, 1 tie. Stated positions 2–0: Baylor +7.5 covered and the MONSTER UNDER on 59.5 cashed (33 total). Two weeks in: machine 120.5 vs market 119.0 across 10 games — still a coin flip with Vegas. Stated leans 3–2 on the season.</a:t>
             </a:r>
           </a:p>
         </p:txBody>
@@ -23792,7 +23792,7 @@
                 </a:solidFill>
                 <a:latin typeface="Arial"/>
               </a:rPr>
-              <a:t>market (DK / Bovada) · DK Texas -120 / Ohio State +100 · Bov Texas -110 / Ohio State -110</a:t>
+              <a:t>market (DK / Bovada) · DK Texas -118 / Ohio State -102 · Bov Texas -110 / Ohio State -110</a:t>
             </a:r>
           </a:p>
         </p:txBody>

</xml_diff>

<commit_message>
Ep3 final: Wed 9/9 8:22 AM MT lines, AP Week 2 poll in, deck rebuilt (21 slides) and pushed; notes synced
Co-Authored-By: Claude Fable 5.1 <noreply@anthropic.com>
</commit_message>
<xml_diff>
--- a/decks/2026_Week2_Episode3.pptx
+++ b/decks/2026_Week2_Episode3.pptx
@@ -3216,7 +3216,7 @@
                 </a:solidFill>
                 <a:latin typeface="Arial"/>
               </a:rPr>
-              <a:t>our in-season rating after 51 rated games · Δ = move vs ESPN's preseason FPI (0.0 = no rated game yet) · AP = week 1 poll · NR = not ranked</a:t>
+              <a:t>our in-season rating after 51 rated games · Δ = move vs ESPN's preseason FPI (0.0 = no rated game yet) · AP = week 2 poll · NR = not ranked</a:t>
             </a:r>
           </a:p>
         </p:txBody>
@@ -3713,7 +3713,7 @@
                 </a:solidFill>
                 <a:latin typeface="Arial"/>
               </a:rPr>
-              <a:t>AP 4</a:t>
+              <a:t>AP 3</a:t>
             </a:r>
           </a:p>
         </p:txBody>
@@ -3956,7 +3956,7 @@
                 </a:solidFill>
                 <a:latin typeface="Arial"/>
               </a:rPr>
-              <a:t>AP 5</a:t>
+              <a:t>AP 4</a:t>
             </a:r>
           </a:p>
         </p:txBody>
@@ -4243,7 +4243,7 @@
                 </a:solidFill>
                 <a:latin typeface="Arial"/>
               </a:rPr>
-              <a:t>AP 3</a:t>
+              <a:t>AP 2</a:t>
             </a:r>
           </a:p>
         </p:txBody>
@@ -4773,7 +4773,7 @@
                 </a:solidFill>
                 <a:latin typeface="Arial"/>
               </a:rPr>
-              <a:t>AP 11</a:t>
+              <a:t>AP 8</a:t>
             </a:r>
           </a:p>
         </p:txBody>
@@ -5303,7 +5303,7 @@
                 </a:solidFill>
                 <a:latin typeface="Arial"/>
               </a:rPr>
-              <a:t>AP 6</a:t>
+              <a:t>AP 5</a:t>
             </a:r>
           </a:p>
         </p:txBody>
@@ -5546,7 +5546,7 @@
                 </a:solidFill>
                 <a:latin typeface="Arial"/>
               </a:rPr>
-              <a:t>AP 2</a:t>
+              <a:t>AP 6</a:t>
             </a:r>
           </a:p>
         </p:txBody>
@@ -5833,7 +5833,7 @@
                 </a:solidFill>
                 <a:latin typeface="Arial"/>
               </a:rPr>
-              <a:t>AP 13</a:t>
+              <a:t>AP 12</a:t>
             </a:r>
           </a:p>
         </p:txBody>
@@ -6076,7 +6076,7 @@
                 </a:solidFill>
                 <a:latin typeface="Arial"/>
               </a:rPr>
-              <a:t>AP 12</a:t>
+              <a:t>AP 13</a:t>
             </a:r>
           </a:p>
         </p:txBody>
@@ -6363,7 +6363,7 @@
                 </a:solidFill>
                 <a:latin typeface="Arial"/>
               </a:rPr>
-              <a:t>AP 8</a:t>
+              <a:t>AP 10</a:t>
             </a:r>
           </a:p>
         </p:txBody>
@@ -6606,7 +6606,7 @@
                 </a:solidFill>
                 <a:latin typeface="Arial"/>
               </a:rPr>
-              <a:t>AP 10</a:t>
+              <a:t>AP 11</a:t>
             </a:r>
           </a:p>
         </p:txBody>
@@ -7423,7 +7423,7 @@
                 </a:solidFill>
                 <a:latin typeface="Arial"/>
               </a:rPr>
-              <a:t>AP 20</a:t>
+              <a:t>AP 18</a:t>
             </a:r>
           </a:p>
         </p:txBody>
@@ -7710,7 +7710,7 @@
                 </a:solidFill>
                 <a:latin typeface="Arial"/>
               </a:rPr>
-              <a:t>AP 18</a:t>
+              <a:t>AP 16</a:t>
             </a:r>
           </a:p>
         </p:txBody>
@@ -8240,7 +8240,7 @@
                 </a:solidFill>
                 <a:latin typeface="Arial"/>
               </a:rPr>
-              <a:t>AP 14</a:t>
+              <a:t>AP 15</a:t>
             </a:r>
           </a:p>
         </p:txBody>
@@ -8483,7 +8483,7 @@
                 </a:solidFill>
                 <a:latin typeface="Arial"/>
               </a:rPr>
-              <a:t>AP 25</a:t>
+              <a:t>AP 23</a:t>
             </a:r>
           </a:p>
         </p:txBody>
@@ -8770,7 +8770,7 @@
                 </a:solidFill>
                 <a:latin typeface="Arial"/>
               </a:rPr>
-              <a:t>NR</a:t>
+              <a:t>AP 25</a:t>
             </a:r>
           </a:p>
         </p:txBody>
@@ -9013,7 +9013,7 @@
                 </a:solidFill>
                 <a:latin typeface="Arial"/>
               </a:rPr>
-              <a:t>AP 16</a:t>
+              <a:t>NR</a:t>
             </a:r>
           </a:p>
         </p:txBody>
@@ -9300,7 +9300,7 @@
                 </a:solidFill>
                 <a:latin typeface="Arial"/>
               </a:rPr>
-              <a:t>AP 19</a:t>
+              <a:t>AP 17</a:t>
             </a:r>
           </a:p>
         </p:txBody>
@@ -10073,7 +10073,7 @@
                 </a:solidFill>
                 <a:latin typeface="Arial"/>
               </a:rPr>
-              <a:t>AP 22</a:t>
+              <a:t>AP 21</a:t>
             </a:r>
           </a:p>
         </p:txBody>
@@ -10152,7 +10152,7 @@
                 </a:solidFill>
                 <a:latin typeface="Arial"/>
               </a:rPr>
-              <a:t>Biggest splits with the voters: LSU (machine #5, AP #11) · Oregon (machine #8, AP #2) · Missouri (machine #19, AP #25) · Tennessee (machine #15, AP #20)</a:t>
+              <a:t>Biggest splits with the voters: Virginia (machine #20, AP #25) · SMU (machine #22, AP #17) · Ole Miss (machine #13, AP #9) · Missouri (machine #19, AP #23)</a:t>
             </a:r>
           </a:p>
         </p:txBody>
@@ -10187,7 +10187,7 @@
                 </a:solidFill>
                 <a:latin typeface="Arial"/>
               </a:rPr>
-              <a:t>In our 25, not theirs: Florida, Virginia, Auburn, South Carolina   |   In theirs, not ours: Washington (AP 17), Utah (AP 21), Houston (AP 23), Louisville (AP 24)</a:t>
+              <a:t>In our 25, not theirs: Florida, Michigan, Auburn, South Carolina   |   In theirs, not ours: Washington (AP 19), Utah (AP 20), Houston (AP 22), Louisville (AP 24)</a:t>
             </a:r>
           </a:p>
         </p:txBody>
@@ -12500,7 +12500,7 @@
                 </a:solidFill>
                 <a:latin typeface="Arial"/>
               </a:rPr>
-              <a:t>market (DK / Bovada) · DK Texas A&amp;M -625 / Arizona State +455 · Bov Texas A&amp;M -650 / Arizona State +450</a:t>
+              <a:t>market (DK / Bovada) · DK Texas A&amp;M -650 / Arizona State +470 · Bov Texas A&amp;M -650 / Arizona State +450</a:t>
             </a:r>
           </a:p>
         </p:txBody>
@@ -15146,7 +15146,7 @@
                 </a:solidFill>
                 <a:latin typeface="Arial"/>
               </a:rPr>
-              <a:t>market (DK / Bovada) · DK BYU -285 / Arizona +230 · Bov BYU -310 / Arizona +255</a:t>
+              <a:t>market (DK / Bovada) · DK BYU -290 / Arizona +235 · Bov BYU -310 / Arizona +255</a:t>
             </a:r>
           </a:p>
         </p:txBody>
@@ -15181,7 +15181,7 @@
                 </a:solidFill>
                 <a:latin typeface="Arial"/>
               </a:rPr>
-              <a:t>BYU 29 – Arizona 21</a:t>
+              <a:t>BYU 28 – Arizona 20</a:t>
             </a:r>
           </a:p>
         </p:txBody>
@@ -17792,7 +17792,7 @@
                 </a:solidFill>
                 <a:latin typeface="Arial"/>
               </a:rPr>
-              <a:t>market (DK / Bovada) · DK Kentucky +320 / Alabama -410 · Bov Kentucky +320 / Alabama -430</a:t>
+              <a:t>market (DK / Bovada) · DK Kentucky +330 / Alabama -425 · Bov Kentucky +320 / Alabama -430</a:t>
             </a:r>
           </a:p>
         </p:txBody>
@@ -24881,7 +24881,7 @@
                 </a:solidFill>
                 <a:latin typeface="Arial"/>
               </a:rPr>
-              <a:t>Texas 26 – Ohio State 22</a:t>
+              <a:t>Texas 27 – Ohio State 23</a:t>
             </a:r>
           </a:p>
         </p:txBody>
@@ -25736,7 +25736,7 @@
                 </a:solidFill>
                 <a:latin typeface="Arial"/>
               </a:rPr>
-              <a:t>BYU 29 – Arizona 21</a:t>
+              <a:t>BYU 28 – Arizona 20</a:t>
             </a:r>
           </a:p>
         </p:txBody>
@@ -26240,7 +26240,7 @@
                 </a:solidFill>
                 <a:latin typeface="Arial"/>
               </a:rPr>
-              <a:t>Arkansas +12.5 at #21 Utah · ML +360</a:t>
+              <a:t>Arkansas +12.5 at #20 Utah · ML +390</a:t>
             </a:r>
           </a:p>
         </p:txBody>
@@ -32618,7 +32618,7 @@
                 </a:solidFill>
                 <a:latin typeface="Arial"/>
               </a:rPr>
-              <a:t>Machine = our in-season rating (ESPN preseason FPI prior + 2026 results, λ 3, cap ±28) + 2.5 HFA · empirical margin curve (σ 15.9) · lines as of Sep 8 · model plays graded vs first-seen lines</a:t>
+              <a:t>Machine = our in-season rating (ESPN preseason FPI prior + 2026 results, λ 3, cap ±28) + 2.5 HFA · empirical margin curve (σ 15.9) · lines as of Sep 9 · model plays graded vs first-seen lines</a:t>
             </a:r>
           </a:p>
         </p:txBody>
@@ -34132,7 +34132,7 @@
                 </a:solidFill>
                 <a:latin typeface="Arial"/>
               </a:rPr>
-              <a:t>Sat Sep 12 · 7:30 ET · No. 1 at No. 5 · the 2025 opener rematch (OSU 14–7) · Arch's last tour vs Sayin-to-Smith</a:t>
+              <a:t>Sat Sep 12 · 7:30 ET · No. 1 at No. 4 · the 2025 opener rematch (OSU 14–7) · Arch's last tour vs Sayin-to-Smith</a:t>
             </a:r>
           </a:p>
         </p:txBody>
@@ -34816,7 +34816,7 @@
                 </a:solidFill>
                 <a:latin typeface="Arial"/>
               </a:rPr>
-              <a:t>market (DK / Bovada) · DK Texas -118 / Ohio State -102 · Bov Texas -110 / Ohio State -110</a:t>
+              <a:t>market (DK / Bovada) · DK Texas -122 / Ohio State +102 · Bov Texas -110 / Ohio State -110</a:t>
             </a:r>
           </a:p>
         </p:txBody>
@@ -34851,7 +34851,7 @@
                 </a:solidFill>
                 <a:latin typeface="Arial"/>
               </a:rPr>
-              <a:t>Texas 26 – Ohio State 22</a:t>
+              <a:t>Texas 27 – Ohio State 23</a:t>
             </a:r>
           </a:p>
         </p:txBody>
@@ -37462,7 +37462,7 @@
                 </a:solidFill>
                 <a:latin typeface="Arial"/>
               </a:rPr>
-              <a:t>market (DK / Bovada) · DK Michigan +180 / Oklahoma -218 · Bov Michigan +175 / Oklahoma -210</a:t>
+              <a:t>market (DK / Bovada) · DK Michigan +190 / Oklahoma -230 · Bov Michigan +175 / Oklahoma -210</a:t>
             </a:r>
           </a:p>
         </p:txBody>

</xml_diff>

<commit_message>
Ep3: Upset Board slide (week's alerts + scorecard from the workbook via boards JSON) before the closer; notes slide 21/22
Co-Authored-By: Claude Fable 5.1 <noreply@anthropic.com>
</commit_message>
<xml_diff>
--- a/decks/2026_Week2_Episode3.pptx
+++ b/decks/2026_Week2_Episode3.pptx
@@ -26,6 +26,7 @@
     <p:sldId id="274" r:id="rId25"/>
     <p:sldId id="275" r:id="rId26"/>
     <p:sldId id="276" r:id="rId27"/>
+    <p:sldId id="277" r:id="rId28"/>
   </p:sldIdLst>
   <p:sldSz cx="12191695" cy="6858000" type="screen4x3"/>
   <p:notesSz cx="6858000" cy="9144000"/>
@@ -24549,6 +24550,3271 @@
 </file>
 
 <file path=ppt/slides/slide21.xml><?xml version="1.0" encoding="utf-8"?>
+<p:sld xmlns:a="http://schemas.openxmlformats.org/drawingml/2006/main" xmlns:p="http://schemas.openxmlformats.org/presentationml/2006/main" xmlns:r="http://schemas.openxmlformats.org/officeDocument/2006/relationships">
+  <p:cSld>
+    <p:bg>
+      <p:bgPr>
+        <a:solidFill>
+          <a:srgbClr val="0A2851"/>
+        </a:solidFill>
+        <a:effectLst/>
+      </p:bgPr>
+    </p:bg>
+    <p:spTree>
+      <p:nvGrpSpPr>
+        <p:cNvPr id="1" name=""/>
+        <p:cNvGrpSpPr/>
+        <p:nvPr/>
+      </p:nvGrpSpPr>
+      <p:grpSpPr/>
+      <p:sp>
+        <p:nvSpPr>
+          <p:cNvPr id="2" name="TextBox 1"/>
+          <p:cNvSpPr txBox="1"/>
+          <p:nvPr/>
+        </p:nvSpPr>
+        <p:spPr>
+          <a:xfrm>
+            <a:off x="822960" y="384048"/>
+            <a:ext cx="10515600" cy="365760"/>
+          </a:xfrm>
+          <a:prstGeom prst="rect">
+            <a:avLst/>
+          </a:prstGeom>
+          <a:noFill/>
+        </p:spPr>
+        <p:txBody>
+          <a:bodyPr wrap="square" lIns="0" rIns="0" tIns="0" bIns="0">
+            <a:spAutoFit/>
+          </a:bodyPr>
+          <a:lstStyle/>
+          <a:p>
+            <a:pPr algn="l"/>
+            <a:r>
+              <a:rPr sz="1400" b="1" i="0">
+                <a:solidFill>
+                  <a:srgbClr val="F47321"/>
+                </a:solidFill>
+                <a:latin typeface="Arial"/>
+              </a:rPr>
+              <a:t>EPISODE 3 · WEEK 2 · THE MACHINE'S ALERTS</a:t>
+            </a:r>
+          </a:p>
+        </p:txBody>
+      </p:sp>
+      <p:sp>
+        <p:nvSpPr>
+          <p:cNvPr id="3" name="TextBox 2"/>
+          <p:cNvSpPr txBox="1"/>
+          <p:nvPr/>
+        </p:nvSpPr>
+        <p:spPr>
+          <a:xfrm>
+            <a:off x="822960" y="694944"/>
+            <a:ext cx="10515600" cy="731520"/>
+          </a:xfrm>
+          <a:prstGeom prst="rect">
+            <a:avLst/>
+          </a:prstGeom>
+          <a:noFill/>
+        </p:spPr>
+        <p:txBody>
+          <a:bodyPr wrap="square" lIns="0" rIns="0" tIns="0" bIns="0">
+            <a:spAutoFit/>
+          </a:bodyPr>
+          <a:lstStyle/>
+          <a:p>
+            <a:pPr algn="l"/>
+            <a:r>
+              <a:rPr sz="4000" b="1" i="0">
+                <a:solidFill>
+                  <a:srgbClr val="FFFFFF"/>
+                </a:solidFill>
+                <a:latin typeface="Arial"/>
+              </a:rPr>
+              <a:t>The Upset Board</a:t>
+            </a:r>
+          </a:p>
+        </p:txBody>
+      </p:sp>
+      <p:sp>
+        <p:nvSpPr>
+          <p:cNvPr id="4" name="TextBox 3"/>
+          <p:cNvSpPr txBox="1"/>
+          <p:nvPr/>
+        </p:nvSpPr>
+        <p:spPr>
+          <a:xfrm>
+            <a:off x="822960" y="1371600"/>
+            <a:ext cx="10515600" cy="274320"/>
+          </a:xfrm>
+          <a:prstGeom prst="rect">
+            <a:avLst/>
+          </a:prstGeom>
+          <a:noFill/>
+        </p:spPr>
+        <p:txBody>
+          <a:bodyPr wrap="square" lIns="0" rIns="0" tIns="0" bIns="0">
+            <a:spAutoFit/>
+          </a:bodyPr>
+          <a:lstStyle/>
+          <a:p>
+            <a:pPr algn="l"/>
+            <a:r>
+              <a:rPr sz="1050" b="0" i="1">
+                <a:solidFill>
+                  <a:srgbClr val="CADCFC"/>
+                </a:solidFill>
+                <a:latin typeface="Arial"/>
+              </a:rPr>
+              <a:t>RED = machine takes the dog outright (spread ≥ 3) · YEL = same side, 6+ points of disagreement · ⚑ = Monster Under total · graded vs the line first seen</a:t>
+            </a:r>
+          </a:p>
+        </p:txBody>
+      </p:sp>
+      <p:sp>
+        <p:nvSpPr>
+          <p:cNvPr id="5" name="TextBox 4"/>
+          <p:cNvSpPr txBox="1"/>
+          <p:nvPr/>
+        </p:nvSpPr>
+        <p:spPr>
+          <a:xfrm>
+            <a:off x="822960" y="1673352"/>
+            <a:ext cx="457200" cy="201168"/>
+          </a:xfrm>
+          <a:prstGeom prst="rect">
+            <a:avLst/>
+          </a:prstGeom>
+          <a:noFill/>
+        </p:spPr>
+        <p:txBody>
+          <a:bodyPr wrap="square" lIns="0" rIns="0" tIns="0" bIns="0">
+            <a:spAutoFit/>
+          </a:bodyPr>
+          <a:lstStyle/>
+          <a:p>
+            <a:pPr algn="l"/>
+            <a:r>
+              <a:rPr sz="800" b="1" i="0">
+                <a:solidFill>
+                  <a:srgbClr val="CADCFC"/>
+                </a:solidFill>
+                <a:latin typeface="Arial"/>
+              </a:rPr>
+              <a:t>TIER</a:t>
+            </a:r>
+          </a:p>
+        </p:txBody>
+      </p:sp>
+      <p:sp>
+        <p:nvSpPr>
+          <p:cNvPr id="6" name="TextBox 5"/>
+          <p:cNvSpPr txBox="1"/>
+          <p:nvPr/>
+        </p:nvSpPr>
+        <p:spPr>
+          <a:xfrm>
+            <a:off x="1325880" y="1673352"/>
+            <a:ext cx="2743200" cy="201168"/>
+          </a:xfrm>
+          <a:prstGeom prst="rect">
+            <a:avLst/>
+          </a:prstGeom>
+          <a:noFill/>
+        </p:spPr>
+        <p:txBody>
+          <a:bodyPr wrap="square" lIns="0" rIns="0" tIns="0" bIns="0">
+            <a:spAutoFit/>
+          </a:bodyPr>
+          <a:lstStyle/>
+          <a:p>
+            <a:pPr algn="l"/>
+            <a:r>
+              <a:rPr sz="800" b="1" i="0">
+                <a:solidFill>
+                  <a:srgbClr val="CADCFC"/>
+                </a:solidFill>
+                <a:latin typeface="Arial"/>
+              </a:rPr>
+              <a:t>MATCHUP</a:t>
+            </a:r>
+          </a:p>
+        </p:txBody>
+      </p:sp>
+      <p:sp>
+        <p:nvSpPr>
+          <p:cNvPr id="7" name="TextBox 6"/>
+          <p:cNvSpPr txBox="1"/>
+          <p:nvPr/>
+        </p:nvSpPr>
+        <p:spPr>
+          <a:xfrm>
+            <a:off x="4114800" y="1673352"/>
+            <a:ext cx="2011680" cy="201168"/>
+          </a:xfrm>
+          <a:prstGeom prst="rect">
+            <a:avLst/>
+          </a:prstGeom>
+          <a:noFill/>
+        </p:spPr>
+        <p:txBody>
+          <a:bodyPr wrap="square" lIns="0" rIns="0" tIns="0" bIns="0">
+            <a:spAutoFit/>
+          </a:bodyPr>
+          <a:lstStyle/>
+          <a:p>
+            <a:pPr algn="l"/>
+            <a:r>
+              <a:rPr sz="800" b="1" i="0">
+                <a:solidFill>
+                  <a:srgbClr val="CADCFC"/>
+                </a:solidFill>
+                <a:latin typeface="Arial"/>
+              </a:rPr>
+              <a:t>ALERT LINE → NOW</a:t>
+            </a:r>
+          </a:p>
+        </p:txBody>
+      </p:sp>
+      <p:sp>
+        <p:nvSpPr>
+          <p:cNvPr id="8" name="TextBox 7"/>
+          <p:cNvSpPr txBox="1"/>
+          <p:nvPr/>
+        </p:nvSpPr>
+        <p:spPr>
+          <a:xfrm>
+            <a:off x="6172200" y="1673352"/>
+            <a:ext cx="502920" cy="201168"/>
+          </a:xfrm>
+          <a:prstGeom prst="rect">
+            <a:avLst/>
+          </a:prstGeom>
+          <a:noFill/>
+        </p:spPr>
+        <p:txBody>
+          <a:bodyPr wrap="square" lIns="0" rIns="0" tIns="0" bIns="0">
+            <a:spAutoFit/>
+          </a:bodyPr>
+          <a:lstStyle/>
+          <a:p>
+            <a:pPr algn="r"/>
+            <a:r>
+              <a:rPr sz="800" b="1" i="0">
+                <a:solidFill>
+                  <a:srgbClr val="CADCFC"/>
+                </a:solidFill>
+                <a:latin typeface="Arial"/>
+              </a:rPr>
+              <a:t>CLV</a:t>
+            </a:r>
+          </a:p>
+        </p:txBody>
+      </p:sp>
+      <p:sp>
+        <p:nvSpPr>
+          <p:cNvPr id="9" name="TextBox 8"/>
+          <p:cNvSpPr txBox="1"/>
+          <p:nvPr/>
+        </p:nvSpPr>
+        <p:spPr>
+          <a:xfrm>
+            <a:off x="6720840" y="1673352"/>
+            <a:ext cx="1188720" cy="201168"/>
+          </a:xfrm>
+          <a:prstGeom prst="rect">
+            <a:avLst/>
+          </a:prstGeom>
+          <a:noFill/>
+        </p:spPr>
+        <p:txBody>
+          <a:bodyPr wrap="square" lIns="0" rIns="0" tIns="0" bIns="0">
+            <a:spAutoFit/>
+          </a:bodyPr>
+          <a:lstStyle/>
+          <a:p>
+            <a:pPr algn="r"/>
+            <a:r>
+              <a:rPr sz="800" b="1" i="0">
+                <a:solidFill>
+                  <a:srgbClr val="CADCFC"/>
+                </a:solidFill>
+                <a:latin typeface="Arial"/>
+              </a:rPr>
+              <a:t>MACHINE (HOME)</a:t>
+            </a:r>
+          </a:p>
+        </p:txBody>
+      </p:sp>
+      <p:sp>
+        <p:nvSpPr>
+          <p:cNvPr id="10" name="TextBox 9"/>
+          <p:cNvSpPr txBox="1"/>
+          <p:nvPr/>
+        </p:nvSpPr>
+        <p:spPr>
+          <a:xfrm>
+            <a:off x="7955279" y="1673352"/>
+            <a:ext cx="548640" cy="201168"/>
+          </a:xfrm>
+          <a:prstGeom prst="rect">
+            <a:avLst/>
+          </a:prstGeom>
+          <a:noFill/>
+        </p:spPr>
+        <p:txBody>
+          <a:bodyPr wrap="square" lIns="0" rIns="0" tIns="0" bIns="0">
+            <a:spAutoFit/>
+          </a:bodyPr>
+          <a:lstStyle/>
+          <a:p>
+            <a:pPr algn="r"/>
+            <a:r>
+              <a:rPr sz="800" b="1" i="0">
+                <a:solidFill>
+                  <a:srgbClr val="CADCFC"/>
+                </a:solidFill>
+                <a:latin typeface="Arial"/>
+              </a:rPr>
+              <a:t>EDGE</a:t>
+            </a:r>
+          </a:p>
+        </p:txBody>
+      </p:sp>
+      <p:sp>
+        <p:nvSpPr>
+          <p:cNvPr id="11" name="TextBox 10"/>
+          <p:cNvSpPr txBox="1"/>
+          <p:nvPr/>
+        </p:nvSpPr>
+        <p:spPr>
+          <a:xfrm>
+            <a:off x="8641080" y="1673352"/>
+            <a:ext cx="1508760" cy="201168"/>
+          </a:xfrm>
+          <a:prstGeom prst="rect">
+            <a:avLst/>
+          </a:prstGeom>
+          <a:noFill/>
+        </p:spPr>
+        <p:txBody>
+          <a:bodyPr wrap="square" lIns="0" rIns="0" tIns="0" bIns="0">
+            <a:spAutoFit/>
+          </a:bodyPr>
+          <a:lstStyle/>
+          <a:p>
+            <a:pPr algn="l"/>
+            <a:r>
+              <a:rPr sz="800" b="1" i="0">
+                <a:solidFill>
+                  <a:srgbClr val="CADCFC"/>
+                </a:solidFill>
+                <a:latin typeface="Arial"/>
+              </a:rPr>
+              <a:t>MACHINE SIDE</a:t>
+            </a:r>
+          </a:p>
+        </p:txBody>
+      </p:sp>
+      <p:sp>
+        <p:nvSpPr>
+          <p:cNvPr id="12" name="TextBox 11"/>
+          <p:cNvSpPr txBox="1"/>
+          <p:nvPr/>
+        </p:nvSpPr>
+        <p:spPr>
+          <a:xfrm>
+            <a:off x="10195560" y="1673352"/>
+            <a:ext cx="1143000" cy="201168"/>
+          </a:xfrm>
+          <a:prstGeom prst="rect">
+            <a:avLst/>
+          </a:prstGeom>
+          <a:noFill/>
+        </p:spPr>
+        <p:txBody>
+          <a:bodyPr wrap="square" lIns="0" rIns="0" tIns="0" bIns="0">
+            <a:spAutoFit/>
+          </a:bodyPr>
+          <a:lstStyle/>
+          <a:p>
+            <a:pPr algn="r"/>
+            <a:r>
+              <a:rPr sz="800" b="1" i="0">
+                <a:solidFill>
+                  <a:srgbClr val="CADCFC"/>
+                </a:solidFill>
+                <a:latin typeface="Arial"/>
+              </a:rPr>
+              <a:t>DOG ML / O/U</a:t>
+            </a:r>
+          </a:p>
+        </p:txBody>
+      </p:sp>
+      <p:sp>
+        <p:nvSpPr>
+          <p:cNvPr id="13" name="Rectangle 12"/>
+          <p:cNvSpPr/>
+          <p:nvPr/>
+        </p:nvSpPr>
+        <p:spPr>
+          <a:xfrm>
+            <a:off x="822960" y="1901952"/>
+            <a:ext cx="10515600" cy="347472"/>
+          </a:xfrm>
+          <a:prstGeom prst="rect">
+            <a:avLst/>
+          </a:prstGeom>
+          <a:solidFill>
+            <a:srgbClr val="123568"/>
+          </a:solidFill>
+          <a:ln>
+            <a:noFill/>
+          </a:ln>
+          <a:effectLst/>
+        </p:spPr>
+        <p:style>
+          <a:lnRef idx="1">
+            <a:schemeClr val="accent1"/>
+          </a:lnRef>
+          <a:fillRef idx="3">
+            <a:schemeClr val="accent1"/>
+          </a:fillRef>
+          <a:effectRef idx="2">
+            <a:schemeClr val="accent1"/>
+          </a:effectRef>
+          <a:fontRef idx="minor">
+            <a:schemeClr val="lt1"/>
+          </a:fontRef>
+        </p:style>
+        <p:txBody>
+          <a:bodyPr rtlCol="0" anchor="ctr"/>
+          <a:lstStyle/>
+          <a:p>
+            <a:pPr algn="ctr"/>
+          </a:p>
+        </p:txBody>
+      </p:sp>
+      <p:sp>
+        <p:nvSpPr>
+          <p:cNvPr id="14" name="TextBox 13"/>
+          <p:cNvSpPr txBox="1"/>
+          <p:nvPr/>
+        </p:nvSpPr>
+        <p:spPr>
+          <a:xfrm>
+            <a:off x="868680" y="1947672"/>
+            <a:ext cx="457200" cy="274320"/>
+          </a:xfrm>
+          <a:prstGeom prst="rect">
+            <a:avLst/>
+          </a:prstGeom>
+          <a:noFill/>
+        </p:spPr>
+        <p:txBody>
+          <a:bodyPr wrap="square" lIns="0" rIns="0" tIns="0" bIns="0">
+            <a:spAutoFit/>
+          </a:bodyPr>
+          <a:lstStyle/>
+          <a:p>
+            <a:pPr algn="l"/>
+            <a:r>
+              <a:rPr sz="1000" b="1" i="0">
+                <a:solidFill>
+                  <a:srgbClr val="FF7A7A"/>
+                </a:solidFill>
+                <a:latin typeface="Arial"/>
+              </a:rPr>
+              <a:t>RED</a:t>
+            </a:r>
+          </a:p>
+        </p:txBody>
+      </p:sp>
+      <p:sp>
+        <p:nvSpPr>
+          <p:cNvPr id="15" name="TextBox 14"/>
+          <p:cNvSpPr txBox="1"/>
+          <p:nvPr/>
+        </p:nvSpPr>
+        <p:spPr>
+          <a:xfrm>
+            <a:off x="1325880" y="1947672"/>
+            <a:ext cx="2743200" cy="274320"/>
+          </a:xfrm>
+          <a:prstGeom prst="rect">
+            <a:avLst/>
+          </a:prstGeom>
+          <a:noFill/>
+        </p:spPr>
+        <p:txBody>
+          <a:bodyPr wrap="square" lIns="0" rIns="0" tIns="0" bIns="0">
+            <a:spAutoFit/>
+          </a:bodyPr>
+          <a:lstStyle/>
+          <a:p>
+            <a:pPr algn="l"/>
+            <a:r>
+              <a:rPr sz="1150" b="1" i="0">
+                <a:solidFill>
+                  <a:srgbClr val="FFFFFF"/>
+                </a:solidFill>
+                <a:latin typeface="Arial"/>
+              </a:rPr>
+              <a:t>South Florida at Army</a:t>
+            </a:r>
+          </a:p>
+        </p:txBody>
+      </p:sp>
+      <p:sp>
+        <p:nvSpPr>
+          <p:cNvPr id="16" name="TextBox 15"/>
+          <p:cNvSpPr txBox="1"/>
+          <p:nvPr/>
+        </p:nvSpPr>
+        <p:spPr>
+          <a:xfrm>
+            <a:off x="4114800" y="1965960"/>
+            <a:ext cx="2011680" cy="274320"/>
+          </a:xfrm>
+          <a:prstGeom prst="rect">
+            <a:avLst/>
+          </a:prstGeom>
+          <a:noFill/>
+        </p:spPr>
+        <p:txBody>
+          <a:bodyPr wrap="square" lIns="0" rIns="0" tIns="0" bIns="0">
+            <a:spAutoFit/>
+          </a:bodyPr>
+          <a:lstStyle/>
+          <a:p>
+            <a:pPr algn="l"/>
+            <a:r>
+              <a:rPr sz="900" b="0" i="0">
+                <a:solidFill>
+                  <a:srgbClr val="CADCFC"/>
+                </a:solidFill>
+                <a:latin typeface="Arial"/>
+              </a:rPr>
+              <a:t>Army -3.5 (unch.)</a:t>
+            </a:r>
+          </a:p>
+        </p:txBody>
+      </p:sp>
+      <p:sp>
+        <p:nvSpPr>
+          <p:cNvPr id="17" name="TextBox 16"/>
+          <p:cNvSpPr txBox="1"/>
+          <p:nvPr/>
+        </p:nvSpPr>
+        <p:spPr>
+          <a:xfrm>
+            <a:off x="6172200" y="1956816"/>
+            <a:ext cx="502920" cy="274320"/>
+          </a:xfrm>
+          <a:prstGeom prst="rect">
+            <a:avLst/>
+          </a:prstGeom>
+          <a:noFill/>
+        </p:spPr>
+        <p:txBody>
+          <a:bodyPr wrap="square" lIns="0" rIns="0" tIns="0" bIns="0">
+            <a:spAutoFit/>
+          </a:bodyPr>
+          <a:lstStyle/>
+          <a:p>
+            <a:pPr algn="r"/>
+            <a:r>
+              <a:rPr sz="1000" b="0" i="0">
+                <a:solidFill>
+                  <a:srgbClr val="CADCFC"/>
+                </a:solidFill>
+                <a:latin typeface="Arial"/>
+              </a:rPr>
+              <a:t>0</a:t>
+            </a:r>
+          </a:p>
+        </p:txBody>
+      </p:sp>
+      <p:sp>
+        <p:nvSpPr>
+          <p:cNvPr id="18" name="TextBox 17"/>
+          <p:cNvSpPr txBox="1"/>
+          <p:nvPr/>
+        </p:nvSpPr>
+        <p:spPr>
+          <a:xfrm>
+            <a:off x="6720840" y="1956816"/>
+            <a:ext cx="1188720" cy="274320"/>
+          </a:xfrm>
+          <a:prstGeom prst="rect">
+            <a:avLst/>
+          </a:prstGeom>
+          <a:noFill/>
+        </p:spPr>
+        <p:txBody>
+          <a:bodyPr wrap="square" lIns="0" rIns="0" tIns="0" bIns="0">
+            <a:spAutoFit/>
+          </a:bodyPr>
+          <a:lstStyle/>
+          <a:p>
+            <a:pPr algn="r"/>
+            <a:r>
+              <a:rPr sz="1000" b="0" i="0">
+                <a:solidFill>
+                  <a:srgbClr val="FFFFFF"/>
+                </a:solidFill>
+                <a:latin typeface="Arial"/>
+              </a:rPr>
+              <a:t>-1.4</a:t>
+            </a:r>
+          </a:p>
+        </p:txBody>
+      </p:sp>
+      <p:sp>
+        <p:nvSpPr>
+          <p:cNvPr id="19" name="TextBox 18"/>
+          <p:cNvSpPr txBox="1"/>
+          <p:nvPr/>
+        </p:nvSpPr>
+        <p:spPr>
+          <a:xfrm>
+            <a:off x="7955279" y="1956816"/>
+            <a:ext cx="548640" cy="274320"/>
+          </a:xfrm>
+          <a:prstGeom prst="rect">
+            <a:avLst/>
+          </a:prstGeom>
+          <a:noFill/>
+        </p:spPr>
+        <p:txBody>
+          <a:bodyPr wrap="square" lIns="0" rIns="0" tIns="0" bIns="0">
+            <a:spAutoFit/>
+          </a:bodyPr>
+          <a:lstStyle/>
+          <a:p>
+            <a:pPr algn="r"/>
+            <a:r>
+              <a:rPr sz="1050" b="1" i="0">
+                <a:solidFill>
+                  <a:srgbClr val="F47321"/>
+                </a:solidFill>
+                <a:latin typeface="Arial"/>
+              </a:rPr>
+              <a:t>4.9</a:t>
+            </a:r>
+          </a:p>
+        </p:txBody>
+      </p:sp>
+      <p:sp>
+        <p:nvSpPr>
+          <p:cNvPr id="20" name="TextBox 19"/>
+          <p:cNvSpPr txBox="1"/>
+          <p:nvPr/>
+        </p:nvSpPr>
+        <p:spPr>
+          <a:xfrm>
+            <a:off x="8641080" y="1956816"/>
+            <a:ext cx="1508760" cy="274320"/>
+          </a:xfrm>
+          <a:prstGeom prst="rect">
+            <a:avLst/>
+          </a:prstGeom>
+          <a:noFill/>
+        </p:spPr>
+        <p:txBody>
+          <a:bodyPr wrap="square" lIns="0" rIns="0" tIns="0" bIns="0">
+            <a:spAutoFit/>
+          </a:bodyPr>
+          <a:lstStyle/>
+          <a:p>
+            <a:pPr algn="l"/>
+            <a:r>
+              <a:rPr sz="1000" b="0" i="0">
+                <a:solidFill>
+                  <a:srgbClr val="FFFFFF"/>
+                </a:solidFill>
+                <a:latin typeface="Arial"/>
+              </a:rPr>
+              <a:t>South Florida</a:t>
+            </a:r>
+          </a:p>
+        </p:txBody>
+      </p:sp>
+      <p:sp>
+        <p:nvSpPr>
+          <p:cNvPr id="21" name="TextBox 20"/>
+          <p:cNvSpPr txBox="1"/>
+          <p:nvPr/>
+        </p:nvSpPr>
+        <p:spPr>
+          <a:xfrm>
+            <a:off x="10195560" y="1965960"/>
+            <a:ext cx="1143000" cy="274320"/>
+          </a:xfrm>
+          <a:prstGeom prst="rect">
+            <a:avLst/>
+          </a:prstGeom>
+          <a:noFill/>
+        </p:spPr>
+        <p:txBody>
+          <a:bodyPr wrap="square" lIns="0" rIns="0" tIns="0" bIns="0">
+            <a:spAutoFit/>
+          </a:bodyPr>
+          <a:lstStyle/>
+          <a:p>
+            <a:pPr algn="r"/>
+            <a:r>
+              <a:rPr sz="900" b="1" i="0">
+                <a:solidFill>
+                  <a:srgbClr val="F47321"/>
+                </a:solidFill>
+                <a:latin typeface="Arial"/>
+              </a:rPr>
+              <a:t>+154 · 46.5</a:t>
+            </a:r>
+          </a:p>
+        </p:txBody>
+      </p:sp>
+      <p:sp>
+        <p:nvSpPr>
+          <p:cNvPr id="22" name="TextBox 21"/>
+          <p:cNvSpPr txBox="1"/>
+          <p:nvPr/>
+        </p:nvSpPr>
+        <p:spPr>
+          <a:xfrm>
+            <a:off x="868680" y="2295144"/>
+            <a:ext cx="457200" cy="274320"/>
+          </a:xfrm>
+          <a:prstGeom prst="rect">
+            <a:avLst/>
+          </a:prstGeom>
+          <a:noFill/>
+        </p:spPr>
+        <p:txBody>
+          <a:bodyPr wrap="square" lIns="0" rIns="0" tIns="0" bIns="0">
+            <a:spAutoFit/>
+          </a:bodyPr>
+          <a:lstStyle/>
+          <a:p>
+            <a:pPr algn="l"/>
+            <a:r>
+              <a:rPr sz="1000" b="1" i="0">
+                <a:solidFill>
+                  <a:srgbClr val="F47321"/>
+                </a:solidFill>
+                <a:latin typeface="Arial"/>
+              </a:rPr>
+              <a:t>YEL</a:t>
+            </a:r>
+          </a:p>
+        </p:txBody>
+      </p:sp>
+      <p:sp>
+        <p:nvSpPr>
+          <p:cNvPr id="23" name="TextBox 22"/>
+          <p:cNvSpPr txBox="1"/>
+          <p:nvPr/>
+        </p:nvSpPr>
+        <p:spPr>
+          <a:xfrm>
+            <a:off x="1325880" y="2295144"/>
+            <a:ext cx="2743200" cy="274320"/>
+          </a:xfrm>
+          <a:prstGeom prst="rect">
+            <a:avLst/>
+          </a:prstGeom>
+          <a:noFill/>
+        </p:spPr>
+        <p:txBody>
+          <a:bodyPr wrap="square" lIns="0" rIns="0" tIns="0" bIns="0">
+            <a:spAutoFit/>
+          </a:bodyPr>
+          <a:lstStyle/>
+          <a:p>
+            <a:pPr algn="l"/>
+            <a:r>
+              <a:rPr sz="1150" b="1" i="0">
+                <a:solidFill>
+                  <a:srgbClr val="FFFFFF"/>
+                </a:solidFill>
+                <a:latin typeface="Arial"/>
+              </a:rPr>
+              <a:t>Charlotte at Ole Miss</a:t>
+            </a:r>
+          </a:p>
+        </p:txBody>
+      </p:sp>
+      <p:sp>
+        <p:nvSpPr>
+          <p:cNvPr id="24" name="TextBox 23"/>
+          <p:cNvSpPr txBox="1"/>
+          <p:nvPr/>
+        </p:nvSpPr>
+        <p:spPr>
+          <a:xfrm>
+            <a:off x="4114800" y="2313432"/>
+            <a:ext cx="2011680" cy="274320"/>
+          </a:xfrm>
+          <a:prstGeom prst="rect">
+            <a:avLst/>
+          </a:prstGeom>
+          <a:noFill/>
+        </p:spPr>
+        <p:txBody>
+          <a:bodyPr wrap="square" lIns="0" rIns="0" tIns="0" bIns="0">
+            <a:spAutoFit/>
+          </a:bodyPr>
+          <a:lstStyle/>
+          <a:p>
+            <a:pPr algn="l"/>
+            <a:r>
+              <a:rPr sz="900" b="0" i="0">
+                <a:solidFill>
+                  <a:srgbClr val="CADCFC"/>
+                </a:solidFill>
+                <a:latin typeface="Arial"/>
+              </a:rPr>
+              <a:t>Ole Miss -47.5 (unch.)</a:t>
+            </a:r>
+          </a:p>
+        </p:txBody>
+      </p:sp>
+      <p:sp>
+        <p:nvSpPr>
+          <p:cNvPr id="25" name="TextBox 24"/>
+          <p:cNvSpPr txBox="1"/>
+          <p:nvPr/>
+        </p:nvSpPr>
+        <p:spPr>
+          <a:xfrm>
+            <a:off x="6172200" y="2304288"/>
+            <a:ext cx="502920" cy="274320"/>
+          </a:xfrm>
+          <a:prstGeom prst="rect">
+            <a:avLst/>
+          </a:prstGeom>
+          <a:noFill/>
+        </p:spPr>
+        <p:txBody>
+          <a:bodyPr wrap="square" lIns="0" rIns="0" tIns="0" bIns="0">
+            <a:spAutoFit/>
+          </a:bodyPr>
+          <a:lstStyle/>
+          <a:p>
+            <a:pPr algn="r"/>
+            <a:r>
+              <a:rPr sz="1000" b="0" i="0">
+                <a:solidFill>
+                  <a:srgbClr val="CADCFC"/>
+                </a:solidFill>
+                <a:latin typeface="Arial"/>
+              </a:rPr>
+              <a:t>0</a:t>
+            </a:r>
+          </a:p>
+        </p:txBody>
+      </p:sp>
+      <p:sp>
+        <p:nvSpPr>
+          <p:cNvPr id="26" name="TextBox 25"/>
+          <p:cNvSpPr txBox="1"/>
+          <p:nvPr/>
+        </p:nvSpPr>
+        <p:spPr>
+          <a:xfrm>
+            <a:off x="6720840" y="2304288"/>
+            <a:ext cx="1188720" cy="274320"/>
+          </a:xfrm>
+          <a:prstGeom prst="rect">
+            <a:avLst/>
+          </a:prstGeom>
+          <a:noFill/>
+        </p:spPr>
+        <p:txBody>
+          <a:bodyPr wrap="square" lIns="0" rIns="0" tIns="0" bIns="0">
+            <a:spAutoFit/>
+          </a:bodyPr>
+          <a:lstStyle/>
+          <a:p>
+            <a:pPr algn="r"/>
+            <a:r>
+              <a:rPr sz="1000" b="0" i="0">
+                <a:solidFill>
+                  <a:srgbClr val="FFFFFF"/>
+                </a:solidFill>
+                <a:latin typeface="Arial"/>
+              </a:rPr>
+              <a:t>+32.4</a:t>
+            </a:r>
+          </a:p>
+        </p:txBody>
+      </p:sp>
+      <p:sp>
+        <p:nvSpPr>
+          <p:cNvPr id="27" name="TextBox 26"/>
+          <p:cNvSpPr txBox="1"/>
+          <p:nvPr/>
+        </p:nvSpPr>
+        <p:spPr>
+          <a:xfrm>
+            <a:off x="7955279" y="2304288"/>
+            <a:ext cx="548640" cy="274320"/>
+          </a:xfrm>
+          <a:prstGeom prst="rect">
+            <a:avLst/>
+          </a:prstGeom>
+          <a:noFill/>
+        </p:spPr>
+        <p:txBody>
+          <a:bodyPr wrap="square" lIns="0" rIns="0" tIns="0" bIns="0">
+            <a:spAutoFit/>
+          </a:bodyPr>
+          <a:lstStyle/>
+          <a:p>
+            <a:pPr algn="r"/>
+            <a:r>
+              <a:rPr sz="1050" b="1" i="0">
+                <a:solidFill>
+                  <a:srgbClr val="F47321"/>
+                </a:solidFill>
+                <a:latin typeface="Arial"/>
+              </a:rPr>
+              <a:t>15.1</a:t>
+            </a:r>
+          </a:p>
+        </p:txBody>
+      </p:sp>
+      <p:sp>
+        <p:nvSpPr>
+          <p:cNvPr id="28" name="TextBox 27"/>
+          <p:cNvSpPr txBox="1"/>
+          <p:nvPr/>
+        </p:nvSpPr>
+        <p:spPr>
+          <a:xfrm>
+            <a:off x="8641080" y="2304288"/>
+            <a:ext cx="1508760" cy="274320"/>
+          </a:xfrm>
+          <a:prstGeom prst="rect">
+            <a:avLst/>
+          </a:prstGeom>
+          <a:noFill/>
+        </p:spPr>
+        <p:txBody>
+          <a:bodyPr wrap="square" lIns="0" rIns="0" tIns="0" bIns="0">
+            <a:spAutoFit/>
+          </a:bodyPr>
+          <a:lstStyle/>
+          <a:p>
+            <a:pPr algn="l"/>
+            <a:r>
+              <a:rPr sz="1000" b="0" i="0">
+                <a:solidFill>
+                  <a:srgbClr val="FFFFFF"/>
+                </a:solidFill>
+                <a:latin typeface="Arial"/>
+              </a:rPr>
+              <a:t>Charlotte</a:t>
+            </a:r>
+          </a:p>
+        </p:txBody>
+      </p:sp>
+      <p:sp>
+        <p:nvSpPr>
+          <p:cNvPr id="29" name="TextBox 28"/>
+          <p:cNvSpPr txBox="1"/>
+          <p:nvPr/>
+        </p:nvSpPr>
+        <p:spPr>
+          <a:xfrm>
+            <a:off x="10195560" y="2313432"/>
+            <a:ext cx="1143000" cy="274320"/>
+          </a:xfrm>
+          <a:prstGeom prst="rect">
+            <a:avLst/>
+          </a:prstGeom>
+          <a:noFill/>
+        </p:spPr>
+        <p:txBody>
+          <a:bodyPr wrap="square" lIns="0" rIns="0" tIns="0" bIns="0">
+            <a:spAutoFit/>
+          </a:bodyPr>
+          <a:lstStyle/>
+          <a:p>
+            <a:pPr algn="r"/>
+            <a:r>
+              <a:rPr sz="900" b="1" i="0">
+                <a:solidFill>
+                  <a:srgbClr val="F47321"/>
+                </a:solidFill>
+                <a:latin typeface="Arial"/>
+              </a:rPr>
+              <a:t>60.5 ⚑</a:t>
+            </a:r>
+          </a:p>
+        </p:txBody>
+      </p:sp>
+      <p:sp>
+        <p:nvSpPr>
+          <p:cNvPr id="30" name="Rectangle 29"/>
+          <p:cNvSpPr/>
+          <p:nvPr/>
+        </p:nvSpPr>
+        <p:spPr>
+          <a:xfrm>
+            <a:off x="822960" y="2596896"/>
+            <a:ext cx="10515600" cy="347472"/>
+          </a:xfrm>
+          <a:prstGeom prst="rect">
+            <a:avLst/>
+          </a:prstGeom>
+          <a:solidFill>
+            <a:srgbClr val="123568"/>
+          </a:solidFill>
+          <a:ln>
+            <a:noFill/>
+          </a:ln>
+          <a:effectLst/>
+        </p:spPr>
+        <p:style>
+          <a:lnRef idx="1">
+            <a:schemeClr val="accent1"/>
+          </a:lnRef>
+          <a:fillRef idx="3">
+            <a:schemeClr val="accent1"/>
+          </a:fillRef>
+          <a:effectRef idx="2">
+            <a:schemeClr val="accent1"/>
+          </a:effectRef>
+          <a:fontRef idx="minor">
+            <a:schemeClr val="lt1"/>
+          </a:fontRef>
+        </p:style>
+        <p:txBody>
+          <a:bodyPr rtlCol="0" anchor="ctr"/>
+          <a:lstStyle/>
+          <a:p>
+            <a:pPr algn="ctr"/>
+          </a:p>
+        </p:txBody>
+      </p:sp>
+      <p:sp>
+        <p:nvSpPr>
+          <p:cNvPr id="31" name="TextBox 30"/>
+          <p:cNvSpPr txBox="1"/>
+          <p:nvPr/>
+        </p:nvSpPr>
+        <p:spPr>
+          <a:xfrm>
+            <a:off x="868680" y="2642615"/>
+            <a:ext cx="457200" cy="274320"/>
+          </a:xfrm>
+          <a:prstGeom prst="rect">
+            <a:avLst/>
+          </a:prstGeom>
+          <a:noFill/>
+        </p:spPr>
+        <p:txBody>
+          <a:bodyPr wrap="square" lIns="0" rIns="0" tIns="0" bIns="0">
+            <a:spAutoFit/>
+          </a:bodyPr>
+          <a:lstStyle/>
+          <a:p>
+            <a:pPr algn="l"/>
+            <a:r>
+              <a:rPr sz="1000" b="1" i="0">
+                <a:solidFill>
+                  <a:srgbClr val="F47321"/>
+                </a:solidFill>
+                <a:latin typeface="Arial"/>
+              </a:rPr>
+              <a:t>YEL</a:t>
+            </a:r>
+          </a:p>
+        </p:txBody>
+      </p:sp>
+      <p:sp>
+        <p:nvSpPr>
+          <p:cNvPr id="32" name="TextBox 31"/>
+          <p:cNvSpPr txBox="1"/>
+          <p:nvPr/>
+        </p:nvSpPr>
+        <p:spPr>
+          <a:xfrm>
+            <a:off x="1325880" y="2642615"/>
+            <a:ext cx="2743200" cy="274320"/>
+          </a:xfrm>
+          <a:prstGeom prst="rect">
+            <a:avLst/>
+          </a:prstGeom>
+          <a:noFill/>
+        </p:spPr>
+        <p:txBody>
+          <a:bodyPr wrap="square" lIns="0" rIns="0" tIns="0" bIns="0">
+            <a:spAutoFit/>
+          </a:bodyPr>
+          <a:lstStyle/>
+          <a:p>
+            <a:pPr algn="l"/>
+            <a:r>
+              <a:rPr sz="1150" b="1" i="0">
+                <a:solidFill>
+                  <a:srgbClr val="FFFFFF"/>
+                </a:solidFill>
+                <a:latin typeface="Arial"/>
+              </a:rPr>
+              <a:t>Southern Miss at Auburn</a:t>
+            </a:r>
+          </a:p>
+        </p:txBody>
+      </p:sp>
+      <p:sp>
+        <p:nvSpPr>
+          <p:cNvPr id="33" name="TextBox 32"/>
+          <p:cNvSpPr txBox="1"/>
+          <p:nvPr/>
+        </p:nvSpPr>
+        <p:spPr>
+          <a:xfrm>
+            <a:off x="4114800" y="2660903"/>
+            <a:ext cx="2011680" cy="274320"/>
+          </a:xfrm>
+          <a:prstGeom prst="rect">
+            <a:avLst/>
+          </a:prstGeom>
+          <a:noFill/>
+        </p:spPr>
+        <p:txBody>
+          <a:bodyPr wrap="square" lIns="0" rIns="0" tIns="0" bIns="0">
+            <a:spAutoFit/>
+          </a:bodyPr>
+          <a:lstStyle/>
+          <a:p>
+            <a:pPr algn="l"/>
+            <a:r>
+              <a:rPr sz="900" b="0" i="0">
+                <a:solidFill>
+                  <a:srgbClr val="CADCFC"/>
+                </a:solidFill>
+                <a:latin typeface="Arial"/>
+              </a:rPr>
+              <a:t>Auburn -31.5 → Auburn -33.5</a:t>
+            </a:r>
+          </a:p>
+        </p:txBody>
+      </p:sp>
+      <p:sp>
+        <p:nvSpPr>
+          <p:cNvPr id="34" name="TextBox 33"/>
+          <p:cNvSpPr txBox="1"/>
+          <p:nvPr/>
+        </p:nvSpPr>
+        <p:spPr>
+          <a:xfrm>
+            <a:off x="6172200" y="2651760"/>
+            <a:ext cx="502920" cy="274320"/>
+          </a:xfrm>
+          <a:prstGeom prst="rect">
+            <a:avLst/>
+          </a:prstGeom>
+          <a:noFill/>
+        </p:spPr>
+        <p:txBody>
+          <a:bodyPr wrap="square" lIns="0" rIns="0" tIns="0" bIns="0">
+            <a:spAutoFit/>
+          </a:bodyPr>
+          <a:lstStyle/>
+          <a:p>
+            <a:pPr algn="r"/>
+            <a:r>
+              <a:rPr sz="1000" b="1" i="0">
+                <a:solidFill>
+                  <a:srgbClr val="FF7A7A"/>
+                </a:solidFill>
+                <a:latin typeface="Arial"/>
+              </a:rPr>
+              <a:t>-2</a:t>
+            </a:r>
+          </a:p>
+        </p:txBody>
+      </p:sp>
+      <p:sp>
+        <p:nvSpPr>
+          <p:cNvPr id="35" name="TextBox 34"/>
+          <p:cNvSpPr txBox="1"/>
+          <p:nvPr/>
+        </p:nvSpPr>
+        <p:spPr>
+          <a:xfrm>
+            <a:off x="6720840" y="2651760"/>
+            <a:ext cx="1188720" cy="274320"/>
+          </a:xfrm>
+          <a:prstGeom prst="rect">
+            <a:avLst/>
+          </a:prstGeom>
+          <a:noFill/>
+        </p:spPr>
+        <p:txBody>
+          <a:bodyPr wrap="square" lIns="0" rIns="0" tIns="0" bIns="0">
+            <a:spAutoFit/>
+          </a:bodyPr>
+          <a:lstStyle/>
+          <a:p>
+            <a:pPr algn="r"/>
+            <a:r>
+              <a:rPr sz="1000" b="0" i="0">
+                <a:solidFill>
+                  <a:srgbClr val="FFFFFF"/>
+                </a:solidFill>
+                <a:latin typeface="Arial"/>
+              </a:rPr>
+              <a:t>+18.7</a:t>
+            </a:r>
+          </a:p>
+        </p:txBody>
+      </p:sp>
+      <p:sp>
+        <p:nvSpPr>
+          <p:cNvPr id="36" name="TextBox 35"/>
+          <p:cNvSpPr txBox="1"/>
+          <p:nvPr/>
+        </p:nvSpPr>
+        <p:spPr>
+          <a:xfrm>
+            <a:off x="7955279" y="2651760"/>
+            <a:ext cx="548640" cy="274320"/>
+          </a:xfrm>
+          <a:prstGeom prst="rect">
+            <a:avLst/>
+          </a:prstGeom>
+          <a:noFill/>
+        </p:spPr>
+        <p:txBody>
+          <a:bodyPr wrap="square" lIns="0" rIns="0" tIns="0" bIns="0">
+            <a:spAutoFit/>
+          </a:bodyPr>
+          <a:lstStyle/>
+          <a:p>
+            <a:pPr algn="r"/>
+            <a:r>
+              <a:rPr sz="1050" b="1" i="0">
+                <a:solidFill>
+                  <a:srgbClr val="F47321"/>
+                </a:solidFill>
+                <a:latin typeface="Arial"/>
+              </a:rPr>
+              <a:t>12.8</a:t>
+            </a:r>
+          </a:p>
+        </p:txBody>
+      </p:sp>
+      <p:sp>
+        <p:nvSpPr>
+          <p:cNvPr id="37" name="TextBox 36"/>
+          <p:cNvSpPr txBox="1"/>
+          <p:nvPr/>
+        </p:nvSpPr>
+        <p:spPr>
+          <a:xfrm>
+            <a:off x="8641080" y="2651760"/>
+            <a:ext cx="1508760" cy="274320"/>
+          </a:xfrm>
+          <a:prstGeom prst="rect">
+            <a:avLst/>
+          </a:prstGeom>
+          <a:noFill/>
+        </p:spPr>
+        <p:txBody>
+          <a:bodyPr wrap="square" lIns="0" rIns="0" tIns="0" bIns="0">
+            <a:spAutoFit/>
+          </a:bodyPr>
+          <a:lstStyle/>
+          <a:p>
+            <a:pPr algn="l"/>
+            <a:r>
+              <a:rPr sz="1000" b="0" i="0">
+                <a:solidFill>
+                  <a:srgbClr val="FFFFFF"/>
+                </a:solidFill>
+                <a:latin typeface="Arial"/>
+              </a:rPr>
+              <a:t>Southern Miss</a:t>
+            </a:r>
+          </a:p>
+        </p:txBody>
+      </p:sp>
+      <p:sp>
+        <p:nvSpPr>
+          <p:cNvPr id="38" name="TextBox 37"/>
+          <p:cNvSpPr txBox="1"/>
+          <p:nvPr/>
+        </p:nvSpPr>
+        <p:spPr>
+          <a:xfrm>
+            <a:off x="10195560" y="2660903"/>
+            <a:ext cx="1143000" cy="274320"/>
+          </a:xfrm>
+          <a:prstGeom prst="rect">
+            <a:avLst/>
+          </a:prstGeom>
+          <a:noFill/>
+        </p:spPr>
+        <p:txBody>
+          <a:bodyPr wrap="square" lIns="0" rIns="0" tIns="0" bIns="0">
+            <a:spAutoFit/>
+          </a:bodyPr>
+          <a:lstStyle/>
+          <a:p>
+            <a:pPr algn="r"/>
+            <a:r>
+              <a:rPr sz="900" b="0" i="0">
+                <a:solidFill>
+                  <a:srgbClr val="CADCFC"/>
+                </a:solidFill>
+                <a:latin typeface="Arial"/>
+              </a:rPr>
+              <a:t>56.5</a:t>
+            </a:r>
+          </a:p>
+        </p:txBody>
+      </p:sp>
+      <p:sp>
+        <p:nvSpPr>
+          <p:cNvPr id="39" name="TextBox 38"/>
+          <p:cNvSpPr txBox="1"/>
+          <p:nvPr/>
+        </p:nvSpPr>
+        <p:spPr>
+          <a:xfrm>
+            <a:off x="868680" y="2990088"/>
+            <a:ext cx="457200" cy="274320"/>
+          </a:xfrm>
+          <a:prstGeom prst="rect">
+            <a:avLst/>
+          </a:prstGeom>
+          <a:noFill/>
+        </p:spPr>
+        <p:txBody>
+          <a:bodyPr wrap="square" lIns="0" rIns="0" tIns="0" bIns="0">
+            <a:spAutoFit/>
+          </a:bodyPr>
+          <a:lstStyle/>
+          <a:p>
+            <a:pPr algn="l"/>
+            <a:r>
+              <a:rPr sz="1000" b="1" i="0">
+                <a:solidFill>
+                  <a:srgbClr val="F47321"/>
+                </a:solidFill>
+                <a:latin typeface="Arial"/>
+              </a:rPr>
+              <a:t>YEL</a:t>
+            </a:r>
+          </a:p>
+        </p:txBody>
+      </p:sp>
+      <p:sp>
+        <p:nvSpPr>
+          <p:cNvPr id="40" name="TextBox 39"/>
+          <p:cNvSpPr txBox="1"/>
+          <p:nvPr/>
+        </p:nvSpPr>
+        <p:spPr>
+          <a:xfrm>
+            <a:off x="1325880" y="2990088"/>
+            <a:ext cx="2743200" cy="274320"/>
+          </a:xfrm>
+          <a:prstGeom prst="rect">
+            <a:avLst/>
+          </a:prstGeom>
+          <a:noFill/>
+        </p:spPr>
+        <p:txBody>
+          <a:bodyPr wrap="square" lIns="0" rIns="0" tIns="0" bIns="0">
+            <a:spAutoFit/>
+          </a:bodyPr>
+          <a:lstStyle/>
+          <a:p>
+            <a:pPr algn="l"/>
+            <a:r>
+              <a:rPr sz="1150" b="1" i="0">
+                <a:solidFill>
+                  <a:srgbClr val="FFFFFF"/>
+                </a:solidFill>
+                <a:latin typeface="Arial"/>
+              </a:rPr>
+              <a:t>Buffalo at Florida International</a:t>
+            </a:r>
+          </a:p>
+        </p:txBody>
+      </p:sp>
+      <p:sp>
+        <p:nvSpPr>
+          <p:cNvPr id="41" name="TextBox 40"/>
+          <p:cNvSpPr txBox="1"/>
+          <p:nvPr/>
+        </p:nvSpPr>
+        <p:spPr>
+          <a:xfrm>
+            <a:off x="4114800" y="3008376"/>
+            <a:ext cx="2011680" cy="274320"/>
+          </a:xfrm>
+          <a:prstGeom prst="rect">
+            <a:avLst/>
+          </a:prstGeom>
+          <a:noFill/>
+        </p:spPr>
+        <p:txBody>
+          <a:bodyPr wrap="square" lIns="0" rIns="0" tIns="0" bIns="0">
+            <a:spAutoFit/>
+          </a:bodyPr>
+          <a:lstStyle/>
+          <a:p>
+            <a:pPr algn="l"/>
+            <a:r>
+              <a:rPr sz="900" b="0" i="0">
+                <a:solidFill>
+                  <a:srgbClr val="CADCFC"/>
+                </a:solidFill>
+                <a:latin typeface="Arial"/>
+              </a:rPr>
+              <a:t>FIU -10.5 (unch.)</a:t>
+            </a:r>
+          </a:p>
+        </p:txBody>
+      </p:sp>
+      <p:sp>
+        <p:nvSpPr>
+          <p:cNvPr id="42" name="TextBox 41"/>
+          <p:cNvSpPr txBox="1"/>
+          <p:nvPr/>
+        </p:nvSpPr>
+        <p:spPr>
+          <a:xfrm>
+            <a:off x="6172200" y="2999232"/>
+            <a:ext cx="502920" cy="274320"/>
+          </a:xfrm>
+          <a:prstGeom prst="rect">
+            <a:avLst/>
+          </a:prstGeom>
+          <a:noFill/>
+        </p:spPr>
+        <p:txBody>
+          <a:bodyPr wrap="square" lIns="0" rIns="0" tIns="0" bIns="0">
+            <a:spAutoFit/>
+          </a:bodyPr>
+          <a:lstStyle/>
+          <a:p>
+            <a:pPr algn="r"/>
+            <a:r>
+              <a:rPr sz="1000" b="0" i="0">
+                <a:solidFill>
+                  <a:srgbClr val="CADCFC"/>
+                </a:solidFill>
+                <a:latin typeface="Arial"/>
+              </a:rPr>
+              <a:t>0</a:t>
+            </a:r>
+          </a:p>
+        </p:txBody>
+      </p:sp>
+      <p:sp>
+        <p:nvSpPr>
+          <p:cNvPr id="43" name="TextBox 42"/>
+          <p:cNvSpPr txBox="1"/>
+          <p:nvPr/>
+        </p:nvSpPr>
+        <p:spPr>
+          <a:xfrm>
+            <a:off x="6720840" y="2999232"/>
+            <a:ext cx="1188720" cy="274320"/>
+          </a:xfrm>
+          <a:prstGeom prst="rect">
+            <a:avLst/>
+          </a:prstGeom>
+          <a:noFill/>
+        </p:spPr>
+        <p:txBody>
+          <a:bodyPr wrap="square" lIns="0" rIns="0" tIns="0" bIns="0">
+            <a:spAutoFit/>
+          </a:bodyPr>
+          <a:lstStyle/>
+          <a:p>
+            <a:pPr algn="r"/>
+            <a:r>
+              <a:rPr sz="1000" b="0" i="0">
+                <a:solidFill>
+                  <a:srgbClr val="FFFFFF"/>
+                </a:solidFill>
+                <a:latin typeface="Arial"/>
+              </a:rPr>
+              <a:t>+1.5</a:t>
+            </a:r>
+          </a:p>
+        </p:txBody>
+      </p:sp>
+      <p:sp>
+        <p:nvSpPr>
+          <p:cNvPr id="44" name="TextBox 43"/>
+          <p:cNvSpPr txBox="1"/>
+          <p:nvPr/>
+        </p:nvSpPr>
+        <p:spPr>
+          <a:xfrm>
+            <a:off x="7955279" y="2999232"/>
+            <a:ext cx="548640" cy="274320"/>
+          </a:xfrm>
+          <a:prstGeom prst="rect">
+            <a:avLst/>
+          </a:prstGeom>
+          <a:noFill/>
+        </p:spPr>
+        <p:txBody>
+          <a:bodyPr wrap="square" lIns="0" rIns="0" tIns="0" bIns="0">
+            <a:spAutoFit/>
+          </a:bodyPr>
+          <a:lstStyle/>
+          <a:p>
+            <a:pPr algn="r"/>
+            <a:r>
+              <a:rPr sz="1050" b="1" i="0">
+                <a:solidFill>
+                  <a:srgbClr val="F47321"/>
+                </a:solidFill>
+                <a:latin typeface="Arial"/>
+              </a:rPr>
+              <a:t>9.0</a:t>
+            </a:r>
+          </a:p>
+        </p:txBody>
+      </p:sp>
+      <p:sp>
+        <p:nvSpPr>
+          <p:cNvPr id="45" name="TextBox 44"/>
+          <p:cNvSpPr txBox="1"/>
+          <p:nvPr/>
+        </p:nvSpPr>
+        <p:spPr>
+          <a:xfrm>
+            <a:off x="8641080" y="2999232"/>
+            <a:ext cx="1508760" cy="274320"/>
+          </a:xfrm>
+          <a:prstGeom prst="rect">
+            <a:avLst/>
+          </a:prstGeom>
+          <a:noFill/>
+        </p:spPr>
+        <p:txBody>
+          <a:bodyPr wrap="square" lIns="0" rIns="0" tIns="0" bIns="0">
+            <a:spAutoFit/>
+          </a:bodyPr>
+          <a:lstStyle/>
+          <a:p>
+            <a:pPr algn="l"/>
+            <a:r>
+              <a:rPr sz="1000" b="0" i="0">
+                <a:solidFill>
+                  <a:srgbClr val="FFFFFF"/>
+                </a:solidFill>
+                <a:latin typeface="Arial"/>
+              </a:rPr>
+              <a:t>Buffalo</a:t>
+            </a:r>
+          </a:p>
+        </p:txBody>
+      </p:sp>
+      <p:sp>
+        <p:nvSpPr>
+          <p:cNvPr id="46" name="TextBox 45"/>
+          <p:cNvSpPr txBox="1"/>
+          <p:nvPr/>
+        </p:nvSpPr>
+        <p:spPr>
+          <a:xfrm>
+            <a:off x="10195560" y="3008376"/>
+            <a:ext cx="1143000" cy="274320"/>
+          </a:xfrm>
+          <a:prstGeom prst="rect">
+            <a:avLst/>
+          </a:prstGeom>
+          <a:noFill/>
+        </p:spPr>
+        <p:txBody>
+          <a:bodyPr wrap="square" lIns="0" rIns="0" tIns="0" bIns="0">
+            <a:spAutoFit/>
+          </a:bodyPr>
+          <a:lstStyle/>
+          <a:p>
+            <a:pPr algn="r"/>
+            <a:r>
+              <a:rPr sz="900" b="0" i="0">
+                <a:solidFill>
+                  <a:srgbClr val="CADCFC"/>
+                </a:solidFill>
+                <a:latin typeface="Arial"/>
+              </a:rPr>
+              <a:t>47.5</a:t>
+            </a:r>
+          </a:p>
+        </p:txBody>
+      </p:sp>
+      <p:sp>
+        <p:nvSpPr>
+          <p:cNvPr id="47" name="Rectangle 46"/>
+          <p:cNvSpPr/>
+          <p:nvPr/>
+        </p:nvSpPr>
+        <p:spPr>
+          <a:xfrm>
+            <a:off x="822960" y="3291840"/>
+            <a:ext cx="10515600" cy="347472"/>
+          </a:xfrm>
+          <a:prstGeom prst="rect">
+            <a:avLst/>
+          </a:prstGeom>
+          <a:solidFill>
+            <a:srgbClr val="123568"/>
+          </a:solidFill>
+          <a:ln>
+            <a:noFill/>
+          </a:ln>
+          <a:effectLst/>
+        </p:spPr>
+        <p:style>
+          <a:lnRef idx="1">
+            <a:schemeClr val="accent1"/>
+          </a:lnRef>
+          <a:fillRef idx="3">
+            <a:schemeClr val="accent1"/>
+          </a:fillRef>
+          <a:effectRef idx="2">
+            <a:schemeClr val="accent1"/>
+          </a:effectRef>
+          <a:fontRef idx="minor">
+            <a:schemeClr val="lt1"/>
+          </a:fontRef>
+        </p:style>
+        <p:txBody>
+          <a:bodyPr rtlCol="0" anchor="ctr"/>
+          <a:lstStyle/>
+          <a:p>
+            <a:pPr algn="ctr"/>
+          </a:p>
+        </p:txBody>
+      </p:sp>
+      <p:sp>
+        <p:nvSpPr>
+          <p:cNvPr id="48" name="TextBox 47"/>
+          <p:cNvSpPr txBox="1"/>
+          <p:nvPr/>
+        </p:nvSpPr>
+        <p:spPr>
+          <a:xfrm>
+            <a:off x="868680" y="3337560"/>
+            <a:ext cx="457200" cy="274320"/>
+          </a:xfrm>
+          <a:prstGeom prst="rect">
+            <a:avLst/>
+          </a:prstGeom>
+          <a:noFill/>
+        </p:spPr>
+        <p:txBody>
+          <a:bodyPr wrap="square" lIns="0" rIns="0" tIns="0" bIns="0">
+            <a:spAutoFit/>
+          </a:bodyPr>
+          <a:lstStyle/>
+          <a:p>
+            <a:pPr algn="l"/>
+            <a:r>
+              <a:rPr sz="1000" b="1" i="0">
+                <a:solidFill>
+                  <a:srgbClr val="F47321"/>
+                </a:solidFill>
+                <a:latin typeface="Arial"/>
+              </a:rPr>
+              <a:t>YEL</a:t>
+            </a:r>
+          </a:p>
+        </p:txBody>
+      </p:sp>
+      <p:sp>
+        <p:nvSpPr>
+          <p:cNvPr id="49" name="TextBox 48"/>
+          <p:cNvSpPr txBox="1"/>
+          <p:nvPr/>
+        </p:nvSpPr>
+        <p:spPr>
+          <a:xfrm>
+            <a:off x="1325880" y="3337560"/>
+            <a:ext cx="2743200" cy="274320"/>
+          </a:xfrm>
+          <a:prstGeom prst="rect">
+            <a:avLst/>
+          </a:prstGeom>
+          <a:noFill/>
+        </p:spPr>
+        <p:txBody>
+          <a:bodyPr wrap="square" lIns="0" rIns="0" tIns="0" bIns="0">
+            <a:spAutoFit/>
+          </a:bodyPr>
+          <a:lstStyle/>
+          <a:p>
+            <a:pPr algn="l"/>
+            <a:r>
+              <a:rPr sz="1150" b="1" i="0">
+                <a:solidFill>
+                  <a:srgbClr val="FFFFFF"/>
+                </a:solidFill>
+                <a:latin typeface="Arial"/>
+              </a:rPr>
+              <a:t>San Diego State at UCLA</a:t>
+            </a:r>
+          </a:p>
+        </p:txBody>
+      </p:sp>
+      <p:sp>
+        <p:nvSpPr>
+          <p:cNvPr id="50" name="TextBox 49"/>
+          <p:cNvSpPr txBox="1"/>
+          <p:nvPr/>
+        </p:nvSpPr>
+        <p:spPr>
+          <a:xfrm>
+            <a:off x="4114800" y="3355848"/>
+            <a:ext cx="2011680" cy="274320"/>
+          </a:xfrm>
+          <a:prstGeom prst="rect">
+            <a:avLst/>
+          </a:prstGeom>
+          <a:noFill/>
+        </p:spPr>
+        <p:txBody>
+          <a:bodyPr wrap="square" lIns="0" rIns="0" tIns="0" bIns="0">
+            <a:spAutoFit/>
+          </a:bodyPr>
+          <a:lstStyle/>
+          <a:p>
+            <a:pPr algn="l"/>
+            <a:r>
+              <a:rPr sz="900" b="0" i="0">
+                <a:solidFill>
+                  <a:srgbClr val="CADCFC"/>
+                </a:solidFill>
+                <a:latin typeface="Arial"/>
+              </a:rPr>
+              <a:t>UCLA -9.5 → UCLA -11.5</a:t>
+            </a:r>
+          </a:p>
+        </p:txBody>
+      </p:sp>
+      <p:sp>
+        <p:nvSpPr>
+          <p:cNvPr id="51" name="TextBox 50"/>
+          <p:cNvSpPr txBox="1"/>
+          <p:nvPr/>
+        </p:nvSpPr>
+        <p:spPr>
+          <a:xfrm>
+            <a:off x="6172200" y="3346704"/>
+            <a:ext cx="502920" cy="274320"/>
+          </a:xfrm>
+          <a:prstGeom prst="rect">
+            <a:avLst/>
+          </a:prstGeom>
+          <a:noFill/>
+        </p:spPr>
+        <p:txBody>
+          <a:bodyPr wrap="square" lIns="0" rIns="0" tIns="0" bIns="0">
+            <a:spAutoFit/>
+          </a:bodyPr>
+          <a:lstStyle/>
+          <a:p>
+            <a:pPr algn="r"/>
+            <a:r>
+              <a:rPr sz="1000" b="1" i="0">
+                <a:solidFill>
+                  <a:srgbClr val="FF7A7A"/>
+                </a:solidFill>
+                <a:latin typeface="Arial"/>
+              </a:rPr>
+              <a:t>-2</a:t>
+            </a:r>
+          </a:p>
+        </p:txBody>
+      </p:sp>
+      <p:sp>
+        <p:nvSpPr>
+          <p:cNvPr id="52" name="TextBox 51"/>
+          <p:cNvSpPr txBox="1"/>
+          <p:nvPr/>
+        </p:nvSpPr>
+        <p:spPr>
+          <a:xfrm>
+            <a:off x="6720840" y="3346704"/>
+            <a:ext cx="1188720" cy="274320"/>
+          </a:xfrm>
+          <a:prstGeom prst="rect">
+            <a:avLst/>
+          </a:prstGeom>
+          <a:noFill/>
+        </p:spPr>
+        <p:txBody>
+          <a:bodyPr wrap="square" lIns="0" rIns="0" tIns="0" bIns="0">
+            <a:spAutoFit/>
+          </a:bodyPr>
+          <a:lstStyle/>
+          <a:p>
+            <a:pPr algn="r"/>
+            <a:r>
+              <a:rPr sz="1000" b="0" i="0">
+                <a:solidFill>
+                  <a:srgbClr val="FFFFFF"/>
+                </a:solidFill>
+                <a:latin typeface="Arial"/>
+              </a:rPr>
+              <a:t>+6.4</a:t>
+            </a:r>
+          </a:p>
+        </p:txBody>
+      </p:sp>
+      <p:sp>
+        <p:nvSpPr>
+          <p:cNvPr id="53" name="TextBox 52"/>
+          <p:cNvSpPr txBox="1"/>
+          <p:nvPr/>
+        </p:nvSpPr>
+        <p:spPr>
+          <a:xfrm>
+            <a:off x="7955279" y="3346704"/>
+            <a:ext cx="548640" cy="274320"/>
+          </a:xfrm>
+          <a:prstGeom prst="rect">
+            <a:avLst/>
+          </a:prstGeom>
+          <a:noFill/>
+        </p:spPr>
+        <p:txBody>
+          <a:bodyPr wrap="square" lIns="0" rIns="0" tIns="0" bIns="0">
+            <a:spAutoFit/>
+          </a:bodyPr>
+          <a:lstStyle/>
+          <a:p>
+            <a:pPr algn="r"/>
+            <a:r>
+              <a:rPr sz="1050" b="1" i="0">
+                <a:solidFill>
+                  <a:srgbClr val="F47321"/>
+                </a:solidFill>
+                <a:latin typeface="Arial"/>
+              </a:rPr>
+              <a:t>7.9</a:t>
+            </a:r>
+          </a:p>
+        </p:txBody>
+      </p:sp>
+      <p:sp>
+        <p:nvSpPr>
+          <p:cNvPr id="54" name="TextBox 53"/>
+          <p:cNvSpPr txBox="1"/>
+          <p:nvPr/>
+        </p:nvSpPr>
+        <p:spPr>
+          <a:xfrm>
+            <a:off x="8641080" y="3346704"/>
+            <a:ext cx="1508760" cy="274320"/>
+          </a:xfrm>
+          <a:prstGeom prst="rect">
+            <a:avLst/>
+          </a:prstGeom>
+          <a:noFill/>
+        </p:spPr>
+        <p:txBody>
+          <a:bodyPr wrap="square" lIns="0" rIns="0" tIns="0" bIns="0">
+            <a:spAutoFit/>
+          </a:bodyPr>
+          <a:lstStyle/>
+          <a:p>
+            <a:pPr algn="l"/>
+            <a:r>
+              <a:rPr sz="1000" b="0" i="0">
+                <a:solidFill>
+                  <a:srgbClr val="FFFFFF"/>
+                </a:solidFill>
+                <a:latin typeface="Arial"/>
+              </a:rPr>
+              <a:t>San Diego State</a:t>
+            </a:r>
+          </a:p>
+        </p:txBody>
+      </p:sp>
+      <p:sp>
+        <p:nvSpPr>
+          <p:cNvPr id="55" name="TextBox 54"/>
+          <p:cNvSpPr txBox="1"/>
+          <p:nvPr/>
+        </p:nvSpPr>
+        <p:spPr>
+          <a:xfrm>
+            <a:off x="10195560" y="3355848"/>
+            <a:ext cx="1143000" cy="274320"/>
+          </a:xfrm>
+          <a:prstGeom prst="rect">
+            <a:avLst/>
+          </a:prstGeom>
+          <a:noFill/>
+        </p:spPr>
+        <p:txBody>
+          <a:bodyPr wrap="square" lIns="0" rIns="0" tIns="0" bIns="0">
+            <a:spAutoFit/>
+          </a:bodyPr>
+          <a:lstStyle/>
+          <a:p>
+            <a:pPr algn="r"/>
+            <a:r>
+              <a:rPr sz="900" b="0" i="0">
+                <a:solidFill>
+                  <a:srgbClr val="CADCFC"/>
+                </a:solidFill>
+                <a:latin typeface="Arial"/>
+              </a:rPr>
+              <a:t>55.5</a:t>
+            </a:r>
+          </a:p>
+        </p:txBody>
+      </p:sp>
+      <p:sp>
+        <p:nvSpPr>
+          <p:cNvPr id="56" name="TextBox 55"/>
+          <p:cNvSpPr txBox="1"/>
+          <p:nvPr/>
+        </p:nvSpPr>
+        <p:spPr>
+          <a:xfrm>
+            <a:off x="868680" y="3685032"/>
+            <a:ext cx="457200" cy="274320"/>
+          </a:xfrm>
+          <a:prstGeom prst="rect">
+            <a:avLst/>
+          </a:prstGeom>
+          <a:noFill/>
+        </p:spPr>
+        <p:txBody>
+          <a:bodyPr wrap="square" lIns="0" rIns="0" tIns="0" bIns="0">
+            <a:spAutoFit/>
+          </a:bodyPr>
+          <a:lstStyle/>
+          <a:p>
+            <a:pPr algn="l"/>
+            <a:r>
+              <a:rPr sz="1000" b="1" i="0">
+                <a:solidFill>
+                  <a:srgbClr val="F47321"/>
+                </a:solidFill>
+                <a:latin typeface="Arial"/>
+              </a:rPr>
+              <a:t>YEL</a:t>
+            </a:r>
+          </a:p>
+        </p:txBody>
+      </p:sp>
+      <p:sp>
+        <p:nvSpPr>
+          <p:cNvPr id="57" name="TextBox 56"/>
+          <p:cNvSpPr txBox="1"/>
+          <p:nvPr/>
+        </p:nvSpPr>
+        <p:spPr>
+          <a:xfrm>
+            <a:off x="1325880" y="3685032"/>
+            <a:ext cx="2743200" cy="274320"/>
+          </a:xfrm>
+          <a:prstGeom prst="rect">
+            <a:avLst/>
+          </a:prstGeom>
+          <a:noFill/>
+        </p:spPr>
+        <p:txBody>
+          <a:bodyPr wrap="square" lIns="0" rIns="0" tIns="0" bIns="0">
+            <a:spAutoFit/>
+          </a:bodyPr>
+          <a:lstStyle/>
+          <a:p>
+            <a:pPr algn="l"/>
+            <a:r>
+              <a:rPr sz="1150" b="1" i="0">
+                <a:solidFill>
+                  <a:srgbClr val="FFFFFF"/>
+                </a:solidFill>
+                <a:latin typeface="Arial"/>
+              </a:rPr>
+              <a:t>Utah State at Washington</a:t>
+            </a:r>
+          </a:p>
+        </p:txBody>
+      </p:sp>
+      <p:sp>
+        <p:nvSpPr>
+          <p:cNvPr id="58" name="TextBox 57"/>
+          <p:cNvSpPr txBox="1"/>
+          <p:nvPr/>
+        </p:nvSpPr>
+        <p:spPr>
+          <a:xfrm>
+            <a:off x="4114800" y="3703320"/>
+            <a:ext cx="2011680" cy="274320"/>
+          </a:xfrm>
+          <a:prstGeom prst="rect">
+            <a:avLst/>
+          </a:prstGeom>
+          <a:noFill/>
+        </p:spPr>
+        <p:txBody>
+          <a:bodyPr wrap="square" lIns="0" rIns="0" tIns="0" bIns="0">
+            <a:spAutoFit/>
+          </a:bodyPr>
+          <a:lstStyle/>
+          <a:p>
+            <a:pPr algn="l"/>
+            <a:r>
+              <a:rPr sz="900" b="0" i="0">
+                <a:solidFill>
+                  <a:srgbClr val="CADCFC"/>
+                </a:solidFill>
+                <a:latin typeface="Arial"/>
+              </a:rPr>
+              <a:t>Washington -26.5 (unch.)</a:t>
+            </a:r>
+          </a:p>
+        </p:txBody>
+      </p:sp>
+      <p:sp>
+        <p:nvSpPr>
+          <p:cNvPr id="59" name="TextBox 58"/>
+          <p:cNvSpPr txBox="1"/>
+          <p:nvPr/>
+        </p:nvSpPr>
+        <p:spPr>
+          <a:xfrm>
+            <a:off x="6172200" y="3694176"/>
+            <a:ext cx="502920" cy="274320"/>
+          </a:xfrm>
+          <a:prstGeom prst="rect">
+            <a:avLst/>
+          </a:prstGeom>
+          <a:noFill/>
+        </p:spPr>
+        <p:txBody>
+          <a:bodyPr wrap="square" lIns="0" rIns="0" tIns="0" bIns="0">
+            <a:spAutoFit/>
+          </a:bodyPr>
+          <a:lstStyle/>
+          <a:p>
+            <a:pPr algn="r"/>
+            <a:r>
+              <a:rPr sz="1000" b="0" i="0">
+                <a:solidFill>
+                  <a:srgbClr val="CADCFC"/>
+                </a:solidFill>
+                <a:latin typeface="Arial"/>
+              </a:rPr>
+              <a:t>0</a:t>
+            </a:r>
+          </a:p>
+        </p:txBody>
+      </p:sp>
+      <p:sp>
+        <p:nvSpPr>
+          <p:cNvPr id="60" name="TextBox 59"/>
+          <p:cNvSpPr txBox="1"/>
+          <p:nvPr/>
+        </p:nvSpPr>
+        <p:spPr>
+          <a:xfrm>
+            <a:off x="6720840" y="3694176"/>
+            <a:ext cx="1188720" cy="274320"/>
+          </a:xfrm>
+          <a:prstGeom prst="rect">
+            <a:avLst/>
+          </a:prstGeom>
+          <a:noFill/>
+        </p:spPr>
+        <p:txBody>
+          <a:bodyPr wrap="square" lIns="0" rIns="0" tIns="0" bIns="0">
+            <a:spAutoFit/>
+          </a:bodyPr>
+          <a:lstStyle/>
+          <a:p>
+            <a:pPr algn="r"/>
+            <a:r>
+              <a:rPr sz="1000" b="0" i="0">
+                <a:solidFill>
+                  <a:srgbClr val="FFFFFF"/>
+                </a:solidFill>
+                <a:latin typeface="Arial"/>
+              </a:rPr>
+              <a:t>+18.6</a:t>
+            </a:r>
+          </a:p>
+        </p:txBody>
+      </p:sp>
+      <p:sp>
+        <p:nvSpPr>
+          <p:cNvPr id="61" name="TextBox 60"/>
+          <p:cNvSpPr txBox="1"/>
+          <p:nvPr/>
+        </p:nvSpPr>
+        <p:spPr>
+          <a:xfrm>
+            <a:off x="7955279" y="3694176"/>
+            <a:ext cx="548640" cy="274320"/>
+          </a:xfrm>
+          <a:prstGeom prst="rect">
+            <a:avLst/>
+          </a:prstGeom>
+          <a:noFill/>
+        </p:spPr>
+        <p:txBody>
+          <a:bodyPr wrap="square" lIns="0" rIns="0" tIns="0" bIns="0">
+            <a:spAutoFit/>
+          </a:bodyPr>
+          <a:lstStyle/>
+          <a:p>
+            <a:pPr algn="r"/>
+            <a:r>
+              <a:rPr sz="1050" b="1" i="0">
+                <a:solidFill>
+                  <a:srgbClr val="F47321"/>
+                </a:solidFill>
+                <a:latin typeface="Arial"/>
+              </a:rPr>
+              <a:t>7.9</a:t>
+            </a:r>
+          </a:p>
+        </p:txBody>
+      </p:sp>
+      <p:sp>
+        <p:nvSpPr>
+          <p:cNvPr id="62" name="TextBox 61"/>
+          <p:cNvSpPr txBox="1"/>
+          <p:nvPr/>
+        </p:nvSpPr>
+        <p:spPr>
+          <a:xfrm>
+            <a:off x="8641080" y="3694176"/>
+            <a:ext cx="1508760" cy="274320"/>
+          </a:xfrm>
+          <a:prstGeom prst="rect">
+            <a:avLst/>
+          </a:prstGeom>
+          <a:noFill/>
+        </p:spPr>
+        <p:txBody>
+          <a:bodyPr wrap="square" lIns="0" rIns="0" tIns="0" bIns="0">
+            <a:spAutoFit/>
+          </a:bodyPr>
+          <a:lstStyle/>
+          <a:p>
+            <a:pPr algn="l"/>
+            <a:r>
+              <a:rPr sz="1000" b="0" i="0">
+                <a:solidFill>
+                  <a:srgbClr val="FFFFFF"/>
+                </a:solidFill>
+                <a:latin typeface="Arial"/>
+              </a:rPr>
+              <a:t>Utah State</a:t>
+            </a:r>
+          </a:p>
+        </p:txBody>
+      </p:sp>
+      <p:sp>
+        <p:nvSpPr>
+          <p:cNvPr id="63" name="TextBox 62"/>
+          <p:cNvSpPr txBox="1"/>
+          <p:nvPr/>
+        </p:nvSpPr>
+        <p:spPr>
+          <a:xfrm>
+            <a:off x="10195560" y="3703320"/>
+            <a:ext cx="1143000" cy="274320"/>
+          </a:xfrm>
+          <a:prstGeom prst="rect">
+            <a:avLst/>
+          </a:prstGeom>
+          <a:noFill/>
+        </p:spPr>
+        <p:txBody>
+          <a:bodyPr wrap="square" lIns="0" rIns="0" tIns="0" bIns="0">
+            <a:spAutoFit/>
+          </a:bodyPr>
+          <a:lstStyle/>
+          <a:p>
+            <a:pPr algn="r"/>
+            <a:r>
+              <a:rPr sz="900" b="0" i="0">
+                <a:solidFill>
+                  <a:srgbClr val="CADCFC"/>
+                </a:solidFill>
+                <a:latin typeface="Arial"/>
+              </a:rPr>
+              <a:t>55.5</a:t>
+            </a:r>
+          </a:p>
+        </p:txBody>
+      </p:sp>
+      <p:sp>
+        <p:nvSpPr>
+          <p:cNvPr id="64" name="Rectangle 63"/>
+          <p:cNvSpPr/>
+          <p:nvPr/>
+        </p:nvSpPr>
+        <p:spPr>
+          <a:xfrm>
+            <a:off x="822960" y="3986784"/>
+            <a:ext cx="10515600" cy="347472"/>
+          </a:xfrm>
+          <a:prstGeom prst="rect">
+            <a:avLst/>
+          </a:prstGeom>
+          <a:solidFill>
+            <a:srgbClr val="123568"/>
+          </a:solidFill>
+          <a:ln>
+            <a:noFill/>
+          </a:ln>
+          <a:effectLst/>
+        </p:spPr>
+        <p:style>
+          <a:lnRef idx="1">
+            <a:schemeClr val="accent1"/>
+          </a:lnRef>
+          <a:fillRef idx="3">
+            <a:schemeClr val="accent1"/>
+          </a:fillRef>
+          <a:effectRef idx="2">
+            <a:schemeClr val="accent1"/>
+          </a:effectRef>
+          <a:fontRef idx="minor">
+            <a:schemeClr val="lt1"/>
+          </a:fontRef>
+        </p:style>
+        <p:txBody>
+          <a:bodyPr rtlCol="0" anchor="ctr"/>
+          <a:lstStyle/>
+          <a:p>
+            <a:pPr algn="ctr"/>
+          </a:p>
+        </p:txBody>
+      </p:sp>
+      <p:sp>
+        <p:nvSpPr>
+          <p:cNvPr id="65" name="TextBox 64"/>
+          <p:cNvSpPr txBox="1"/>
+          <p:nvPr/>
+        </p:nvSpPr>
+        <p:spPr>
+          <a:xfrm>
+            <a:off x="868680" y="4032504"/>
+            <a:ext cx="457200" cy="274320"/>
+          </a:xfrm>
+          <a:prstGeom prst="rect">
+            <a:avLst/>
+          </a:prstGeom>
+          <a:noFill/>
+        </p:spPr>
+        <p:txBody>
+          <a:bodyPr wrap="square" lIns="0" rIns="0" tIns="0" bIns="0">
+            <a:spAutoFit/>
+          </a:bodyPr>
+          <a:lstStyle/>
+          <a:p>
+            <a:pPr algn="l"/>
+            <a:r>
+              <a:rPr sz="1000" b="1" i="0">
+                <a:solidFill>
+                  <a:srgbClr val="F47321"/>
+                </a:solidFill>
+                <a:latin typeface="Arial"/>
+              </a:rPr>
+              <a:t>YEL</a:t>
+            </a:r>
+          </a:p>
+        </p:txBody>
+      </p:sp>
+      <p:sp>
+        <p:nvSpPr>
+          <p:cNvPr id="66" name="TextBox 65"/>
+          <p:cNvSpPr txBox="1"/>
+          <p:nvPr/>
+        </p:nvSpPr>
+        <p:spPr>
+          <a:xfrm>
+            <a:off x="1325880" y="4032504"/>
+            <a:ext cx="2743200" cy="274320"/>
+          </a:xfrm>
+          <a:prstGeom prst="rect">
+            <a:avLst/>
+          </a:prstGeom>
+          <a:noFill/>
+        </p:spPr>
+        <p:txBody>
+          <a:bodyPr wrap="square" lIns="0" rIns="0" tIns="0" bIns="0">
+            <a:spAutoFit/>
+          </a:bodyPr>
+          <a:lstStyle/>
+          <a:p>
+            <a:pPr algn="l"/>
+            <a:r>
+              <a:rPr sz="1150" b="1" i="0">
+                <a:solidFill>
+                  <a:srgbClr val="FFFFFF"/>
+                </a:solidFill>
+                <a:latin typeface="Arial"/>
+              </a:rPr>
+              <a:t>Arkansas at Utah</a:t>
+            </a:r>
+          </a:p>
+        </p:txBody>
+      </p:sp>
+      <p:sp>
+        <p:nvSpPr>
+          <p:cNvPr id="67" name="TextBox 66"/>
+          <p:cNvSpPr txBox="1"/>
+          <p:nvPr/>
+        </p:nvSpPr>
+        <p:spPr>
+          <a:xfrm>
+            <a:off x="4114800" y="4050792"/>
+            <a:ext cx="2011680" cy="274320"/>
+          </a:xfrm>
+          <a:prstGeom prst="rect">
+            <a:avLst/>
+          </a:prstGeom>
+          <a:noFill/>
+        </p:spPr>
+        <p:txBody>
+          <a:bodyPr wrap="square" lIns="0" rIns="0" tIns="0" bIns="0">
+            <a:spAutoFit/>
+          </a:bodyPr>
+          <a:lstStyle/>
+          <a:p>
+            <a:pPr algn="l"/>
+            <a:r>
+              <a:rPr sz="900" b="0" i="0">
+                <a:solidFill>
+                  <a:srgbClr val="CADCFC"/>
+                </a:solidFill>
+                <a:latin typeface="Arial"/>
+              </a:rPr>
+              <a:t>Utah -13.5 → Utah -12.5</a:t>
+            </a:r>
+          </a:p>
+        </p:txBody>
+      </p:sp>
+      <p:sp>
+        <p:nvSpPr>
+          <p:cNvPr id="68" name="TextBox 67"/>
+          <p:cNvSpPr txBox="1"/>
+          <p:nvPr/>
+        </p:nvSpPr>
+        <p:spPr>
+          <a:xfrm>
+            <a:off x="6172200" y="4041648"/>
+            <a:ext cx="502920" cy="274320"/>
+          </a:xfrm>
+          <a:prstGeom prst="rect">
+            <a:avLst/>
+          </a:prstGeom>
+          <a:noFill/>
+        </p:spPr>
+        <p:txBody>
+          <a:bodyPr wrap="square" lIns="0" rIns="0" tIns="0" bIns="0">
+            <a:spAutoFit/>
+          </a:bodyPr>
+          <a:lstStyle/>
+          <a:p>
+            <a:pPr algn="r"/>
+            <a:r>
+              <a:rPr sz="1000" b="1" i="0">
+                <a:solidFill>
+                  <a:srgbClr val="5CD68A"/>
+                </a:solidFill>
+                <a:latin typeface="Arial"/>
+              </a:rPr>
+              <a:t>+1</a:t>
+            </a:r>
+          </a:p>
+        </p:txBody>
+      </p:sp>
+      <p:sp>
+        <p:nvSpPr>
+          <p:cNvPr id="69" name="TextBox 68"/>
+          <p:cNvSpPr txBox="1"/>
+          <p:nvPr/>
+        </p:nvSpPr>
+        <p:spPr>
+          <a:xfrm>
+            <a:off x="6720840" y="4041648"/>
+            <a:ext cx="1188720" cy="274320"/>
+          </a:xfrm>
+          <a:prstGeom prst="rect">
+            <a:avLst/>
+          </a:prstGeom>
+          <a:noFill/>
+        </p:spPr>
+        <p:txBody>
+          <a:bodyPr wrap="square" lIns="0" rIns="0" tIns="0" bIns="0">
+            <a:spAutoFit/>
+          </a:bodyPr>
+          <a:lstStyle/>
+          <a:p>
+            <a:pPr algn="r"/>
+            <a:r>
+              <a:rPr sz="1000" b="0" i="0">
+                <a:solidFill>
+                  <a:srgbClr val="FFFFFF"/>
+                </a:solidFill>
+                <a:latin typeface="Arial"/>
+              </a:rPr>
+              <a:t>+6.6</a:t>
+            </a:r>
+          </a:p>
+        </p:txBody>
+      </p:sp>
+      <p:sp>
+        <p:nvSpPr>
+          <p:cNvPr id="70" name="TextBox 69"/>
+          <p:cNvSpPr txBox="1"/>
+          <p:nvPr/>
+        </p:nvSpPr>
+        <p:spPr>
+          <a:xfrm>
+            <a:off x="7955279" y="4041648"/>
+            <a:ext cx="548640" cy="274320"/>
+          </a:xfrm>
+          <a:prstGeom prst="rect">
+            <a:avLst/>
+          </a:prstGeom>
+          <a:noFill/>
+        </p:spPr>
+        <p:txBody>
+          <a:bodyPr wrap="square" lIns="0" rIns="0" tIns="0" bIns="0">
+            <a:spAutoFit/>
+          </a:bodyPr>
+          <a:lstStyle/>
+          <a:p>
+            <a:pPr algn="r"/>
+            <a:r>
+              <a:rPr sz="1050" b="1" i="0">
+                <a:solidFill>
+                  <a:srgbClr val="F47321"/>
+                </a:solidFill>
+                <a:latin typeface="Arial"/>
+              </a:rPr>
+              <a:t>6.9</a:t>
+            </a:r>
+          </a:p>
+        </p:txBody>
+      </p:sp>
+      <p:sp>
+        <p:nvSpPr>
+          <p:cNvPr id="71" name="TextBox 70"/>
+          <p:cNvSpPr txBox="1"/>
+          <p:nvPr/>
+        </p:nvSpPr>
+        <p:spPr>
+          <a:xfrm>
+            <a:off x="8641080" y="4041648"/>
+            <a:ext cx="1508760" cy="274320"/>
+          </a:xfrm>
+          <a:prstGeom prst="rect">
+            <a:avLst/>
+          </a:prstGeom>
+          <a:noFill/>
+        </p:spPr>
+        <p:txBody>
+          <a:bodyPr wrap="square" lIns="0" rIns="0" tIns="0" bIns="0">
+            <a:spAutoFit/>
+          </a:bodyPr>
+          <a:lstStyle/>
+          <a:p>
+            <a:pPr algn="l"/>
+            <a:r>
+              <a:rPr sz="1000" b="0" i="0">
+                <a:solidFill>
+                  <a:srgbClr val="FFFFFF"/>
+                </a:solidFill>
+                <a:latin typeface="Arial"/>
+              </a:rPr>
+              <a:t>Arkansas</a:t>
+            </a:r>
+          </a:p>
+        </p:txBody>
+      </p:sp>
+      <p:sp>
+        <p:nvSpPr>
+          <p:cNvPr id="72" name="TextBox 71"/>
+          <p:cNvSpPr txBox="1"/>
+          <p:nvPr/>
+        </p:nvSpPr>
+        <p:spPr>
+          <a:xfrm>
+            <a:off x="10195560" y="4050792"/>
+            <a:ext cx="1143000" cy="274320"/>
+          </a:xfrm>
+          <a:prstGeom prst="rect">
+            <a:avLst/>
+          </a:prstGeom>
+          <a:noFill/>
+        </p:spPr>
+        <p:txBody>
+          <a:bodyPr wrap="square" lIns="0" rIns="0" tIns="0" bIns="0">
+            <a:spAutoFit/>
+          </a:bodyPr>
+          <a:lstStyle/>
+          <a:p>
+            <a:pPr algn="r"/>
+            <a:r>
+              <a:rPr sz="900" b="0" i="0">
+                <a:solidFill>
+                  <a:srgbClr val="CADCFC"/>
+                </a:solidFill>
+                <a:latin typeface="Arial"/>
+              </a:rPr>
+              <a:t>54.5</a:t>
+            </a:r>
+          </a:p>
+        </p:txBody>
+      </p:sp>
+      <p:sp>
+        <p:nvSpPr>
+          <p:cNvPr id="73" name="TextBox 72"/>
+          <p:cNvSpPr txBox="1"/>
+          <p:nvPr/>
+        </p:nvSpPr>
+        <p:spPr>
+          <a:xfrm>
+            <a:off x="868680" y="4379976"/>
+            <a:ext cx="457200" cy="274320"/>
+          </a:xfrm>
+          <a:prstGeom prst="rect">
+            <a:avLst/>
+          </a:prstGeom>
+          <a:noFill/>
+        </p:spPr>
+        <p:txBody>
+          <a:bodyPr wrap="square" lIns="0" rIns="0" tIns="0" bIns="0">
+            <a:spAutoFit/>
+          </a:bodyPr>
+          <a:lstStyle/>
+          <a:p>
+            <a:pPr algn="l"/>
+            <a:r>
+              <a:rPr sz="1000" b="1" i="0">
+                <a:solidFill>
+                  <a:srgbClr val="F47321"/>
+                </a:solidFill>
+                <a:latin typeface="Arial"/>
+              </a:rPr>
+              <a:t>YEL</a:t>
+            </a:r>
+          </a:p>
+        </p:txBody>
+      </p:sp>
+      <p:sp>
+        <p:nvSpPr>
+          <p:cNvPr id="74" name="TextBox 73"/>
+          <p:cNvSpPr txBox="1"/>
+          <p:nvPr/>
+        </p:nvSpPr>
+        <p:spPr>
+          <a:xfrm>
+            <a:off x="1325880" y="4379976"/>
+            <a:ext cx="2743200" cy="274320"/>
+          </a:xfrm>
+          <a:prstGeom prst="rect">
+            <a:avLst/>
+          </a:prstGeom>
+          <a:noFill/>
+        </p:spPr>
+        <p:txBody>
+          <a:bodyPr wrap="square" lIns="0" rIns="0" tIns="0" bIns="0">
+            <a:spAutoFit/>
+          </a:bodyPr>
+          <a:lstStyle/>
+          <a:p>
+            <a:pPr algn="l"/>
+            <a:r>
+              <a:rPr sz="1150" b="1" i="0">
+                <a:solidFill>
+                  <a:srgbClr val="FFFFFF"/>
+                </a:solidFill>
+                <a:latin typeface="Arial"/>
+              </a:rPr>
+              <a:t>Sacramento State at Fresno State</a:t>
+            </a:r>
+          </a:p>
+        </p:txBody>
+      </p:sp>
+      <p:sp>
+        <p:nvSpPr>
+          <p:cNvPr id="75" name="TextBox 74"/>
+          <p:cNvSpPr txBox="1"/>
+          <p:nvPr/>
+        </p:nvSpPr>
+        <p:spPr>
+          <a:xfrm>
+            <a:off x="4114800" y="4398264"/>
+            <a:ext cx="2011680" cy="274320"/>
+          </a:xfrm>
+          <a:prstGeom prst="rect">
+            <a:avLst/>
+          </a:prstGeom>
+          <a:noFill/>
+        </p:spPr>
+        <p:txBody>
+          <a:bodyPr wrap="square" lIns="0" rIns="0" tIns="0" bIns="0">
+            <a:spAutoFit/>
+          </a:bodyPr>
+          <a:lstStyle/>
+          <a:p>
+            <a:pPr algn="l"/>
+            <a:r>
+              <a:rPr sz="900" b="0" i="0">
+                <a:solidFill>
+                  <a:srgbClr val="CADCFC"/>
+                </a:solidFill>
+                <a:latin typeface="Arial"/>
+              </a:rPr>
+              <a:t>Fresno State -18.5 (unch.)</a:t>
+            </a:r>
+          </a:p>
+        </p:txBody>
+      </p:sp>
+      <p:sp>
+        <p:nvSpPr>
+          <p:cNvPr id="76" name="TextBox 75"/>
+          <p:cNvSpPr txBox="1"/>
+          <p:nvPr/>
+        </p:nvSpPr>
+        <p:spPr>
+          <a:xfrm>
+            <a:off x="6172200" y="4389120"/>
+            <a:ext cx="502920" cy="274320"/>
+          </a:xfrm>
+          <a:prstGeom prst="rect">
+            <a:avLst/>
+          </a:prstGeom>
+          <a:noFill/>
+        </p:spPr>
+        <p:txBody>
+          <a:bodyPr wrap="square" lIns="0" rIns="0" tIns="0" bIns="0">
+            <a:spAutoFit/>
+          </a:bodyPr>
+          <a:lstStyle/>
+          <a:p>
+            <a:pPr algn="r"/>
+            <a:r>
+              <a:rPr sz="1000" b="0" i="0">
+                <a:solidFill>
+                  <a:srgbClr val="CADCFC"/>
+                </a:solidFill>
+                <a:latin typeface="Arial"/>
+              </a:rPr>
+              <a:t>0</a:t>
+            </a:r>
+          </a:p>
+        </p:txBody>
+      </p:sp>
+      <p:sp>
+        <p:nvSpPr>
+          <p:cNvPr id="77" name="TextBox 76"/>
+          <p:cNvSpPr txBox="1"/>
+          <p:nvPr/>
+        </p:nvSpPr>
+        <p:spPr>
+          <a:xfrm>
+            <a:off x="6720840" y="4389120"/>
+            <a:ext cx="1188720" cy="274320"/>
+          </a:xfrm>
+          <a:prstGeom prst="rect">
+            <a:avLst/>
+          </a:prstGeom>
+          <a:noFill/>
+        </p:spPr>
+        <p:txBody>
+          <a:bodyPr wrap="square" lIns="0" rIns="0" tIns="0" bIns="0">
+            <a:spAutoFit/>
+          </a:bodyPr>
+          <a:lstStyle/>
+          <a:p>
+            <a:pPr algn="r"/>
+            <a:r>
+              <a:rPr sz="1000" b="0" i="0">
+                <a:solidFill>
+                  <a:srgbClr val="FFFFFF"/>
+                </a:solidFill>
+                <a:latin typeface="Arial"/>
+              </a:rPr>
+              <a:t>+11.6</a:t>
+            </a:r>
+          </a:p>
+        </p:txBody>
+      </p:sp>
+      <p:sp>
+        <p:nvSpPr>
+          <p:cNvPr id="78" name="TextBox 77"/>
+          <p:cNvSpPr txBox="1"/>
+          <p:nvPr/>
+        </p:nvSpPr>
+        <p:spPr>
+          <a:xfrm>
+            <a:off x="7955279" y="4389120"/>
+            <a:ext cx="548640" cy="274320"/>
+          </a:xfrm>
+          <a:prstGeom prst="rect">
+            <a:avLst/>
+          </a:prstGeom>
+          <a:noFill/>
+        </p:spPr>
+        <p:txBody>
+          <a:bodyPr wrap="square" lIns="0" rIns="0" tIns="0" bIns="0">
+            <a:spAutoFit/>
+          </a:bodyPr>
+          <a:lstStyle/>
+          <a:p>
+            <a:pPr algn="r"/>
+            <a:r>
+              <a:rPr sz="1050" b="1" i="0">
+                <a:solidFill>
+                  <a:srgbClr val="F47321"/>
+                </a:solidFill>
+                <a:latin typeface="Arial"/>
+              </a:rPr>
+              <a:t>6.9</a:t>
+            </a:r>
+          </a:p>
+        </p:txBody>
+      </p:sp>
+      <p:sp>
+        <p:nvSpPr>
+          <p:cNvPr id="79" name="TextBox 78"/>
+          <p:cNvSpPr txBox="1"/>
+          <p:nvPr/>
+        </p:nvSpPr>
+        <p:spPr>
+          <a:xfrm>
+            <a:off x="8641080" y="4389120"/>
+            <a:ext cx="1508760" cy="274320"/>
+          </a:xfrm>
+          <a:prstGeom prst="rect">
+            <a:avLst/>
+          </a:prstGeom>
+          <a:noFill/>
+        </p:spPr>
+        <p:txBody>
+          <a:bodyPr wrap="square" lIns="0" rIns="0" tIns="0" bIns="0">
+            <a:spAutoFit/>
+          </a:bodyPr>
+          <a:lstStyle/>
+          <a:p>
+            <a:pPr algn="l"/>
+            <a:r>
+              <a:rPr sz="1000" b="0" i="0">
+                <a:solidFill>
+                  <a:srgbClr val="FFFFFF"/>
+                </a:solidFill>
+                <a:latin typeface="Arial"/>
+              </a:rPr>
+              <a:t>Sacramento State</a:t>
+            </a:r>
+          </a:p>
+        </p:txBody>
+      </p:sp>
+      <p:sp>
+        <p:nvSpPr>
+          <p:cNvPr id="80" name="TextBox 79"/>
+          <p:cNvSpPr txBox="1"/>
+          <p:nvPr/>
+        </p:nvSpPr>
+        <p:spPr>
+          <a:xfrm>
+            <a:off x="10195560" y="4398264"/>
+            <a:ext cx="1143000" cy="274320"/>
+          </a:xfrm>
+          <a:prstGeom prst="rect">
+            <a:avLst/>
+          </a:prstGeom>
+          <a:noFill/>
+        </p:spPr>
+        <p:txBody>
+          <a:bodyPr wrap="square" lIns="0" rIns="0" tIns="0" bIns="0">
+            <a:spAutoFit/>
+          </a:bodyPr>
+          <a:lstStyle/>
+          <a:p>
+            <a:pPr algn="r"/>
+            <a:r>
+              <a:rPr sz="900" b="0" i="0">
+                <a:solidFill>
+                  <a:srgbClr val="CADCFC"/>
+                </a:solidFill>
+                <a:latin typeface="Arial"/>
+              </a:rPr>
+              <a:t>45.5</a:t>
+            </a:r>
+          </a:p>
+        </p:txBody>
+      </p:sp>
+      <p:sp>
+        <p:nvSpPr>
+          <p:cNvPr id="81" name="Rectangle 80"/>
+          <p:cNvSpPr/>
+          <p:nvPr/>
+        </p:nvSpPr>
+        <p:spPr>
+          <a:xfrm>
+            <a:off x="822960" y="4681728"/>
+            <a:ext cx="10515600" cy="347472"/>
+          </a:xfrm>
+          <a:prstGeom prst="rect">
+            <a:avLst/>
+          </a:prstGeom>
+          <a:solidFill>
+            <a:srgbClr val="123568"/>
+          </a:solidFill>
+          <a:ln>
+            <a:noFill/>
+          </a:ln>
+          <a:effectLst/>
+        </p:spPr>
+        <p:style>
+          <a:lnRef idx="1">
+            <a:schemeClr val="accent1"/>
+          </a:lnRef>
+          <a:fillRef idx="3">
+            <a:schemeClr val="accent1"/>
+          </a:fillRef>
+          <a:effectRef idx="2">
+            <a:schemeClr val="accent1"/>
+          </a:effectRef>
+          <a:fontRef idx="minor">
+            <a:schemeClr val="lt1"/>
+          </a:fontRef>
+        </p:style>
+        <p:txBody>
+          <a:bodyPr rtlCol="0" anchor="ctr"/>
+          <a:lstStyle/>
+          <a:p>
+            <a:pPr algn="ctr"/>
+          </a:p>
+        </p:txBody>
+      </p:sp>
+      <p:sp>
+        <p:nvSpPr>
+          <p:cNvPr id="82" name="TextBox 81"/>
+          <p:cNvSpPr txBox="1"/>
+          <p:nvPr/>
+        </p:nvSpPr>
+        <p:spPr>
+          <a:xfrm>
+            <a:off x="868680" y="4727448"/>
+            <a:ext cx="457200" cy="274320"/>
+          </a:xfrm>
+          <a:prstGeom prst="rect">
+            <a:avLst/>
+          </a:prstGeom>
+          <a:noFill/>
+        </p:spPr>
+        <p:txBody>
+          <a:bodyPr wrap="square" lIns="0" rIns="0" tIns="0" bIns="0">
+            <a:spAutoFit/>
+          </a:bodyPr>
+          <a:lstStyle/>
+          <a:p>
+            <a:pPr algn="l"/>
+            <a:r>
+              <a:rPr sz="1000" b="1" i="0">
+                <a:solidFill>
+                  <a:srgbClr val="F47321"/>
+                </a:solidFill>
+                <a:latin typeface="Arial"/>
+              </a:rPr>
+              <a:t>YEL</a:t>
+            </a:r>
+          </a:p>
+        </p:txBody>
+      </p:sp>
+      <p:sp>
+        <p:nvSpPr>
+          <p:cNvPr id="83" name="TextBox 82"/>
+          <p:cNvSpPr txBox="1"/>
+          <p:nvPr/>
+        </p:nvSpPr>
+        <p:spPr>
+          <a:xfrm>
+            <a:off x="1325880" y="4727448"/>
+            <a:ext cx="2743200" cy="274320"/>
+          </a:xfrm>
+          <a:prstGeom prst="rect">
+            <a:avLst/>
+          </a:prstGeom>
+          <a:noFill/>
+        </p:spPr>
+        <p:txBody>
+          <a:bodyPr wrap="square" lIns="0" rIns="0" tIns="0" bIns="0">
+            <a:spAutoFit/>
+          </a:bodyPr>
+          <a:lstStyle/>
+          <a:p>
+            <a:pPr algn="l"/>
+            <a:r>
+              <a:rPr sz="1150" b="1" i="0">
+                <a:solidFill>
+                  <a:srgbClr val="FFFFFF"/>
+                </a:solidFill>
+                <a:latin typeface="Arial"/>
+              </a:rPr>
+              <a:t>Washington State at Kansas State</a:t>
+            </a:r>
+          </a:p>
+        </p:txBody>
+      </p:sp>
+      <p:sp>
+        <p:nvSpPr>
+          <p:cNvPr id="84" name="TextBox 83"/>
+          <p:cNvSpPr txBox="1"/>
+          <p:nvPr/>
+        </p:nvSpPr>
+        <p:spPr>
+          <a:xfrm>
+            <a:off x="4114800" y="4745736"/>
+            <a:ext cx="2011680" cy="274320"/>
+          </a:xfrm>
+          <a:prstGeom prst="rect">
+            <a:avLst/>
+          </a:prstGeom>
+          <a:noFill/>
+        </p:spPr>
+        <p:txBody>
+          <a:bodyPr wrap="square" lIns="0" rIns="0" tIns="0" bIns="0">
+            <a:spAutoFit/>
+          </a:bodyPr>
+          <a:lstStyle/>
+          <a:p>
+            <a:pPr algn="l"/>
+            <a:r>
+              <a:rPr sz="900" b="0" i="0">
+                <a:solidFill>
+                  <a:srgbClr val="CADCFC"/>
+                </a:solidFill>
+                <a:latin typeface="Arial"/>
+              </a:rPr>
+              <a:t>K-State -17.5 → K-State -19.5</a:t>
+            </a:r>
+          </a:p>
+        </p:txBody>
+      </p:sp>
+      <p:sp>
+        <p:nvSpPr>
+          <p:cNvPr id="85" name="TextBox 84"/>
+          <p:cNvSpPr txBox="1"/>
+          <p:nvPr/>
+        </p:nvSpPr>
+        <p:spPr>
+          <a:xfrm>
+            <a:off x="6172200" y="4736592"/>
+            <a:ext cx="502920" cy="274320"/>
+          </a:xfrm>
+          <a:prstGeom prst="rect">
+            <a:avLst/>
+          </a:prstGeom>
+          <a:noFill/>
+        </p:spPr>
+        <p:txBody>
+          <a:bodyPr wrap="square" lIns="0" rIns="0" tIns="0" bIns="0">
+            <a:spAutoFit/>
+          </a:bodyPr>
+          <a:lstStyle/>
+          <a:p>
+            <a:pPr algn="r"/>
+            <a:r>
+              <a:rPr sz="1000" b="1" i="0">
+                <a:solidFill>
+                  <a:srgbClr val="FF7A7A"/>
+                </a:solidFill>
+                <a:latin typeface="Arial"/>
+              </a:rPr>
+              <a:t>-2</a:t>
+            </a:r>
+          </a:p>
+        </p:txBody>
+      </p:sp>
+      <p:sp>
+        <p:nvSpPr>
+          <p:cNvPr id="86" name="TextBox 85"/>
+          <p:cNvSpPr txBox="1"/>
+          <p:nvPr/>
+        </p:nvSpPr>
+        <p:spPr>
+          <a:xfrm>
+            <a:off x="6720840" y="4736592"/>
+            <a:ext cx="1188720" cy="274320"/>
+          </a:xfrm>
+          <a:prstGeom prst="rect">
+            <a:avLst/>
+          </a:prstGeom>
+          <a:noFill/>
+        </p:spPr>
+        <p:txBody>
+          <a:bodyPr wrap="square" lIns="0" rIns="0" tIns="0" bIns="0">
+            <a:spAutoFit/>
+          </a:bodyPr>
+          <a:lstStyle/>
+          <a:p>
+            <a:pPr algn="r"/>
+            <a:r>
+              <a:rPr sz="1000" b="0" i="0">
+                <a:solidFill>
+                  <a:srgbClr val="FFFFFF"/>
+                </a:solidFill>
+                <a:latin typeface="Arial"/>
+              </a:rPr>
+              <a:t>+11.2</a:t>
+            </a:r>
+          </a:p>
+        </p:txBody>
+      </p:sp>
+      <p:sp>
+        <p:nvSpPr>
+          <p:cNvPr id="87" name="TextBox 86"/>
+          <p:cNvSpPr txBox="1"/>
+          <p:nvPr/>
+        </p:nvSpPr>
+        <p:spPr>
+          <a:xfrm>
+            <a:off x="7955279" y="4736592"/>
+            <a:ext cx="548640" cy="274320"/>
+          </a:xfrm>
+          <a:prstGeom prst="rect">
+            <a:avLst/>
+          </a:prstGeom>
+          <a:noFill/>
+        </p:spPr>
+        <p:txBody>
+          <a:bodyPr wrap="square" lIns="0" rIns="0" tIns="0" bIns="0">
+            <a:spAutoFit/>
+          </a:bodyPr>
+          <a:lstStyle/>
+          <a:p>
+            <a:pPr algn="r"/>
+            <a:r>
+              <a:rPr sz="1050" b="1" i="0">
+                <a:solidFill>
+                  <a:srgbClr val="F47321"/>
+                </a:solidFill>
+                <a:latin typeface="Arial"/>
+              </a:rPr>
+              <a:t>6.3</a:t>
+            </a:r>
+          </a:p>
+        </p:txBody>
+      </p:sp>
+      <p:sp>
+        <p:nvSpPr>
+          <p:cNvPr id="88" name="TextBox 87"/>
+          <p:cNvSpPr txBox="1"/>
+          <p:nvPr/>
+        </p:nvSpPr>
+        <p:spPr>
+          <a:xfrm>
+            <a:off x="8641080" y="4736592"/>
+            <a:ext cx="1508760" cy="274320"/>
+          </a:xfrm>
+          <a:prstGeom prst="rect">
+            <a:avLst/>
+          </a:prstGeom>
+          <a:noFill/>
+        </p:spPr>
+        <p:txBody>
+          <a:bodyPr wrap="square" lIns="0" rIns="0" tIns="0" bIns="0">
+            <a:spAutoFit/>
+          </a:bodyPr>
+          <a:lstStyle/>
+          <a:p>
+            <a:pPr algn="l"/>
+            <a:r>
+              <a:rPr sz="1000" b="0" i="0">
+                <a:solidFill>
+                  <a:srgbClr val="FFFFFF"/>
+                </a:solidFill>
+                <a:latin typeface="Arial"/>
+              </a:rPr>
+              <a:t>Washington State</a:t>
+            </a:r>
+          </a:p>
+        </p:txBody>
+      </p:sp>
+      <p:sp>
+        <p:nvSpPr>
+          <p:cNvPr id="89" name="TextBox 88"/>
+          <p:cNvSpPr txBox="1"/>
+          <p:nvPr/>
+        </p:nvSpPr>
+        <p:spPr>
+          <a:xfrm>
+            <a:off x="10195560" y="4745736"/>
+            <a:ext cx="1143000" cy="274320"/>
+          </a:xfrm>
+          <a:prstGeom prst="rect">
+            <a:avLst/>
+          </a:prstGeom>
+          <a:noFill/>
+        </p:spPr>
+        <p:txBody>
+          <a:bodyPr wrap="square" lIns="0" rIns="0" tIns="0" bIns="0">
+            <a:spAutoFit/>
+          </a:bodyPr>
+          <a:lstStyle/>
+          <a:p>
+            <a:pPr algn="r"/>
+            <a:r>
+              <a:rPr sz="900" b="0" i="0">
+                <a:solidFill>
+                  <a:srgbClr val="CADCFC"/>
+                </a:solidFill>
+                <a:latin typeface="Arial"/>
+              </a:rPr>
+              <a:t>48.5</a:t>
+            </a:r>
+          </a:p>
+        </p:txBody>
+      </p:sp>
+      <p:sp>
+        <p:nvSpPr>
+          <p:cNvPr id="90" name="Rounded Rectangle 89"/>
+          <p:cNvSpPr/>
+          <p:nvPr/>
+        </p:nvSpPr>
+        <p:spPr>
+          <a:xfrm>
+            <a:off x="822960" y="5138928"/>
+            <a:ext cx="10515600" cy="566928"/>
+          </a:xfrm>
+          <a:prstGeom prst="roundRect">
+            <a:avLst/>
+          </a:prstGeom>
+          <a:solidFill>
+            <a:srgbClr val="123568"/>
+          </a:solidFill>
+          <a:ln>
+            <a:noFill/>
+          </a:ln>
+          <a:effectLst/>
+        </p:spPr>
+        <p:style>
+          <a:lnRef idx="1">
+            <a:schemeClr val="accent1"/>
+          </a:lnRef>
+          <a:fillRef idx="3">
+            <a:schemeClr val="accent1"/>
+          </a:fillRef>
+          <a:effectRef idx="2">
+            <a:schemeClr val="accent1"/>
+          </a:effectRef>
+          <a:fontRef idx="minor">
+            <a:schemeClr val="lt1"/>
+          </a:fontRef>
+        </p:style>
+        <p:txBody>
+          <a:bodyPr rtlCol="0" anchor="ctr"/>
+          <a:lstStyle/>
+          <a:p>
+            <a:pPr algn="ctr"/>
+          </a:p>
+        </p:txBody>
+      </p:sp>
+      <p:sp>
+        <p:nvSpPr>
+          <p:cNvPr id="91" name="TextBox 90"/>
+          <p:cNvSpPr txBox="1"/>
+          <p:nvPr/>
+        </p:nvSpPr>
+        <p:spPr>
+          <a:xfrm>
+            <a:off x="1005840" y="5193792"/>
+            <a:ext cx="10241280" cy="256032"/>
+          </a:xfrm>
+          <a:prstGeom prst="rect">
+            <a:avLst/>
+          </a:prstGeom>
+          <a:noFill/>
+        </p:spPr>
+        <p:txBody>
+          <a:bodyPr wrap="square" lIns="0" rIns="0" tIns="0" bIns="0">
+            <a:spAutoFit/>
+          </a:bodyPr>
+          <a:lstStyle/>
+          <a:p>
+            <a:pPr algn="l"/>
+            <a:r>
+              <a:rPr sz="950" b="1" i="0">
+                <a:solidFill>
+                  <a:srgbClr val="FFFFFF"/>
+                </a:solidFill>
+                <a:latin typeface="Arial"/>
+              </a:rPr>
+              <a:t>Scorecard 2026 (vs first-seen lines): 41 alerts · model side 19-5-1 ATS · RED dogs outright 1-2 · avg CLV +2.04 · beat/tie/lost the close 8-1-16 · 16 pending</a:t>
+            </a:r>
+          </a:p>
+        </p:txBody>
+      </p:sp>
+      <p:sp>
+        <p:nvSpPr>
+          <p:cNvPr id="92" name="TextBox 91"/>
+          <p:cNvSpPr txBox="1"/>
+          <p:nvPr/>
+        </p:nvSpPr>
+        <p:spPr>
+          <a:xfrm>
+            <a:off x="1005840" y="5431536"/>
+            <a:ext cx="10241280" cy="256032"/>
+          </a:xfrm>
+          <a:prstGeom prst="rect">
+            <a:avLst/>
+          </a:prstGeom>
+          <a:noFill/>
+        </p:spPr>
+        <p:txBody>
+          <a:bodyPr wrap="square" lIns="0" rIns="0" tIns="0" bIns="0">
+            <a:spAutoFit/>
+          </a:bodyPr>
+          <a:lstStyle/>
+          <a:p>
+            <a:pPr algn="l"/>
+            <a:r>
+              <a:rPr sz="850" b="0" i="0">
+                <a:solidFill>
+                  <a:srgbClr val="CADCFC"/>
+                </a:solidFill>
+                <a:latin typeface="Arial"/>
+              </a:rPr>
+              <a:t>Backtest 2023–25: these rules ran 49.7% ATS — a research shortlist and a narrative engine, not a bet slip · RED dogs at +401 or longer on the road are ATS-only (longshot moneylines bled −22.9% ROI 2021–25)</a:t>
+            </a:r>
+          </a:p>
+        </p:txBody>
+      </p:sp>
+    </p:spTree>
+  </p:cSld>
+  <p:clrMapOvr>
+    <a:masterClrMapping/>
+  </p:clrMapOvr>
+</p:sld>
+</file>
+
+<file path=ppt/slides/slide22.xml><?xml version="1.0" encoding="utf-8"?>
 <p:sld xmlns:a="http://schemas.openxmlformats.org/drawingml/2006/main" xmlns:p="http://schemas.openxmlformats.org/presentationml/2006/main" xmlns:r="http://schemas.openxmlformats.org/officeDocument/2006/relationships">
   <p:cSld>
     <p:bg>

</xml_diff>

<commit_message>
Ep3: Upset Board slide removed (RENDER_UPSET_BOARD=False); deck back to 21 slides, notes synced
Co-Authored-By: Claude Fable 5.1 <noreply@anthropic.com>
</commit_message>
<xml_diff>
--- a/decks/2026_Week2_Episode3.pptx
+++ b/decks/2026_Week2_Episode3.pptx
@@ -26,7 +26,6 @@
     <p:sldId id="274" r:id="rId25"/>
     <p:sldId id="275" r:id="rId26"/>
     <p:sldId id="276" r:id="rId27"/>
-    <p:sldId id="277" r:id="rId28"/>
   </p:sldIdLst>
   <p:sldSz cx="12191695" cy="6858000" type="screen4x3"/>
   <p:notesSz cx="6858000" cy="9144000"/>
@@ -24550,3271 +24549,6 @@
 </file>
 
 <file path=ppt/slides/slide21.xml><?xml version="1.0" encoding="utf-8"?>
-<p:sld xmlns:a="http://schemas.openxmlformats.org/drawingml/2006/main" xmlns:p="http://schemas.openxmlformats.org/presentationml/2006/main" xmlns:r="http://schemas.openxmlformats.org/officeDocument/2006/relationships">
-  <p:cSld>
-    <p:bg>
-      <p:bgPr>
-        <a:solidFill>
-          <a:srgbClr val="0A2851"/>
-        </a:solidFill>
-        <a:effectLst/>
-      </p:bgPr>
-    </p:bg>
-    <p:spTree>
-      <p:nvGrpSpPr>
-        <p:cNvPr id="1" name=""/>
-        <p:cNvGrpSpPr/>
-        <p:nvPr/>
-      </p:nvGrpSpPr>
-      <p:grpSpPr/>
-      <p:sp>
-        <p:nvSpPr>
-          <p:cNvPr id="2" name="TextBox 1"/>
-          <p:cNvSpPr txBox="1"/>
-          <p:nvPr/>
-        </p:nvSpPr>
-        <p:spPr>
-          <a:xfrm>
-            <a:off x="822960" y="384048"/>
-            <a:ext cx="10515600" cy="365760"/>
-          </a:xfrm>
-          <a:prstGeom prst="rect">
-            <a:avLst/>
-          </a:prstGeom>
-          <a:noFill/>
-        </p:spPr>
-        <p:txBody>
-          <a:bodyPr wrap="square" lIns="0" rIns="0" tIns="0" bIns="0">
-            <a:spAutoFit/>
-          </a:bodyPr>
-          <a:lstStyle/>
-          <a:p>
-            <a:pPr algn="l"/>
-            <a:r>
-              <a:rPr sz="1400" b="1" i="0">
-                <a:solidFill>
-                  <a:srgbClr val="F47321"/>
-                </a:solidFill>
-                <a:latin typeface="Arial"/>
-              </a:rPr>
-              <a:t>EPISODE 3 · WEEK 2 · THE MACHINE'S ALERTS</a:t>
-            </a:r>
-          </a:p>
-        </p:txBody>
-      </p:sp>
-      <p:sp>
-        <p:nvSpPr>
-          <p:cNvPr id="3" name="TextBox 2"/>
-          <p:cNvSpPr txBox="1"/>
-          <p:nvPr/>
-        </p:nvSpPr>
-        <p:spPr>
-          <a:xfrm>
-            <a:off x="822960" y="694944"/>
-            <a:ext cx="10515600" cy="731520"/>
-          </a:xfrm>
-          <a:prstGeom prst="rect">
-            <a:avLst/>
-          </a:prstGeom>
-          <a:noFill/>
-        </p:spPr>
-        <p:txBody>
-          <a:bodyPr wrap="square" lIns="0" rIns="0" tIns="0" bIns="0">
-            <a:spAutoFit/>
-          </a:bodyPr>
-          <a:lstStyle/>
-          <a:p>
-            <a:pPr algn="l"/>
-            <a:r>
-              <a:rPr sz="4000" b="1" i="0">
-                <a:solidFill>
-                  <a:srgbClr val="FFFFFF"/>
-                </a:solidFill>
-                <a:latin typeface="Arial"/>
-              </a:rPr>
-              <a:t>The Upset Board</a:t>
-            </a:r>
-          </a:p>
-        </p:txBody>
-      </p:sp>
-      <p:sp>
-        <p:nvSpPr>
-          <p:cNvPr id="4" name="TextBox 3"/>
-          <p:cNvSpPr txBox="1"/>
-          <p:nvPr/>
-        </p:nvSpPr>
-        <p:spPr>
-          <a:xfrm>
-            <a:off x="822960" y="1371600"/>
-            <a:ext cx="10515600" cy="274320"/>
-          </a:xfrm>
-          <a:prstGeom prst="rect">
-            <a:avLst/>
-          </a:prstGeom>
-          <a:noFill/>
-        </p:spPr>
-        <p:txBody>
-          <a:bodyPr wrap="square" lIns="0" rIns="0" tIns="0" bIns="0">
-            <a:spAutoFit/>
-          </a:bodyPr>
-          <a:lstStyle/>
-          <a:p>
-            <a:pPr algn="l"/>
-            <a:r>
-              <a:rPr sz="1050" b="0" i="1">
-                <a:solidFill>
-                  <a:srgbClr val="CADCFC"/>
-                </a:solidFill>
-                <a:latin typeface="Arial"/>
-              </a:rPr>
-              <a:t>RED = machine takes the dog outright (spread ≥ 3) · YEL = same side, 6+ points of disagreement · ⚑ = Monster Under total · graded vs the line first seen</a:t>
-            </a:r>
-          </a:p>
-        </p:txBody>
-      </p:sp>
-      <p:sp>
-        <p:nvSpPr>
-          <p:cNvPr id="5" name="TextBox 4"/>
-          <p:cNvSpPr txBox="1"/>
-          <p:nvPr/>
-        </p:nvSpPr>
-        <p:spPr>
-          <a:xfrm>
-            <a:off x="822960" y="1673352"/>
-            <a:ext cx="457200" cy="201168"/>
-          </a:xfrm>
-          <a:prstGeom prst="rect">
-            <a:avLst/>
-          </a:prstGeom>
-          <a:noFill/>
-        </p:spPr>
-        <p:txBody>
-          <a:bodyPr wrap="square" lIns="0" rIns="0" tIns="0" bIns="0">
-            <a:spAutoFit/>
-          </a:bodyPr>
-          <a:lstStyle/>
-          <a:p>
-            <a:pPr algn="l"/>
-            <a:r>
-              <a:rPr sz="800" b="1" i="0">
-                <a:solidFill>
-                  <a:srgbClr val="CADCFC"/>
-                </a:solidFill>
-                <a:latin typeface="Arial"/>
-              </a:rPr>
-              <a:t>TIER</a:t>
-            </a:r>
-          </a:p>
-        </p:txBody>
-      </p:sp>
-      <p:sp>
-        <p:nvSpPr>
-          <p:cNvPr id="6" name="TextBox 5"/>
-          <p:cNvSpPr txBox="1"/>
-          <p:nvPr/>
-        </p:nvSpPr>
-        <p:spPr>
-          <a:xfrm>
-            <a:off x="1325880" y="1673352"/>
-            <a:ext cx="2743200" cy="201168"/>
-          </a:xfrm>
-          <a:prstGeom prst="rect">
-            <a:avLst/>
-          </a:prstGeom>
-          <a:noFill/>
-        </p:spPr>
-        <p:txBody>
-          <a:bodyPr wrap="square" lIns="0" rIns="0" tIns="0" bIns="0">
-            <a:spAutoFit/>
-          </a:bodyPr>
-          <a:lstStyle/>
-          <a:p>
-            <a:pPr algn="l"/>
-            <a:r>
-              <a:rPr sz="800" b="1" i="0">
-                <a:solidFill>
-                  <a:srgbClr val="CADCFC"/>
-                </a:solidFill>
-                <a:latin typeface="Arial"/>
-              </a:rPr>
-              <a:t>MATCHUP</a:t>
-            </a:r>
-          </a:p>
-        </p:txBody>
-      </p:sp>
-      <p:sp>
-        <p:nvSpPr>
-          <p:cNvPr id="7" name="TextBox 6"/>
-          <p:cNvSpPr txBox="1"/>
-          <p:nvPr/>
-        </p:nvSpPr>
-        <p:spPr>
-          <a:xfrm>
-            <a:off x="4114800" y="1673352"/>
-            <a:ext cx="2011680" cy="201168"/>
-          </a:xfrm>
-          <a:prstGeom prst="rect">
-            <a:avLst/>
-          </a:prstGeom>
-          <a:noFill/>
-        </p:spPr>
-        <p:txBody>
-          <a:bodyPr wrap="square" lIns="0" rIns="0" tIns="0" bIns="0">
-            <a:spAutoFit/>
-          </a:bodyPr>
-          <a:lstStyle/>
-          <a:p>
-            <a:pPr algn="l"/>
-            <a:r>
-              <a:rPr sz="800" b="1" i="0">
-                <a:solidFill>
-                  <a:srgbClr val="CADCFC"/>
-                </a:solidFill>
-                <a:latin typeface="Arial"/>
-              </a:rPr>
-              <a:t>ALERT LINE → NOW</a:t>
-            </a:r>
-          </a:p>
-        </p:txBody>
-      </p:sp>
-      <p:sp>
-        <p:nvSpPr>
-          <p:cNvPr id="8" name="TextBox 7"/>
-          <p:cNvSpPr txBox="1"/>
-          <p:nvPr/>
-        </p:nvSpPr>
-        <p:spPr>
-          <a:xfrm>
-            <a:off x="6172200" y="1673352"/>
-            <a:ext cx="502920" cy="201168"/>
-          </a:xfrm>
-          <a:prstGeom prst="rect">
-            <a:avLst/>
-          </a:prstGeom>
-          <a:noFill/>
-        </p:spPr>
-        <p:txBody>
-          <a:bodyPr wrap="square" lIns="0" rIns="0" tIns="0" bIns="0">
-            <a:spAutoFit/>
-          </a:bodyPr>
-          <a:lstStyle/>
-          <a:p>
-            <a:pPr algn="r"/>
-            <a:r>
-              <a:rPr sz="800" b="1" i="0">
-                <a:solidFill>
-                  <a:srgbClr val="CADCFC"/>
-                </a:solidFill>
-                <a:latin typeface="Arial"/>
-              </a:rPr>
-              <a:t>CLV</a:t>
-            </a:r>
-          </a:p>
-        </p:txBody>
-      </p:sp>
-      <p:sp>
-        <p:nvSpPr>
-          <p:cNvPr id="9" name="TextBox 8"/>
-          <p:cNvSpPr txBox="1"/>
-          <p:nvPr/>
-        </p:nvSpPr>
-        <p:spPr>
-          <a:xfrm>
-            <a:off x="6720840" y="1673352"/>
-            <a:ext cx="1188720" cy="201168"/>
-          </a:xfrm>
-          <a:prstGeom prst="rect">
-            <a:avLst/>
-          </a:prstGeom>
-          <a:noFill/>
-        </p:spPr>
-        <p:txBody>
-          <a:bodyPr wrap="square" lIns="0" rIns="0" tIns="0" bIns="0">
-            <a:spAutoFit/>
-          </a:bodyPr>
-          <a:lstStyle/>
-          <a:p>
-            <a:pPr algn="r"/>
-            <a:r>
-              <a:rPr sz="800" b="1" i="0">
-                <a:solidFill>
-                  <a:srgbClr val="CADCFC"/>
-                </a:solidFill>
-                <a:latin typeface="Arial"/>
-              </a:rPr>
-              <a:t>MACHINE (HOME)</a:t>
-            </a:r>
-          </a:p>
-        </p:txBody>
-      </p:sp>
-      <p:sp>
-        <p:nvSpPr>
-          <p:cNvPr id="10" name="TextBox 9"/>
-          <p:cNvSpPr txBox="1"/>
-          <p:nvPr/>
-        </p:nvSpPr>
-        <p:spPr>
-          <a:xfrm>
-            <a:off x="7955279" y="1673352"/>
-            <a:ext cx="548640" cy="201168"/>
-          </a:xfrm>
-          <a:prstGeom prst="rect">
-            <a:avLst/>
-          </a:prstGeom>
-          <a:noFill/>
-        </p:spPr>
-        <p:txBody>
-          <a:bodyPr wrap="square" lIns="0" rIns="0" tIns="0" bIns="0">
-            <a:spAutoFit/>
-          </a:bodyPr>
-          <a:lstStyle/>
-          <a:p>
-            <a:pPr algn="r"/>
-            <a:r>
-              <a:rPr sz="800" b="1" i="0">
-                <a:solidFill>
-                  <a:srgbClr val="CADCFC"/>
-                </a:solidFill>
-                <a:latin typeface="Arial"/>
-              </a:rPr>
-              <a:t>EDGE</a:t>
-            </a:r>
-          </a:p>
-        </p:txBody>
-      </p:sp>
-      <p:sp>
-        <p:nvSpPr>
-          <p:cNvPr id="11" name="TextBox 10"/>
-          <p:cNvSpPr txBox="1"/>
-          <p:nvPr/>
-        </p:nvSpPr>
-        <p:spPr>
-          <a:xfrm>
-            <a:off x="8641080" y="1673352"/>
-            <a:ext cx="1508760" cy="201168"/>
-          </a:xfrm>
-          <a:prstGeom prst="rect">
-            <a:avLst/>
-          </a:prstGeom>
-          <a:noFill/>
-        </p:spPr>
-        <p:txBody>
-          <a:bodyPr wrap="square" lIns="0" rIns="0" tIns="0" bIns="0">
-            <a:spAutoFit/>
-          </a:bodyPr>
-          <a:lstStyle/>
-          <a:p>
-            <a:pPr algn="l"/>
-            <a:r>
-              <a:rPr sz="800" b="1" i="0">
-                <a:solidFill>
-                  <a:srgbClr val="CADCFC"/>
-                </a:solidFill>
-                <a:latin typeface="Arial"/>
-              </a:rPr>
-              <a:t>MACHINE SIDE</a:t>
-            </a:r>
-          </a:p>
-        </p:txBody>
-      </p:sp>
-      <p:sp>
-        <p:nvSpPr>
-          <p:cNvPr id="12" name="TextBox 11"/>
-          <p:cNvSpPr txBox="1"/>
-          <p:nvPr/>
-        </p:nvSpPr>
-        <p:spPr>
-          <a:xfrm>
-            <a:off x="10195560" y="1673352"/>
-            <a:ext cx="1143000" cy="201168"/>
-          </a:xfrm>
-          <a:prstGeom prst="rect">
-            <a:avLst/>
-          </a:prstGeom>
-          <a:noFill/>
-        </p:spPr>
-        <p:txBody>
-          <a:bodyPr wrap="square" lIns="0" rIns="0" tIns="0" bIns="0">
-            <a:spAutoFit/>
-          </a:bodyPr>
-          <a:lstStyle/>
-          <a:p>
-            <a:pPr algn="r"/>
-            <a:r>
-              <a:rPr sz="800" b="1" i="0">
-                <a:solidFill>
-                  <a:srgbClr val="CADCFC"/>
-                </a:solidFill>
-                <a:latin typeface="Arial"/>
-              </a:rPr>
-              <a:t>DOG ML / O/U</a:t>
-            </a:r>
-          </a:p>
-        </p:txBody>
-      </p:sp>
-      <p:sp>
-        <p:nvSpPr>
-          <p:cNvPr id="13" name="Rectangle 12"/>
-          <p:cNvSpPr/>
-          <p:nvPr/>
-        </p:nvSpPr>
-        <p:spPr>
-          <a:xfrm>
-            <a:off x="822960" y="1901952"/>
-            <a:ext cx="10515600" cy="347472"/>
-          </a:xfrm>
-          <a:prstGeom prst="rect">
-            <a:avLst/>
-          </a:prstGeom>
-          <a:solidFill>
-            <a:srgbClr val="123568"/>
-          </a:solidFill>
-          <a:ln>
-            <a:noFill/>
-          </a:ln>
-          <a:effectLst/>
-        </p:spPr>
-        <p:style>
-          <a:lnRef idx="1">
-            <a:schemeClr val="accent1"/>
-          </a:lnRef>
-          <a:fillRef idx="3">
-            <a:schemeClr val="accent1"/>
-          </a:fillRef>
-          <a:effectRef idx="2">
-            <a:schemeClr val="accent1"/>
-          </a:effectRef>
-          <a:fontRef idx="minor">
-            <a:schemeClr val="lt1"/>
-          </a:fontRef>
-        </p:style>
-        <p:txBody>
-          <a:bodyPr rtlCol="0" anchor="ctr"/>
-          <a:lstStyle/>
-          <a:p>
-            <a:pPr algn="ctr"/>
-          </a:p>
-        </p:txBody>
-      </p:sp>
-      <p:sp>
-        <p:nvSpPr>
-          <p:cNvPr id="14" name="TextBox 13"/>
-          <p:cNvSpPr txBox="1"/>
-          <p:nvPr/>
-        </p:nvSpPr>
-        <p:spPr>
-          <a:xfrm>
-            <a:off x="868680" y="1947672"/>
-            <a:ext cx="457200" cy="274320"/>
-          </a:xfrm>
-          <a:prstGeom prst="rect">
-            <a:avLst/>
-          </a:prstGeom>
-          <a:noFill/>
-        </p:spPr>
-        <p:txBody>
-          <a:bodyPr wrap="square" lIns="0" rIns="0" tIns="0" bIns="0">
-            <a:spAutoFit/>
-          </a:bodyPr>
-          <a:lstStyle/>
-          <a:p>
-            <a:pPr algn="l"/>
-            <a:r>
-              <a:rPr sz="1000" b="1" i="0">
-                <a:solidFill>
-                  <a:srgbClr val="FF7A7A"/>
-                </a:solidFill>
-                <a:latin typeface="Arial"/>
-              </a:rPr>
-              <a:t>RED</a:t>
-            </a:r>
-          </a:p>
-        </p:txBody>
-      </p:sp>
-      <p:sp>
-        <p:nvSpPr>
-          <p:cNvPr id="15" name="TextBox 14"/>
-          <p:cNvSpPr txBox="1"/>
-          <p:nvPr/>
-        </p:nvSpPr>
-        <p:spPr>
-          <a:xfrm>
-            <a:off x="1325880" y="1947672"/>
-            <a:ext cx="2743200" cy="274320"/>
-          </a:xfrm>
-          <a:prstGeom prst="rect">
-            <a:avLst/>
-          </a:prstGeom>
-          <a:noFill/>
-        </p:spPr>
-        <p:txBody>
-          <a:bodyPr wrap="square" lIns="0" rIns="0" tIns="0" bIns="0">
-            <a:spAutoFit/>
-          </a:bodyPr>
-          <a:lstStyle/>
-          <a:p>
-            <a:pPr algn="l"/>
-            <a:r>
-              <a:rPr sz="1150" b="1" i="0">
-                <a:solidFill>
-                  <a:srgbClr val="FFFFFF"/>
-                </a:solidFill>
-                <a:latin typeface="Arial"/>
-              </a:rPr>
-              <a:t>South Florida at Army</a:t>
-            </a:r>
-          </a:p>
-        </p:txBody>
-      </p:sp>
-      <p:sp>
-        <p:nvSpPr>
-          <p:cNvPr id="16" name="TextBox 15"/>
-          <p:cNvSpPr txBox="1"/>
-          <p:nvPr/>
-        </p:nvSpPr>
-        <p:spPr>
-          <a:xfrm>
-            <a:off x="4114800" y="1965960"/>
-            <a:ext cx="2011680" cy="274320"/>
-          </a:xfrm>
-          <a:prstGeom prst="rect">
-            <a:avLst/>
-          </a:prstGeom>
-          <a:noFill/>
-        </p:spPr>
-        <p:txBody>
-          <a:bodyPr wrap="square" lIns="0" rIns="0" tIns="0" bIns="0">
-            <a:spAutoFit/>
-          </a:bodyPr>
-          <a:lstStyle/>
-          <a:p>
-            <a:pPr algn="l"/>
-            <a:r>
-              <a:rPr sz="900" b="0" i="0">
-                <a:solidFill>
-                  <a:srgbClr val="CADCFC"/>
-                </a:solidFill>
-                <a:latin typeface="Arial"/>
-              </a:rPr>
-              <a:t>Army -3.5 (unch.)</a:t>
-            </a:r>
-          </a:p>
-        </p:txBody>
-      </p:sp>
-      <p:sp>
-        <p:nvSpPr>
-          <p:cNvPr id="17" name="TextBox 16"/>
-          <p:cNvSpPr txBox="1"/>
-          <p:nvPr/>
-        </p:nvSpPr>
-        <p:spPr>
-          <a:xfrm>
-            <a:off x="6172200" y="1956816"/>
-            <a:ext cx="502920" cy="274320"/>
-          </a:xfrm>
-          <a:prstGeom prst="rect">
-            <a:avLst/>
-          </a:prstGeom>
-          <a:noFill/>
-        </p:spPr>
-        <p:txBody>
-          <a:bodyPr wrap="square" lIns="0" rIns="0" tIns="0" bIns="0">
-            <a:spAutoFit/>
-          </a:bodyPr>
-          <a:lstStyle/>
-          <a:p>
-            <a:pPr algn="r"/>
-            <a:r>
-              <a:rPr sz="1000" b="0" i="0">
-                <a:solidFill>
-                  <a:srgbClr val="CADCFC"/>
-                </a:solidFill>
-                <a:latin typeface="Arial"/>
-              </a:rPr>
-              <a:t>0</a:t>
-            </a:r>
-          </a:p>
-        </p:txBody>
-      </p:sp>
-      <p:sp>
-        <p:nvSpPr>
-          <p:cNvPr id="18" name="TextBox 17"/>
-          <p:cNvSpPr txBox="1"/>
-          <p:nvPr/>
-        </p:nvSpPr>
-        <p:spPr>
-          <a:xfrm>
-            <a:off x="6720840" y="1956816"/>
-            <a:ext cx="1188720" cy="274320"/>
-          </a:xfrm>
-          <a:prstGeom prst="rect">
-            <a:avLst/>
-          </a:prstGeom>
-          <a:noFill/>
-        </p:spPr>
-        <p:txBody>
-          <a:bodyPr wrap="square" lIns="0" rIns="0" tIns="0" bIns="0">
-            <a:spAutoFit/>
-          </a:bodyPr>
-          <a:lstStyle/>
-          <a:p>
-            <a:pPr algn="r"/>
-            <a:r>
-              <a:rPr sz="1000" b="0" i="0">
-                <a:solidFill>
-                  <a:srgbClr val="FFFFFF"/>
-                </a:solidFill>
-                <a:latin typeface="Arial"/>
-              </a:rPr>
-              <a:t>-1.4</a:t>
-            </a:r>
-          </a:p>
-        </p:txBody>
-      </p:sp>
-      <p:sp>
-        <p:nvSpPr>
-          <p:cNvPr id="19" name="TextBox 18"/>
-          <p:cNvSpPr txBox="1"/>
-          <p:nvPr/>
-        </p:nvSpPr>
-        <p:spPr>
-          <a:xfrm>
-            <a:off x="7955279" y="1956816"/>
-            <a:ext cx="548640" cy="274320"/>
-          </a:xfrm>
-          <a:prstGeom prst="rect">
-            <a:avLst/>
-          </a:prstGeom>
-          <a:noFill/>
-        </p:spPr>
-        <p:txBody>
-          <a:bodyPr wrap="square" lIns="0" rIns="0" tIns="0" bIns="0">
-            <a:spAutoFit/>
-          </a:bodyPr>
-          <a:lstStyle/>
-          <a:p>
-            <a:pPr algn="r"/>
-            <a:r>
-              <a:rPr sz="1050" b="1" i="0">
-                <a:solidFill>
-                  <a:srgbClr val="F47321"/>
-                </a:solidFill>
-                <a:latin typeface="Arial"/>
-              </a:rPr>
-              <a:t>4.9</a:t>
-            </a:r>
-          </a:p>
-        </p:txBody>
-      </p:sp>
-      <p:sp>
-        <p:nvSpPr>
-          <p:cNvPr id="20" name="TextBox 19"/>
-          <p:cNvSpPr txBox="1"/>
-          <p:nvPr/>
-        </p:nvSpPr>
-        <p:spPr>
-          <a:xfrm>
-            <a:off x="8641080" y="1956816"/>
-            <a:ext cx="1508760" cy="274320"/>
-          </a:xfrm>
-          <a:prstGeom prst="rect">
-            <a:avLst/>
-          </a:prstGeom>
-          <a:noFill/>
-        </p:spPr>
-        <p:txBody>
-          <a:bodyPr wrap="square" lIns="0" rIns="0" tIns="0" bIns="0">
-            <a:spAutoFit/>
-          </a:bodyPr>
-          <a:lstStyle/>
-          <a:p>
-            <a:pPr algn="l"/>
-            <a:r>
-              <a:rPr sz="1000" b="0" i="0">
-                <a:solidFill>
-                  <a:srgbClr val="FFFFFF"/>
-                </a:solidFill>
-                <a:latin typeface="Arial"/>
-              </a:rPr>
-              <a:t>South Florida</a:t>
-            </a:r>
-          </a:p>
-        </p:txBody>
-      </p:sp>
-      <p:sp>
-        <p:nvSpPr>
-          <p:cNvPr id="21" name="TextBox 20"/>
-          <p:cNvSpPr txBox="1"/>
-          <p:nvPr/>
-        </p:nvSpPr>
-        <p:spPr>
-          <a:xfrm>
-            <a:off x="10195560" y="1965960"/>
-            <a:ext cx="1143000" cy="274320"/>
-          </a:xfrm>
-          <a:prstGeom prst="rect">
-            <a:avLst/>
-          </a:prstGeom>
-          <a:noFill/>
-        </p:spPr>
-        <p:txBody>
-          <a:bodyPr wrap="square" lIns="0" rIns="0" tIns="0" bIns="0">
-            <a:spAutoFit/>
-          </a:bodyPr>
-          <a:lstStyle/>
-          <a:p>
-            <a:pPr algn="r"/>
-            <a:r>
-              <a:rPr sz="900" b="1" i="0">
-                <a:solidFill>
-                  <a:srgbClr val="F47321"/>
-                </a:solidFill>
-                <a:latin typeface="Arial"/>
-              </a:rPr>
-              <a:t>+154 · 46.5</a:t>
-            </a:r>
-          </a:p>
-        </p:txBody>
-      </p:sp>
-      <p:sp>
-        <p:nvSpPr>
-          <p:cNvPr id="22" name="TextBox 21"/>
-          <p:cNvSpPr txBox="1"/>
-          <p:nvPr/>
-        </p:nvSpPr>
-        <p:spPr>
-          <a:xfrm>
-            <a:off x="868680" y="2295144"/>
-            <a:ext cx="457200" cy="274320"/>
-          </a:xfrm>
-          <a:prstGeom prst="rect">
-            <a:avLst/>
-          </a:prstGeom>
-          <a:noFill/>
-        </p:spPr>
-        <p:txBody>
-          <a:bodyPr wrap="square" lIns="0" rIns="0" tIns="0" bIns="0">
-            <a:spAutoFit/>
-          </a:bodyPr>
-          <a:lstStyle/>
-          <a:p>
-            <a:pPr algn="l"/>
-            <a:r>
-              <a:rPr sz="1000" b="1" i="0">
-                <a:solidFill>
-                  <a:srgbClr val="F47321"/>
-                </a:solidFill>
-                <a:latin typeface="Arial"/>
-              </a:rPr>
-              <a:t>YEL</a:t>
-            </a:r>
-          </a:p>
-        </p:txBody>
-      </p:sp>
-      <p:sp>
-        <p:nvSpPr>
-          <p:cNvPr id="23" name="TextBox 22"/>
-          <p:cNvSpPr txBox="1"/>
-          <p:nvPr/>
-        </p:nvSpPr>
-        <p:spPr>
-          <a:xfrm>
-            <a:off x="1325880" y="2295144"/>
-            <a:ext cx="2743200" cy="274320"/>
-          </a:xfrm>
-          <a:prstGeom prst="rect">
-            <a:avLst/>
-          </a:prstGeom>
-          <a:noFill/>
-        </p:spPr>
-        <p:txBody>
-          <a:bodyPr wrap="square" lIns="0" rIns="0" tIns="0" bIns="0">
-            <a:spAutoFit/>
-          </a:bodyPr>
-          <a:lstStyle/>
-          <a:p>
-            <a:pPr algn="l"/>
-            <a:r>
-              <a:rPr sz="1150" b="1" i="0">
-                <a:solidFill>
-                  <a:srgbClr val="FFFFFF"/>
-                </a:solidFill>
-                <a:latin typeface="Arial"/>
-              </a:rPr>
-              <a:t>Charlotte at Ole Miss</a:t>
-            </a:r>
-          </a:p>
-        </p:txBody>
-      </p:sp>
-      <p:sp>
-        <p:nvSpPr>
-          <p:cNvPr id="24" name="TextBox 23"/>
-          <p:cNvSpPr txBox="1"/>
-          <p:nvPr/>
-        </p:nvSpPr>
-        <p:spPr>
-          <a:xfrm>
-            <a:off x="4114800" y="2313432"/>
-            <a:ext cx="2011680" cy="274320"/>
-          </a:xfrm>
-          <a:prstGeom prst="rect">
-            <a:avLst/>
-          </a:prstGeom>
-          <a:noFill/>
-        </p:spPr>
-        <p:txBody>
-          <a:bodyPr wrap="square" lIns="0" rIns="0" tIns="0" bIns="0">
-            <a:spAutoFit/>
-          </a:bodyPr>
-          <a:lstStyle/>
-          <a:p>
-            <a:pPr algn="l"/>
-            <a:r>
-              <a:rPr sz="900" b="0" i="0">
-                <a:solidFill>
-                  <a:srgbClr val="CADCFC"/>
-                </a:solidFill>
-                <a:latin typeface="Arial"/>
-              </a:rPr>
-              <a:t>Ole Miss -47.5 (unch.)</a:t>
-            </a:r>
-          </a:p>
-        </p:txBody>
-      </p:sp>
-      <p:sp>
-        <p:nvSpPr>
-          <p:cNvPr id="25" name="TextBox 24"/>
-          <p:cNvSpPr txBox="1"/>
-          <p:nvPr/>
-        </p:nvSpPr>
-        <p:spPr>
-          <a:xfrm>
-            <a:off x="6172200" y="2304288"/>
-            <a:ext cx="502920" cy="274320"/>
-          </a:xfrm>
-          <a:prstGeom prst="rect">
-            <a:avLst/>
-          </a:prstGeom>
-          <a:noFill/>
-        </p:spPr>
-        <p:txBody>
-          <a:bodyPr wrap="square" lIns="0" rIns="0" tIns="0" bIns="0">
-            <a:spAutoFit/>
-          </a:bodyPr>
-          <a:lstStyle/>
-          <a:p>
-            <a:pPr algn="r"/>
-            <a:r>
-              <a:rPr sz="1000" b="0" i="0">
-                <a:solidFill>
-                  <a:srgbClr val="CADCFC"/>
-                </a:solidFill>
-                <a:latin typeface="Arial"/>
-              </a:rPr>
-              <a:t>0</a:t>
-            </a:r>
-          </a:p>
-        </p:txBody>
-      </p:sp>
-      <p:sp>
-        <p:nvSpPr>
-          <p:cNvPr id="26" name="TextBox 25"/>
-          <p:cNvSpPr txBox="1"/>
-          <p:nvPr/>
-        </p:nvSpPr>
-        <p:spPr>
-          <a:xfrm>
-            <a:off x="6720840" y="2304288"/>
-            <a:ext cx="1188720" cy="274320"/>
-          </a:xfrm>
-          <a:prstGeom prst="rect">
-            <a:avLst/>
-          </a:prstGeom>
-          <a:noFill/>
-        </p:spPr>
-        <p:txBody>
-          <a:bodyPr wrap="square" lIns="0" rIns="0" tIns="0" bIns="0">
-            <a:spAutoFit/>
-          </a:bodyPr>
-          <a:lstStyle/>
-          <a:p>
-            <a:pPr algn="r"/>
-            <a:r>
-              <a:rPr sz="1000" b="0" i="0">
-                <a:solidFill>
-                  <a:srgbClr val="FFFFFF"/>
-                </a:solidFill>
-                <a:latin typeface="Arial"/>
-              </a:rPr>
-              <a:t>+32.4</a:t>
-            </a:r>
-          </a:p>
-        </p:txBody>
-      </p:sp>
-      <p:sp>
-        <p:nvSpPr>
-          <p:cNvPr id="27" name="TextBox 26"/>
-          <p:cNvSpPr txBox="1"/>
-          <p:nvPr/>
-        </p:nvSpPr>
-        <p:spPr>
-          <a:xfrm>
-            <a:off x="7955279" y="2304288"/>
-            <a:ext cx="548640" cy="274320"/>
-          </a:xfrm>
-          <a:prstGeom prst="rect">
-            <a:avLst/>
-          </a:prstGeom>
-          <a:noFill/>
-        </p:spPr>
-        <p:txBody>
-          <a:bodyPr wrap="square" lIns="0" rIns="0" tIns="0" bIns="0">
-            <a:spAutoFit/>
-          </a:bodyPr>
-          <a:lstStyle/>
-          <a:p>
-            <a:pPr algn="r"/>
-            <a:r>
-              <a:rPr sz="1050" b="1" i="0">
-                <a:solidFill>
-                  <a:srgbClr val="F47321"/>
-                </a:solidFill>
-                <a:latin typeface="Arial"/>
-              </a:rPr>
-              <a:t>15.1</a:t>
-            </a:r>
-          </a:p>
-        </p:txBody>
-      </p:sp>
-      <p:sp>
-        <p:nvSpPr>
-          <p:cNvPr id="28" name="TextBox 27"/>
-          <p:cNvSpPr txBox="1"/>
-          <p:nvPr/>
-        </p:nvSpPr>
-        <p:spPr>
-          <a:xfrm>
-            <a:off x="8641080" y="2304288"/>
-            <a:ext cx="1508760" cy="274320"/>
-          </a:xfrm>
-          <a:prstGeom prst="rect">
-            <a:avLst/>
-          </a:prstGeom>
-          <a:noFill/>
-        </p:spPr>
-        <p:txBody>
-          <a:bodyPr wrap="square" lIns="0" rIns="0" tIns="0" bIns="0">
-            <a:spAutoFit/>
-          </a:bodyPr>
-          <a:lstStyle/>
-          <a:p>
-            <a:pPr algn="l"/>
-            <a:r>
-              <a:rPr sz="1000" b="0" i="0">
-                <a:solidFill>
-                  <a:srgbClr val="FFFFFF"/>
-                </a:solidFill>
-                <a:latin typeface="Arial"/>
-              </a:rPr>
-              <a:t>Charlotte</a:t>
-            </a:r>
-          </a:p>
-        </p:txBody>
-      </p:sp>
-      <p:sp>
-        <p:nvSpPr>
-          <p:cNvPr id="29" name="TextBox 28"/>
-          <p:cNvSpPr txBox="1"/>
-          <p:nvPr/>
-        </p:nvSpPr>
-        <p:spPr>
-          <a:xfrm>
-            <a:off x="10195560" y="2313432"/>
-            <a:ext cx="1143000" cy="274320"/>
-          </a:xfrm>
-          <a:prstGeom prst="rect">
-            <a:avLst/>
-          </a:prstGeom>
-          <a:noFill/>
-        </p:spPr>
-        <p:txBody>
-          <a:bodyPr wrap="square" lIns="0" rIns="0" tIns="0" bIns="0">
-            <a:spAutoFit/>
-          </a:bodyPr>
-          <a:lstStyle/>
-          <a:p>
-            <a:pPr algn="r"/>
-            <a:r>
-              <a:rPr sz="900" b="1" i="0">
-                <a:solidFill>
-                  <a:srgbClr val="F47321"/>
-                </a:solidFill>
-                <a:latin typeface="Arial"/>
-              </a:rPr>
-              <a:t>60.5 ⚑</a:t>
-            </a:r>
-          </a:p>
-        </p:txBody>
-      </p:sp>
-      <p:sp>
-        <p:nvSpPr>
-          <p:cNvPr id="30" name="Rectangle 29"/>
-          <p:cNvSpPr/>
-          <p:nvPr/>
-        </p:nvSpPr>
-        <p:spPr>
-          <a:xfrm>
-            <a:off x="822960" y="2596896"/>
-            <a:ext cx="10515600" cy="347472"/>
-          </a:xfrm>
-          <a:prstGeom prst="rect">
-            <a:avLst/>
-          </a:prstGeom>
-          <a:solidFill>
-            <a:srgbClr val="123568"/>
-          </a:solidFill>
-          <a:ln>
-            <a:noFill/>
-          </a:ln>
-          <a:effectLst/>
-        </p:spPr>
-        <p:style>
-          <a:lnRef idx="1">
-            <a:schemeClr val="accent1"/>
-          </a:lnRef>
-          <a:fillRef idx="3">
-            <a:schemeClr val="accent1"/>
-          </a:fillRef>
-          <a:effectRef idx="2">
-            <a:schemeClr val="accent1"/>
-          </a:effectRef>
-          <a:fontRef idx="minor">
-            <a:schemeClr val="lt1"/>
-          </a:fontRef>
-        </p:style>
-        <p:txBody>
-          <a:bodyPr rtlCol="0" anchor="ctr"/>
-          <a:lstStyle/>
-          <a:p>
-            <a:pPr algn="ctr"/>
-          </a:p>
-        </p:txBody>
-      </p:sp>
-      <p:sp>
-        <p:nvSpPr>
-          <p:cNvPr id="31" name="TextBox 30"/>
-          <p:cNvSpPr txBox="1"/>
-          <p:nvPr/>
-        </p:nvSpPr>
-        <p:spPr>
-          <a:xfrm>
-            <a:off x="868680" y="2642615"/>
-            <a:ext cx="457200" cy="274320"/>
-          </a:xfrm>
-          <a:prstGeom prst="rect">
-            <a:avLst/>
-          </a:prstGeom>
-          <a:noFill/>
-        </p:spPr>
-        <p:txBody>
-          <a:bodyPr wrap="square" lIns="0" rIns="0" tIns="0" bIns="0">
-            <a:spAutoFit/>
-          </a:bodyPr>
-          <a:lstStyle/>
-          <a:p>
-            <a:pPr algn="l"/>
-            <a:r>
-              <a:rPr sz="1000" b="1" i="0">
-                <a:solidFill>
-                  <a:srgbClr val="F47321"/>
-                </a:solidFill>
-                <a:latin typeface="Arial"/>
-              </a:rPr>
-              <a:t>YEL</a:t>
-            </a:r>
-          </a:p>
-        </p:txBody>
-      </p:sp>
-      <p:sp>
-        <p:nvSpPr>
-          <p:cNvPr id="32" name="TextBox 31"/>
-          <p:cNvSpPr txBox="1"/>
-          <p:nvPr/>
-        </p:nvSpPr>
-        <p:spPr>
-          <a:xfrm>
-            <a:off x="1325880" y="2642615"/>
-            <a:ext cx="2743200" cy="274320"/>
-          </a:xfrm>
-          <a:prstGeom prst="rect">
-            <a:avLst/>
-          </a:prstGeom>
-          <a:noFill/>
-        </p:spPr>
-        <p:txBody>
-          <a:bodyPr wrap="square" lIns="0" rIns="0" tIns="0" bIns="0">
-            <a:spAutoFit/>
-          </a:bodyPr>
-          <a:lstStyle/>
-          <a:p>
-            <a:pPr algn="l"/>
-            <a:r>
-              <a:rPr sz="1150" b="1" i="0">
-                <a:solidFill>
-                  <a:srgbClr val="FFFFFF"/>
-                </a:solidFill>
-                <a:latin typeface="Arial"/>
-              </a:rPr>
-              <a:t>Southern Miss at Auburn</a:t>
-            </a:r>
-          </a:p>
-        </p:txBody>
-      </p:sp>
-      <p:sp>
-        <p:nvSpPr>
-          <p:cNvPr id="33" name="TextBox 32"/>
-          <p:cNvSpPr txBox="1"/>
-          <p:nvPr/>
-        </p:nvSpPr>
-        <p:spPr>
-          <a:xfrm>
-            <a:off x="4114800" y="2660903"/>
-            <a:ext cx="2011680" cy="274320"/>
-          </a:xfrm>
-          <a:prstGeom prst="rect">
-            <a:avLst/>
-          </a:prstGeom>
-          <a:noFill/>
-        </p:spPr>
-        <p:txBody>
-          <a:bodyPr wrap="square" lIns="0" rIns="0" tIns="0" bIns="0">
-            <a:spAutoFit/>
-          </a:bodyPr>
-          <a:lstStyle/>
-          <a:p>
-            <a:pPr algn="l"/>
-            <a:r>
-              <a:rPr sz="900" b="0" i="0">
-                <a:solidFill>
-                  <a:srgbClr val="CADCFC"/>
-                </a:solidFill>
-                <a:latin typeface="Arial"/>
-              </a:rPr>
-              <a:t>Auburn -31.5 → Auburn -33.5</a:t>
-            </a:r>
-          </a:p>
-        </p:txBody>
-      </p:sp>
-      <p:sp>
-        <p:nvSpPr>
-          <p:cNvPr id="34" name="TextBox 33"/>
-          <p:cNvSpPr txBox="1"/>
-          <p:nvPr/>
-        </p:nvSpPr>
-        <p:spPr>
-          <a:xfrm>
-            <a:off x="6172200" y="2651760"/>
-            <a:ext cx="502920" cy="274320"/>
-          </a:xfrm>
-          <a:prstGeom prst="rect">
-            <a:avLst/>
-          </a:prstGeom>
-          <a:noFill/>
-        </p:spPr>
-        <p:txBody>
-          <a:bodyPr wrap="square" lIns="0" rIns="0" tIns="0" bIns="0">
-            <a:spAutoFit/>
-          </a:bodyPr>
-          <a:lstStyle/>
-          <a:p>
-            <a:pPr algn="r"/>
-            <a:r>
-              <a:rPr sz="1000" b="1" i="0">
-                <a:solidFill>
-                  <a:srgbClr val="FF7A7A"/>
-                </a:solidFill>
-                <a:latin typeface="Arial"/>
-              </a:rPr>
-              <a:t>-2</a:t>
-            </a:r>
-          </a:p>
-        </p:txBody>
-      </p:sp>
-      <p:sp>
-        <p:nvSpPr>
-          <p:cNvPr id="35" name="TextBox 34"/>
-          <p:cNvSpPr txBox="1"/>
-          <p:nvPr/>
-        </p:nvSpPr>
-        <p:spPr>
-          <a:xfrm>
-            <a:off x="6720840" y="2651760"/>
-            <a:ext cx="1188720" cy="274320"/>
-          </a:xfrm>
-          <a:prstGeom prst="rect">
-            <a:avLst/>
-          </a:prstGeom>
-          <a:noFill/>
-        </p:spPr>
-        <p:txBody>
-          <a:bodyPr wrap="square" lIns="0" rIns="0" tIns="0" bIns="0">
-            <a:spAutoFit/>
-          </a:bodyPr>
-          <a:lstStyle/>
-          <a:p>
-            <a:pPr algn="r"/>
-            <a:r>
-              <a:rPr sz="1000" b="0" i="0">
-                <a:solidFill>
-                  <a:srgbClr val="FFFFFF"/>
-                </a:solidFill>
-                <a:latin typeface="Arial"/>
-              </a:rPr>
-              <a:t>+18.7</a:t>
-            </a:r>
-          </a:p>
-        </p:txBody>
-      </p:sp>
-      <p:sp>
-        <p:nvSpPr>
-          <p:cNvPr id="36" name="TextBox 35"/>
-          <p:cNvSpPr txBox="1"/>
-          <p:nvPr/>
-        </p:nvSpPr>
-        <p:spPr>
-          <a:xfrm>
-            <a:off x="7955279" y="2651760"/>
-            <a:ext cx="548640" cy="274320"/>
-          </a:xfrm>
-          <a:prstGeom prst="rect">
-            <a:avLst/>
-          </a:prstGeom>
-          <a:noFill/>
-        </p:spPr>
-        <p:txBody>
-          <a:bodyPr wrap="square" lIns="0" rIns="0" tIns="0" bIns="0">
-            <a:spAutoFit/>
-          </a:bodyPr>
-          <a:lstStyle/>
-          <a:p>
-            <a:pPr algn="r"/>
-            <a:r>
-              <a:rPr sz="1050" b="1" i="0">
-                <a:solidFill>
-                  <a:srgbClr val="F47321"/>
-                </a:solidFill>
-                <a:latin typeface="Arial"/>
-              </a:rPr>
-              <a:t>12.8</a:t>
-            </a:r>
-          </a:p>
-        </p:txBody>
-      </p:sp>
-      <p:sp>
-        <p:nvSpPr>
-          <p:cNvPr id="37" name="TextBox 36"/>
-          <p:cNvSpPr txBox="1"/>
-          <p:nvPr/>
-        </p:nvSpPr>
-        <p:spPr>
-          <a:xfrm>
-            <a:off x="8641080" y="2651760"/>
-            <a:ext cx="1508760" cy="274320"/>
-          </a:xfrm>
-          <a:prstGeom prst="rect">
-            <a:avLst/>
-          </a:prstGeom>
-          <a:noFill/>
-        </p:spPr>
-        <p:txBody>
-          <a:bodyPr wrap="square" lIns="0" rIns="0" tIns="0" bIns="0">
-            <a:spAutoFit/>
-          </a:bodyPr>
-          <a:lstStyle/>
-          <a:p>
-            <a:pPr algn="l"/>
-            <a:r>
-              <a:rPr sz="1000" b="0" i="0">
-                <a:solidFill>
-                  <a:srgbClr val="FFFFFF"/>
-                </a:solidFill>
-                <a:latin typeface="Arial"/>
-              </a:rPr>
-              <a:t>Southern Miss</a:t>
-            </a:r>
-          </a:p>
-        </p:txBody>
-      </p:sp>
-      <p:sp>
-        <p:nvSpPr>
-          <p:cNvPr id="38" name="TextBox 37"/>
-          <p:cNvSpPr txBox="1"/>
-          <p:nvPr/>
-        </p:nvSpPr>
-        <p:spPr>
-          <a:xfrm>
-            <a:off x="10195560" y="2660903"/>
-            <a:ext cx="1143000" cy="274320"/>
-          </a:xfrm>
-          <a:prstGeom prst="rect">
-            <a:avLst/>
-          </a:prstGeom>
-          <a:noFill/>
-        </p:spPr>
-        <p:txBody>
-          <a:bodyPr wrap="square" lIns="0" rIns="0" tIns="0" bIns="0">
-            <a:spAutoFit/>
-          </a:bodyPr>
-          <a:lstStyle/>
-          <a:p>
-            <a:pPr algn="r"/>
-            <a:r>
-              <a:rPr sz="900" b="0" i="0">
-                <a:solidFill>
-                  <a:srgbClr val="CADCFC"/>
-                </a:solidFill>
-                <a:latin typeface="Arial"/>
-              </a:rPr>
-              <a:t>56.5</a:t>
-            </a:r>
-          </a:p>
-        </p:txBody>
-      </p:sp>
-      <p:sp>
-        <p:nvSpPr>
-          <p:cNvPr id="39" name="TextBox 38"/>
-          <p:cNvSpPr txBox="1"/>
-          <p:nvPr/>
-        </p:nvSpPr>
-        <p:spPr>
-          <a:xfrm>
-            <a:off x="868680" y="2990088"/>
-            <a:ext cx="457200" cy="274320"/>
-          </a:xfrm>
-          <a:prstGeom prst="rect">
-            <a:avLst/>
-          </a:prstGeom>
-          <a:noFill/>
-        </p:spPr>
-        <p:txBody>
-          <a:bodyPr wrap="square" lIns="0" rIns="0" tIns="0" bIns="0">
-            <a:spAutoFit/>
-          </a:bodyPr>
-          <a:lstStyle/>
-          <a:p>
-            <a:pPr algn="l"/>
-            <a:r>
-              <a:rPr sz="1000" b="1" i="0">
-                <a:solidFill>
-                  <a:srgbClr val="F47321"/>
-                </a:solidFill>
-                <a:latin typeface="Arial"/>
-              </a:rPr>
-              <a:t>YEL</a:t>
-            </a:r>
-          </a:p>
-        </p:txBody>
-      </p:sp>
-      <p:sp>
-        <p:nvSpPr>
-          <p:cNvPr id="40" name="TextBox 39"/>
-          <p:cNvSpPr txBox="1"/>
-          <p:nvPr/>
-        </p:nvSpPr>
-        <p:spPr>
-          <a:xfrm>
-            <a:off x="1325880" y="2990088"/>
-            <a:ext cx="2743200" cy="274320"/>
-          </a:xfrm>
-          <a:prstGeom prst="rect">
-            <a:avLst/>
-          </a:prstGeom>
-          <a:noFill/>
-        </p:spPr>
-        <p:txBody>
-          <a:bodyPr wrap="square" lIns="0" rIns="0" tIns="0" bIns="0">
-            <a:spAutoFit/>
-          </a:bodyPr>
-          <a:lstStyle/>
-          <a:p>
-            <a:pPr algn="l"/>
-            <a:r>
-              <a:rPr sz="1150" b="1" i="0">
-                <a:solidFill>
-                  <a:srgbClr val="FFFFFF"/>
-                </a:solidFill>
-                <a:latin typeface="Arial"/>
-              </a:rPr>
-              <a:t>Buffalo at Florida International</a:t>
-            </a:r>
-          </a:p>
-        </p:txBody>
-      </p:sp>
-      <p:sp>
-        <p:nvSpPr>
-          <p:cNvPr id="41" name="TextBox 40"/>
-          <p:cNvSpPr txBox="1"/>
-          <p:nvPr/>
-        </p:nvSpPr>
-        <p:spPr>
-          <a:xfrm>
-            <a:off x="4114800" y="3008376"/>
-            <a:ext cx="2011680" cy="274320"/>
-          </a:xfrm>
-          <a:prstGeom prst="rect">
-            <a:avLst/>
-          </a:prstGeom>
-          <a:noFill/>
-        </p:spPr>
-        <p:txBody>
-          <a:bodyPr wrap="square" lIns="0" rIns="0" tIns="0" bIns="0">
-            <a:spAutoFit/>
-          </a:bodyPr>
-          <a:lstStyle/>
-          <a:p>
-            <a:pPr algn="l"/>
-            <a:r>
-              <a:rPr sz="900" b="0" i="0">
-                <a:solidFill>
-                  <a:srgbClr val="CADCFC"/>
-                </a:solidFill>
-                <a:latin typeface="Arial"/>
-              </a:rPr>
-              <a:t>FIU -10.5 (unch.)</a:t>
-            </a:r>
-          </a:p>
-        </p:txBody>
-      </p:sp>
-      <p:sp>
-        <p:nvSpPr>
-          <p:cNvPr id="42" name="TextBox 41"/>
-          <p:cNvSpPr txBox="1"/>
-          <p:nvPr/>
-        </p:nvSpPr>
-        <p:spPr>
-          <a:xfrm>
-            <a:off x="6172200" y="2999232"/>
-            <a:ext cx="502920" cy="274320"/>
-          </a:xfrm>
-          <a:prstGeom prst="rect">
-            <a:avLst/>
-          </a:prstGeom>
-          <a:noFill/>
-        </p:spPr>
-        <p:txBody>
-          <a:bodyPr wrap="square" lIns="0" rIns="0" tIns="0" bIns="0">
-            <a:spAutoFit/>
-          </a:bodyPr>
-          <a:lstStyle/>
-          <a:p>
-            <a:pPr algn="r"/>
-            <a:r>
-              <a:rPr sz="1000" b="0" i="0">
-                <a:solidFill>
-                  <a:srgbClr val="CADCFC"/>
-                </a:solidFill>
-                <a:latin typeface="Arial"/>
-              </a:rPr>
-              <a:t>0</a:t>
-            </a:r>
-          </a:p>
-        </p:txBody>
-      </p:sp>
-      <p:sp>
-        <p:nvSpPr>
-          <p:cNvPr id="43" name="TextBox 42"/>
-          <p:cNvSpPr txBox="1"/>
-          <p:nvPr/>
-        </p:nvSpPr>
-        <p:spPr>
-          <a:xfrm>
-            <a:off x="6720840" y="2999232"/>
-            <a:ext cx="1188720" cy="274320"/>
-          </a:xfrm>
-          <a:prstGeom prst="rect">
-            <a:avLst/>
-          </a:prstGeom>
-          <a:noFill/>
-        </p:spPr>
-        <p:txBody>
-          <a:bodyPr wrap="square" lIns="0" rIns="0" tIns="0" bIns="0">
-            <a:spAutoFit/>
-          </a:bodyPr>
-          <a:lstStyle/>
-          <a:p>
-            <a:pPr algn="r"/>
-            <a:r>
-              <a:rPr sz="1000" b="0" i="0">
-                <a:solidFill>
-                  <a:srgbClr val="FFFFFF"/>
-                </a:solidFill>
-                <a:latin typeface="Arial"/>
-              </a:rPr>
-              <a:t>+1.5</a:t>
-            </a:r>
-          </a:p>
-        </p:txBody>
-      </p:sp>
-      <p:sp>
-        <p:nvSpPr>
-          <p:cNvPr id="44" name="TextBox 43"/>
-          <p:cNvSpPr txBox="1"/>
-          <p:nvPr/>
-        </p:nvSpPr>
-        <p:spPr>
-          <a:xfrm>
-            <a:off x="7955279" y="2999232"/>
-            <a:ext cx="548640" cy="274320"/>
-          </a:xfrm>
-          <a:prstGeom prst="rect">
-            <a:avLst/>
-          </a:prstGeom>
-          <a:noFill/>
-        </p:spPr>
-        <p:txBody>
-          <a:bodyPr wrap="square" lIns="0" rIns="0" tIns="0" bIns="0">
-            <a:spAutoFit/>
-          </a:bodyPr>
-          <a:lstStyle/>
-          <a:p>
-            <a:pPr algn="r"/>
-            <a:r>
-              <a:rPr sz="1050" b="1" i="0">
-                <a:solidFill>
-                  <a:srgbClr val="F47321"/>
-                </a:solidFill>
-                <a:latin typeface="Arial"/>
-              </a:rPr>
-              <a:t>9.0</a:t>
-            </a:r>
-          </a:p>
-        </p:txBody>
-      </p:sp>
-      <p:sp>
-        <p:nvSpPr>
-          <p:cNvPr id="45" name="TextBox 44"/>
-          <p:cNvSpPr txBox="1"/>
-          <p:nvPr/>
-        </p:nvSpPr>
-        <p:spPr>
-          <a:xfrm>
-            <a:off x="8641080" y="2999232"/>
-            <a:ext cx="1508760" cy="274320"/>
-          </a:xfrm>
-          <a:prstGeom prst="rect">
-            <a:avLst/>
-          </a:prstGeom>
-          <a:noFill/>
-        </p:spPr>
-        <p:txBody>
-          <a:bodyPr wrap="square" lIns="0" rIns="0" tIns="0" bIns="0">
-            <a:spAutoFit/>
-          </a:bodyPr>
-          <a:lstStyle/>
-          <a:p>
-            <a:pPr algn="l"/>
-            <a:r>
-              <a:rPr sz="1000" b="0" i="0">
-                <a:solidFill>
-                  <a:srgbClr val="FFFFFF"/>
-                </a:solidFill>
-                <a:latin typeface="Arial"/>
-              </a:rPr>
-              <a:t>Buffalo</a:t>
-            </a:r>
-          </a:p>
-        </p:txBody>
-      </p:sp>
-      <p:sp>
-        <p:nvSpPr>
-          <p:cNvPr id="46" name="TextBox 45"/>
-          <p:cNvSpPr txBox="1"/>
-          <p:nvPr/>
-        </p:nvSpPr>
-        <p:spPr>
-          <a:xfrm>
-            <a:off x="10195560" y="3008376"/>
-            <a:ext cx="1143000" cy="274320"/>
-          </a:xfrm>
-          <a:prstGeom prst="rect">
-            <a:avLst/>
-          </a:prstGeom>
-          <a:noFill/>
-        </p:spPr>
-        <p:txBody>
-          <a:bodyPr wrap="square" lIns="0" rIns="0" tIns="0" bIns="0">
-            <a:spAutoFit/>
-          </a:bodyPr>
-          <a:lstStyle/>
-          <a:p>
-            <a:pPr algn="r"/>
-            <a:r>
-              <a:rPr sz="900" b="0" i="0">
-                <a:solidFill>
-                  <a:srgbClr val="CADCFC"/>
-                </a:solidFill>
-                <a:latin typeface="Arial"/>
-              </a:rPr>
-              <a:t>47.5</a:t>
-            </a:r>
-          </a:p>
-        </p:txBody>
-      </p:sp>
-      <p:sp>
-        <p:nvSpPr>
-          <p:cNvPr id="47" name="Rectangle 46"/>
-          <p:cNvSpPr/>
-          <p:nvPr/>
-        </p:nvSpPr>
-        <p:spPr>
-          <a:xfrm>
-            <a:off x="822960" y="3291840"/>
-            <a:ext cx="10515600" cy="347472"/>
-          </a:xfrm>
-          <a:prstGeom prst="rect">
-            <a:avLst/>
-          </a:prstGeom>
-          <a:solidFill>
-            <a:srgbClr val="123568"/>
-          </a:solidFill>
-          <a:ln>
-            <a:noFill/>
-          </a:ln>
-          <a:effectLst/>
-        </p:spPr>
-        <p:style>
-          <a:lnRef idx="1">
-            <a:schemeClr val="accent1"/>
-          </a:lnRef>
-          <a:fillRef idx="3">
-            <a:schemeClr val="accent1"/>
-          </a:fillRef>
-          <a:effectRef idx="2">
-            <a:schemeClr val="accent1"/>
-          </a:effectRef>
-          <a:fontRef idx="minor">
-            <a:schemeClr val="lt1"/>
-          </a:fontRef>
-        </p:style>
-        <p:txBody>
-          <a:bodyPr rtlCol="0" anchor="ctr"/>
-          <a:lstStyle/>
-          <a:p>
-            <a:pPr algn="ctr"/>
-          </a:p>
-        </p:txBody>
-      </p:sp>
-      <p:sp>
-        <p:nvSpPr>
-          <p:cNvPr id="48" name="TextBox 47"/>
-          <p:cNvSpPr txBox="1"/>
-          <p:nvPr/>
-        </p:nvSpPr>
-        <p:spPr>
-          <a:xfrm>
-            <a:off x="868680" y="3337560"/>
-            <a:ext cx="457200" cy="274320"/>
-          </a:xfrm>
-          <a:prstGeom prst="rect">
-            <a:avLst/>
-          </a:prstGeom>
-          <a:noFill/>
-        </p:spPr>
-        <p:txBody>
-          <a:bodyPr wrap="square" lIns="0" rIns="0" tIns="0" bIns="0">
-            <a:spAutoFit/>
-          </a:bodyPr>
-          <a:lstStyle/>
-          <a:p>
-            <a:pPr algn="l"/>
-            <a:r>
-              <a:rPr sz="1000" b="1" i="0">
-                <a:solidFill>
-                  <a:srgbClr val="F47321"/>
-                </a:solidFill>
-                <a:latin typeface="Arial"/>
-              </a:rPr>
-              <a:t>YEL</a:t>
-            </a:r>
-          </a:p>
-        </p:txBody>
-      </p:sp>
-      <p:sp>
-        <p:nvSpPr>
-          <p:cNvPr id="49" name="TextBox 48"/>
-          <p:cNvSpPr txBox="1"/>
-          <p:nvPr/>
-        </p:nvSpPr>
-        <p:spPr>
-          <a:xfrm>
-            <a:off x="1325880" y="3337560"/>
-            <a:ext cx="2743200" cy="274320"/>
-          </a:xfrm>
-          <a:prstGeom prst="rect">
-            <a:avLst/>
-          </a:prstGeom>
-          <a:noFill/>
-        </p:spPr>
-        <p:txBody>
-          <a:bodyPr wrap="square" lIns="0" rIns="0" tIns="0" bIns="0">
-            <a:spAutoFit/>
-          </a:bodyPr>
-          <a:lstStyle/>
-          <a:p>
-            <a:pPr algn="l"/>
-            <a:r>
-              <a:rPr sz="1150" b="1" i="0">
-                <a:solidFill>
-                  <a:srgbClr val="FFFFFF"/>
-                </a:solidFill>
-                <a:latin typeface="Arial"/>
-              </a:rPr>
-              <a:t>San Diego State at UCLA</a:t>
-            </a:r>
-          </a:p>
-        </p:txBody>
-      </p:sp>
-      <p:sp>
-        <p:nvSpPr>
-          <p:cNvPr id="50" name="TextBox 49"/>
-          <p:cNvSpPr txBox="1"/>
-          <p:nvPr/>
-        </p:nvSpPr>
-        <p:spPr>
-          <a:xfrm>
-            <a:off x="4114800" y="3355848"/>
-            <a:ext cx="2011680" cy="274320"/>
-          </a:xfrm>
-          <a:prstGeom prst="rect">
-            <a:avLst/>
-          </a:prstGeom>
-          <a:noFill/>
-        </p:spPr>
-        <p:txBody>
-          <a:bodyPr wrap="square" lIns="0" rIns="0" tIns="0" bIns="0">
-            <a:spAutoFit/>
-          </a:bodyPr>
-          <a:lstStyle/>
-          <a:p>
-            <a:pPr algn="l"/>
-            <a:r>
-              <a:rPr sz="900" b="0" i="0">
-                <a:solidFill>
-                  <a:srgbClr val="CADCFC"/>
-                </a:solidFill>
-                <a:latin typeface="Arial"/>
-              </a:rPr>
-              <a:t>UCLA -9.5 → UCLA -11.5</a:t>
-            </a:r>
-          </a:p>
-        </p:txBody>
-      </p:sp>
-      <p:sp>
-        <p:nvSpPr>
-          <p:cNvPr id="51" name="TextBox 50"/>
-          <p:cNvSpPr txBox="1"/>
-          <p:nvPr/>
-        </p:nvSpPr>
-        <p:spPr>
-          <a:xfrm>
-            <a:off x="6172200" y="3346704"/>
-            <a:ext cx="502920" cy="274320"/>
-          </a:xfrm>
-          <a:prstGeom prst="rect">
-            <a:avLst/>
-          </a:prstGeom>
-          <a:noFill/>
-        </p:spPr>
-        <p:txBody>
-          <a:bodyPr wrap="square" lIns="0" rIns="0" tIns="0" bIns="0">
-            <a:spAutoFit/>
-          </a:bodyPr>
-          <a:lstStyle/>
-          <a:p>
-            <a:pPr algn="r"/>
-            <a:r>
-              <a:rPr sz="1000" b="1" i="0">
-                <a:solidFill>
-                  <a:srgbClr val="FF7A7A"/>
-                </a:solidFill>
-                <a:latin typeface="Arial"/>
-              </a:rPr>
-              <a:t>-2</a:t>
-            </a:r>
-          </a:p>
-        </p:txBody>
-      </p:sp>
-      <p:sp>
-        <p:nvSpPr>
-          <p:cNvPr id="52" name="TextBox 51"/>
-          <p:cNvSpPr txBox="1"/>
-          <p:nvPr/>
-        </p:nvSpPr>
-        <p:spPr>
-          <a:xfrm>
-            <a:off x="6720840" y="3346704"/>
-            <a:ext cx="1188720" cy="274320"/>
-          </a:xfrm>
-          <a:prstGeom prst="rect">
-            <a:avLst/>
-          </a:prstGeom>
-          <a:noFill/>
-        </p:spPr>
-        <p:txBody>
-          <a:bodyPr wrap="square" lIns="0" rIns="0" tIns="0" bIns="0">
-            <a:spAutoFit/>
-          </a:bodyPr>
-          <a:lstStyle/>
-          <a:p>
-            <a:pPr algn="r"/>
-            <a:r>
-              <a:rPr sz="1000" b="0" i="0">
-                <a:solidFill>
-                  <a:srgbClr val="FFFFFF"/>
-                </a:solidFill>
-                <a:latin typeface="Arial"/>
-              </a:rPr>
-              <a:t>+6.4</a:t>
-            </a:r>
-          </a:p>
-        </p:txBody>
-      </p:sp>
-      <p:sp>
-        <p:nvSpPr>
-          <p:cNvPr id="53" name="TextBox 52"/>
-          <p:cNvSpPr txBox="1"/>
-          <p:nvPr/>
-        </p:nvSpPr>
-        <p:spPr>
-          <a:xfrm>
-            <a:off x="7955279" y="3346704"/>
-            <a:ext cx="548640" cy="274320"/>
-          </a:xfrm>
-          <a:prstGeom prst="rect">
-            <a:avLst/>
-          </a:prstGeom>
-          <a:noFill/>
-        </p:spPr>
-        <p:txBody>
-          <a:bodyPr wrap="square" lIns="0" rIns="0" tIns="0" bIns="0">
-            <a:spAutoFit/>
-          </a:bodyPr>
-          <a:lstStyle/>
-          <a:p>
-            <a:pPr algn="r"/>
-            <a:r>
-              <a:rPr sz="1050" b="1" i="0">
-                <a:solidFill>
-                  <a:srgbClr val="F47321"/>
-                </a:solidFill>
-                <a:latin typeface="Arial"/>
-              </a:rPr>
-              <a:t>7.9</a:t>
-            </a:r>
-          </a:p>
-        </p:txBody>
-      </p:sp>
-      <p:sp>
-        <p:nvSpPr>
-          <p:cNvPr id="54" name="TextBox 53"/>
-          <p:cNvSpPr txBox="1"/>
-          <p:nvPr/>
-        </p:nvSpPr>
-        <p:spPr>
-          <a:xfrm>
-            <a:off x="8641080" y="3346704"/>
-            <a:ext cx="1508760" cy="274320"/>
-          </a:xfrm>
-          <a:prstGeom prst="rect">
-            <a:avLst/>
-          </a:prstGeom>
-          <a:noFill/>
-        </p:spPr>
-        <p:txBody>
-          <a:bodyPr wrap="square" lIns="0" rIns="0" tIns="0" bIns="0">
-            <a:spAutoFit/>
-          </a:bodyPr>
-          <a:lstStyle/>
-          <a:p>
-            <a:pPr algn="l"/>
-            <a:r>
-              <a:rPr sz="1000" b="0" i="0">
-                <a:solidFill>
-                  <a:srgbClr val="FFFFFF"/>
-                </a:solidFill>
-                <a:latin typeface="Arial"/>
-              </a:rPr>
-              <a:t>San Diego State</a:t>
-            </a:r>
-          </a:p>
-        </p:txBody>
-      </p:sp>
-      <p:sp>
-        <p:nvSpPr>
-          <p:cNvPr id="55" name="TextBox 54"/>
-          <p:cNvSpPr txBox="1"/>
-          <p:nvPr/>
-        </p:nvSpPr>
-        <p:spPr>
-          <a:xfrm>
-            <a:off x="10195560" y="3355848"/>
-            <a:ext cx="1143000" cy="274320"/>
-          </a:xfrm>
-          <a:prstGeom prst="rect">
-            <a:avLst/>
-          </a:prstGeom>
-          <a:noFill/>
-        </p:spPr>
-        <p:txBody>
-          <a:bodyPr wrap="square" lIns="0" rIns="0" tIns="0" bIns="0">
-            <a:spAutoFit/>
-          </a:bodyPr>
-          <a:lstStyle/>
-          <a:p>
-            <a:pPr algn="r"/>
-            <a:r>
-              <a:rPr sz="900" b="0" i="0">
-                <a:solidFill>
-                  <a:srgbClr val="CADCFC"/>
-                </a:solidFill>
-                <a:latin typeface="Arial"/>
-              </a:rPr>
-              <a:t>55.5</a:t>
-            </a:r>
-          </a:p>
-        </p:txBody>
-      </p:sp>
-      <p:sp>
-        <p:nvSpPr>
-          <p:cNvPr id="56" name="TextBox 55"/>
-          <p:cNvSpPr txBox="1"/>
-          <p:nvPr/>
-        </p:nvSpPr>
-        <p:spPr>
-          <a:xfrm>
-            <a:off x="868680" y="3685032"/>
-            <a:ext cx="457200" cy="274320"/>
-          </a:xfrm>
-          <a:prstGeom prst="rect">
-            <a:avLst/>
-          </a:prstGeom>
-          <a:noFill/>
-        </p:spPr>
-        <p:txBody>
-          <a:bodyPr wrap="square" lIns="0" rIns="0" tIns="0" bIns="0">
-            <a:spAutoFit/>
-          </a:bodyPr>
-          <a:lstStyle/>
-          <a:p>
-            <a:pPr algn="l"/>
-            <a:r>
-              <a:rPr sz="1000" b="1" i="0">
-                <a:solidFill>
-                  <a:srgbClr val="F47321"/>
-                </a:solidFill>
-                <a:latin typeface="Arial"/>
-              </a:rPr>
-              <a:t>YEL</a:t>
-            </a:r>
-          </a:p>
-        </p:txBody>
-      </p:sp>
-      <p:sp>
-        <p:nvSpPr>
-          <p:cNvPr id="57" name="TextBox 56"/>
-          <p:cNvSpPr txBox="1"/>
-          <p:nvPr/>
-        </p:nvSpPr>
-        <p:spPr>
-          <a:xfrm>
-            <a:off x="1325880" y="3685032"/>
-            <a:ext cx="2743200" cy="274320"/>
-          </a:xfrm>
-          <a:prstGeom prst="rect">
-            <a:avLst/>
-          </a:prstGeom>
-          <a:noFill/>
-        </p:spPr>
-        <p:txBody>
-          <a:bodyPr wrap="square" lIns="0" rIns="0" tIns="0" bIns="0">
-            <a:spAutoFit/>
-          </a:bodyPr>
-          <a:lstStyle/>
-          <a:p>
-            <a:pPr algn="l"/>
-            <a:r>
-              <a:rPr sz="1150" b="1" i="0">
-                <a:solidFill>
-                  <a:srgbClr val="FFFFFF"/>
-                </a:solidFill>
-                <a:latin typeface="Arial"/>
-              </a:rPr>
-              <a:t>Utah State at Washington</a:t>
-            </a:r>
-          </a:p>
-        </p:txBody>
-      </p:sp>
-      <p:sp>
-        <p:nvSpPr>
-          <p:cNvPr id="58" name="TextBox 57"/>
-          <p:cNvSpPr txBox="1"/>
-          <p:nvPr/>
-        </p:nvSpPr>
-        <p:spPr>
-          <a:xfrm>
-            <a:off x="4114800" y="3703320"/>
-            <a:ext cx="2011680" cy="274320"/>
-          </a:xfrm>
-          <a:prstGeom prst="rect">
-            <a:avLst/>
-          </a:prstGeom>
-          <a:noFill/>
-        </p:spPr>
-        <p:txBody>
-          <a:bodyPr wrap="square" lIns="0" rIns="0" tIns="0" bIns="0">
-            <a:spAutoFit/>
-          </a:bodyPr>
-          <a:lstStyle/>
-          <a:p>
-            <a:pPr algn="l"/>
-            <a:r>
-              <a:rPr sz="900" b="0" i="0">
-                <a:solidFill>
-                  <a:srgbClr val="CADCFC"/>
-                </a:solidFill>
-                <a:latin typeface="Arial"/>
-              </a:rPr>
-              <a:t>Washington -26.5 (unch.)</a:t>
-            </a:r>
-          </a:p>
-        </p:txBody>
-      </p:sp>
-      <p:sp>
-        <p:nvSpPr>
-          <p:cNvPr id="59" name="TextBox 58"/>
-          <p:cNvSpPr txBox="1"/>
-          <p:nvPr/>
-        </p:nvSpPr>
-        <p:spPr>
-          <a:xfrm>
-            <a:off x="6172200" y="3694176"/>
-            <a:ext cx="502920" cy="274320"/>
-          </a:xfrm>
-          <a:prstGeom prst="rect">
-            <a:avLst/>
-          </a:prstGeom>
-          <a:noFill/>
-        </p:spPr>
-        <p:txBody>
-          <a:bodyPr wrap="square" lIns="0" rIns="0" tIns="0" bIns="0">
-            <a:spAutoFit/>
-          </a:bodyPr>
-          <a:lstStyle/>
-          <a:p>
-            <a:pPr algn="r"/>
-            <a:r>
-              <a:rPr sz="1000" b="0" i="0">
-                <a:solidFill>
-                  <a:srgbClr val="CADCFC"/>
-                </a:solidFill>
-                <a:latin typeface="Arial"/>
-              </a:rPr>
-              <a:t>0</a:t>
-            </a:r>
-          </a:p>
-        </p:txBody>
-      </p:sp>
-      <p:sp>
-        <p:nvSpPr>
-          <p:cNvPr id="60" name="TextBox 59"/>
-          <p:cNvSpPr txBox="1"/>
-          <p:nvPr/>
-        </p:nvSpPr>
-        <p:spPr>
-          <a:xfrm>
-            <a:off x="6720840" y="3694176"/>
-            <a:ext cx="1188720" cy="274320"/>
-          </a:xfrm>
-          <a:prstGeom prst="rect">
-            <a:avLst/>
-          </a:prstGeom>
-          <a:noFill/>
-        </p:spPr>
-        <p:txBody>
-          <a:bodyPr wrap="square" lIns="0" rIns="0" tIns="0" bIns="0">
-            <a:spAutoFit/>
-          </a:bodyPr>
-          <a:lstStyle/>
-          <a:p>
-            <a:pPr algn="r"/>
-            <a:r>
-              <a:rPr sz="1000" b="0" i="0">
-                <a:solidFill>
-                  <a:srgbClr val="FFFFFF"/>
-                </a:solidFill>
-                <a:latin typeface="Arial"/>
-              </a:rPr>
-              <a:t>+18.6</a:t>
-            </a:r>
-          </a:p>
-        </p:txBody>
-      </p:sp>
-      <p:sp>
-        <p:nvSpPr>
-          <p:cNvPr id="61" name="TextBox 60"/>
-          <p:cNvSpPr txBox="1"/>
-          <p:nvPr/>
-        </p:nvSpPr>
-        <p:spPr>
-          <a:xfrm>
-            <a:off x="7955279" y="3694176"/>
-            <a:ext cx="548640" cy="274320"/>
-          </a:xfrm>
-          <a:prstGeom prst="rect">
-            <a:avLst/>
-          </a:prstGeom>
-          <a:noFill/>
-        </p:spPr>
-        <p:txBody>
-          <a:bodyPr wrap="square" lIns="0" rIns="0" tIns="0" bIns="0">
-            <a:spAutoFit/>
-          </a:bodyPr>
-          <a:lstStyle/>
-          <a:p>
-            <a:pPr algn="r"/>
-            <a:r>
-              <a:rPr sz="1050" b="1" i="0">
-                <a:solidFill>
-                  <a:srgbClr val="F47321"/>
-                </a:solidFill>
-                <a:latin typeface="Arial"/>
-              </a:rPr>
-              <a:t>7.9</a:t>
-            </a:r>
-          </a:p>
-        </p:txBody>
-      </p:sp>
-      <p:sp>
-        <p:nvSpPr>
-          <p:cNvPr id="62" name="TextBox 61"/>
-          <p:cNvSpPr txBox="1"/>
-          <p:nvPr/>
-        </p:nvSpPr>
-        <p:spPr>
-          <a:xfrm>
-            <a:off x="8641080" y="3694176"/>
-            <a:ext cx="1508760" cy="274320"/>
-          </a:xfrm>
-          <a:prstGeom prst="rect">
-            <a:avLst/>
-          </a:prstGeom>
-          <a:noFill/>
-        </p:spPr>
-        <p:txBody>
-          <a:bodyPr wrap="square" lIns="0" rIns="0" tIns="0" bIns="0">
-            <a:spAutoFit/>
-          </a:bodyPr>
-          <a:lstStyle/>
-          <a:p>
-            <a:pPr algn="l"/>
-            <a:r>
-              <a:rPr sz="1000" b="0" i="0">
-                <a:solidFill>
-                  <a:srgbClr val="FFFFFF"/>
-                </a:solidFill>
-                <a:latin typeface="Arial"/>
-              </a:rPr>
-              <a:t>Utah State</a:t>
-            </a:r>
-          </a:p>
-        </p:txBody>
-      </p:sp>
-      <p:sp>
-        <p:nvSpPr>
-          <p:cNvPr id="63" name="TextBox 62"/>
-          <p:cNvSpPr txBox="1"/>
-          <p:nvPr/>
-        </p:nvSpPr>
-        <p:spPr>
-          <a:xfrm>
-            <a:off x="10195560" y="3703320"/>
-            <a:ext cx="1143000" cy="274320"/>
-          </a:xfrm>
-          <a:prstGeom prst="rect">
-            <a:avLst/>
-          </a:prstGeom>
-          <a:noFill/>
-        </p:spPr>
-        <p:txBody>
-          <a:bodyPr wrap="square" lIns="0" rIns="0" tIns="0" bIns="0">
-            <a:spAutoFit/>
-          </a:bodyPr>
-          <a:lstStyle/>
-          <a:p>
-            <a:pPr algn="r"/>
-            <a:r>
-              <a:rPr sz="900" b="0" i="0">
-                <a:solidFill>
-                  <a:srgbClr val="CADCFC"/>
-                </a:solidFill>
-                <a:latin typeface="Arial"/>
-              </a:rPr>
-              <a:t>55.5</a:t>
-            </a:r>
-          </a:p>
-        </p:txBody>
-      </p:sp>
-      <p:sp>
-        <p:nvSpPr>
-          <p:cNvPr id="64" name="Rectangle 63"/>
-          <p:cNvSpPr/>
-          <p:nvPr/>
-        </p:nvSpPr>
-        <p:spPr>
-          <a:xfrm>
-            <a:off x="822960" y="3986784"/>
-            <a:ext cx="10515600" cy="347472"/>
-          </a:xfrm>
-          <a:prstGeom prst="rect">
-            <a:avLst/>
-          </a:prstGeom>
-          <a:solidFill>
-            <a:srgbClr val="123568"/>
-          </a:solidFill>
-          <a:ln>
-            <a:noFill/>
-          </a:ln>
-          <a:effectLst/>
-        </p:spPr>
-        <p:style>
-          <a:lnRef idx="1">
-            <a:schemeClr val="accent1"/>
-          </a:lnRef>
-          <a:fillRef idx="3">
-            <a:schemeClr val="accent1"/>
-          </a:fillRef>
-          <a:effectRef idx="2">
-            <a:schemeClr val="accent1"/>
-          </a:effectRef>
-          <a:fontRef idx="minor">
-            <a:schemeClr val="lt1"/>
-          </a:fontRef>
-        </p:style>
-        <p:txBody>
-          <a:bodyPr rtlCol="0" anchor="ctr"/>
-          <a:lstStyle/>
-          <a:p>
-            <a:pPr algn="ctr"/>
-          </a:p>
-        </p:txBody>
-      </p:sp>
-      <p:sp>
-        <p:nvSpPr>
-          <p:cNvPr id="65" name="TextBox 64"/>
-          <p:cNvSpPr txBox="1"/>
-          <p:nvPr/>
-        </p:nvSpPr>
-        <p:spPr>
-          <a:xfrm>
-            <a:off x="868680" y="4032504"/>
-            <a:ext cx="457200" cy="274320"/>
-          </a:xfrm>
-          <a:prstGeom prst="rect">
-            <a:avLst/>
-          </a:prstGeom>
-          <a:noFill/>
-        </p:spPr>
-        <p:txBody>
-          <a:bodyPr wrap="square" lIns="0" rIns="0" tIns="0" bIns="0">
-            <a:spAutoFit/>
-          </a:bodyPr>
-          <a:lstStyle/>
-          <a:p>
-            <a:pPr algn="l"/>
-            <a:r>
-              <a:rPr sz="1000" b="1" i="0">
-                <a:solidFill>
-                  <a:srgbClr val="F47321"/>
-                </a:solidFill>
-                <a:latin typeface="Arial"/>
-              </a:rPr>
-              <a:t>YEL</a:t>
-            </a:r>
-          </a:p>
-        </p:txBody>
-      </p:sp>
-      <p:sp>
-        <p:nvSpPr>
-          <p:cNvPr id="66" name="TextBox 65"/>
-          <p:cNvSpPr txBox="1"/>
-          <p:nvPr/>
-        </p:nvSpPr>
-        <p:spPr>
-          <a:xfrm>
-            <a:off x="1325880" y="4032504"/>
-            <a:ext cx="2743200" cy="274320"/>
-          </a:xfrm>
-          <a:prstGeom prst="rect">
-            <a:avLst/>
-          </a:prstGeom>
-          <a:noFill/>
-        </p:spPr>
-        <p:txBody>
-          <a:bodyPr wrap="square" lIns="0" rIns="0" tIns="0" bIns="0">
-            <a:spAutoFit/>
-          </a:bodyPr>
-          <a:lstStyle/>
-          <a:p>
-            <a:pPr algn="l"/>
-            <a:r>
-              <a:rPr sz="1150" b="1" i="0">
-                <a:solidFill>
-                  <a:srgbClr val="FFFFFF"/>
-                </a:solidFill>
-                <a:latin typeface="Arial"/>
-              </a:rPr>
-              <a:t>Arkansas at Utah</a:t>
-            </a:r>
-          </a:p>
-        </p:txBody>
-      </p:sp>
-      <p:sp>
-        <p:nvSpPr>
-          <p:cNvPr id="67" name="TextBox 66"/>
-          <p:cNvSpPr txBox="1"/>
-          <p:nvPr/>
-        </p:nvSpPr>
-        <p:spPr>
-          <a:xfrm>
-            <a:off x="4114800" y="4050792"/>
-            <a:ext cx="2011680" cy="274320"/>
-          </a:xfrm>
-          <a:prstGeom prst="rect">
-            <a:avLst/>
-          </a:prstGeom>
-          <a:noFill/>
-        </p:spPr>
-        <p:txBody>
-          <a:bodyPr wrap="square" lIns="0" rIns="0" tIns="0" bIns="0">
-            <a:spAutoFit/>
-          </a:bodyPr>
-          <a:lstStyle/>
-          <a:p>
-            <a:pPr algn="l"/>
-            <a:r>
-              <a:rPr sz="900" b="0" i="0">
-                <a:solidFill>
-                  <a:srgbClr val="CADCFC"/>
-                </a:solidFill>
-                <a:latin typeface="Arial"/>
-              </a:rPr>
-              <a:t>Utah -13.5 → Utah -12.5</a:t>
-            </a:r>
-          </a:p>
-        </p:txBody>
-      </p:sp>
-      <p:sp>
-        <p:nvSpPr>
-          <p:cNvPr id="68" name="TextBox 67"/>
-          <p:cNvSpPr txBox="1"/>
-          <p:nvPr/>
-        </p:nvSpPr>
-        <p:spPr>
-          <a:xfrm>
-            <a:off x="6172200" y="4041648"/>
-            <a:ext cx="502920" cy="274320"/>
-          </a:xfrm>
-          <a:prstGeom prst="rect">
-            <a:avLst/>
-          </a:prstGeom>
-          <a:noFill/>
-        </p:spPr>
-        <p:txBody>
-          <a:bodyPr wrap="square" lIns="0" rIns="0" tIns="0" bIns="0">
-            <a:spAutoFit/>
-          </a:bodyPr>
-          <a:lstStyle/>
-          <a:p>
-            <a:pPr algn="r"/>
-            <a:r>
-              <a:rPr sz="1000" b="1" i="0">
-                <a:solidFill>
-                  <a:srgbClr val="5CD68A"/>
-                </a:solidFill>
-                <a:latin typeface="Arial"/>
-              </a:rPr>
-              <a:t>+1</a:t>
-            </a:r>
-          </a:p>
-        </p:txBody>
-      </p:sp>
-      <p:sp>
-        <p:nvSpPr>
-          <p:cNvPr id="69" name="TextBox 68"/>
-          <p:cNvSpPr txBox="1"/>
-          <p:nvPr/>
-        </p:nvSpPr>
-        <p:spPr>
-          <a:xfrm>
-            <a:off x="6720840" y="4041648"/>
-            <a:ext cx="1188720" cy="274320"/>
-          </a:xfrm>
-          <a:prstGeom prst="rect">
-            <a:avLst/>
-          </a:prstGeom>
-          <a:noFill/>
-        </p:spPr>
-        <p:txBody>
-          <a:bodyPr wrap="square" lIns="0" rIns="0" tIns="0" bIns="0">
-            <a:spAutoFit/>
-          </a:bodyPr>
-          <a:lstStyle/>
-          <a:p>
-            <a:pPr algn="r"/>
-            <a:r>
-              <a:rPr sz="1000" b="0" i="0">
-                <a:solidFill>
-                  <a:srgbClr val="FFFFFF"/>
-                </a:solidFill>
-                <a:latin typeface="Arial"/>
-              </a:rPr>
-              <a:t>+6.6</a:t>
-            </a:r>
-          </a:p>
-        </p:txBody>
-      </p:sp>
-      <p:sp>
-        <p:nvSpPr>
-          <p:cNvPr id="70" name="TextBox 69"/>
-          <p:cNvSpPr txBox="1"/>
-          <p:nvPr/>
-        </p:nvSpPr>
-        <p:spPr>
-          <a:xfrm>
-            <a:off x="7955279" y="4041648"/>
-            <a:ext cx="548640" cy="274320"/>
-          </a:xfrm>
-          <a:prstGeom prst="rect">
-            <a:avLst/>
-          </a:prstGeom>
-          <a:noFill/>
-        </p:spPr>
-        <p:txBody>
-          <a:bodyPr wrap="square" lIns="0" rIns="0" tIns="0" bIns="0">
-            <a:spAutoFit/>
-          </a:bodyPr>
-          <a:lstStyle/>
-          <a:p>
-            <a:pPr algn="r"/>
-            <a:r>
-              <a:rPr sz="1050" b="1" i="0">
-                <a:solidFill>
-                  <a:srgbClr val="F47321"/>
-                </a:solidFill>
-                <a:latin typeface="Arial"/>
-              </a:rPr>
-              <a:t>6.9</a:t>
-            </a:r>
-          </a:p>
-        </p:txBody>
-      </p:sp>
-      <p:sp>
-        <p:nvSpPr>
-          <p:cNvPr id="71" name="TextBox 70"/>
-          <p:cNvSpPr txBox="1"/>
-          <p:nvPr/>
-        </p:nvSpPr>
-        <p:spPr>
-          <a:xfrm>
-            <a:off x="8641080" y="4041648"/>
-            <a:ext cx="1508760" cy="274320"/>
-          </a:xfrm>
-          <a:prstGeom prst="rect">
-            <a:avLst/>
-          </a:prstGeom>
-          <a:noFill/>
-        </p:spPr>
-        <p:txBody>
-          <a:bodyPr wrap="square" lIns="0" rIns="0" tIns="0" bIns="0">
-            <a:spAutoFit/>
-          </a:bodyPr>
-          <a:lstStyle/>
-          <a:p>
-            <a:pPr algn="l"/>
-            <a:r>
-              <a:rPr sz="1000" b="0" i="0">
-                <a:solidFill>
-                  <a:srgbClr val="FFFFFF"/>
-                </a:solidFill>
-                <a:latin typeface="Arial"/>
-              </a:rPr>
-              <a:t>Arkansas</a:t>
-            </a:r>
-          </a:p>
-        </p:txBody>
-      </p:sp>
-      <p:sp>
-        <p:nvSpPr>
-          <p:cNvPr id="72" name="TextBox 71"/>
-          <p:cNvSpPr txBox="1"/>
-          <p:nvPr/>
-        </p:nvSpPr>
-        <p:spPr>
-          <a:xfrm>
-            <a:off x="10195560" y="4050792"/>
-            <a:ext cx="1143000" cy="274320"/>
-          </a:xfrm>
-          <a:prstGeom prst="rect">
-            <a:avLst/>
-          </a:prstGeom>
-          <a:noFill/>
-        </p:spPr>
-        <p:txBody>
-          <a:bodyPr wrap="square" lIns="0" rIns="0" tIns="0" bIns="0">
-            <a:spAutoFit/>
-          </a:bodyPr>
-          <a:lstStyle/>
-          <a:p>
-            <a:pPr algn="r"/>
-            <a:r>
-              <a:rPr sz="900" b="0" i="0">
-                <a:solidFill>
-                  <a:srgbClr val="CADCFC"/>
-                </a:solidFill>
-                <a:latin typeface="Arial"/>
-              </a:rPr>
-              <a:t>54.5</a:t>
-            </a:r>
-          </a:p>
-        </p:txBody>
-      </p:sp>
-      <p:sp>
-        <p:nvSpPr>
-          <p:cNvPr id="73" name="TextBox 72"/>
-          <p:cNvSpPr txBox="1"/>
-          <p:nvPr/>
-        </p:nvSpPr>
-        <p:spPr>
-          <a:xfrm>
-            <a:off x="868680" y="4379976"/>
-            <a:ext cx="457200" cy="274320"/>
-          </a:xfrm>
-          <a:prstGeom prst="rect">
-            <a:avLst/>
-          </a:prstGeom>
-          <a:noFill/>
-        </p:spPr>
-        <p:txBody>
-          <a:bodyPr wrap="square" lIns="0" rIns="0" tIns="0" bIns="0">
-            <a:spAutoFit/>
-          </a:bodyPr>
-          <a:lstStyle/>
-          <a:p>
-            <a:pPr algn="l"/>
-            <a:r>
-              <a:rPr sz="1000" b="1" i="0">
-                <a:solidFill>
-                  <a:srgbClr val="F47321"/>
-                </a:solidFill>
-                <a:latin typeface="Arial"/>
-              </a:rPr>
-              <a:t>YEL</a:t>
-            </a:r>
-          </a:p>
-        </p:txBody>
-      </p:sp>
-      <p:sp>
-        <p:nvSpPr>
-          <p:cNvPr id="74" name="TextBox 73"/>
-          <p:cNvSpPr txBox="1"/>
-          <p:nvPr/>
-        </p:nvSpPr>
-        <p:spPr>
-          <a:xfrm>
-            <a:off x="1325880" y="4379976"/>
-            <a:ext cx="2743200" cy="274320"/>
-          </a:xfrm>
-          <a:prstGeom prst="rect">
-            <a:avLst/>
-          </a:prstGeom>
-          <a:noFill/>
-        </p:spPr>
-        <p:txBody>
-          <a:bodyPr wrap="square" lIns="0" rIns="0" tIns="0" bIns="0">
-            <a:spAutoFit/>
-          </a:bodyPr>
-          <a:lstStyle/>
-          <a:p>
-            <a:pPr algn="l"/>
-            <a:r>
-              <a:rPr sz="1150" b="1" i="0">
-                <a:solidFill>
-                  <a:srgbClr val="FFFFFF"/>
-                </a:solidFill>
-                <a:latin typeface="Arial"/>
-              </a:rPr>
-              <a:t>Sacramento State at Fresno State</a:t>
-            </a:r>
-          </a:p>
-        </p:txBody>
-      </p:sp>
-      <p:sp>
-        <p:nvSpPr>
-          <p:cNvPr id="75" name="TextBox 74"/>
-          <p:cNvSpPr txBox="1"/>
-          <p:nvPr/>
-        </p:nvSpPr>
-        <p:spPr>
-          <a:xfrm>
-            <a:off x="4114800" y="4398264"/>
-            <a:ext cx="2011680" cy="274320"/>
-          </a:xfrm>
-          <a:prstGeom prst="rect">
-            <a:avLst/>
-          </a:prstGeom>
-          <a:noFill/>
-        </p:spPr>
-        <p:txBody>
-          <a:bodyPr wrap="square" lIns="0" rIns="0" tIns="0" bIns="0">
-            <a:spAutoFit/>
-          </a:bodyPr>
-          <a:lstStyle/>
-          <a:p>
-            <a:pPr algn="l"/>
-            <a:r>
-              <a:rPr sz="900" b="0" i="0">
-                <a:solidFill>
-                  <a:srgbClr val="CADCFC"/>
-                </a:solidFill>
-                <a:latin typeface="Arial"/>
-              </a:rPr>
-              <a:t>Fresno State -18.5 (unch.)</a:t>
-            </a:r>
-          </a:p>
-        </p:txBody>
-      </p:sp>
-      <p:sp>
-        <p:nvSpPr>
-          <p:cNvPr id="76" name="TextBox 75"/>
-          <p:cNvSpPr txBox="1"/>
-          <p:nvPr/>
-        </p:nvSpPr>
-        <p:spPr>
-          <a:xfrm>
-            <a:off x="6172200" y="4389120"/>
-            <a:ext cx="502920" cy="274320"/>
-          </a:xfrm>
-          <a:prstGeom prst="rect">
-            <a:avLst/>
-          </a:prstGeom>
-          <a:noFill/>
-        </p:spPr>
-        <p:txBody>
-          <a:bodyPr wrap="square" lIns="0" rIns="0" tIns="0" bIns="0">
-            <a:spAutoFit/>
-          </a:bodyPr>
-          <a:lstStyle/>
-          <a:p>
-            <a:pPr algn="r"/>
-            <a:r>
-              <a:rPr sz="1000" b="0" i="0">
-                <a:solidFill>
-                  <a:srgbClr val="CADCFC"/>
-                </a:solidFill>
-                <a:latin typeface="Arial"/>
-              </a:rPr>
-              <a:t>0</a:t>
-            </a:r>
-          </a:p>
-        </p:txBody>
-      </p:sp>
-      <p:sp>
-        <p:nvSpPr>
-          <p:cNvPr id="77" name="TextBox 76"/>
-          <p:cNvSpPr txBox="1"/>
-          <p:nvPr/>
-        </p:nvSpPr>
-        <p:spPr>
-          <a:xfrm>
-            <a:off x="6720840" y="4389120"/>
-            <a:ext cx="1188720" cy="274320"/>
-          </a:xfrm>
-          <a:prstGeom prst="rect">
-            <a:avLst/>
-          </a:prstGeom>
-          <a:noFill/>
-        </p:spPr>
-        <p:txBody>
-          <a:bodyPr wrap="square" lIns="0" rIns="0" tIns="0" bIns="0">
-            <a:spAutoFit/>
-          </a:bodyPr>
-          <a:lstStyle/>
-          <a:p>
-            <a:pPr algn="r"/>
-            <a:r>
-              <a:rPr sz="1000" b="0" i="0">
-                <a:solidFill>
-                  <a:srgbClr val="FFFFFF"/>
-                </a:solidFill>
-                <a:latin typeface="Arial"/>
-              </a:rPr>
-              <a:t>+11.6</a:t>
-            </a:r>
-          </a:p>
-        </p:txBody>
-      </p:sp>
-      <p:sp>
-        <p:nvSpPr>
-          <p:cNvPr id="78" name="TextBox 77"/>
-          <p:cNvSpPr txBox="1"/>
-          <p:nvPr/>
-        </p:nvSpPr>
-        <p:spPr>
-          <a:xfrm>
-            <a:off x="7955279" y="4389120"/>
-            <a:ext cx="548640" cy="274320"/>
-          </a:xfrm>
-          <a:prstGeom prst="rect">
-            <a:avLst/>
-          </a:prstGeom>
-          <a:noFill/>
-        </p:spPr>
-        <p:txBody>
-          <a:bodyPr wrap="square" lIns="0" rIns="0" tIns="0" bIns="0">
-            <a:spAutoFit/>
-          </a:bodyPr>
-          <a:lstStyle/>
-          <a:p>
-            <a:pPr algn="r"/>
-            <a:r>
-              <a:rPr sz="1050" b="1" i="0">
-                <a:solidFill>
-                  <a:srgbClr val="F47321"/>
-                </a:solidFill>
-                <a:latin typeface="Arial"/>
-              </a:rPr>
-              <a:t>6.9</a:t>
-            </a:r>
-          </a:p>
-        </p:txBody>
-      </p:sp>
-      <p:sp>
-        <p:nvSpPr>
-          <p:cNvPr id="79" name="TextBox 78"/>
-          <p:cNvSpPr txBox="1"/>
-          <p:nvPr/>
-        </p:nvSpPr>
-        <p:spPr>
-          <a:xfrm>
-            <a:off x="8641080" y="4389120"/>
-            <a:ext cx="1508760" cy="274320"/>
-          </a:xfrm>
-          <a:prstGeom prst="rect">
-            <a:avLst/>
-          </a:prstGeom>
-          <a:noFill/>
-        </p:spPr>
-        <p:txBody>
-          <a:bodyPr wrap="square" lIns="0" rIns="0" tIns="0" bIns="0">
-            <a:spAutoFit/>
-          </a:bodyPr>
-          <a:lstStyle/>
-          <a:p>
-            <a:pPr algn="l"/>
-            <a:r>
-              <a:rPr sz="1000" b="0" i="0">
-                <a:solidFill>
-                  <a:srgbClr val="FFFFFF"/>
-                </a:solidFill>
-                <a:latin typeface="Arial"/>
-              </a:rPr>
-              <a:t>Sacramento State</a:t>
-            </a:r>
-          </a:p>
-        </p:txBody>
-      </p:sp>
-      <p:sp>
-        <p:nvSpPr>
-          <p:cNvPr id="80" name="TextBox 79"/>
-          <p:cNvSpPr txBox="1"/>
-          <p:nvPr/>
-        </p:nvSpPr>
-        <p:spPr>
-          <a:xfrm>
-            <a:off x="10195560" y="4398264"/>
-            <a:ext cx="1143000" cy="274320"/>
-          </a:xfrm>
-          <a:prstGeom prst="rect">
-            <a:avLst/>
-          </a:prstGeom>
-          <a:noFill/>
-        </p:spPr>
-        <p:txBody>
-          <a:bodyPr wrap="square" lIns="0" rIns="0" tIns="0" bIns="0">
-            <a:spAutoFit/>
-          </a:bodyPr>
-          <a:lstStyle/>
-          <a:p>
-            <a:pPr algn="r"/>
-            <a:r>
-              <a:rPr sz="900" b="0" i="0">
-                <a:solidFill>
-                  <a:srgbClr val="CADCFC"/>
-                </a:solidFill>
-                <a:latin typeface="Arial"/>
-              </a:rPr>
-              <a:t>45.5</a:t>
-            </a:r>
-          </a:p>
-        </p:txBody>
-      </p:sp>
-      <p:sp>
-        <p:nvSpPr>
-          <p:cNvPr id="81" name="Rectangle 80"/>
-          <p:cNvSpPr/>
-          <p:nvPr/>
-        </p:nvSpPr>
-        <p:spPr>
-          <a:xfrm>
-            <a:off x="822960" y="4681728"/>
-            <a:ext cx="10515600" cy="347472"/>
-          </a:xfrm>
-          <a:prstGeom prst="rect">
-            <a:avLst/>
-          </a:prstGeom>
-          <a:solidFill>
-            <a:srgbClr val="123568"/>
-          </a:solidFill>
-          <a:ln>
-            <a:noFill/>
-          </a:ln>
-          <a:effectLst/>
-        </p:spPr>
-        <p:style>
-          <a:lnRef idx="1">
-            <a:schemeClr val="accent1"/>
-          </a:lnRef>
-          <a:fillRef idx="3">
-            <a:schemeClr val="accent1"/>
-          </a:fillRef>
-          <a:effectRef idx="2">
-            <a:schemeClr val="accent1"/>
-          </a:effectRef>
-          <a:fontRef idx="minor">
-            <a:schemeClr val="lt1"/>
-          </a:fontRef>
-        </p:style>
-        <p:txBody>
-          <a:bodyPr rtlCol="0" anchor="ctr"/>
-          <a:lstStyle/>
-          <a:p>
-            <a:pPr algn="ctr"/>
-          </a:p>
-        </p:txBody>
-      </p:sp>
-      <p:sp>
-        <p:nvSpPr>
-          <p:cNvPr id="82" name="TextBox 81"/>
-          <p:cNvSpPr txBox="1"/>
-          <p:nvPr/>
-        </p:nvSpPr>
-        <p:spPr>
-          <a:xfrm>
-            <a:off x="868680" y="4727448"/>
-            <a:ext cx="457200" cy="274320"/>
-          </a:xfrm>
-          <a:prstGeom prst="rect">
-            <a:avLst/>
-          </a:prstGeom>
-          <a:noFill/>
-        </p:spPr>
-        <p:txBody>
-          <a:bodyPr wrap="square" lIns="0" rIns="0" tIns="0" bIns="0">
-            <a:spAutoFit/>
-          </a:bodyPr>
-          <a:lstStyle/>
-          <a:p>
-            <a:pPr algn="l"/>
-            <a:r>
-              <a:rPr sz="1000" b="1" i="0">
-                <a:solidFill>
-                  <a:srgbClr val="F47321"/>
-                </a:solidFill>
-                <a:latin typeface="Arial"/>
-              </a:rPr>
-              <a:t>YEL</a:t>
-            </a:r>
-          </a:p>
-        </p:txBody>
-      </p:sp>
-      <p:sp>
-        <p:nvSpPr>
-          <p:cNvPr id="83" name="TextBox 82"/>
-          <p:cNvSpPr txBox="1"/>
-          <p:nvPr/>
-        </p:nvSpPr>
-        <p:spPr>
-          <a:xfrm>
-            <a:off x="1325880" y="4727448"/>
-            <a:ext cx="2743200" cy="274320"/>
-          </a:xfrm>
-          <a:prstGeom prst="rect">
-            <a:avLst/>
-          </a:prstGeom>
-          <a:noFill/>
-        </p:spPr>
-        <p:txBody>
-          <a:bodyPr wrap="square" lIns="0" rIns="0" tIns="0" bIns="0">
-            <a:spAutoFit/>
-          </a:bodyPr>
-          <a:lstStyle/>
-          <a:p>
-            <a:pPr algn="l"/>
-            <a:r>
-              <a:rPr sz="1150" b="1" i="0">
-                <a:solidFill>
-                  <a:srgbClr val="FFFFFF"/>
-                </a:solidFill>
-                <a:latin typeface="Arial"/>
-              </a:rPr>
-              <a:t>Washington State at Kansas State</a:t>
-            </a:r>
-          </a:p>
-        </p:txBody>
-      </p:sp>
-      <p:sp>
-        <p:nvSpPr>
-          <p:cNvPr id="84" name="TextBox 83"/>
-          <p:cNvSpPr txBox="1"/>
-          <p:nvPr/>
-        </p:nvSpPr>
-        <p:spPr>
-          <a:xfrm>
-            <a:off x="4114800" y="4745736"/>
-            <a:ext cx="2011680" cy="274320"/>
-          </a:xfrm>
-          <a:prstGeom prst="rect">
-            <a:avLst/>
-          </a:prstGeom>
-          <a:noFill/>
-        </p:spPr>
-        <p:txBody>
-          <a:bodyPr wrap="square" lIns="0" rIns="0" tIns="0" bIns="0">
-            <a:spAutoFit/>
-          </a:bodyPr>
-          <a:lstStyle/>
-          <a:p>
-            <a:pPr algn="l"/>
-            <a:r>
-              <a:rPr sz="900" b="0" i="0">
-                <a:solidFill>
-                  <a:srgbClr val="CADCFC"/>
-                </a:solidFill>
-                <a:latin typeface="Arial"/>
-              </a:rPr>
-              <a:t>K-State -17.5 → K-State -19.5</a:t>
-            </a:r>
-          </a:p>
-        </p:txBody>
-      </p:sp>
-      <p:sp>
-        <p:nvSpPr>
-          <p:cNvPr id="85" name="TextBox 84"/>
-          <p:cNvSpPr txBox="1"/>
-          <p:nvPr/>
-        </p:nvSpPr>
-        <p:spPr>
-          <a:xfrm>
-            <a:off x="6172200" y="4736592"/>
-            <a:ext cx="502920" cy="274320"/>
-          </a:xfrm>
-          <a:prstGeom prst="rect">
-            <a:avLst/>
-          </a:prstGeom>
-          <a:noFill/>
-        </p:spPr>
-        <p:txBody>
-          <a:bodyPr wrap="square" lIns="0" rIns="0" tIns="0" bIns="0">
-            <a:spAutoFit/>
-          </a:bodyPr>
-          <a:lstStyle/>
-          <a:p>
-            <a:pPr algn="r"/>
-            <a:r>
-              <a:rPr sz="1000" b="1" i="0">
-                <a:solidFill>
-                  <a:srgbClr val="FF7A7A"/>
-                </a:solidFill>
-                <a:latin typeface="Arial"/>
-              </a:rPr>
-              <a:t>-2</a:t>
-            </a:r>
-          </a:p>
-        </p:txBody>
-      </p:sp>
-      <p:sp>
-        <p:nvSpPr>
-          <p:cNvPr id="86" name="TextBox 85"/>
-          <p:cNvSpPr txBox="1"/>
-          <p:nvPr/>
-        </p:nvSpPr>
-        <p:spPr>
-          <a:xfrm>
-            <a:off x="6720840" y="4736592"/>
-            <a:ext cx="1188720" cy="274320"/>
-          </a:xfrm>
-          <a:prstGeom prst="rect">
-            <a:avLst/>
-          </a:prstGeom>
-          <a:noFill/>
-        </p:spPr>
-        <p:txBody>
-          <a:bodyPr wrap="square" lIns="0" rIns="0" tIns="0" bIns="0">
-            <a:spAutoFit/>
-          </a:bodyPr>
-          <a:lstStyle/>
-          <a:p>
-            <a:pPr algn="r"/>
-            <a:r>
-              <a:rPr sz="1000" b="0" i="0">
-                <a:solidFill>
-                  <a:srgbClr val="FFFFFF"/>
-                </a:solidFill>
-                <a:latin typeface="Arial"/>
-              </a:rPr>
-              <a:t>+11.2</a:t>
-            </a:r>
-          </a:p>
-        </p:txBody>
-      </p:sp>
-      <p:sp>
-        <p:nvSpPr>
-          <p:cNvPr id="87" name="TextBox 86"/>
-          <p:cNvSpPr txBox="1"/>
-          <p:nvPr/>
-        </p:nvSpPr>
-        <p:spPr>
-          <a:xfrm>
-            <a:off x="7955279" y="4736592"/>
-            <a:ext cx="548640" cy="274320"/>
-          </a:xfrm>
-          <a:prstGeom prst="rect">
-            <a:avLst/>
-          </a:prstGeom>
-          <a:noFill/>
-        </p:spPr>
-        <p:txBody>
-          <a:bodyPr wrap="square" lIns="0" rIns="0" tIns="0" bIns="0">
-            <a:spAutoFit/>
-          </a:bodyPr>
-          <a:lstStyle/>
-          <a:p>
-            <a:pPr algn="r"/>
-            <a:r>
-              <a:rPr sz="1050" b="1" i="0">
-                <a:solidFill>
-                  <a:srgbClr val="F47321"/>
-                </a:solidFill>
-                <a:latin typeface="Arial"/>
-              </a:rPr>
-              <a:t>6.3</a:t>
-            </a:r>
-          </a:p>
-        </p:txBody>
-      </p:sp>
-      <p:sp>
-        <p:nvSpPr>
-          <p:cNvPr id="88" name="TextBox 87"/>
-          <p:cNvSpPr txBox="1"/>
-          <p:nvPr/>
-        </p:nvSpPr>
-        <p:spPr>
-          <a:xfrm>
-            <a:off x="8641080" y="4736592"/>
-            <a:ext cx="1508760" cy="274320"/>
-          </a:xfrm>
-          <a:prstGeom prst="rect">
-            <a:avLst/>
-          </a:prstGeom>
-          <a:noFill/>
-        </p:spPr>
-        <p:txBody>
-          <a:bodyPr wrap="square" lIns="0" rIns="0" tIns="0" bIns="0">
-            <a:spAutoFit/>
-          </a:bodyPr>
-          <a:lstStyle/>
-          <a:p>
-            <a:pPr algn="l"/>
-            <a:r>
-              <a:rPr sz="1000" b="0" i="0">
-                <a:solidFill>
-                  <a:srgbClr val="FFFFFF"/>
-                </a:solidFill>
-                <a:latin typeface="Arial"/>
-              </a:rPr>
-              <a:t>Washington State</a:t>
-            </a:r>
-          </a:p>
-        </p:txBody>
-      </p:sp>
-      <p:sp>
-        <p:nvSpPr>
-          <p:cNvPr id="89" name="TextBox 88"/>
-          <p:cNvSpPr txBox="1"/>
-          <p:nvPr/>
-        </p:nvSpPr>
-        <p:spPr>
-          <a:xfrm>
-            <a:off x="10195560" y="4745736"/>
-            <a:ext cx="1143000" cy="274320"/>
-          </a:xfrm>
-          <a:prstGeom prst="rect">
-            <a:avLst/>
-          </a:prstGeom>
-          <a:noFill/>
-        </p:spPr>
-        <p:txBody>
-          <a:bodyPr wrap="square" lIns="0" rIns="0" tIns="0" bIns="0">
-            <a:spAutoFit/>
-          </a:bodyPr>
-          <a:lstStyle/>
-          <a:p>
-            <a:pPr algn="r"/>
-            <a:r>
-              <a:rPr sz="900" b="0" i="0">
-                <a:solidFill>
-                  <a:srgbClr val="CADCFC"/>
-                </a:solidFill>
-                <a:latin typeface="Arial"/>
-              </a:rPr>
-              <a:t>48.5</a:t>
-            </a:r>
-          </a:p>
-        </p:txBody>
-      </p:sp>
-      <p:sp>
-        <p:nvSpPr>
-          <p:cNvPr id="90" name="Rounded Rectangle 89"/>
-          <p:cNvSpPr/>
-          <p:nvPr/>
-        </p:nvSpPr>
-        <p:spPr>
-          <a:xfrm>
-            <a:off x="822960" y="5138928"/>
-            <a:ext cx="10515600" cy="566928"/>
-          </a:xfrm>
-          <a:prstGeom prst="roundRect">
-            <a:avLst/>
-          </a:prstGeom>
-          <a:solidFill>
-            <a:srgbClr val="123568"/>
-          </a:solidFill>
-          <a:ln>
-            <a:noFill/>
-          </a:ln>
-          <a:effectLst/>
-        </p:spPr>
-        <p:style>
-          <a:lnRef idx="1">
-            <a:schemeClr val="accent1"/>
-          </a:lnRef>
-          <a:fillRef idx="3">
-            <a:schemeClr val="accent1"/>
-          </a:fillRef>
-          <a:effectRef idx="2">
-            <a:schemeClr val="accent1"/>
-          </a:effectRef>
-          <a:fontRef idx="minor">
-            <a:schemeClr val="lt1"/>
-          </a:fontRef>
-        </p:style>
-        <p:txBody>
-          <a:bodyPr rtlCol="0" anchor="ctr"/>
-          <a:lstStyle/>
-          <a:p>
-            <a:pPr algn="ctr"/>
-          </a:p>
-        </p:txBody>
-      </p:sp>
-      <p:sp>
-        <p:nvSpPr>
-          <p:cNvPr id="91" name="TextBox 90"/>
-          <p:cNvSpPr txBox="1"/>
-          <p:nvPr/>
-        </p:nvSpPr>
-        <p:spPr>
-          <a:xfrm>
-            <a:off x="1005840" y="5193792"/>
-            <a:ext cx="10241280" cy="256032"/>
-          </a:xfrm>
-          <a:prstGeom prst="rect">
-            <a:avLst/>
-          </a:prstGeom>
-          <a:noFill/>
-        </p:spPr>
-        <p:txBody>
-          <a:bodyPr wrap="square" lIns="0" rIns="0" tIns="0" bIns="0">
-            <a:spAutoFit/>
-          </a:bodyPr>
-          <a:lstStyle/>
-          <a:p>
-            <a:pPr algn="l"/>
-            <a:r>
-              <a:rPr sz="950" b="1" i="0">
-                <a:solidFill>
-                  <a:srgbClr val="FFFFFF"/>
-                </a:solidFill>
-                <a:latin typeface="Arial"/>
-              </a:rPr>
-              <a:t>Scorecard 2026 (vs first-seen lines): 41 alerts · model side 19-5-1 ATS · RED dogs outright 1-2 · avg CLV +2.04 · beat/tie/lost the close 8-1-16 · 16 pending</a:t>
-            </a:r>
-          </a:p>
-        </p:txBody>
-      </p:sp>
-      <p:sp>
-        <p:nvSpPr>
-          <p:cNvPr id="92" name="TextBox 91"/>
-          <p:cNvSpPr txBox="1"/>
-          <p:nvPr/>
-        </p:nvSpPr>
-        <p:spPr>
-          <a:xfrm>
-            <a:off x="1005840" y="5431536"/>
-            <a:ext cx="10241280" cy="256032"/>
-          </a:xfrm>
-          <a:prstGeom prst="rect">
-            <a:avLst/>
-          </a:prstGeom>
-          <a:noFill/>
-        </p:spPr>
-        <p:txBody>
-          <a:bodyPr wrap="square" lIns="0" rIns="0" tIns="0" bIns="0">
-            <a:spAutoFit/>
-          </a:bodyPr>
-          <a:lstStyle/>
-          <a:p>
-            <a:pPr algn="l"/>
-            <a:r>
-              <a:rPr sz="850" b="0" i="0">
-                <a:solidFill>
-                  <a:srgbClr val="CADCFC"/>
-                </a:solidFill>
-                <a:latin typeface="Arial"/>
-              </a:rPr>
-              <a:t>Backtest 2023–25: these rules ran 49.7% ATS — a research shortlist and a narrative engine, not a bet slip · RED dogs at +401 or longer on the road are ATS-only (longshot moneylines bled −22.9% ROI 2021–25)</a:t>
-            </a:r>
-          </a:p>
-        </p:txBody>
-      </p:sp>
-    </p:spTree>
-  </p:cSld>
-  <p:clrMapOvr>
-    <a:masterClrMapping/>
-  </p:clrMapOvr>
-</p:sld>
-</file>
-
-<file path=ppt/slides/slide22.xml><?xml version="1.0" encoding="utf-8"?>
 <p:sld xmlns:a="http://schemas.openxmlformats.org/drawingml/2006/main" xmlns:p="http://schemas.openxmlformats.org/presentationml/2006/main" xmlns:r="http://schemas.openxmlformats.org/officeDocument/2006/relationships">
   <p:cSld>
     <p:bg>

</xml_diff>

<commit_message>
Ep3 Heisman slide: top 5 with a one-line explanation per player (HEISMAN_WHY), next-up line; notes to match
Co-Authored-By: Claude Fable 5.1 <noreply@anthropic.com>
</commit_message>
<xml_diff>
--- a/decks/2026_Week2_Episode3.pptx
+++ b/decks/2026_Week2_Episode3.pptx
@@ -26735,7 +26735,7 @@
         <p:spPr>
           <a:xfrm>
             <a:off x="822960" y="1901952"/>
-            <a:ext cx="10515600" cy="329184"/>
+            <a:ext cx="10515600" cy="566928"/>
           </a:xfrm>
           <a:prstGeom prst="rect">
             <a:avLst/>
@@ -26881,6 +26881,41 @@
         </p:nvSpPr>
         <p:spPr>
           <a:xfrm>
+            <a:off x="1600200" y="2203704"/>
+            <a:ext cx="9692640" cy="256032"/>
+          </a:xfrm>
+          <a:prstGeom prst="rect">
+            <a:avLst/>
+          </a:prstGeom>
+          <a:noFill/>
+        </p:spPr>
+        <p:txBody>
+          <a:bodyPr wrap="square" lIns="0" rIns="0" tIns="0" bIns="0">
+            <a:spAutoFit/>
+          </a:bodyPr>
+          <a:lstStyle/>
+          <a:p>
+            <a:pPr algn="l"/>
+            <a:r>
+              <a:rPr sz="950" b="0" i="0">
+                <a:solidFill>
+                  <a:srgbClr val="CADCFC"/>
+                </a:solidFill>
+                <a:latin typeface="Arial"/>
+              </a:rPr>
+              <a:t>Best returning efficiency in the sport (0.545 in 2025, No. 1 in success rate) on a title favorite — the market has him 8th at +1400</a:t>
+            </a:r>
+          </a:p>
+        </p:txBody>
+      </p:sp>
+      <p:sp>
+        <p:nvSpPr>
+          <p:cNvPr id="19" name="TextBox 18"/>
+          <p:cNvSpPr txBox="1"/>
+          <p:nvPr/>
+        </p:nvSpPr>
+        <p:spPr>
+          <a:xfrm>
             <a:off x="1600200" y="1938528"/>
             <a:ext cx="2468880" cy="274320"/>
           </a:xfrm>
@@ -26910,7 +26945,7 @@
       </p:sp>
       <p:sp>
         <p:nvSpPr>
-          <p:cNvPr id="19" name="TextBox 18"/>
+          <p:cNvPr id="20" name="TextBox 19"/>
           <p:cNvSpPr txBox="1"/>
           <p:nvPr/>
         </p:nvSpPr>
@@ -26945,7 +26980,7 @@
       </p:sp>
       <p:sp>
         <p:nvSpPr>
-          <p:cNvPr id="20" name="TextBox 19"/>
+          <p:cNvPr id="21" name="TextBox 20"/>
           <p:cNvSpPr txBox="1"/>
           <p:nvPr/>
         </p:nvSpPr>
@@ -26980,7 +27015,7 @@
       </p:sp>
       <p:sp>
         <p:nvSpPr>
-          <p:cNvPr id="21" name="TextBox 20"/>
+          <p:cNvPr id="22" name="TextBox 21"/>
           <p:cNvSpPr txBox="1"/>
           <p:nvPr/>
         </p:nvSpPr>
@@ -27015,7 +27050,7 @@
       </p:sp>
       <p:sp>
         <p:nvSpPr>
-          <p:cNvPr id="22" name="TextBox 21"/>
+          <p:cNvPr id="23" name="TextBox 22"/>
           <p:cNvSpPr txBox="1"/>
           <p:nvPr/>
         </p:nvSpPr>
@@ -27050,7 +27085,7 @@
       </p:sp>
       <p:sp>
         <p:nvSpPr>
-          <p:cNvPr id="23" name="TextBox 22"/>
+          <p:cNvPr id="24" name="TextBox 23"/>
           <p:cNvSpPr txBox="1"/>
           <p:nvPr/>
         </p:nvSpPr>
@@ -27085,7 +27120,7 @@
       </p:sp>
       <p:sp>
         <p:nvSpPr>
-          <p:cNvPr id="24" name="TextBox 23"/>
+          <p:cNvPr id="25" name="TextBox 24"/>
           <p:cNvSpPr txBox="1"/>
           <p:nvPr/>
         </p:nvSpPr>
@@ -27120,7 +27155,7 @@
       </p:sp>
       <p:sp>
         <p:nvSpPr>
-          <p:cNvPr id="25" name="TextBox 24"/>
+          <p:cNvPr id="26" name="TextBox 25"/>
           <p:cNvSpPr txBox="1"/>
           <p:nvPr/>
         </p:nvSpPr>
@@ -27155,7 +27190,7 @@
       </p:sp>
       <p:sp>
         <p:nvSpPr>
-          <p:cNvPr id="26" name="TextBox 25"/>
+          <p:cNvPr id="27" name="TextBox 26"/>
           <p:cNvSpPr txBox="1"/>
           <p:nvPr/>
         </p:nvSpPr>
@@ -27190,13 +27225,13 @@
       </p:sp>
       <p:sp>
         <p:nvSpPr>
-          <p:cNvPr id="27" name="TextBox 26"/>
-          <p:cNvSpPr txBox="1"/>
-          <p:nvPr/>
-        </p:nvSpPr>
-        <p:spPr>
-          <a:xfrm>
-            <a:off x="822960" y="2267712"/>
+          <p:cNvPr id="28" name="TextBox 27"/>
+          <p:cNvSpPr txBox="1"/>
+          <p:nvPr/>
+        </p:nvSpPr>
+        <p:spPr>
+          <a:xfrm>
+            <a:off x="822960" y="2505456"/>
             <a:ext cx="365760" cy="274320"/>
           </a:xfrm>
           <a:prstGeom prst="rect">
@@ -27225,13 +27260,13 @@
       </p:sp>
       <p:sp>
         <p:nvSpPr>
-          <p:cNvPr id="28" name="Oval 27"/>
+          <p:cNvPr id="29" name="Oval 28"/>
           <p:cNvSpPr/>
           <p:nvPr/>
         </p:nvSpPr>
         <p:spPr>
           <a:xfrm>
-            <a:off x="1234440" y="2258568"/>
+            <a:off x="1234440" y="2496312"/>
             <a:ext cx="274320" cy="274320"/>
           </a:xfrm>
           <a:prstGeom prst="ellipse">
@@ -27269,7 +27304,7 @@
       </p:sp>
       <p:pic>
         <p:nvPicPr>
-          <p:cNvPr id="29" name="Picture 28" descr="miami.png"/>
+          <p:cNvPr id="30" name="Picture 29" descr="miami.png"/>
           <p:cNvPicPr>
             <a:picLocks noChangeAspect="1"/>
           </p:cNvPicPr>
@@ -27283,7 +27318,7 @@
         </p:blipFill>
         <p:spPr>
           <a:xfrm>
-            <a:off x="1266444" y="2290572"/>
+            <a:off x="1266444" y="2528316"/>
             <a:ext cx="210312" cy="210312"/>
           </a:xfrm>
           <a:prstGeom prst="rect">
@@ -27293,13 +27328,48 @@
       </p:pic>
       <p:sp>
         <p:nvSpPr>
-          <p:cNvPr id="30" name="TextBox 29"/>
-          <p:cNvSpPr txBox="1"/>
-          <p:nvPr/>
-        </p:nvSpPr>
-        <p:spPr>
-          <a:xfrm>
-            <a:off x="1600200" y="2267712"/>
+          <p:cNvPr id="31" name="TextBox 30"/>
+          <p:cNvSpPr txBox="1"/>
+          <p:nvPr/>
+        </p:nvSpPr>
+        <p:spPr>
+          <a:xfrm>
+            <a:off x="1600200" y="2770632"/>
+            <a:ext cx="9692640" cy="256032"/>
+          </a:xfrm>
+          <a:prstGeom prst="rect">
+            <a:avLst/>
+          </a:prstGeom>
+          <a:noFill/>
+        </p:spPr>
+        <p:txBody>
+          <a:bodyPr wrap="square" lIns="0" rIns="0" tIns="0" bIns="0">
+            <a:spAutoFit/>
+          </a:bodyPr>
+          <a:lstStyle/>
+          <a:p>
+            <a:pPr algn="l"/>
+            <a:r>
+              <a:rPr sz="950" b="0" i="0">
+                <a:solidFill>
+                  <a:srgbClr val="CADCFC"/>
+                </a:solidFill>
+                <a:latin typeface="Arial"/>
+              </a:rPr>
+              <a:t>401 yards, 5 TD, 90% at Stanford — but the prior is a Duke season (0.371); Miami's 74% P(10+) is the best team factor on the board</a:t>
+            </a:r>
+          </a:p>
+        </p:txBody>
+      </p:sp>
+      <p:sp>
+        <p:nvSpPr>
+          <p:cNvPr id="32" name="TextBox 31"/>
+          <p:cNvSpPr txBox="1"/>
+          <p:nvPr/>
+        </p:nvSpPr>
+        <p:spPr>
+          <a:xfrm>
+            <a:off x="1600200" y="2505456"/>
             <a:ext cx="2468880" cy="274320"/>
           </a:xfrm>
           <a:prstGeom prst="rect">
@@ -27328,13 +27398,13 @@
       </p:sp>
       <p:sp>
         <p:nvSpPr>
-          <p:cNvPr id="31" name="TextBox 30"/>
-          <p:cNvSpPr txBox="1"/>
-          <p:nvPr/>
-        </p:nvSpPr>
-        <p:spPr>
-          <a:xfrm>
-            <a:off x="4114800" y="2276856"/>
+          <p:cNvPr id="33" name="TextBox 32"/>
+          <p:cNvSpPr txBox="1"/>
+          <p:nvPr/>
+        </p:nvSpPr>
+        <p:spPr>
+          <a:xfrm>
+            <a:off x="4114800" y="2514600"/>
             <a:ext cx="1097280" cy="274320"/>
           </a:xfrm>
           <a:prstGeom prst="rect">
@@ -27363,13 +27433,13 @@
       </p:sp>
       <p:sp>
         <p:nvSpPr>
-          <p:cNvPr id="32" name="TextBox 31"/>
-          <p:cNvSpPr txBox="1"/>
-          <p:nvPr/>
-        </p:nvSpPr>
-        <p:spPr>
-          <a:xfrm>
-            <a:off x="5257800" y="2276856"/>
+          <p:cNvPr id="34" name="TextBox 33"/>
+          <p:cNvSpPr txBox="1"/>
+          <p:nvPr/>
+        </p:nvSpPr>
+        <p:spPr>
+          <a:xfrm>
+            <a:off x="5257800" y="2514600"/>
             <a:ext cx="731520" cy="274320"/>
           </a:xfrm>
           <a:prstGeom prst="rect">
@@ -27398,13 +27468,13 @@
       </p:sp>
       <p:sp>
         <p:nvSpPr>
-          <p:cNvPr id="33" name="TextBox 32"/>
-          <p:cNvSpPr txBox="1"/>
-          <p:nvPr/>
-        </p:nvSpPr>
-        <p:spPr>
-          <a:xfrm>
-            <a:off x="6035040" y="2276856"/>
+          <p:cNvPr id="35" name="TextBox 34"/>
+          <p:cNvSpPr txBox="1"/>
+          <p:nvPr/>
+        </p:nvSpPr>
+        <p:spPr>
+          <a:xfrm>
+            <a:off x="6035040" y="2514600"/>
             <a:ext cx="640080" cy="274320"/>
           </a:xfrm>
           <a:prstGeom prst="rect">
@@ -27433,13 +27503,13 @@
       </p:sp>
       <p:sp>
         <p:nvSpPr>
-          <p:cNvPr id="34" name="TextBox 33"/>
-          <p:cNvSpPr txBox="1"/>
-          <p:nvPr/>
-        </p:nvSpPr>
-        <p:spPr>
-          <a:xfrm>
-            <a:off x="6720840" y="2276856"/>
+          <p:cNvPr id="36" name="TextBox 35"/>
+          <p:cNvSpPr txBox="1"/>
+          <p:nvPr/>
+        </p:nvSpPr>
+        <p:spPr>
+          <a:xfrm>
+            <a:off x="6720840" y="2514600"/>
             <a:ext cx="822960" cy="274320"/>
           </a:xfrm>
           <a:prstGeom prst="rect">
@@ -27468,13 +27538,13 @@
       </p:sp>
       <p:sp>
         <p:nvSpPr>
-          <p:cNvPr id="35" name="TextBox 34"/>
-          <p:cNvSpPr txBox="1"/>
-          <p:nvPr/>
-        </p:nvSpPr>
-        <p:spPr>
-          <a:xfrm>
-            <a:off x="7589520" y="2267712"/>
+          <p:cNvPr id="37" name="TextBox 36"/>
+          <p:cNvSpPr txBox="1"/>
+          <p:nvPr/>
+        </p:nvSpPr>
+        <p:spPr>
+          <a:xfrm>
+            <a:off x="7589520" y="2505456"/>
             <a:ext cx="640080" cy="274320"/>
           </a:xfrm>
           <a:prstGeom prst="rect">
@@ -27503,13 +27573,13 @@
       </p:sp>
       <p:sp>
         <p:nvSpPr>
-          <p:cNvPr id="36" name="TextBox 35"/>
-          <p:cNvSpPr txBox="1"/>
-          <p:nvPr/>
-        </p:nvSpPr>
-        <p:spPr>
-          <a:xfrm>
-            <a:off x="8275320" y="2276856"/>
+          <p:cNvPr id="38" name="TextBox 37"/>
+          <p:cNvSpPr txBox="1"/>
+          <p:nvPr/>
+        </p:nvSpPr>
+        <p:spPr>
+          <a:xfrm>
+            <a:off x="8275320" y="2514600"/>
             <a:ext cx="822960" cy="274320"/>
           </a:xfrm>
           <a:prstGeom prst="rect">
@@ -27538,13 +27608,13 @@
       </p:sp>
       <p:sp>
         <p:nvSpPr>
-          <p:cNvPr id="37" name="TextBox 36"/>
-          <p:cNvSpPr txBox="1"/>
-          <p:nvPr/>
-        </p:nvSpPr>
-        <p:spPr>
-          <a:xfrm>
-            <a:off x="9144000" y="2276856"/>
+          <p:cNvPr id="39" name="TextBox 38"/>
+          <p:cNvSpPr txBox="1"/>
+          <p:nvPr/>
+        </p:nvSpPr>
+        <p:spPr>
+          <a:xfrm>
+            <a:off x="9144000" y="2514600"/>
             <a:ext cx="822960" cy="274320"/>
           </a:xfrm>
           <a:prstGeom prst="rect">
@@ -27573,13 +27643,13 @@
       </p:sp>
       <p:sp>
         <p:nvSpPr>
-          <p:cNvPr id="38" name="TextBox 37"/>
-          <p:cNvSpPr txBox="1"/>
-          <p:nvPr/>
-        </p:nvSpPr>
-        <p:spPr>
-          <a:xfrm>
-            <a:off x="10012680" y="2276856"/>
+          <p:cNvPr id="40" name="TextBox 39"/>
+          <p:cNvSpPr txBox="1"/>
+          <p:nvPr/>
+        </p:nvSpPr>
+        <p:spPr>
+          <a:xfrm>
+            <a:off x="10012680" y="2514600"/>
             <a:ext cx="1325880" cy="274320"/>
           </a:xfrm>
           <a:prstGeom prst="rect">
@@ -27608,14 +27678,14 @@
       </p:sp>
       <p:sp>
         <p:nvSpPr>
-          <p:cNvPr id="39" name="Rectangle 38"/>
+          <p:cNvPr id="41" name="Rectangle 40"/>
           <p:cNvSpPr/>
           <p:nvPr/>
         </p:nvSpPr>
         <p:spPr>
           <a:xfrm>
-            <a:off x="822960" y="2560320"/>
-            <a:ext cx="10515600" cy="329184"/>
+            <a:off x="822960" y="3035808"/>
+            <a:ext cx="10515600" cy="566928"/>
           </a:xfrm>
           <a:prstGeom prst="rect">
             <a:avLst/>
@@ -27652,13 +27722,13 @@
       </p:sp>
       <p:sp>
         <p:nvSpPr>
-          <p:cNvPr id="40" name="TextBox 39"/>
-          <p:cNvSpPr txBox="1"/>
-          <p:nvPr/>
-        </p:nvSpPr>
-        <p:spPr>
-          <a:xfrm>
-            <a:off x="822960" y="2596896"/>
+          <p:cNvPr id="42" name="TextBox 41"/>
+          <p:cNvSpPr txBox="1"/>
+          <p:nvPr/>
+        </p:nvSpPr>
+        <p:spPr>
+          <a:xfrm>
+            <a:off x="822960" y="3072384"/>
             <a:ext cx="365760" cy="274320"/>
           </a:xfrm>
           <a:prstGeom prst="rect">
@@ -27687,13 +27757,13 @@
       </p:sp>
       <p:sp>
         <p:nvSpPr>
-          <p:cNvPr id="41" name="Oval 40"/>
+          <p:cNvPr id="43" name="Oval 42"/>
           <p:cNvSpPr/>
           <p:nvPr/>
         </p:nvSpPr>
         <p:spPr>
           <a:xfrm>
-            <a:off x="1234440" y="2587751"/>
+            <a:off x="1234440" y="3063240"/>
             <a:ext cx="274320" cy="274320"/>
           </a:xfrm>
           <a:prstGeom prst="ellipse">
@@ -27731,7 +27801,7 @@
       </p:sp>
       <p:pic>
         <p:nvPicPr>
-          <p:cNvPr id="42" name="Picture 41" descr="notredame.png"/>
+          <p:cNvPr id="44" name="Picture 43" descr="notredame.png"/>
           <p:cNvPicPr>
             <a:picLocks noChangeAspect="1"/>
           </p:cNvPicPr>
@@ -27745,7 +27815,7 @@
         </p:blipFill>
         <p:spPr>
           <a:xfrm>
-            <a:off x="1266444" y="2619756"/>
+            <a:off x="1266444" y="3095244"/>
             <a:ext cx="210312" cy="210312"/>
           </a:xfrm>
           <a:prstGeom prst="rect">
@@ -27755,13 +27825,48 @@
       </p:pic>
       <p:sp>
         <p:nvSpPr>
-          <p:cNvPr id="43" name="TextBox 42"/>
-          <p:cNvSpPr txBox="1"/>
-          <p:nvPr/>
-        </p:nvSpPr>
-        <p:spPr>
-          <a:xfrm>
-            <a:off x="1600200" y="2596896"/>
+          <p:cNvPr id="45" name="TextBox 44"/>
+          <p:cNvSpPr txBox="1"/>
+          <p:nvPr/>
+        </p:nvSpPr>
+        <p:spPr>
+          <a:xfrm>
+            <a:off x="1600200" y="3337560"/>
+            <a:ext cx="9692640" cy="256032"/>
+          </a:xfrm>
+          <a:prstGeom prst="rect">
+            <a:avLst/>
+          </a:prstGeom>
+          <a:noFill/>
+        </p:spPr>
+        <p:txBody>
+          <a:bodyPr wrap="square" lIns="0" rIns="0" tIns="0" bIns="0">
+            <a:spAutoFit/>
+          </a:bodyPr>
+          <a:lstStyle/>
+          <a:p>
+            <a:pPr algn="l"/>
+            <a:r>
+              <a:rPr sz="950" b="0" i="0">
+                <a:solidFill>
+                  <a:srgbClr val="CADCFC"/>
+                </a:solidFill>
+                <a:latin typeface="Arial"/>
+              </a:rPr>
+              <a:t>Carried by the team: Notre Dame's 91% P(10+) is the board's highest; the efficiency line is average so far (0.398 on 31 plays, 0.433 prior)</a:t>
+            </a:r>
+          </a:p>
+        </p:txBody>
+      </p:sp>
+      <p:sp>
+        <p:nvSpPr>
+          <p:cNvPr id="46" name="TextBox 45"/>
+          <p:cNvSpPr txBox="1"/>
+          <p:nvPr/>
+        </p:nvSpPr>
+        <p:spPr>
+          <a:xfrm>
+            <a:off x="1600200" y="3072384"/>
             <a:ext cx="2468880" cy="274320"/>
           </a:xfrm>
           <a:prstGeom prst="rect">
@@ -27790,13 +27895,13 @@
       </p:sp>
       <p:sp>
         <p:nvSpPr>
-          <p:cNvPr id="44" name="TextBox 43"/>
-          <p:cNvSpPr txBox="1"/>
-          <p:nvPr/>
-        </p:nvSpPr>
-        <p:spPr>
-          <a:xfrm>
-            <a:off x="4114800" y="2606039"/>
+          <p:cNvPr id="47" name="TextBox 46"/>
+          <p:cNvSpPr txBox="1"/>
+          <p:nvPr/>
+        </p:nvSpPr>
+        <p:spPr>
+          <a:xfrm>
+            <a:off x="4114800" y="3081528"/>
             <a:ext cx="1097280" cy="274320"/>
           </a:xfrm>
           <a:prstGeom prst="rect">
@@ -27825,13 +27930,13 @@
       </p:sp>
       <p:sp>
         <p:nvSpPr>
-          <p:cNvPr id="45" name="TextBox 44"/>
-          <p:cNvSpPr txBox="1"/>
-          <p:nvPr/>
-        </p:nvSpPr>
-        <p:spPr>
-          <a:xfrm>
-            <a:off x="5257800" y="2606039"/>
+          <p:cNvPr id="48" name="TextBox 47"/>
+          <p:cNvSpPr txBox="1"/>
+          <p:nvPr/>
+        </p:nvSpPr>
+        <p:spPr>
+          <a:xfrm>
+            <a:off x="5257800" y="3081528"/>
             <a:ext cx="731520" cy="274320"/>
           </a:xfrm>
           <a:prstGeom prst="rect">
@@ -27860,13 +27965,13 @@
       </p:sp>
       <p:sp>
         <p:nvSpPr>
-          <p:cNvPr id="46" name="TextBox 45"/>
-          <p:cNvSpPr txBox="1"/>
-          <p:nvPr/>
-        </p:nvSpPr>
-        <p:spPr>
-          <a:xfrm>
-            <a:off x="6035040" y="2606039"/>
+          <p:cNvPr id="49" name="TextBox 48"/>
+          <p:cNvSpPr txBox="1"/>
+          <p:nvPr/>
+        </p:nvSpPr>
+        <p:spPr>
+          <a:xfrm>
+            <a:off x="6035040" y="3081528"/>
             <a:ext cx="640080" cy="274320"/>
           </a:xfrm>
           <a:prstGeom prst="rect">
@@ -27895,13 +28000,13 @@
       </p:sp>
       <p:sp>
         <p:nvSpPr>
-          <p:cNvPr id="47" name="TextBox 46"/>
-          <p:cNvSpPr txBox="1"/>
-          <p:nvPr/>
-        </p:nvSpPr>
-        <p:spPr>
-          <a:xfrm>
-            <a:off x="6720840" y="2606039"/>
+          <p:cNvPr id="50" name="TextBox 49"/>
+          <p:cNvSpPr txBox="1"/>
+          <p:nvPr/>
+        </p:nvSpPr>
+        <p:spPr>
+          <a:xfrm>
+            <a:off x="6720840" y="3081528"/>
             <a:ext cx="822960" cy="274320"/>
           </a:xfrm>
           <a:prstGeom prst="rect">
@@ -27930,13 +28035,13 @@
       </p:sp>
       <p:sp>
         <p:nvSpPr>
-          <p:cNvPr id="48" name="TextBox 47"/>
-          <p:cNvSpPr txBox="1"/>
-          <p:nvPr/>
-        </p:nvSpPr>
-        <p:spPr>
-          <a:xfrm>
-            <a:off x="7589520" y="2596896"/>
+          <p:cNvPr id="51" name="TextBox 50"/>
+          <p:cNvSpPr txBox="1"/>
+          <p:nvPr/>
+        </p:nvSpPr>
+        <p:spPr>
+          <a:xfrm>
+            <a:off x="7589520" y="3072384"/>
             <a:ext cx="640080" cy="274320"/>
           </a:xfrm>
           <a:prstGeom prst="rect">
@@ -27965,13 +28070,13 @@
       </p:sp>
       <p:sp>
         <p:nvSpPr>
-          <p:cNvPr id="49" name="TextBox 48"/>
-          <p:cNvSpPr txBox="1"/>
-          <p:nvPr/>
-        </p:nvSpPr>
-        <p:spPr>
-          <a:xfrm>
-            <a:off x="8275320" y="2606039"/>
+          <p:cNvPr id="52" name="TextBox 51"/>
+          <p:cNvSpPr txBox="1"/>
+          <p:nvPr/>
+        </p:nvSpPr>
+        <p:spPr>
+          <a:xfrm>
+            <a:off x="8275320" y="3081528"/>
             <a:ext cx="822960" cy="274320"/>
           </a:xfrm>
           <a:prstGeom prst="rect">
@@ -28000,13 +28105,13 @@
       </p:sp>
       <p:sp>
         <p:nvSpPr>
-          <p:cNvPr id="50" name="TextBox 49"/>
-          <p:cNvSpPr txBox="1"/>
-          <p:nvPr/>
-        </p:nvSpPr>
-        <p:spPr>
-          <a:xfrm>
-            <a:off x="9144000" y="2606039"/>
+          <p:cNvPr id="53" name="TextBox 52"/>
+          <p:cNvSpPr txBox="1"/>
+          <p:nvPr/>
+        </p:nvSpPr>
+        <p:spPr>
+          <a:xfrm>
+            <a:off x="9144000" y="3081528"/>
             <a:ext cx="822960" cy="274320"/>
           </a:xfrm>
           <a:prstGeom prst="rect">
@@ -28035,13 +28140,13 @@
       </p:sp>
       <p:sp>
         <p:nvSpPr>
-          <p:cNvPr id="51" name="TextBox 50"/>
-          <p:cNvSpPr txBox="1"/>
-          <p:nvPr/>
-        </p:nvSpPr>
-        <p:spPr>
-          <a:xfrm>
-            <a:off x="10012680" y="2606039"/>
+          <p:cNvPr id="54" name="TextBox 53"/>
+          <p:cNvSpPr txBox="1"/>
+          <p:nvPr/>
+        </p:nvSpPr>
+        <p:spPr>
+          <a:xfrm>
+            <a:off x="10012680" y="3081528"/>
             <a:ext cx="1325880" cy="274320"/>
           </a:xfrm>
           <a:prstGeom prst="rect">
@@ -28070,13 +28175,13 @@
       </p:sp>
       <p:sp>
         <p:nvSpPr>
-          <p:cNvPr id="52" name="TextBox 51"/>
-          <p:cNvSpPr txBox="1"/>
-          <p:nvPr/>
-        </p:nvSpPr>
-        <p:spPr>
-          <a:xfrm>
-            <a:off x="822960" y="2926080"/>
+          <p:cNvPr id="55" name="TextBox 54"/>
+          <p:cNvSpPr txBox="1"/>
+          <p:nvPr/>
+        </p:nvSpPr>
+        <p:spPr>
+          <a:xfrm>
+            <a:off x="822960" y="3639312"/>
             <a:ext cx="365760" cy="274320"/>
           </a:xfrm>
           <a:prstGeom prst="rect">
@@ -28105,13 +28210,13 @@
       </p:sp>
       <p:sp>
         <p:nvSpPr>
-          <p:cNvPr id="53" name="Oval 52"/>
+          <p:cNvPr id="56" name="Oval 55"/>
           <p:cNvSpPr/>
           <p:nvPr/>
         </p:nvSpPr>
         <p:spPr>
           <a:xfrm>
-            <a:off x="1234440" y="2916936"/>
+            <a:off x="1234440" y="3630168"/>
             <a:ext cx="274320" cy="274320"/>
           </a:xfrm>
           <a:prstGeom prst="ellipse">
@@ -28149,7 +28254,7 @@
       </p:sp>
       <p:pic>
         <p:nvPicPr>
-          <p:cNvPr id="54" name="Picture 53" descr="indiana.png"/>
+          <p:cNvPr id="57" name="Picture 56" descr="indiana.png"/>
           <p:cNvPicPr>
             <a:picLocks noChangeAspect="1"/>
           </p:cNvPicPr>
@@ -28163,7 +28268,7 @@
         </p:blipFill>
         <p:spPr>
           <a:xfrm>
-            <a:off x="1266444" y="2948940"/>
+            <a:off x="1266444" y="3662172"/>
             <a:ext cx="210312" cy="210312"/>
           </a:xfrm>
           <a:prstGeom prst="rect">
@@ -28173,13 +28278,48 @@
       </p:pic>
       <p:sp>
         <p:nvSpPr>
-          <p:cNvPr id="55" name="TextBox 54"/>
-          <p:cNvSpPr txBox="1"/>
-          <p:nvPr/>
-        </p:nvSpPr>
-        <p:spPr>
-          <a:xfrm>
-            <a:off x="1600200" y="2926080"/>
+          <p:cNvPr id="58" name="TextBox 57"/>
+          <p:cNvSpPr txBox="1"/>
+          <p:nvPr/>
+        </p:nvSpPr>
+        <p:spPr>
+          <a:xfrm>
+            <a:off x="1600200" y="3904487"/>
+            <a:ext cx="9692640" cy="256032"/>
+          </a:xfrm>
+          <a:prstGeom prst="rect">
+            <a:avLst/>
+          </a:prstGeom>
+          <a:noFill/>
+        </p:spPr>
+        <p:txBody>
+          <a:bodyPr wrap="square" lIns="0" rIns="0" tIns="0" bIns="0">
+            <a:spAutoFit/>
+          </a:bodyPr>
+          <a:lstStyle/>
+          <a:p>
+            <a:pPr algn="l"/>
+            <a:r>
+              <a:rPr sz="950" b="0" i="0">
+                <a:solidFill>
+                  <a:srgbClr val="CADCFC"/>
+                </a:solidFill>
+                <a:latin typeface="Arial"/>
+              </a:rPr>
+              <a:t>1.639 per play on 15 plays — a tiny sample — plus Indiana's 73% P(10+) and the offense that made a Heisman winner of a transfer last year</a:t>
+            </a:r>
+          </a:p>
+        </p:txBody>
+      </p:sp>
+      <p:sp>
+        <p:nvSpPr>
+          <p:cNvPr id="59" name="TextBox 58"/>
+          <p:cNvSpPr txBox="1"/>
+          <p:nvPr/>
+        </p:nvSpPr>
+        <p:spPr>
+          <a:xfrm>
+            <a:off x="1600200" y="3639312"/>
             <a:ext cx="2468880" cy="274320"/>
           </a:xfrm>
           <a:prstGeom prst="rect">
@@ -28208,13 +28348,13 @@
       </p:sp>
       <p:sp>
         <p:nvSpPr>
-          <p:cNvPr id="56" name="TextBox 55"/>
-          <p:cNvSpPr txBox="1"/>
-          <p:nvPr/>
-        </p:nvSpPr>
-        <p:spPr>
-          <a:xfrm>
-            <a:off x="4114800" y="2935224"/>
+          <p:cNvPr id="60" name="TextBox 59"/>
+          <p:cNvSpPr txBox="1"/>
+          <p:nvPr/>
+        </p:nvSpPr>
+        <p:spPr>
+          <a:xfrm>
+            <a:off x="4114800" y="3648456"/>
             <a:ext cx="1097280" cy="274320"/>
           </a:xfrm>
           <a:prstGeom prst="rect">
@@ -28243,13 +28383,13 @@
       </p:sp>
       <p:sp>
         <p:nvSpPr>
-          <p:cNvPr id="57" name="TextBox 56"/>
-          <p:cNvSpPr txBox="1"/>
-          <p:nvPr/>
-        </p:nvSpPr>
-        <p:spPr>
-          <a:xfrm>
-            <a:off x="5257800" y="2935224"/>
+          <p:cNvPr id="61" name="TextBox 60"/>
+          <p:cNvSpPr txBox="1"/>
+          <p:nvPr/>
+        </p:nvSpPr>
+        <p:spPr>
+          <a:xfrm>
+            <a:off x="5257800" y="3648456"/>
             <a:ext cx="731520" cy="274320"/>
           </a:xfrm>
           <a:prstGeom prst="rect">
@@ -28278,13 +28418,13 @@
       </p:sp>
       <p:sp>
         <p:nvSpPr>
-          <p:cNvPr id="58" name="TextBox 57"/>
-          <p:cNvSpPr txBox="1"/>
-          <p:nvPr/>
-        </p:nvSpPr>
-        <p:spPr>
-          <a:xfrm>
-            <a:off x="6035040" y="2935224"/>
+          <p:cNvPr id="62" name="TextBox 61"/>
+          <p:cNvSpPr txBox="1"/>
+          <p:nvPr/>
+        </p:nvSpPr>
+        <p:spPr>
+          <a:xfrm>
+            <a:off x="6035040" y="3648456"/>
             <a:ext cx="640080" cy="274320"/>
           </a:xfrm>
           <a:prstGeom prst="rect">
@@ -28313,13 +28453,13 @@
       </p:sp>
       <p:sp>
         <p:nvSpPr>
-          <p:cNvPr id="59" name="TextBox 58"/>
-          <p:cNvSpPr txBox="1"/>
-          <p:nvPr/>
-        </p:nvSpPr>
-        <p:spPr>
-          <a:xfrm>
-            <a:off x="6720840" y="2935224"/>
+          <p:cNvPr id="63" name="TextBox 62"/>
+          <p:cNvSpPr txBox="1"/>
+          <p:nvPr/>
+        </p:nvSpPr>
+        <p:spPr>
+          <a:xfrm>
+            <a:off x="6720840" y="3648456"/>
             <a:ext cx="822960" cy="274320"/>
           </a:xfrm>
           <a:prstGeom prst="rect">
@@ -28348,13 +28488,13 @@
       </p:sp>
       <p:sp>
         <p:nvSpPr>
-          <p:cNvPr id="60" name="TextBox 59"/>
-          <p:cNvSpPr txBox="1"/>
-          <p:nvPr/>
-        </p:nvSpPr>
-        <p:spPr>
-          <a:xfrm>
-            <a:off x="7589520" y="2926080"/>
+          <p:cNvPr id="64" name="TextBox 63"/>
+          <p:cNvSpPr txBox="1"/>
+          <p:nvPr/>
+        </p:nvSpPr>
+        <p:spPr>
+          <a:xfrm>
+            <a:off x="7589520" y="3639312"/>
             <a:ext cx="640080" cy="274320"/>
           </a:xfrm>
           <a:prstGeom prst="rect">
@@ -28383,13 +28523,13 @@
       </p:sp>
       <p:sp>
         <p:nvSpPr>
-          <p:cNvPr id="61" name="TextBox 60"/>
-          <p:cNvSpPr txBox="1"/>
-          <p:nvPr/>
-        </p:nvSpPr>
-        <p:spPr>
-          <a:xfrm>
-            <a:off x="8275320" y="2935224"/>
+          <p:cNvPr id="65" name="TextBox 64"/>
+          <p:cNvSpPr txBox="1"/>
+          <p:nvPr/>
+        </p:nvSpPr>
+        <p:spPr>
+          <a:xfrm>
+            <a:off x="8275320" y="3648456"/>
             <a:ext cx="822960" cy="274320"/>
           </a:xfrm>
           <a:prstGeom prst="rect">
@@ -28418,13 +28558,13 @@
       </p:sp>
       <p:sp>
         <p:nvSpPr>
-          <p:cNvPr id="62" name="TextBox 61"/>
-          <p:cNvSpPr txBox="1"/>
-          <p:nvPr/>
-        </p:nvSpPr>
-        <p:spPr>
-          <a:xfrm>
-            <a:off x="9144000" y="2935224"/>
+          <p:cNvPr id="66" name="TextBox 65"/>
+          <p:cNvSpPr txBox="1"/>
+          <p:nvPr/>
+        </p:nvSpPr>
+        <p:spPr>
+          <a:xfrm>
+            <a:off x="9144000" y="3648456"/>
             <a:ext cx="822960" cy="274320"/>
           </a:xfrm>
           <a:prstGeom prst="rect">
@@ -28453,13 +28593,13 @@
       </p:sp>
       <p:sp>
         <p:nvSpPr>
-          <p:cNvPr id="63" name="TextBox 62"/>
-          <p:cNvSpPr txBox="1"/>
-          <p:nvPr/>
-        </p:nvSpPr>
-        <p:spPr>
-          <a:xfrm>
-            <a:off x="10012680" y="2935224"/>
+          <p:cNvPr id="67" name="TextBox 66"/>
+          <p:cNvSpPr txBox="1"/>
+          <p:nvPr/>
+        </p:nvSpPr>
+        <p:spPr>
+          <a:xfrm>
+            <a:off x="10012680" y="3648456"/>
             <a:ext cx="1325880" cy="274320"/>
           </a:xfrm>
           <a:prstGeom prst="rect">
@@ -28488,14 +28628,14 @@
       </p:sp>
       <p:sp>
         <p:nvSpPr>
-          <p:cNvPr id="64" name="Rectangle 63"/>
+          <p:cNvPr id="68" name="Rectangle 67"/>
           <p:cNvSpPr/>
           <p:nvPr/>
         </p:nvSpPr>
         <p:spPr>
           <a:xfrm>
-            <a:off x="822960" y="3218688"/>
-            <a:ext cx="10515600" cy="329184"/>
+            <a:off x="822960" y="4169664"/>
+            <a:ext cx="10515600" cy="566928"/>
           </a:xfrm>
           <a:prstGeom prst="rect">
             <a:avLst/>
@@ -28532,13 +28672,13 @@
       </p:sp>
       <p:sp>
         <p:nvSpPr>
-          <p:cNvPr id="65" name="TextBox 64"/>
-          <p:cNvSpPr txBox="1"/>
-          <p:nvPr/>
-        </p:nvSpPr>
-        <p:spPr>
-          <a:xfrm>
-            <a:off x="822960" y="3255264"/>
+          <p:cNvPr id="69" name="TextBox 68"/>
+          <p:cNvSpPr txBox="1"/>
+          <p:nvPr/>
+        </p:nvSpPr>
+        <p:spPr>
+          <a:xfrm>
+            <a:off x="822960" y="4206240"/>
             <a:ext cx="365760" cy="274320"/>
           </a:xfrm>
           <a:prstGeom prst="rect">
@@ -28567,13 +28707,13 @@
       </p:sp>
       <p:sp>
         <p:nvSpPr>
-          <p:cNvPr id="66" name="Oval 65"/>
+          <p:cNvPr id="70" name="Oval 69"/>
           <p:cNvSpPr/>
           <p:nvPr/>
         </p:nvSpPr>
         <p:spPr>
           <a:xfrm>
-            <a:off x="1234440" y="3246120"/>
+            <a:off x="1234440" y="4197096"/>
             <a:ext cx="274320" cy="274320"/>
           </a:xfrm>
           <a:prstGeom prst="ellipse">
@@ -28611,7 +28751,7 @@
       </p:sp>
       <p:pic>
         <p:nvPicPr>
-          <p:cNvPr id="67" name="Picture 66" descr="texastech.png"/>
+          <p:cNvPr id="71" name="Picture 70" descr="texastech.png"/>
           <p:cNvPicPr>
             <a:picLocks noChangeAspect="1"/>
           </p:cNvPicPr>
@@ -28625,7 +28765,7 @@
         </p:blipFill>
         <p:spPr>
           <a:xfrm>
-            <a:off x="1266444" y="3278124"/>
+            <a:off x="1266444" y="4229100"/>
             <a:ext cx="210312" cy="210312"/>
           </a:xfrm>
           <a:prstGeom prst="rect">
@@ -28635,13 +28775,48 @@
       </p:pic>
       <p:sp>
         <p:nvSpPr>
-          <p:cNvPr id="68" name="TextBox 67"/>
-          <p:cNvSpPr txBox="1"/>
-          <p:nvPr/>
-        </p:nvSpPr>
-        <p:spPr>
-          <a:xfrm>
-            <a:off x="1600200" y="3255264"/>
+          <p:cNvPr id="72" name="TextBox 71"/>
+          <p:cNvSpPr txBox="1"/>
+          <p:nvPr/>
+        </p:nvSpPr>
+        <p:spPr>
+          <a:xfrm>
+            <a:off x="1600200" y="4471416"/>
+            <a:ext cx="9692640" cy="256032"/>
+          </a:xfrm>
+          <a:prstGeom prst="rect">
+            <a:avLst/>
+          </a:prstGeom>
+          <a:noFill/>
+        </p:spPr>
+        <p:txBody>
+          <a:bodyPr wrap="square" lIns="0" rIns="0" tIns="0" bIns="0">
+            <a:spAutoFit/>
+          </a:bodyPr>
+          <a:lstStyle/>
+          <a:p>
+            <a:pPr algn="l"/>
+            <a:r>
+              <a:rPr sz="950" b="0" i="0">
+                <a:solidFill>
+                  <a:srgbClr val="CADCFC"/>
+                </a:solidFill>
+                <a:latin typeface="Arial"/>
+              </a:rPr>
+              <a:t>Situation, not tape: Texas Tech's 80% P(10+) is 2nd on the board while his efficiency is 8th of 9 (0.384) — Houston in Lubbock is the first real test</a:t>
+            </a:r>
+          </a:p>
+        </p:txBody>
+      </p:sp>
+      <p:sp>
+        <p:nvSpPr>
+          <p:cNvPr id="73" name="TextBox 72"/>
+          <p:cNvSpPr txBox="1"/>
+          <p:nvPr/>
+        </p:nvSpPr>
+        <p:spPr>
+          <a:xfrm>
+            <a:off x="1600200" y="4206240"/>
             <a:ext cx="2468880" cy="274320"/>
           </a:xfrm>
           <a:prstGeom prst="rect">
@@ -28670,13 +28845,13 @@
       </p:sp>
       <p:sp>
         <p:nvSpPr>
-          <p:cNvPr id="69" name="TextBox 68"/>
-          <p:cNvSpPr txBox="1"/>
-          <p:nvPr/>
-        </p:nvSpPr>
-        <p:spPr>
-          <a:xfrm>
-            <a:off x="4114800" y="3264408"/>
+          <p:cNvPr id="74" name="TextBox 73"/>
+          <p:cNvSpPr txBox="1"/>
+          <p:nvPr/>
+        </p:nvSpPr>
+        <p:spPr>
+          <a:xfrm>
+            <a:off x="4114800" y="4215384"/>
             <a:ext cx="1097280" cy="274320"/>
           </a:xfrm>
           <a:prstGeom prst="rect">
@@ -28705,13 +28880,13 @@
       </p:sp>
       <p:sp>
         <p:nvSpPr>
-          <p:cNvPr id="70" name="TextBox 69"/>
-          <p:cNvSpPr txBox="1"/>
-          <p:nvPr/>
-        </p:nvSpPr>
-        <p:spPr>
-          <a:xfrm>
-            <a:off x="5257800" y="3264408"/>
+          <p:cNvPr id="75" name="TextBox 74"/>
+          <p:cNvSpPr txBox="1"/>
+          <p:nvPr/>
+        </p:nvSpPr>
+        <p:spPr>
+          <a:xfrm>
+            <a:off x="5257800" y="4215384"/>
             <a:ext cx="731520" cy="274320"/>
           </a:xfrm>
           <a:prstGeom prst="rect">
@@ -28740,13 +28915,13 @@
       </p:sp>
       <p:sp>
         <p:nvSpPr>
-          <p:cNvPr id="71" name="TextBox 70"/>
-          <p:cNvSpPr txBox="1"/>
-          <p:nvPr/>
-        </p:nvSpPr>
-        <p:spPr>
-          <a:xfrm>
-            <a:off x="6035040" y="3264408"/>
+          <p:cNvPr id="76" name="TextBox 75"/>
+          <p:cNvSpPr txBox="1"/>
+          <p:nvPr/>
+        </p:nvSpPr>
+        <p:spPr>
+          <a:xfrm>
+            <a:off x="6035040" y="4215384"/>
             <a:ext cx="640080" cy="274320"/>
           </a:xfrm>
           <a:prstGeom prst="rect">
@@ -28775,13 +28950,13 @@
       </p:sp>
       <p:sp>
         <p:nvSpPr>
-          <p:cNvPr id="72" name="TextBox 71"/>
-          <p:cNvSpPr txBox="1"/>
-          <p:nvPr/>
-        </p:nvSpPr>
-        <p:spPr>
-          <a:xfrm>
-            <a:off x="6720840" y="3264408"/>
+          <p:cNvPr id="77" name="TextBox 76"/>
+          <p:cNvSpPr txBox="1"/>
+          <p:nvPr/>
+        </p:nvSpPr>
+        <p:spPr>
+          <a:xfrm>
+            <a:off x="6720840" y="4215384"/>
             <a:ext cx="822960" cy="274320"/>
           </a:xfrm>
           <a:prstGeom prst="rect">
@@ -28810,13 +28985,13 @@
       </p:sp>
       <p:sp>
         <p:nvSpPr>
-          <p:cNvPr id="73" name="TextBox 72"/>
-          <p:cNvSpPr txBox="1"/>
-          <p:nvPr/>
-        </p:nvSpPr>
-        <p:spPr>
-          <a:xfrm>
-            <a:off x="7589520" y="3255264"/>
+          <p:cNvPr id="78" name="TextBox 77"/>
+          <p:cNvSpPr txBox="1"/>
+          <p:nvPr/>
+        </p:nvSpPr>
+        <p:spPr>
+          <a:xfrm>
+            <a:off x="7589520" y="4206240"/>
             <a:ext cx="640080" cy="274320"/>
           </a:xfrm>
           <a:prstGeom prst="rect">
@@ -28845,13 +29020,13 @@
       </p:sp>
       <p:sp>
         <p:nvSpPr>
-          <p:cNvPr id="74" name="TextBox 73"/>
-          <p:cNvSpPr txBox="1"/>
-          <p:nvPr/>
-        </p:nvSpPr>
-        <p:spPr>
-          <a:xfrm>
-            <a:off x="8275320" y="3264408"/>
+          <p:cNvPr id="79" name="TextBox 78"/>
+          <p:cNvSpPr txBox="1"/>
+          <p:nvPr/>
+        </p:nvSpPr>
+        <p:spPr>
+          <a:xfrm>
+            <a:off x="8275320" y="4215384"/>
             <a:ext cx="822960" cy="274320"/>
           </a:xfrm>
           <a:prstGeom prst="rect">
@@ -28880,13 +29055,13 @@
       </p:sp>
       <p:sp>
         <p:nvSpPr>
-          <p:cNvPr id="75" name="TextBox 74"/>
-          <p:cNvSpPr txBox="1"/>
-          <p:nvPr/>
-        </p:nvSpPr>
-        <p:spPr>
-          <a:xfrm>
-            <a:off x="9144000" y="3264408"/>
+          <p:cNvPr id="80" name="TextBox 79"/>
+          <p:cNvSpPr txBox="1"/>
+          <p:nvPr/>
+        </p:nvSpPr>
+        <p:spPr>
+          <a:xfrm>
+            <a:off x="9144000" y="4215384"/>
             <a:ext cx="822960" cy="274320"/>
           </a:xfrm>
           <a:prstGeom prst="rect">
@@ -28915,13 +29090,13 @@
       </p:sp>
       <p:sp>
         <p:nvSpPr>
-          <p:cNvPr id="76" name="TextBox 75"/>
-          <p:cNvSpPr txBox="1"/>
-          <p:nvPr/>
-        </p:nvSpPr>
-        <p:spPr>
-          <a:xfrm>
-            <a:off x="10012680" y="3264408"/>
+          <p:cNvPr id="81" name="TextBox 80"/>
+          <p:cNvSpPr txBox="1"/>
+          <p:nvPr/>
+        </p:nvSpPr>
+        <p:spPr>
+          <a:xfrm>
+            <a:off x="10012680" y="4215384"/>
             <a:ext cx="1325880" cy="274320"/>
           </a:xfrm>
           <a:prstGeom prst="rect">
@@ -28950,1773 +29125,48 @@
       </p:sp>
       <p:sp>
         <p:nvSpPr>
-          <p:cNvPr id="77" name="TextBox 76"/>
-          <p:cNvSpPr txBox="1"/>
-          <p:nvPr/>
-        </p:nvSpPr>
-        <p:spPr>
-          <a:xfrm>
-            <a:off x="822960" y="3584448"/>
-            <a:ext cx="365760" cy="274320"/>
-          </a:xfrm>
-          <a:prstGeom prst="rect">
-            <a:avLst/>
-          </a:prstGeom>
-          <a:noFill/>
-        </p:spPr>
-        <p:txBody>
-          <a:bodyPr wrap="square" lIns="0" rIns="0" tIns="0" bIns="0">
-            <a:spAutoFit/>
-          </a:bodyPr>
-          <a:lstStyle/>
-          <a:p>
-            <a:pPr algn="r"/>
-            <a:r>
-              <a:rPr sz="1300" b="1" i="0">
-                <a:solidFill>
-                  <a:srgbClr val="F47321"/>
-                </a:solidFill>
-                <a:latin typeface="Arial"/>
-              </a:rPr>
-              <a:t>6</a:t>
-            </a:r>
-          </a:p>
-        </p:txBody>
-      </p:sp>
-      <p:sp>
-        <p:nvSpPr>
-          <p:cNvPr id="78" name="Oval 77"/>
+          <p:cNvPr id="82" name="TextBox 81"/>
+          <p:cNvSpPr txBox="1"/>
+          <p:nvPr/>
+        </p:nvSpPr>
+        <p:spPr>
+          <a:xfrm>
+            <a:off x="822960" y="4773168"/>
+            <a:ext cx="10515600" cy="256032"/>
+          </a:xfrm>
+          <a:prstGeom prst="rect">
+            <a:avLst/>
+          </a:prstGeom>
+          <a:noFill/>
+        </p:spPr>
+        <p:txBody>
+          <a:bodyPr wrap="square" lIns="0" rIns="0" tIns="0" bIns="0">
+            <a:spAutoFit/>
+          </a:bodyPr>
+          <a:lstStyle/>
+          <a:p>
+            <a:pPr algn="l"/>
+            <a:r>
+              <a:rPr sz="950" b="0" i="1">
+                <a:solidFill>
+                  <a:srgbClr val="CADCFC"/>
+                </a:solidFill>
+                <a:latin typeface="Arial"/>
+              </a:rPr>
+              <a:t>Next up: Dante Moore 31.3 (market #6) · Jayden Maiava 30.9 (market #10) · Arch Manning 30.6 (market #2) · Sam Leavitt 25.9 (market #9)</a:t>
+            </a:r>
+          </a:p>
+        </p:txBody>
+      </p:sp>
+      <p:sp>
+        <p:nvSpPr>
+          <p:cNvPr id="83" name="Rounded Rectangle 82"/>
           <p:cNvSpPr/>
           <p:nvPr/>
         </p:nvSpPr>
         <p:spPr>
           <a:xfrm>
-            <a:off x="1234440" y="3575303"/>
-            <a:ext cx="274320" cy="274320"/>
-          </a:xfrm>
-          <a:prstGeom prst="ellipse">
-            <a:avLst/>
-          </a:prstGeom>
-          <a:solidFill>
-            <a:srgbClr val="FFFFFF"/>
-          </a:solidFill>
-          <a:ln>
-            <a:noFill/>
-          </a:ln>
-          <a:effectLst/>
-        </p:spPr>
-        <p:style>
-          <a:lnRef idx="1">
-            <a:schemeClr val="accent1"/>
-          </a:lnRef>
-          <a:fillRef idx="3">
-            <a:schemeClr val="accent1"/>
-          </a:fillRef>
-          <a:effectRef idx="2">
-            <a:schemeClr val="accent1"/>
-          </a:effectRef>
-          <a:fontRef idx="minor">
-            <a:schemeClr val="lt1"/>
-          </a:fontRef>
-        </p:style>
-        <p:txBody>
-          <a:bodyPr rtlCol="0" anchor="ctr"/>
-          <a:lstStyle/>
-          <a:p>
-            <a:pPr algn="ctr"/>
-          </a:p>
-        </p:txBody>
-      </p:sp>
-      <p:pic>
-        <p:nvPicPr>
-          <p:cNvPr id="79" name="Picture 78" descr="oregon.png"/>
-          <p:cNvPicPr>
-            <a:picLocks noChangeAspect="1"/>
-          </p:cNvPicPr>
-          <p:nvPr/>
-        </p:nvPicPr>
-        <p:blipFill>
-          <a:blip r:embed="rId7"/>
-          <a:stretch>
-            <a:fillRect/>
-          </a:stretch>
-        </p:blipFill>
-        <p:spPr>
-          <a:xfrm>
-            <a:off x="1266444" y="3607308"/>
-            <a:ext cx="210312" cy="210312"/>
-          </a:xfrm>
-          <a:prstGeom prst="rect">
-            <a:avLst/>
-          </a:prstGeom>
-        </p:spPr>
-      </p:pic>
-      <p:sp>
-        <p:nvSpPr>
-          <p:cNvPr id="80" name="TextBox 79"/>
-          <p:cNvSpPr txBox="1"/>
-          <p:nvPr/>
-        </p:nvSpPr>
-        <p:spPr>
-          <a:xfrm>
-            <a:off x="1600200" y="3584448"/>
-            <a:ext cx="2468880" cy="274320"/>
-          </a:xfrm>
-          <a:prstGeom prst="rect">
-            <a:avLst/>
-          </a:prstGeom>
-          <a:noFill/>
-        </p:spPr>
-        <p:txBody>
-          <a:bodyPr wrap="square" lIns="0" rIns="0" tIns="0" bIns="0">
-            <a:spAutoFit/>
-          </a:bodyPr>
-          <a:lstStyle/>
-          <a:p>
-            <a:pPr algn="l"/>
-            <a:r>
-              <a:rPr sz="1200" b="1" i="0">
-                <a:solidFill>
-                  <a:srgbClr val="FFFFFF"/>
-                </a:solidFill>
-                <a:latin typeface="Arial"/>
-              </a:rPr>
-              <a:t>Dante Moore · Oregon</a:t>
-            </a:r>
-          </a:p>
-        </p:txBody>
-      </p:sp>
-      <p:sp>
-        <p:nvSpPr>
-          <p:cNvPr id="81" name="TextBox 80"/>
-          <p:cNvSpPr txBox="1"/>
-          <p:nvPr/>
-        </p:nvSpPr>
-        <p:spPr>
-          <a:xfrm>
-            <a:off x="4114800" y="3593591"/>
-            <a:ext cx="1097280" cy="274320"/>
-          </a:xfrm>
-          <a:prstGeom prst="rect">
-            <a:avLst/>
-          </a:prstGeom>
-          <a:noFill/>
-        </p:spPr>
-        <p:txBody>
-          <a:bodyPr wrap="square" lIns="0" rIns="0" tIns="0" bIns="0">
-            <a:spAutoFit/>
-          </a:bodyPr>
-          <a:lstStyle/>
-          <a:p>
-            <a:pPr algn="r"/>
-            <a:r>
-              <a:rPr sz="1050" b="0" i="0">
-                <a:solidFill>
-                  <a:srgbClr val="FFFFFF"/>
-                </a:solidFill>
-                <a:latin typeface="Arial"/>
-              </a:rPr>
-              <a:t>0.367 (39)</a:t>
-            </a:r>
-          </a:p>
-        </p:txBody>
-      </p:sp>
-      <p:sp>
-        <p:nvSpPr>
-          <p:cNvPr id="82" name="TextBox 81"/>
-          <p:cNvSpPr txBox="1"/>
-          <p:nvPr/>
-        </p:nvSpPr>
-        <p:spPr>
-          <a:xfrm>
-            <a:off x="5257800" y="3593591"/>
-            <a:ext cx="731520" cy="274320"/>
-          </a:xfrm>
-          <a:prstGeom prst="rect">
-            <a:avLst/>
-          </a:prstGeom>
-          <a:noFill/>
-        </p:spPr>
-        <p:txBody>
-          <a:bodyPr wrap="square" lIns="0" rIns="0" tIns="0" bIns="0">
-            <a:spAutoFit/>
-          </a:bodyPr>
-          <a:lstStyle/>
-          <a:p>
-            <a:pPr algn="r"/>
-            <a:r>
-              <a:rPr sz="1050" b="0" i="0">
-                <a:solidFill>
-                  <a:srgbClr val="CADCFC"/>
-                </a:solidFill>
-                <a:latin typeface="Arial"/>
-              </a:rPr>
-              <a:t>0.409</a:t>
-            </a:r>
-          </a:p>
-        </p:txBody>
-      </p:sp>
-      <p:sp>
-        <p:nvSpPr>
-          <p:cNvPr id="83" name="TextBox 82"/>
-          <p:cNvSpPr txBox="1"/>
-          <p:nvPr/>
-        </p:nvSpPr>
-        <p:spPr>
-          <a:xfrm>
-            <a:off x="6035040" y="3593591"/>
-            <a:ext cx="640080" cy="274320"/>
-          </a:xfrm>
-          <a:prstGeom prst="rect">
-            <a:avLst/>
-          </a:prstGeom>
-          <a:noFill/>
-        </p:spPr>
-        <p:txBody>
-          <a:bodyPr wrap="square" lIns="0" rIns="0" tIns="0" bIns="0">
-            <a:spAutoFit/>
-          </a:bodyPr>
-          <a:lstStyle/>
-          <a:p>
-            <a:pPr algn="r"/>
-            <a:r>
-              <a:rPr sz="1050" b="0" i="0">
-                <a:solidFill>
-                  <a:srgbClr val="FFFFFF"/>
-                </a:solidFill>
-                <a:latin typeface="Arial"/>
-              </a:rPr>
-              <a:t>0.400</a:t>
-            </a:r>
-          </a:p>
-        </p:txBody>
-      </p:sp>
-      <p:sp>
-        <p:nvSpPr>
-          <p:cNvPr id="84" name="TextBox 83"/>
-          <p:cNvSpPr txBox="1"/>
-          <p:nvPr/>
-        </p:nvSpPr>
-        <p:spPr>
-          <a:xfrm>
-            <a:off x="6720840" y="3593591"/>
-            <a:ext cx="822960" cy="274320"/>
-          </a:xfrm>
-          <a:prstGeom prst="rect">
-            <a:avLst/>
-          </a:prstGeom>
-          <a:noFill/>
-        </p:spPr>
-        <p:txBody>
-          <a:bodyPr wrap="square" lIns="0" rIns="0" tIns="0" bIns="0">
-            <a:spAutoFit/>
-          </a:bodyPr>
-          <a:lstStyle/>
-          <a:p>
-            <a:pPr algn="r"/>
-            <a:r>
-              <a:rPr sz="1050" b="0" i="0">
-                <a:solidFill>
-                  <a:srgbClr val="FFFFFF"/>
-                </a:solidFill>
-                <a:latin typeface="Arial"/>
-              </a:rPr>
-              <a:t>57%</a:t>
-            </a:r>
-          </a:p>
-        </p:txBody>
-      </p:sp>
-      <p:sp>
-        <p:nvSpPr>
-          <p:cNvPr id="85" name="TextBox 84"/>
-          <p:cNvSpPr txBox="1"/>
-          <p:nvPr/>
-        </p:nvSpPr>
-        <p:spPr>
-          <a:xfrm>
-            <a:off x="7589520" y="3584448"/>
-            <a:ext cx="640080" cy="274320"/>
-          </a:xfrm>
-          <a:prstGeom prst="rect">
-            <a:avLst/>
-          </a:prstGeom>
-          <a:noFill/>
-        </p:spPr>
-        <p:txBody>
-          <a:bodyPr wrap="square" lIns="0" rIns="0" tIns="0" bIns="0">
-            <a:spAutoFit/>
-          </a:bodyPr>
-          <a:lstStyle/>
-          <a:p>
-            <a:pPr algn="r"/>
-            <a:r>
-              <a:rPr sz="1250" b="1" i="0">
-                <a:solidFill>
-                  <a:srgbClr val="F47321"/>
-                </a:solidFill>
-                <a:latin typeface="Arial"/>
-              </a:rPr>
-              <a:t>31.3</a:t>
-            </a:r>
-          </a:p>
-        </p:txBody>
-      </p:sp>
-      <p:sp>
-        <p:nvSpPr>
-          <p:cNvPr id="86" name="TextBox 85"/>
-          <p:cNvSpPr txBox="1"/>
-          <p:nvPr/>
-        </p:nvSpPr>
-        <p:spPr>
-          <a:xfrm>
-            <a:off x="8275320" y="3593591"/>
-            <a:ext cx="822960" cy="274320"/>
-          </a:xfrm>
-          <a:prstGeom prst="rect">
-            <a:avLst/>
-          </a:prstGeom>
-          <a:noFill/>
-        </p:spPr>
-        <p:txBody>
-          <a:bodyPr wrap="square" lIns="0" rIns="0" tIns="0" bIns="0">
-            <a:spAutoFit/>
-          </a:bodyPr>
-          <a:lstStyle/>
-          <a:p>
-            <a:pPr algn="r"/>
-            <a:r>
-              <a:rPr sz="1050" b="0" i="0">
-                <a:solidFill>
-                  <a:srgbClr val="FFFFFF"/>
-                </a:solidFill>
-                <a:latin typeface="Arial"/>
-              </a:rPr>
-              <a:t>+1300</a:t>
-            </a:r>
-          </a:p>
-        </p:txBody>
-      </p:sp>
-      <p:sp>
-        <p:nvSpPr>
-          <p:cNvPr id="87" name="TextBox 86"/>
-          <p:cNvSpPr txBox="1"/>
-          <p:nvPr/>
-        </p:nvSpPr>
-        <p:spPr>
-          <a:xfrm>
-            <a:off x="9144000" y="3593591"/>
-            <a:ext cx="822960" cy="274320"/>
-          </a:xfrm>
-          <a:prstGeom prst="rect">
-            <a:avLst/>
-          </a:prstGeom>
-          <a:noFill/>
-        </p:spPr>
-        <p:txBody>
-          <a:bodyPr wrap="square" lIns="0" rIns="0" tIns="0" bIns="0">
-            <a:spAutoFit/>
-          </a:bodyPr>
-          <a:lstStyle/>
-          <a:p>
-            <a:pPr algn="r"/>
-            <a:r>
-              <a:rPr sz="1050" b="0" i="0">
-                <a:solidFill>
-                  <a:srgbClr val="CADCFC"/>
-                </a:solidFill>
-                <a:latin typeface="Arial"/>
-              </a:rPr>
-              <a:t>#6</a:t>
-            </a:r>
-          </a:p>
-        </p:txBody>
-      </p:sp>
-      <p:sp>
-        <p:nvSpPr>
-          <p:cNvPr id="88" name="TextBox 87"/>
-          <p:cNvSpPr txBox="1"/>
-          <p:nvPr/>
-        </p:nvSpPr>
-        <p:spPr>
-          <a:xfrm>
-            <a:off x="10012680" y="3593591"/>
-            <a:ext cx="1325880" cy="274320"/>
-          </a:xfrm>
-          <a:prstGeom prst="rect">
-            <a:avLst/>
-          </a:prstGeom>
-          <a:noFill/>
-        </p:spPr>
-        <p:txBody>
-          <a:bodyPr wrap="square" lIns="0" rIns="0" tIns="0" bIns="0">
-            <a:spAutoFit/>
-          </a:bodyPr>
-          <a:lstStyle/>
-          <a:p>
-            <a:pPr algn="r"/>
-            <a:r>
-              <a:rPr sz="950" b="0" i="0">
-                <a:solidFill>
-                  <a:srgbClr val="CADCFC"/>
-                </a:solidFill>
-                <a:latin typeface="Arial"/>
-              </a:rPr>
-              <a:t>agree</a:t>
-            </a:r>
-          </a:p>
-        </p:txBody>
-      </p:sp>
-      <p:sp>
-        <p:nvSpPr>
-          <p:cNvPr id="89" name="Rectangle 88"/>
-          <p:cNvSpPr/>
-          <p:nvPr/>
-        </p:nvSpPr>
-        <p:spPr>
-          <a:xfrm>
-            <a:off x="822960" y="3877056"/>
-            <a:ext cx="10515600" cy="329184"/>
-          </a:xfrm>
-          <a:prstGeom prst="rect">
-            <a:avLst/>
-          </a:prstGeom>
-          <a:solidFill>
-            <a:srgbClr val="123568"/>
-          </a:solidFill>
-          <a:ln>
-            <a:noFill/>
-          </a:ln>
-          <a:effectLst/>
-        </p:spPr>
-        <p:style>
-          <a:lnRef idx="1">
-            <a:schemeClr val="accent1"/>
-          </a:lnRef>
-          <a:fillRef idx="3">
-            <a:schemeClr val="accent1"/>
-          </a:fillRef>
-          <a:effectRef idx="2">
-            <a:schemeClr val="accent1"/>
-          </a:effectRef>
-          <a:fontRef idx="minor">
-            <a:schemeClr val="lt1"/>
-          </a:fontRef>
-        </p:style>
-        <p:txBody>
-          <a:bodyPr rtlCol="0" anchor="ctr"/>
-          <a:lstStyle/>
-          <a:p>
-            <a:pPr algn="ctr"/>
-          </a:p>
-        </p:txBody>
-      </p:sp>
-      <p:sp>
-        <p:nvSpPr>
-          <p:cNvPr id="90" name="TextBox 89"/>
-          <p:cNvSpPr txBox="1"/>
-          <p:nvPr/>
-        </p:nvSpPr>
-        <p:spPr>
-          <a:xfrm>
-            <a:off x="822960" y="3913632"/>
-            <a:ext cx="365760" cy="274320"/>
-          </a:xfrm>
-          <a:prstGeom prst="rect">
-            <a:avLst/>
-          </a:prstGeom>
-          <a:noFill/>
-        </p:spPr>
-        <p:txBody>
-          <a:bodyPr wrap="square" lIns="0" rIns="0" tIns="0" bIns="0">
-            <a:spAutoFit/>
-          </a:bodyPr>
-          <a:lstStyle/>
-          <a:p>
-            <a:pPr algn="r"/>
-            <a:r>
-              <a:rPr sz="1300" b="1" i="0">
-                <a:solidFill>
-                  <a:srgbClr val="F47321"/>
-                </a:solidFill>
-                <a:latin typeface="Arial"/>
-              </a:rPr>
-              <a:t>7</a:t>
-            </a:r>
-          </a:p>
-        </p:txBody>
-      </p:sp>
-      <p:sp>
-        <p:nvSpPr>
-          <p:cNvPr id="91" name="Oval 90"/>
-          <p:cNvSpPr/>
-          <p:nvPr/>
-        </p:nvSpPr>
-        <p:spPr>
-          <a:xfrm>
-            <a:off x="1234440" y="3904488"/>
-            <a:ext cx="274320" cy="274320"/>
-          </a:xfrm>
-          <a:prstGeom prst="ellipse">
-            <a:avLst/>
-          </a:prstGeom>
-          <a:solidFill>
-            <a:srgbClr val="FFFFFF"/>
-          </a:solidFill>
-          <a:ln>
-            <a:noFill/>
-          </a:ln>
-          <a:effectLst/>
-        </p:spPr>
-        <p:style>
-          <a:lnRef idx="1">
-            <a:schemeClr val="accent1"/>
-          </a:lnRef>
-          <a:fillRef idx="3">
-            <a:schemeClr val="accent1"/>
-          </a:fillRef>
-          <a:effectRef idx="2">
-            <a:schemeClr val="accent1"/>
-          </a:effectRef>
-          <a:fontRef idx="minor">
-            <a:schemeClr val="lt1"/>
-          </a:fontRef>
-        </p:style>
-        <p:txBody>
-          <a:bodyPr rtlCol="0" anchor="ctr"/>
-          <a:lstStyle/>
-          <a:p>
-            <a:pPr algn="ctr"/>
-          </a:p>
-        </p:txBody>
-      </p:sp>
-      <p:pic>
-        <p:nvPicPr>
-          <p:cNvPr id="92" name="Picture 91" descr="usc.png"/>
-          <p:cNvPicPr>
-            <a:picLocks noChangeAspect="1"/>
-          </p:cNvPicPr>
-          <p:nvPr/>
-        </p:nvPicPr>
-        <p:blipFill>
-          <a:blip r:embed="rId8"/>
-          <a:stretch>
-            <a:fillRect/>
-          </a:stretch>
-        </p:blipFill>
-        <p:spPr>
-          <a:xfrm>
-            <a:off x="1266444" y="3936492"/>
-            <a:ext cx="210312" cy="210312"/>
-          </a:xfrm>
-          <a:prstGeom prst="rect">
-            <a:avLst/>
-          </a:prstGeom>
-        </p:spPr>
-      </p:pic>
-      <p:sp>
-        <p:nvSpPr>
-          <p:cNvPr id="93" name="TextBox 92"/>
-          <p:cNvSpPr txBox="1"/>
-          <p:nvPr/>
-        </p:nvSpPr>
-        <p:spPr>
-          <a:xfrm>
-            <a:off x="1600200" y="3913632"/>
-            <a:ext cx="2468880" cy="274320"/>
-          </a:xfrm>
-          <a:prstGeom prst="rect">
-            <a:avLst/>
-          </a:prstGeom>
-          <a:noFill/>
-        </p:spPr>
-        <p:txBody>
-          <a:bodyPr wrap="square" lIns="0" rIns="0" tIns="0" bIns="0">
-            <a:spAutoFit/>
-          </a:bodyPr>
-          <a:lstStyle/>
-          <a:p>
-            <a:pPr algn="l"/>
-            <a:r>
-              <a:rPr sz="1200" b="1" i="0">
-                <a:solidFill>
-                  <a:srgbClr val="FFFFFF"/>
-                </a:solidFill>
-                <a:latin typeface="Arial"/>
-              </a:rPr>
-              <a:t>Jayden Maiava · USC</a:t>
-            </a:r>
-          </a:p>
-        </p:txBody>
-      </p:sp>
-      <p:sp>
-        <p:nvSpPr>
-          <p:cNvPr id="94" name="TextBox 93"/>
-          <p:cNvSpPr txBox="1"/>
-          <p:nvPr/>
-        </p:nvSpPr>
-        <p:spPr>
-          <a:xfrm>
-            <a:off x="4114800" y="3922776"/>
-            <a:ext cx="1097280" cy="274320"/>
-          </a:xfrm>
-          <a:prstGeom prst="rect">
-            <a:avLst/>
-          </a:prstGeom>
-          <a:noFill/>
-        </p:spPr>
-        <p:txBody>
-          <a:bodyPr wrap="square" lIns="0" rIns="0" tIns="0" bIns="0">
-            <a:spAutoFit/>
-          </a:bodyPr>
-          <a:lstStyle/>
-          <a:p>
-            <a:pPr algn="r"/>
-            <a:r>
-              <a:rPr sz="1050" b="0" i="0">
-                <a:solidFill>
-                  <a:srgbClr val="FFFFFF"/>
-                </a:solidFill>
-                <a:latin typeface="Arial"/>
-              </a:rPr>
-              <a:t>0.569 (60)</a:t>
-            </a:r>
-          </a:p>
-        </p:txBody>
-      </p:sp>
-      <p:sp>
-        <p:nvSpPr>
-          <p:cNvPr id="95" name="TextBox 94"/>
-          <p:cNvSpPr txBox="1"/>
-          <p:nvPr/>
-        </p:nvSpPr>
-        <p:spPr>
-          <a:xfrm>
-            <a:off x="5257800" y="3922776"/>
-            <a:ext cx="731520" cy="274320"/>
-          </a:xfrm>
-          <a:prstGeom prst="rect">
-            <a:avLst/>
-          </a:prstGeom>
-          <a:noFill/>
-        </p:spPr>
-        <p:txBody>
-          <a:bodyPr wrap="square" lIns="0" rIns="0" tIns="0" bIns="0">
-            <a:spAutoFit/>
-          </a:bodyPr>
-          <a:lstStyle/>
-          <a:p>
-            <a:pPr algn="r"/>
-            <a:r>
-              <a:rPr sz="1050" b="0" i="0">
-                <a:solidFill>
-                  <a:srgbClr val="CADCFC"/>
-                </a:solidFill>
-                <a:latin typeface="Arial"/>
-              </a:rPr>
-              <a:t>0.517</a:t>
-            </a:r>
-          </a:p>
-        </p:txBody>
-      </p:sp>
-      <p:sp>
-        <p:nvSpPr>
-          <p:cNvPr id="96" name="TextBox 95"/>
-          <p:cNvSpPr txBox="1"/>
-          <p:nvPr/>
-        </p:nvSpPr>
-        <p:spPr>
-          <a:xfrm>
-            <a:off x="6035040" y="3922776"/>
-            <a:ext cx="640080" cy="274320"/>
-          </a:xfrm>
-          <a:prstGeom prst="rect">
-            <a:avLst/>
-          </a:prstGeom>
-          <a:noFill/>
-        </p:spPr>
-        <p:txBody>
-          <a:bodyPr wrap="square" lIns="0" rIns="0" tIns="0" bIns="0">
-            <a:spAutoFit/>
-          </a:bodyPr>
-          <a:lstStyle/>
-          <a:p>
-            <a:pPr algn="r"/>
-            <a:r>
-              <a:rPr sz="1050" b="0" i="0">
-                <a:solidFill>
-                  <a:srgbClr val="FFFFFF"/>
-                </a:solidFill>
-                <a:latin typeface="Arial"/>
-              </a:rPr>
-              <a:t>0.532</a:t>
-            </a:r>
-          </a:p>
-        </p:txBody>
-      </p:sp>
-      <p:sp>
-        <p:nvSpPr>
-          <p:cNvPr id="97" name="TextBox 96"/>
-          <p:cNvSpPr txBox="1"/>
-          <p:nvPr/>
-        </p:nvSpPr>
-        <p:spPr>
-          <a:xfrm>
-            <a:off x="6720840" y="3922776"/>
-            <a:ext cx="822960" cy="274320"/>
-          </a:xfrm>
-          <a:prstGeom prst="rect">
-            <a:avLst/>
-          </a:prstGeom>
-          <a:noFill/>
-        </p:spPr>
-        <p:txBody>
-          <a:bodyPr wrap="square" lIns="0" rIns="0" tIns="0" bIns="0">
-            <a:spAutoFit/>
-          </a:bodyPr>
-          <a:lstStyle/>
-          <a:p>
-            <a:pPr algn="r"/>
-            <a:r>
-              <a:rPr sz="1050" b="0" i="0">
-                <a:solidFill>
-                  <a:srgbClr val="FFFFFF"/>
-                </a:solidFill>
-                <a:latin typeface="Arial"/>
-              </a:rPr>
-              <a:t>16%</a:t>
-            </a:r>
-          </a:p>
-        </p:txBody>
-      </p:sp>
-      <p:sp>
-        <p:nvSpPr>
-          <p:cNvPr id="98" name="TextBox 97"/>
-          <p:cNvSpPr txBox="1"/>
-          <p:nvPr/>
-        </p:nvSpPr>
-        <p:spPr>
-          <a:xfrm>
-            <a:off x="7589520" y="3913632"/>
-            <a:ext cx="640080" cy="274320"/>
-          </a:xfrm>
-          <a:prstGeom prst="rect">
-            <a:avLst/>
-          </a:prstGeom>
-          <a:noFill/>
-        </p:spPr>
-        <p:txBody>
-          <a:bodyPr wrap="square" lIns="0" rIns="0" tIns="0" bIns="0">
-            <a:spAutoFit/>
-          </a:bodyPr>
-          <a:lstStyle/>
-          <a:p>
-            <a:pPr algn="r"/>
-            <a:r>
-              <a:rPr sz="1250" b="1" i="0">
-                <a:solidFill>
-                  <a:srgbClr val="F47321"/>
-                </a:solidFill>
-                <a:latin typeface="Arial"/>
-              </a:rPr>
-              <a:t>30.9</a:t>
-            </a:r>
-          </a:p>
-        </p:txBody>
-      </p:sp>
-      <p:sp>
-        <p:nvSpPr>
-          <p:cNvPr id="99" name="TextBox 98"/>
-          <p:cNvSpPr txBox="1"/>
-          <p:nvPr/>
-        </p:nvSpPr>
-        <p:spPr>
-          <a:xfrm>
-            <a:off x="8275320" y="3922776"/>
-            <a:ext cx="822960" cy="274320"/>
-          </a:xfrm>
-          <a:prstGeom prst="rect">
-            <a:avLst/>
-          </a:prstGeom>
-          <a:noFill/>
-        </p:spPr>
-        <p:txBody>
-          <a:bodyPr wrap="square" lIns="0" rIns="0" tIns="0" bIns="0">
-            <a:spAutoFit/>
-          </a:bodyPr>
-          <a:lstStyle/>
-          <a:p>
-            <a:pPr algn="r"/>
-            <a:r>
-              <a:rPr sz="1050" b="0" i="0">
-                <a:solidFill>
-                  <a:srgbClr val="FFFFFF"/>
-                </a:solidFill>
-                <a:latin typeface="Arial"/>
-              </a:rPr>
-              <a:t>+1750</a:t>
-            </a:r>
-          </a:p>
-        </p:txBody>
-      </p:sp>
-      <p:sp>
-        <p:nvSpPr>
-          <p:cNvPr id="100" name="TextBox 99"/>
-          <p:cNvSpPr txBox="1"/>
-          <p:nvPr/>
-        </p:nvSpPr>
-        <p:spPr>
-          <a:xfrm>
-            <a:off x="9144000" y="3922776"/>
-            <a:ext cx="822960" cy="274320"/>
-          </a:xfrm>
-          <a:prstGeom prst="rect">
-            <a:avLst/>
-          </a:prstGeom>
-          <a:noFill/>
-        </p:spPr>
-        <p:txBody>
-          <a:bodyPr wrap="square" lIns="0" rIns="0" tIns="0" bIns="0">
-            <a:spAutoFit/>
-          </a:bodyPr>
-          <a:lstStyle/>
-          <a:p>
-            <a:pPr algn="r"/>
-            <a:r>
-              <a:rPr sz="1050" b="0" i="0">
-                <a:solidFill>
-                  <a:srgbClr val="CADCFC"/>
-                </a:solidFill>
-                <a:latin typeface="Arial"/>
-              </a:rPr>
-              <a:t>#10</a:t>
-            </a:r>
-          </a:p>
-        </p:txBody>
-      </p:sp>
-      <p:sp>
-        <p:nvSpPr>
-          <p:cNvPr id="101" name="TextBox 100"/>
-          <p:cNvSpPr txBox="1"/>
-          <p:nvPr/>
-        </p:nvSpPr>
-        <p:spPr>
-          <a:xfrm>
-            <a:off x="10012680" y="3922776"/>
-            <a:ext cx="1325880" cy="274320"/>
-          </a:xfrm>
-          <a:prstGeom prst="rect">
-            <a:avLst/>
-          </a:prstGeom>
-          <a:noFill/>
-        </p:spPr>
-        <p:txBody>
-          <a:bodyPr wrap="square" lIns="0" rIns="0" tIns="0" bIns="0">
-            <a:spAutoFit/>
-          </a:bodyPr>
-          <a:lstStyle/>
-          <a:p>
-            <a:pPr algn="r"/>
-            <a:r>
-              <a:rPr sz="950" b="1" i="0">
-                <a:solidFill>
-                  <a:srgbClr val="5CD68A"/>
-                </a:solidFill>
-                <a:latin typeface="Arial"/>
-              </a:rPr>
-              <a:t>market too low</a:t>
-            </a:r>
-          </a:p>
-        </p:txBody>
-      </p:sp>
-      <p:sp>
-        <p:nvSpPr>
-          <p:cNvPr id="102" name="TextBox 101"/>
-          <p:cNvSpPr txBox="1"/>
-          <p:nvPr/>
-        </p:nvSpPr>
-        <p:spPr>
-          <a:xfrm>
-            <a:off x="822960" y="4242816"/>
-            <a:ext cx="365760" cy="274320"/>
-          </a:xfrm>
-          <a:prstGeom prst="rect">
-            <a:avLst/>
-          </a:prstGeom>
-          <a:noFill/>
-        </p:spPr>
-        <p:txBody>
-          <a:bodyPr wrap="square" lIns="0" rIns="0" tIns="0" bIns="0">
-            <a:spAutoFit/>
-          </a:bodyPr>
-          <a:lstStyle/>
-          <a:p>
-            <a:pPr algn="r"/>
-            <a:r>
-              <a:rPr sz="1300" b="1" i="0">
-                <a:solidFill>
-                  <a:srgbClr val="F47321"/>
-                </a:solidFill>
-                <a:latin typeface="Arial"/>
-              </a:rPr>
-              <a:t>8</a:t>
-            </a:r>
-          </a:p>
-        </p:txBody>
-      </p:sp>
-      <p:sp>
-        <p:nvSpPr>
-          <p:cNvPr id="103" name="Oval 102"/>
-          <p:cNvSpPr/>
-          <p:nvPr/>
-        </p:nvSpPr>
-        <p:spPr>
-          <a:xfrm>
-            <a:off x="1234440" y="4233672"/>
-            <a:ext cx="274320" cy="274320"/>
-          </a:xfrm>
-          <a:prstGeom prst="ellipse">
-            <a:avLst/>
-          </a:prstGeom>
-          <a:solidFill>
-            <a:srgbClr val="FFFFFF"/>
-          </a:solidFill>
-          <a:ln>
-            <a:noFill/>
-          </a:ln>
-          <a:effectLst/>
-        </p:spPr>
-        <p:style>
-          <a:lnRef idx="1">
-            <a:schemeClr val="accent1"/>
-          </a:lnRef>
-          <a:fillRef idx="3">
-            <a:schemeClr val="accent1"/>
-          </a:fillRef>
-          <a:effectRef idx="2">
-            <a:schemeClr val="accent1"/>
-          </a:effectRef>
-          <a:fontRef idx="minor">
-            <a:schemeClr val="lt1"/>
-          </a:fontRef>
-        </p:style>
-        <p:txBody>
-          <a:bodyPr rtlCol="0" anchor="ctr"/>
-          <a:lstStyle/>
-          <a:p>
-            <a:pPr algn="ctr"/>
-          </a:p>
-        </p:txBody>
-      </p:sp>
-      <p:pic>
-        <p:nvPicPr>
-          <p:cNvPr id="104" name="Picture 103" descr="texas.png"/>
-          <p:cNvPicPr>
-            <a:picLocks noChangeAspect="1"/>
-          </p:cNvPicPr>
-          <p:nvPr/>
-        </p:nvPicPr>
-        <p:blipFill>
-          <a:blip r:embed="rId9"/>
-          <a:stretch>
-            <a:fillRect/>
-          </a:stretch>
-        </p:blipFill>
-        <p:spPr>
-          <a:xfrm>
-            <a:off x="1266444" y="4265676"/>
-            <a:ext cx="210312" cy="210312"/>
-          </a:xfrm>
-          <a:prstGeom prst="rect">
-            <a:avLst/>
-          </a:prstGeom>
-        </p:spPr>
-      </p:pic>
-      <p:sp>
-        <p:nvSpPr>
-          <p:cNvPr id="105" name="TextBox 104"/>
-          <p:cNvSpPr txBox="1"/>
-          <p:nvPr/>
-        </p:nvSpPr>
-        <p:spPr>
-          <a:xfrm>
-            <a:off x="1600200" y="4242816"/>
-            <a:ext cx="2468880" cy="274320"/>
-          </a:xfrm>
-          <a:prstGeom prst="rect">
-            <a:avLst/>
-          </a:prstGeom>
-          <a:noFill/>
-        </p:spPr>
-        <p:txBody>
-          <a:bodyPr wrap="square" lIns="0" rIns="0" tIns="0" bIns="0">
-            <a:spAutoFit/>
-          </a:bodyPr>
-          <a:lstStyle/>
-          <a:p>
-            <a:pPr algn="l"/>
-            <a:r>
-              <a:rPr sz="1200" b="1" i="0">
-                <a:solidFill>
-                  <a:srgbClr val="FFFFFF"/>
-                </a:solidFill>
-                <a:latin typeface="Arial"/>
-              </a:rPr>
-              <a:t>Arch Manning · Texas</a:t>
-            </a:r>
-          </a:p>
-        </p:txBody>
-      </p:sp>
-      <p:sp>
-        <p:nvSpPr>
-          <p:cNvPr id="106" name="TextBox 105"/>
-          <p:cNvSpPr txBox="1"/>
-          <p:nvPr/>
-        </p:nvSpPr>
-        <p:spPr>
-          <a:xfrm>
-            <a:off x="4114800" y="4251959"/>
-            <a:ext cx="1097280" cy="274320"/>
-          </a:xfrm>
-          <a:prstGeom prst="rect">
-            <a:avLst/>
-          </a:prstGeom>
-          <a:noFill/>
-        </p:spPr>
-        <p:txBody>
-          <a:bodyPr wrap="square" lIns="0" rIns="0" tIns="0" bIns="0">
-            <a:spAutoFit/>
-          </a:bodyPr>
-          <a:lstStyle/>
-          <a:p>
-            <a:pPr algn="r"/>
-            <a:r>
-              <a:rPr sz="1050" b="0" i="0">
-                <a:solidFill>
-                  <a:srgbClr val="FFFFFF"/>
-                </a:solidFill>
-                <a:latin typeface="Arial"/>
-              </a:rPr>
-              <a:t>0.808 (30)</a:t>
-            </a:r>
-          </a:p>
-        </p:txBody>
-      </p:sp>
-      <p:sp>
-        <p:nvSpPr>
-          <p:cNvPr id="107" name="TextBox 106"/>
-          <p:cNvSpPr txBox="1"/>
-          <p:nvPr/>
-        </p:nvSpPr>
-        <p:spPr>
-          <a:xfrm>
-            <a:off x="5257800" y="4251959"/>
-            <a:ext cx="731520" cy="274320"/>
-          </a:xfrm>
-          <a:prstGeom prst="rect">
-            <a:avLst/>
-          </a:prstGeom>
-          <a:noFill/>
-        </p:spPr>
-        <p:txBody>
-          <a:bodyPr wrap="square" lIns="0" rIns="0" tIns="0" bIns="0">
-            <a:spAutoFit/>
-          </a:bodyPr>
-          <a:lstStyle/>
-          <a:p>
-            <a:pPr algn="r"/>
-            <a:r>
-              <a:rPr sz="1050" b="0" i="0">
-                <a:solidFill>
-                  <a:srgbClr val="CADCFC"/>
-                </a:solidFill>
-                <a:latin typeface="Arial"/>
-              </a:rPr>
-              <a:t>0.338</a:t>
-            </a:r>
-          </a:p>
-        </p:txBody>
-      </p:sp>
-      <p:sp>
-        <p:nvSpPr>
-          <p:cNvPr id="108" name="TextBox 107"/>
-          <p:cNvSpPr txBox="1"/>
-          <p:nvPr/>
-        </p:nvSpPr>
-        <p:spPr>
-          <a:xfrm>
-            <a:off x="6035040" y="4251959"/>
-            <a:ext cx="640080" cy="274320"/>
-          </a:xfrm>
-          <a:prstGeom prst="rect">
-            <a:avLst/>
-          </a:prstGeom>
-          <a:noFill/>
-        </p:spPr>
-        <p:txBody>
-          <a:bodyPr wrap="square" lIns="0" rIns="0" tIns="0" bIns="0">
-            <a:spAutoFit/>
-          </a:bodyPr>
-          <a:lstStyle/>
-          <a:p>
-            <a:pPr algn="r"/>
-            <a:r>
-              <a:rPr sz="1050" b="0" i="0">
-                <a:solidFill>
-                  <a:srgbClr val="FFFFFF"/>
-                </a:solidFill>
-                <a:latin typeface="Arial"/>
-              </a:rPr>
-              <a:t>0.416</a:t>
-            </a:r>
-          </a:p>
-        </p:txBody>
-      </p:sp>
-      <p:sp>
-        <p:nvSpPr>
-          <p:cNvPr id="109" name="TextBox 108"/>
-          <p:cNvSpPr txBox="1"/>
-          <p:nvPr/>
-        </p:nvSpPr>
-        <p:spPr>
-          <a:xfrm>
-            <a:off x="6720840" y="4251959"/>
-            <a:ext cx="822960" cy="274320"/>
-          </a:xfrm>
-          <a:prstGeom prst="rect">
-            <a:avLst/>
-          </a:prstGeom>
-          <a:noFill/>
-        </p:spPr>
-        <p:txBody>
-          <a:bodyPr wrap="square" lIns="0" rIns="0" tIns="0" bIns="0">
-            <a:spAutoFit/>
-          </a:bodyPr>
-          <a:lstStyle/>
-          <a:p>
-            <a:pPr algn="r"/>
-            <a:r>
-              <a:rPr sz="1050" b="0" i="0">
-                <a:solidFill>
-                  <a:srgbClr val="FFFFFF"/>
-                </a:solidFill>
-                <a:latin typeface="Arial"/>
-              </a:rPr>
-              <a:t>47%</a:t>
-            </a:r>
-          </a:p>
-        </p:txBody>
-      </p:sp>
-      <p:sp>
-        <p:nvSpPr>
-          <p:cNvPr id="110" name="TextBox 109"/>
-          <p:cNvSpPr txBox="1"/>
-          <p:nvPr/>
-        </p:nvSpPr>
-        <p:spPr>
-          <a:xfrm>
-            <a:off x="7589520" y="4242816"/>
-            <a:ext cx="640080" cy="274320"/>
-          </a:xfrm>
-          <a:prstGeom prst="rect">
-            <a:avLst/>
-          </a:prstGeom>
-          <a:noFill/>
-        </p:spPr>
-        <p:txBody>
-          <a:bodyPr wrap="square" lIns="0" rIns="0" tIns="0" bIns="0">
-            <a:spAutoFit/>
-          </a:bodyPr>
-          <a:lstStyle/>
-          <a:p>
-            <a:pPr algn="r"/>
-            <a:r>
-              <a:rPr sz="1250" b="1" i="0">
-                <a:solidFill>
-                  <a:srgbClr val="F47321"/>
-                </a:solidFill>
-                <a:latin typeface="Arial"/>
-              </a:rPr>
-              <a:t>30.6</a:t>
-            </a:r>
-          </a:p>
-        </p:txBody>
-      </p:sp>
-      <p:sp>
-        <p:nvSpPr>
-          <p:cNvPr id="111" name="TextBox 110"/>
-          <p:cNvSpPr txBox="1"/>
-          <p:nvPr/>
-        </p:nvSpPr>
-        <p:spPr>
-          <a:xfrm>
-            <a:off x="8275320" y="4251959"/>
-            <a:ext cx="822960" cy="274320"/>
-          </a:xfrm>
-          <a:prstGeom prst="rect">
-            <a:avLst/>
-          </a:prstGeom>
-          <a:noFill/>
-        </p:spPr>
-        <p:txBody>
-          <a:bodyPr wrap="square" lIns="0" rIns="0" tIns="0" bIns="0">
-            <a:spAutoFit/>
-          </a:bodyPr>
-          <a:lstStyle/>
-          <a:p>
-            <a:pPr algn="r"/>
-            <a:r>
-              <a:rPr sz="1050" b="0" i="0">
-                <a:solidFill>
-                  <a:srgbClr val="FFFFFF"/>
-                </a:solidFill>
-                <a:latin typeface="Arial"/>
-              </a:rPr>
-              <a:t>+950</a:t>
-            </a:r>
-          </a:p>
-        </p:txBody>
-      </p:sp>
-      <p:sp>
-        <p:nvSpPr>
-          <p:cNvPr id="112" name="TextBox 111"/>
-          <p:cNvSpPr txBox="1"/>
-          <p:nvPr/>
-        </p:nvSpPr>
-        <p:spPr>
-          <a:xfrm>
-            <a:off x="9144000" y="4251959"/>
-            <a:ext cx="822960" cy="274320"/>
-          </a:xfrm>
-          <a:prstGeom prst="rect">
-            <a:avLst/>
-          </a:prstGeom>
-          <a:noFill/>
-        </p:spPr>
-        <p:txBody>
-          <a:bodyPr wrap="square" lIns="0" rIns="0" tIns="0" bIns="0">
-            <a:spAutoFit/>
-          </a:bodyPr>
-          <a:lstStyle/>
-          <a:p>
-            <a:pPr algn="r"/>
-            <a:r>
-              <a:rPr sz="1050" b="0" i="0">
-                <a:solidFill>
-                  <a:srgbClr val="CADCFC"/>
-                </a:solidFill>
-                <a:latin typeface="Arial"/>
-              </a:rPr>
-              <a:t>#2</a:t>
-            </a:r>
-          </a:p>
-        </p:txBody>
-      </p:sp>
-      <p:sp>
-        <p:nvSpPr>
-          <p:cNvPr id="113" name="TextBox 112"/>
-          <p:cNvSpPr txBox="1"/>
-          <p:nvPr/>
-        </p:nvSpPr>
-        <p:spPr>
-          <a:xfrm>
-            <a:off x="10012680" y="4251959"/>
-            <a:ext cx="1325880" cy="274320"/>
-          </a:xfrm>
-          <a:prstGeom prst="rect">
-            <a:avLst/>
-          </a:prstGeom>
-          <a:noFill/>
-        </p:spPr>
-        <p:txBody>
-          <a:bodyPr wrap="square" lIns="0" rIns="0" tIns="0" bIns="0">
-            <a:spAutoFit/>
-          </a:bodyPr>
-          <a:lstStyle/>
-          <a:p>
-            <a:pPr algn="r"/>
-            <a:r>
-              <a:rPr sz="950" b="1" i="0">
-                <a:solidFill>
-                  <a:srgbClr val="FF7A7A"/>
-                </a:solidFill>
-                <a:latin typeface="Arial"/>
-              </a:rPr>
-              <a:t>market too high</a:t>
-            </a:r>
-          </a:p>
-        </p:txBody>
-      </p:sp>
-      <p:sp>
-        <p:nvSpPr>
-          <p:cNvPr id="114" name="Rectangle 113"/>
-          <p:cNvSpPr/>
-          <p:nvPr/>
-        </p:nvSpPr>
-        <p:spPr>
-          <a:xfrm>
-            <a:off x="822960" y="4535424"/>
-            <a:ext cx="10515600" cy="329184"/>
-          </a:xfrm>
-          <a:prstGeom prst="rect">
-            <a:avLst/>
-          </a:prstGeom>
-          <a:solidFill>
-            <a:srgbClr val="123568"/>
-          </a:solidFill>
-          <a:ln>
-            <a:noFill/>
-          </a:ln>
-          <a:effectLst/>
-        </p:spPr>
-        <p:style>
-          <a:lnRef idx="1">
-            <a:schemeClr val="accent1"/>
-          </a:lnRef>
-          <a:fillRef idx="3">
-            <a:schemeClr val="accent1"/>
-          </a:fillRef>
-          <a:effectRef idx="2">
-            <a:schemeClr val="accent1"/>
-          </a:effectRef>
-          <a:fontRef idx="minor">
-            <a:schemeClr val="lt1"/>
-          </a:fontRef>
-        </p:style>
-        <p:txBody>
-          <a:bodyPr rtlCol="0" anchor="ctr"/>
-          <a:lstStyle/>
-          <a:p>
-            <a:pPr algn="ctr"/>
-          </a:p>
-        </p:txBody>
-      </p:sp>
-      <p:sp>
-        <p:nvSpPr>
-          <p:cNvPr id="115" name="TextBox 114"/>
-          <p:cNvSpPr txBox="1"/>
-          <p:nvPr/>
-        </p:nvSpPr>
-        <p:spPr>
-          <a:xfrm>
-            <a:off x="822960" y="4572000"/>
-            <a:ext cx="365760" cy="274320"/>
-          </a:xfrm>
-          <a:prstGeom prst="rect">
-            <a:avLst/>
-          </a:prstGeom>
-          <a:noFill/>
-        </p:spPr>
-        <p:txBody>
-          <a:bodyPr wrap="square" lIns="0" rIns="0" tIns="0" bIns="0">
-            <a:spAutoFit/>
-          </a:bodyPr>
-          <a:lstStyle/>
-          <a:p>
-            <a:pPr algn="r"/>
-            <a:r>
-              <a:rPr sz="1300" b="1" i="0">
-                <a:solidFill>
-                  <a:srgbClr val="F47321"/>
-                </a:solidFill>
-                <a:latin typeface="Arial"/>
-              </a:rPr>
-              <a:t>9</a:t>
-            </a:r>
-          </a:p>
-        </p:txBody>
-      </p:sp>
-      <p:sp>
-        <p:nvSpPr>
-          <p:cNvPr id="116" name="Oval 115"/>
-          <p:cNvSpPr/>
-          <p:nvPr/>
-        </p:nvSpPr>
-        <p:spPr>
-          <a:xfrm>
-            <a:off x="1234440" y="4562856"/>
-            <a:ext cx="274320" cy="274320"/>
-          </a:xfrm>
-          <a:prstGeom prst="ellipse">
-            <a:avLst/>
-          </a:prstGeom>
-          <a:solidFill>
-            <a:srgbClr val="FFFFFF"/>
-          </a:solidFill>
-          <a:ln>
-            <a:noFill/>
-          </a:ln>
-          <a:effectLst/>
-        </p:spPr>
-        <p:style>
-          <a:lnRef idx="1">
-            <a:schemeClr val="accent1"/>
-          </a:lnRef>
-          <a:fillRef idx="3">
-            <a:schemeClr val="accent1"/>
-          </a:fillRef>
-          <a:effectRef idx="2">
-            <a:schemeClr val="accent1"/>
-          </a:effectRef>
-          <a:fontRef idx="minor">
-            <a:schemeClr val="lt1"/>
-          </a:fontRef>
-        </p:style>
-        <p:txBody>
-          <a:bodyPr rtlCol="0" anchor="ctr"/>
-          <a:lstStyle/>
-          <a:p>
-            <a:pPr algn="ctr"/>
-          </a:p>
-        </p:txBody>
-      </p:sp>
-      <p:pic>
-        <p:nvPicPr>
-          <p:cNvPr id="117" name="Picture 116" descr="lsu.png"/>
-          <p:cNvPicPr>
-            <a:picLocks noChangeAspect="1"/>
-          </p:cNvPicPr>
-          <p:nvPr/>
-        </p:nvPicPr>
-        <p:blipFill>
-          <a:blip r:embed="rId10"/>
-          <a:stretch>
-            <a:fillRect/>
-          </a:stretch>
-        </p:blipFill>
-        <p:spPr>
-          <a:xfrm>
-            <a:off x="1266444" y="4594860"/>
-            <a:ext cx="210312" cy="210312"/>
-          </a:xfrm>
-          <a:prstGeom prst="rect">
-            <a:avLst/>
-          </a:prstGeom>
-        </p:spPr>
-      </p:pic>
-      <p:sp>
-        <p:nvSpPr>
-          <p:cNvPr id="118" name="TextBox 117"/>
-          <p:cNvSpPr txBox="1"/>
-          <p:nvPr/>
-        </p:nvSpPr>
-        <p:spPr>
-          <a:xfrm>
-            <a:off x="1600200" y="4572000"/>
-            <a:ext cx="2468880" cy="274320"/>
-          </a:xfrm>
-          <a:prstGeom prst="rect">
-            <a:avLst/>
-          </a:prstGeom>
-          <a:noFill/>
-        </p:spPr>
-        <p:txBody>
-          <a:bodyPr wrap="square" lIns="0" rIns="0" tIns="0" bIns="0">
-            <a:spAutoFit/>
-          </a:bodyPr>
-          <a:lstStyle/>
-          <a:p>
-            <a:pPr algn="l"/>
-            <a:r>
-              <a:rPr sz="1200" b="1" i="0">
-                <a:solidFill>
-                  <a:srgbClr val="FFFFFF"/>
-                </a:solidFill>
-                <a:latin typeface="Arial"/>
-              </a:rPr>
-              <a:t>Sam Leavitt · LSU</a:t>
-            </a:r>
-          </a:p>
-        </p:txBody>
-      </p:sp>
-      <p:sp>
-        <p:nvSpPr>
-          <p:cNvPr id="119" name="TextBox 118"/>
-          <p:cNvSpPr txBox="1"/>
-          <p:nvPr/>
-        </p:nvSpPr>
-        <p:spPr>
-          <a:xfrm>
-            <a:off x="4114800" y="4581144"/>
-            <a:ext cx="1097280" cy="274320"/>
-          </a:xfrm>
-          <a:prstGeom prst="rect">
-            <a:avLst/>
-          </a:prstGeom>
-          <a:noFill/>
-        </p:spPr>
-        <p:txBody>
-          <a:bodyPr wrap="square" lIns="0" rIns="0" tIns="0" bIns="0">
-            <a:spAutoFit/>
-          </a:bodyPr>
-          <a:lstStyle/>
-          <a:p>
-            <a:pPr algn="r"/>
-            <a:r>
-              <a:rPr sz="1050" b="0" i="0">
-                <a:solidFill>
-                  <a:srgbClr val="FFFFFF"/>
-                </a:solidFill>
-                <a:latin typeface="Arial"/>
-              </a:rPr>
-              <a:t>0.506 (39)</a:t>
-            </a:r>
-          </a:p>
-        </p:txBody>
-      </p:sp>
-      <p:sp>
-        <p:nvSpPr>
-          <p:cNvPr id="120" name="TextBox 119"/>
-          <p:cNvSpPr txBox="1"/>
-          <p:nvPr/>
-        </p:nvSpPr>
-        <p:spPr>
-          <a:xfrm>
-            <a:off x="5257800" y="4581144"/>
-            <a:ext cx="731520" cy="274320"/>
-          </a:xfrm>
-          <a:prstGeom prst="rect">
-            <a:avLst/>
-          </a:prstGeom>
-          <a:noFill/>
-        </p:spPr>
-        <p:txBody>
-          <a:bodyPr wrap="square" lIns="0" rIns="0" tIns="0" bIns="0">
-            <a:spAutoFit/>
-          </a:bodyPr>
-          <a:lstStyle/>
-          <a:p>
-            <a:pPr algn="r"/>
-            <a:r>
-              <a:rPr sz="1050" b="0" i="0">
-                <a:solidFill>
-                  <a:srgbClr val="CADCFC"/>
-                </a:solidFill>
-                <a:latin typeface="Arial"/>
-              </a:rPr>
-              <a:t>0.314</a:t>
-            </a:r>
-          </a:p>
-        </p:txBody>
-      </p:sp>
-      <p:sp>
-        <p:nvSpPr>
-          <p:cNvPr id="121" name="TextBox 120"/>
-          <p:cNvSpPr txBox="1"/>
-          <p:nvPr/>
-        </p:nvSpPr>
-        <p:spPr>
-          <a:xfrm>
-            <a:off x="6035040" y="4581144"/>
-            <a:ext cx="640080" cy="274320"/>
-          </a:xfrm>
-          <a:prstGeom prst="rect">
-            <a:avLst/>
-          </a:prstGeom>
-          <a:noFill/>
-        </p:spPr>
-        <p:txBody>
-          <a:bodyPr wrap="square" lIns="0" rIns="0" tIns="0" bIns="0">
-            <a:spAutoFit/>
-          </a:bodyPr>
-          <a:lstStyle/>
-          <a:p>
-            <a:pPr algn="r"/>
-            <a:r>
-              <a:rPr sz="1050" b="0" i="0">
-                <a:solidFill>
-                  <a:srgbClr val="FFFFFF"/>
-                </a:solidFill>
-                <a:latin typeface="Arial"/>
-              </a:rPr>
-              <a:t>0.354</a:t>
-            </a:r>
-          </a:p>
-        </p:txBody>
-      </p:sp>
-      <p:sp>
-        <p:nvSpPr>
-          <p:cNvPr id="122" name="TextBox 121"/>
-          <p:cNvSpPr txBox="1"/>
-          <p:nvPr/>
-        </p:nvSpPr>
-        <p:spPr>
-          <a:xfrm>
-            <a:off x="6720840" y="4581144"/>
-            <a:ext cx="822960" cy="274320"/>
-          </a:xfrm>
-          <a:prstGeom prst="rect">
-            <a:avLst/>
-          </a:prstGeom>
-          <a:noFill/>
-        </p:spPr>
-        <p:txBody>
-          <a:bodyPr wrap="square" lIns="0" rIns="0" tIns="0" bIns="0">
-            <a:spAutoFit/>
-          </a:bodyPr>
-          <a:lstStyle/>
-          <a:p>
-            <a:pPr algn="r"/>
-            <a:r>
-              <a:rPr sz="1050" b="0" i="0">
-                <a:solidFill>
-                  <a:srgbClr val="FFFFFF"/>
-                </a:solidFill>
-                <a:latin typeface="Arial"/>
-              </a:rPr>
-              <a:t>47%</a:t>
-            </a:r>
-          </a:p>
-        </p:txBody>
-      </p:sp>
-      <p:sp>
-        <p:nvSpPr>
-          <p:cNvPr id="123" name="TextBox 122"/>
-          <p:cNvSpPr txBox="1"/>
-          <p:nvPr/>
-        </p:nvSpPr>
-        <p:spPr>
-          <a:xfrm>
-            <a:off x="7589520" y="4572000"/>
-            <a:ext cx="640080" cy="274320"/>
-          </a:xfrm>
-          <a:prstGeom prst="rect">
-            <a:avLst/>
-          </a:prstGeom>
-          <a:noFill/>
-        </p:spPr>
-        <p:txBody>
-          <a:bodyPr wrap="square" lIns="0" rIns="0" tIns="0" bIns="0">
-            <a:spAutoFit/>
-          </a:bodyPr>
-          <a:lstStyle/>
-          <a:p>
-            <a:pPr algn="r"/>
-            <a:r>
-              <a:rPr sz="1250" b="1" i="0">
-                <a:solidFill>
-                  <a:srgbClr val="F47321"/>
-                </a:solidFill>
-                <a:latin typeface="Arial"/>
-              </a:rPr>
-              <a:t>25.9</a:t>
-            </a:r>
-          </a:p>
-        </p:txBody>
-      </p:sp>
-      <p:sp>
-        <p:nvSpPr>
-          <p:cNvPr id="124" name="TextBox 123"/>
-          <p:cNvSpPr txBox="1"/>
-          <p:nvPr/>
-        </p:nvSpPr>
-        <p:spPr>
-          <a:xfrm>
-            <a:off x="8275320" y="4581144"/>
-            <a:ext cx="822960" cy="274320"/>
-          </a:xfrm>
-          <a:prstGeom prst="rect">
-            <a:avLst/>
-          </a:prstGeom>
-          <a:noFill/>
-        </p:spPr>
-        <p:txBody>
-          <a:bodyPr wrap="square" lIns="0" rIns="0" tIns="0" bIns="0">
-            <a:spAutoFit/>
-          </a:bodyPr>
-          <a:lstStyle/>
-          <a:p>
-            <a:pPr algn="r"/>
-            <a:r>
-              <a:rPr sz="1050" b="0" i="0">
-                <a:solidFill>
-                  <a:srgbClr val="FFFFFF"/>
-                </a:solidFill>
-                <a:latin typeface="Arial"/>
-              </a:rPr>
-              <a:t>+1500</a:t>
-            </a:r>
-          </a:p>
-        </p:txBody>
-      </p:sp>
-      <p:sp>
-        <p:nvSpPr>
-          <p:cNvPr id="125" name="TextBox 124"/>
-          <p:cNvSpPr txBox="1"/>
-          <p:nvPr/>
-        </p:nvSpPr>
-        <p:spPr>
-          <a:xfrm>
-            <a:off x="9144000" y="4581144"/>
-            <a:ext cx="822960" cy="274320"/>
-          </a:xfrm>
-          <a:prstGeom prst="rect">
-            <a:avLst/>
-          </a:prstGeom>
-          <a:noFill/>
-        </p:spPr>
-        <p:txBody>
-          <a:bodyPr wrap="square" lIns="0" rIns="0" tIns="0" bIns="0">
-            <a:spAutoFit/>
-          </a:bodyPr>
-          <a:lstStyle/>
-          <a:p>
-            <a:pPr algn="r"/>
-            <a:r>
-              <a:rPr sz="1050" b="0" i="0">
-                <a:solidFill>
-                  <a:srgbClr val="CADCFC"/>
-                </a:solidFill>
-                <a:latin typeface="Arial"/>
-              </a:rPr>
-              <a:t>#9</a:t>
-            </a:r>
-          </a:p>
-        </p:txBody>
-      </p:sp>
-      <p:sp>
-        <p:nvSpPr>
-          <p:cNvPr id="126" name="TextBox 125"/>
-          <p:cNvSpPr txBox="1"/>
-          <p:nvPr/>
-        </p:nvSpPr>
-        <p:spPr>
-          <a:xfrm>
-            <a:off x="10012680" y="4581144"/>
-            <a:ext cx="1325880" cy="274320"/>
-          </a:xfrm>
-          <a:prstGeom prst="rect">
-            <a:avLst/>
-          </a:prstGeom>
-          <a:noFill/>
-        </p:spPr>
-        <p:txBody>
-          <a:bodyPr wrap="square" lIns="0" rIns="0" tIns="0" bIns="0">
-            <a:spAutoFit/>
-          </a:bodyPr>
-          <a:lstStyle/>
-          <a:p>
-            <a:pPr algn="r"/>
-            <a:r>
-              <a:rPr sz="950" b="0" i="0">
-                <a:solidFill>
-                  <a:srgbClr val="CADCFC"/>
-                </a:solidFill>
-                <a:latin typeface="Arial"/>
-              </a:rPr>
-              <a:t>agree</a:t>
-            </a:r>
-          </a:p>
-        </p:txBody>
-      </p:sp>
-      <p:sp>
-        <p:nvSpPr>
-          <p:cNvPr id="127" name="Rounded Rectangle 126"/>
-          <p:cNvSpPr/>
-          <p:nvPr/>
-        </p:nvSpPr>
-        <p:spPr>
-          <a:xfrm>
-            <a:off x="822960" y="4974336"/>
+            <a:off x="822960" y="5102352"/>
             <a:ext cx="10515600" cy="658368"/>
           </a:xfrm>
           <a:prstGeom prst="roundRect">
@@ -30754,13 +29204,13 @@
       </p:sp>
       <p:sp>
         <p:nvSpPr>
-          <p:cNvPr id="128" name="TextBox 127"/>
-          <p:cNvSpPr txBox="1"/>
-          <p:nvPr/>
-        </p:nvSpPr>
-        <p:spPr>
-          <a:xfrm>
-            <a:off x="1097280" y="5065776"/>
+          <p:cNvPr id="84" name="TextBox 83"/>
+          <p:cNvSpPr txBox="1"/>
+          <p:nvPr/>
+        </p:nvSpPr>
+        <p:spPr>
+          <a:xfrm>
+            <a:off x="1097280" y="5193792"/>
             <a:ext cx="2743200" cy="457200"/>
           </a:xfrm>
           <a:prstGeom prst="rect">
@@ -30789,13 +29239,13 @@
       </p:sp>
       <p:sp>
         <p:nvSpPr>
-          <p:cNvPr id="129" name="TextBox 128"/>
-          <p:cNvSpPr txBox="1"/>
-          <p:nvPr/>
-        </p:nvSpPr>
-        <p:spPr>
-          <a:xfrm>
-            <a:off x="3657600" y="5047488"/>
+          <p:cNvPr id="85" name="TextBox 84"/>
+          <p:cNvSpPr txBox="1"/>
+          <p:nvPr/>
+        </p:nvSpPr>
+        <p:spPr>
+          <a:xfrm>
+            <a:off x="3657600" y="5175504"/>
             <a:ext cx="7498079" cy="502920"/>
           </a:xfrm>
           <a:prstGeom prst="rect">
@@ -30824,13 +29274,13 @@
       </p:sp>
       <p:sp>
         <p:nvSpPr>
-          <p:cNvPr id="130" name="TextBox 129"/>
-          <p:cNvSpPr txBox="1"/>
-          <p:nvPr/>
-        </p:nvSpPr>
-        <p:spPr>
-          <a:xfrm>
-            <a:off x="822960" y="5751576"/>
+          <p:cNvPr id="86" name="TextBox 85"/>
+          <p:cNvSpPr txBox="1"/>
+          <p:nvPr/>
+        </p:nvSpPr>
+        <p:spPr>
+          <a:xfrm>
+            <a:off x="822960" y="5879592"/>
             <a:ext cx="10515600" cy="274320"/>
           </a:xfrm>
           <a:prstGeom prst="rect">
@@ -30859,7 +29309,7 @@
       </p:sp>
       <p:sp>
         <p:nvSpPr>
-          <p:cNvPr id="131" name="TextBox 130"/>
+          <p:cNvPr id="87" name="TextBox 86"/>
           <p:cNvSpPr txBox="1"/>
           <p:nvPr/>
         </p:nvSpPr>

</xml_diff>

<commit_message>
Ep3 card slide: 'Seven Games, One Card' - Superdog + Giant Killer rows from the live boards; notes table to match
Co-Authored-By: Claude Fable 5.1 <noreply@anthropic.com>
</commit_message>
<xml_diff>
--- a/decks/2026_Week2_Episode3.pptx
+++ b/decks/2026_Week2_Episode3.pptx
@@ -29376,8 +29376,8 @@
         </p:nvSpPr>
         <p:spPr>
           <a:xfrm>
-            <a:off x="822960" y="777240"/>
-            <a:ext cx="10515600" cy="411480"/>
+            <a:off x="822960" y="457200"/>
+            <a:ext cx="10515600" cy="365760"/>
           </a:xfrm>
           <a:prstGeom prst="rect">
             <a:avLst/>
@@ -29411,8 +29411,8 @@
         </p:nvSpPr>
         <p:spPr>
           <a:xfrm>
-            <a:off x="822960" y="1097280"/>
-            <a:ext cx="10515600" cy="1005840"/>
+            <a:off x="822960" y="749808"/>
+            <a:ext cx="10515600" cy="822960"/>
           </a:xfrm>
           <a:prstGeom prst="rect">
             <a:avLst/>
@@ -29427,13 +29427,13 @@
           <a:p>
             <a:pPr algn="l"/>
             <a:r>
-              <a:rPr sz="4400" b="1" i="0">
+              <a:rPr sz="4000" b="1" i="0">
                 <a:solidFill>
                   <a:srgbClr val="FFFFFF"/>
                 </a:solidFill>
                 <a:latin typeface="Arial"/>
               </a:rPr>
-              <a:t>Five Games, One Card</a:t>
+              <a:t>Seven Games, One Card</a:t>
             </a:r>
           </a:p>
         </p:txBody>
@@ -29446,8 +29446,8 @@
         </p:nvSpPr>
         <p:spPr>
           <a:xfrm>
-            <a:off x="822960" y="2194560"/>
-            <a:ext cx="10515600" cy="731520"/>
+            <a:off x="822960" y="1755648"/>
+            <a:ext cx="10515600" cy="548640"/>
           </a:xfrm>
           <a:prstGeom prst="roundRect">
             <a:avLst/>
@@ -29490,8 +29490,8 @@
         </p:nvSpPr>
         <p:spPr>
           <a:xfrm>
-            <a:off x="1005840" y="2286000"/>
-            <a:ext cx="548640" cy="548640"/>
+            <a:off x="960120" y="1819656"/>
+            <a:ext cx="420624" cy="420624"/>
           </a:xfrm>
           <a:prstGeom prst="ellipse">
             <a:avLst/>
@@ -29542,8 +29542,8 @@
         </p:blipFill>
         <p:spPr>
           <a:xfrm>
-            <a:off x="1060704" y="2340864"/>
-            <a:ext cx="438912" cy="438912"/>
+            <a:off x="1002182" y="1861718"/>
+            <a:ext cx="336499" cy="336499"/>
           </a:xfrm>
           <a:prstGeom prst="rect">
             <a:avLst/>
@@ -29558,8 +29558,8 @@
         </p:nvSpPr>
         <p:spPr>
           <a:xfrm>
-            <a:off x="1691640" y="2286000"/>
-            <a:ext cx="548640" cy="548640"/>
+            <a:off x="1463040" y="1819656"/>
+            <a:ext cx="420624" cy="420624"/>
           </a:xfrm>
           <a:prstGeom prst="ellipse">
             <a:avLst/>
@@ -29610,8 +29610,8 @@
         </p:blipFill>
         <p:spPr>
           <a:xfrm>
-            <a:off x="1746504" y="2340864"/>
-            <a:ext cx="438912" cy="438912"/>
+            <a:off x="1505102" y="1861718"/>
+            <a:ext cx="336499" cy="336499"/>
           </a:xfrm>
           <a:prstGeom prst="rect">
             <a:avLst/>
@@ -29626,8 +29626,8 @@
         </p:nvSpPr>
         <p:spPr>
           <a:xfrm>
-            <a:off x="2468880" y="2286000"/>
-            <a:ext cx="5943600" cy="365760"/>
+            <a:off x="2057400" y="1792224"/>
+            <a:ext cx="6035040" cy="292608"/>
           </a:xfrm>
           <a:prstGeom prst="rect">
             <a:avLst/>
@@ -29642,7 +29642,7 @@
           <a:p>
             <a:pPr algn="l"/>
             <a:r>
-              <a:rPr sz="1500" b="1" i="0">
+              <a:rPr sz="1400" b="1" i="0">
                 <a:solidFill>
                   <a:srgbClr val="FFFFFF"/>
                 </a:solidFill>
@@ -29661,8 +29661,8 @@
         </p:nvSpPr>
         <p:spPr>
           <a:xfrm>
-            <a:off x="2468880" y="2615184"/>
-            <a:ext cx="5943600" cy="274320"/>
+            <a:off x="2057400" y="2057400"/>
+            <a:ext cx="6035040" cy="237744"/>
           </a:xfrm>
           <a:prstGeom prst="rect">
             <a:avLst/>
@@ -29677,7 +29677,7 @@
           <a:p>
             <a:pPr algn="l"/>
             <a:r>
-              <a:rPr sz="1000" b="0" i="0">
+              <a:rPr sz="900" b="0" i="0">
                 <a:solidFill>
                   <a:srgbClr val="CADCFC"/>
                 </a:solidFill>
@@ -29696,8 +29696,8 @@
         </p:nvSpPr>
         <p:spPr>
           <a:xfrm>
-            <a:off x="7680960" y="2286000"/>
-            <a:ext cx="3474720" cy="365760"/>
+            <a:off x="7772400" y="1801368"/>
+            <a:ext cx="3383280" cy="310896"/>
           </a:xfrm>
           <a:prstGeom prst="rect">
             <a:avLst/>
@@ -29712,7 +29712,7 @@
           <a:p>
             <a:pPr algn="r"/>
             <a:r>
-              <a:rPr sz="1350" b="1" i="0">
+              <a:rPr sz="1250" b="1" i="0">
                 <a:solidFill>
                   <a:srgbClr val="F47321"/>
                 </a:solidFill>
@@ -29731,8 +29731,8 @@
         </p:nvSpPr>
         <p:spPr>
           <a:xfrm>
-            <a:off x="7680960" y="2624328"/>
-            <a:ext cx="3474720" cy="274320"/>
+            <a:off x="7772400" y="2075688"/>
+            <a:ext cx="3383280" cy="228600"/>
           </a:xfrm>
           <a:prstGeom prst="rect">
             <a:avLst/>
@@ -29747,7 +29747,7 @@
           <a:p>
             <a:pPr algn="r"/>
             <a:r>
-              <a:rPr sz="950" b="0" i="0">
+              <a:rPr sz="850" b="0" i="0">
                 <a:solidFill>
                   <a:srgbClr val="CADCFC"/>
                 </a:solidFill>
@@ -29766,8 +29766,8 @@
         </p:nvSpPr>
         <p:spPr>
           <a:xfrm>
-            <a:off x="822960" y="2999232"/>
-            <a:ext cx="10515600" cy="731520"/>
+            <a:off x="822960" y="2359152"/>
+            <a:ext cx="10515600" cy="548640"/>
           </a:xfrm>
           <a:prstGeom prst="roundRect">
             <a:avLst/>
@@ -29810,8 +29810,8 @@
         </p:nvSpPr>
         <p:spPr>
           <a:xfrm>
-            <a:off x="1005840" y="3090672"/>
-            <a:ext cx="548640" cy="548640"/>
+            <a:off x="960120" y="2423160"/>
+            <a:ext cx="420624" cy="420624"/>
           </a:xfrm>
           <a:prstGeom prst="ellipse">
             <a:avLst/>
@@ -29862,8 +29862,8 @@
         </p:blipFill>
         <p:spPr>
           <a:xfrm>
-            <a:off x="1060704" y="3145536"/>
-            <a:ext cx="438912" cy="438912"/>
+            <a:off x="1002182" y="2465222"/>
+            <a:ext cx="336499" cy="336499"/>
           </a:xfrm>
           <a:prstGeom prst="rect">
             <a:avLst/>
@@ -29878,8 +29878,8 @@
         </p:nvSpPr>
         <p:spPr>
           <a:xfrm>
-            <a:off x="1691640" y="3090672"/>
-            <a:ext cx="548640" cy="548640"/>
+            <a:off x="1463040" y="2423160"/>
+            <a:ext cx="420624" cy="420624"/>
           </a:xfrm>
           <a:prstGeom prst="ellipse">
             <a:avLst/>
@@ -29930,8 +29930,8 @@
         </p:blipFill>
         <p:spPr>
           <a:xfrm>
-            <a:off x="1746504" y="3145536"/>
-            <a:ext cx="438912" cy="438912"/>
+            <a:off x="1505102" y="2465222"/>
+            <a:ext cx="336499" cy="336499"/>
           </a:xfrm>
           <a:prstGeom prst="rect">
             <a:avLst/>
@@ -29946,8 +29946,8 @@
         </p:nvSpPr>
         <p:spPr>
           <a:xfrm>
-            <a:off x="2468880" y="3090672"/>
-            <a:ext cx="5943600" cy="365760"/>
+            <a:off x="2057400" y="2395728"/>
+            <a:ext cx="6035040" cy="292608"/>
           </a:xfrm>
           <a:prstGeom prst="rect">
             <a:avLst/>
@@ -29962,7 +29962,7 @@
           <a:p>
             <a:pPr algn="l"/>
             <a:r>
-              <a:rPr sz="1500" b="1" i="0">
+              <a:rPr sz="1400" b="1" i="0">
                 <a:solidFill>
                   <a:srgbClr val="FFFFFF"/>
                 </a:solidFill>
@@ -29981,8 +29981,8 @@
         </p:nvSpPr>
         <p:spPr>
           <a:xfrm>
-            <a:off x="2468880" y="3419856"/>
-            <a:ext cx="5943600" cy="274320"/>
+            <a:off x="2057400" y="2660904"/>
+            <a:ext cx="6035040" cy="237744"/>
           </a:xfrm>
           <a:prstGeom prst="rect">
             <a:avLst/>
@@ -29997,7 +29997,7 @@
           <a:p>
             <a:pPr algn="l"/>
             <a:r>
-              <a:rPr sz="1000" b="0" i="0">
+              <a:rPr sz="900" b="0" i="0">
                 <a:solidFill>
                   <a:srgbClr val="CADCFC"/>
                 </a:solidFill>
@@ -30016,8 +30016,8 @@
         </p:nvSpPr>
         <p:spPr>
           <a:xfrm>
-            <a:off x="7680960" y="3090672"/>
-            <a:ext cx="3474720" cy="365760"/>
+            <a:off x="7772400" y="2404872"/>
+            <a:ext cx="3383280" cy="310896"/>
           </a:xfrm>
           <a:prstGeom prst="rect">
             <a:avLst/>
@@ -30032,7 +30032,7 @@
           <a:p>
             <a:pPr algn="r"/>
             <a:r>
-              <a:rPr sz="1350" b="1" i="0">
+              <a:rPr sz="1250" b="1" i="0">
                 <a:solidFill>
                   <a:srgbClr val="F47321"/>
                 </a:solidFill>
@@ -30051,8 +30051,8 @@
         </p:nvSpPr>
         <p:spPr>
           <a:xfrm>
-            <a:off x="7680960" y="3429000"/>
-            <a:ext cx="3474720" cy="274320"/>
+            <a:off x="7772400" y="2679192"/>
+            <a:ext cx="3383280" cy="228600"/>
           </a:xfrm>
           <a:prstGeom prst="rect">
             <a:avLst/>
@@ -30067,7 +30067,7 @@
           <a:p>
             <a:pPr algn="r"/>
             <a:r>
-              <a:rPr sz="950" b="0" i="0">
+              <a:rPr sz="850" b="0" i="0">
                 <a:solidFill>
                   <a:srgbClr val="CADCFC"/>
                 </a:solidFill>
@@ -30086,8 +30086,8 @@
         </p:nvSpPr>
         <p:spPr>
           <a:xfrm>
-            <a:off x="822960" y="3803904"/>
-            <a:ext cx="10515600" cy="731520"/>
+            <a:off x="822960" y="2962656"/>
+            <a:ext cx="10515600" cy="548640"/>
           </a:xfrm>
           <a:prstGeom prst="roundRect">
             <a:avLst/>
@@ -30130,8 +30130,8 @@
         </p:nvSpPr>
         <p:spPr>
           <a:xfrm>
-            <a:off x="1005840" y="3895344"/>
-            <a:ext cx="548640" cy="548640"/>
+            <a:off x="960120" y="3026664"/>
+            <a:ext cx="420624" cy="420624"/>
           </a:xfrm>
           <a:prstGeom prst="ellipse">
             <a:avLst/>
@@ -30182,8 +30182,8 @@
         </p:blipFill>
         <p:spPr>
           <a:xfrm>
-            <a:off x="1060704" y="3950207"/>
-            <a:ext cx="438912" cy="438912"/>
+            <a:off x="1002182" y="3068726"/>
+            <a:ext cx="336499" cy="336499"/>
           </a:xfrm>
           <a:prstGeom prst="rect">
             <a:avLst/>
@@ -30198,8 +30198,8 @@
         </p:nvSpPr>
         <p:spPr>
           <a:xfrm>
-            <a:off x="1691640" y="3895344"/>
-            <a:ext cx="548640" cy="548640"/>
+            <a:off x="1463040" y="3026664"/>
+            <a:ext cx="420624" cy="420624"/>
           </a:xfrm>
           <a:prstGeom prst="ellipse">
             <a:avLst/>
@@ -30250,8 +30250,8 @@
         </p:blipFill>
         <p:spPr>
           <a:xfrm>
-            <a:off x="1746504" y="3950207"/>
-            <a:ext cx="438912" cy="438912"/>
+            <a:off x="1505102" y="3068726"/>
+            <a:ext cx="336499" cy="336499"/>
           </a:xfrm>
           <a:prstGeom prst="rect">
             <a:avLst/>
@@ -30266,8 +30266,8 @@
         </p:nvSpPr>
         <p:spPr>
           <a:xfrm>
-            <a:off x="2468880" y="3895344"/>
-            <a:ext cx="5943600" cy="365760"/>
+            <a:off x="2057400" y="2999232"/>
+            <a:ext cx="6035040" cy="292608"/>
           </a:xfrm>
           <a:prstGeom prst="rect">
             <a:avLst/>
@@ -30282,7 +30282,7 @@
           <a:p>
             <a:pPr algn="l"/>
             <a:r>
-              <a:rPr sz="1500" b="1" i="0">
+              <a:rPr sz="1400" b="1" i="0">
                 <a:solidFill>
                   <a:srgbClr val="FFFFFF"/>
                 </a:solidFill>
@@ -30301,8 +30301,8 @@
         </p:nvSpPr>
         <p:spPr>
           <a:xfrm>
-            <a:off x="2468880" y="4224528"/>
-            <a:ext cx="5943600" cy="274320"/>
+            <a:off x="2057400" y="3264408"/>
+            <a:ext cx="6035040" cy="237744"/>
           </a:xfrm>
           <a:prstGeom prst="rect">
             <a:avLst/>
@@ -30317,7 +30317,7 @@
           <a:p>
             <a:pPr algn="l"/>
             <a:r>
-              <a:rPr sz="1000" b="0" i="0">
+              <a:rPr sz="900" b="0" i="0">
                 <a:solidFill>
                   <a:srgbClr val="CADCFC"/>
                 </a:solidFill>
@@ -30336,8 +30336,8 @@
         </p:nvSpPr>
         <p:spPr>
           <a:xfrm>
-            <a:off x="7680960" y="3895344"/>
-            <a:ext cx="3474720" cy="365760"/>
+            <a:off x="7772400" y="3008376"/>
+            <a:ext cx="3383280" cy="310896"/>
           </a:xfrm>
           <a:prstGeom prst="rect">
             <a:avLst/>
@@ -30352,7 +30352,7 @@
           <a:p>
             <a:pPr algn="r"/>
             <a:r>
-              <a:rPr sz="1350" b="1" i="0">
+              <a:rPr sz="1250" b="1" i="0">
                 <a:solidFill>
                   <a:srgbClr val="F47321"/>
                 </a:solidFill>
@@ -30371,8 +30371,8 @@
         </p:nvSpPr>
         <p:spPr>
           <a:xfrm>
-            <a:off x="7680960" y="4233672"/>
-            <a:ext cx="3474720" cy="274320"/>
+            <a:off x="7772400" y="3282696"/>
+            <a:ext cx="3383280" cy="228600"/>
           </a:xfrm>
           <a:prstGeom prst="rect">
             <a:avLst/>
@@ -30387,7 +30387,7 @@
           <a:p>
             <a:pPr algn="r"/>
             <a:r>
-              <a:rPr sz="950" b="0" i="0">
+              <a:rPr sz="850" b="0" i="0">
                 <a:solidFill>
                   <a:srgbClr val="CADCFC"/>
                 </a:solidFill>
@@ -30406,8 +30406,8 @@
         </p:nvSpPr>
         <p:spPr>
           <a:xfrm>
-            <a:off x="822960" y="4608576"/>
-            <a:ext cx="10515600" cy="731520"/>
+            <a:off x="822960" y="3566160"/>
+            <a:ext cx="10515600" cy="548640"/>
           </a:xfrm>
           <a:prstGeom prst="roundRect">
             <a:avLst/>
@@ -30450,8 +30450,8 @@
         </p:nvSpPr>
         <p:spPr>
           <a:xfrm>
-            <a:off x="1005840" y="4700016"/>
-            <a:ext cx="548640" cy="548640"/>
+            <a:off x="960120" y="3630168"/>
+            <a:ext cx="420624" cy="420624"/>
           </a:xfrm>
           <a:prstGeom prst="ellipse">
             <a:avLst/>
@@ -30502,8 +30502,8 @@
         </p:blipFill>
         <p:spPr>
           <a:xfrm>
-            <a:off x="1060704" y="4754879"/>
-            <a:ext cx="438912" cy="438912"/>
+            <a:off x="1002182" y="3672230"/>
+            <a:ext cx="336499" cy="336499"/>
           </a:xfrm>
           <a:prstGeom prst="rect">
             <a:avLst/>
@@ -30518,8 +30518,8 @@
         </p:nvSpPr>
         <p:spPr>
           <a:xfrm>
-            <a:off x="1691640" y="4700016"/>
-            <a:ext cx="548640" cy="548640"/>
+            <a:off x="1463040" y="3630168"/>
+            <a:ext cx="420624" cy="420624"/>
           </a:xfrm>
           <a:prstGeom prst="ellipse">
             <a:avLst/>
@@ -30570,8 +30570,8 @@
         </p:blipFill>
         <p:spPr>
           <a:xfrm>
-            <a:off x="1746504" y="4754879"/>
-            <a:ext cx="438912" cy="438912"/>
+            <a:off x="1505102" y="3672230"/>
+            <a:ext cx="336499" cy="336499"/>
           </a:xfrm>
           <a:prstGeom prst="rect">
             <a:avLst/>
@@ -30586,8 +30586,8 @@
         </p:nvSpPr>
         <p:spPr>
           <a:xfrm>
-            <a:off x="2468880" y="4700016"/>
-            <a:ext cx="5943600" cy="365760"/>
+            <a:off x="2057400" y="3602736"/>
+            <a:ext cx="6035040" cy="292608"/>
           </a:xfrm>
           <a:prstGeom prst="rect">
             <a:avLst/>
@@ -30602,7 +30602,7 @@
           <a:p>
             <a:pPr algn="l"/>
             <a:r>
-              <a:rPr sz="1500" b="1" i="0">
+              <a:rPr sz="1400" b="1" i="0">
                 <a:solidFill>
                   <a:srgbClr val="FFFFFF"/>
                 </a:solidFill>
@@ -30621,8 +30621,8 @@
         </p:nvSpPr>
         <p:spPr>
           <a:xfrm>
-            <a:off x="2468880" y="5029200"/>
-            <a:ext cx="5943600" cy="274320"/>
+            <a:off x="2057400" y="3867912"/>
+            <a:ext cx="6035040" cy="237744"/>
           </a:xfrm>
           <a:prstGeom prst="rect">
             <a:avLst/>
@@ -30637,7 +30637,7 @@
           <a:p>
             <a:pPr algn="l"/>
             <a:r>
-              <a:rPr sz="1000" b="0" i="0">
+              <a:rPr sz="900" b="0" i="0">
                 <a:solidFill>
                   <a:srgbClr val="CADCFC"/>
                 </a:solidFill>
@@ -30656,8 +30656,8 @@
         </p:nvSpPr>
         <p:spPr>
           <a:xfrm>
-            <a:off x="7680960" y="4700016"/>
-            <a:ext cx="3474720" cy="365760"/>
+            <a:off x="7772400" y="3611880"/>
+            <a:ext cx="3383280" cy="310896"/>
           </a:xfrm>
           <a:prstGeom prst="rect">
             <a:avLst/>
@@ -30672,7 +30672,7 @@
           <a:p>
             <a:pPr algn="r"/>
             <a:r>
-              <a:rPr sz="1350" b="1" i="0">
+              <a:rPr sz="1250" b="1" i="0">
                 <a:solidFill>
                   <a:srgbClr val="F47321"/>
                 </a:solidFill>
@@ -30691,8 +30691,8 @@
         </p:nvSpPr>
         <p:spPr>
           <a:xfrm>
-            <a:off x="7680960" y="5038344"/>
-            <a:ext cx="3474720" cy="274320"/>
+            <a:off x="7772400" y="3886200"/>
+            <a:ext cx="3383280" cy="228600"/>
           </a:xfrm>
           <a:prstGeom prst="rect">
             <a:avLst/>
@@ -30707,7 +30707,7 @@
           <a:p>
             <a:pPr algn="r"/>
             <a:r>
-              <a:rPr sz="950" b="0" i="0">
+              <a:rPr sz="850" b="0" i="0">
                 <a:solidFill>
                   <a:srgbClr val="CADCFC"/>
                 </a:solidFill>
@@ -30726,8 +30726,8 @@
         </p:nvSpPr>
         <p:spPr>
           <a:xfrm>
-            <a:off x="822960" y="5413248"/>
-            <a:ext cx="10515600" cy="731520"/>
+            <a:off x="822960" y="4169664"/>
+            <a:ext cx="10515600" cy="548640"/>
           </a:xfrm>
           <a:prstGeom prst="roundRect">
             <a:avLst/>
@@ -30770,8 +30770,8 @@
         </p:nvSpPr>
         <p:spPr>
           <a:xfrm>
-            <a:off x="1005840" y="5504688"/>
-            <a:ext cx="548640" cy="548640"/>
+            <a:off x="960120" y="4233672"/>
+            <a:ext cx="420624" cy="420624"/>
           </a:xfrm>
           <a:prstGeom prst="ellipse">
             <a:avLst/>
@@ -30822,8 +30822,8 @@
         </p:blipFill>
         <p:spPr>
           <a:xfrm>
-            <a:off x="1060704" y="5559551"/>
-            <a:ext cx="438912" cy="438912"/>
+            <a:off x="1002182" y="4275734"/>
+            <a:ext cx="336499" cy="336499"/>
           </a:xfrm>
           <a:prstGeom prst="rect">
             <a:avLst/>
@@ -30838,8 +30838,8 @@
         </p:nvSpPr>
         <p:spPr>
           <a:xfrm>
-            <a:off x="1691640" y="5504688"/>
-            <a:ext cx="548640" cy="548640"/>
+            <a:off x="1463040" y="4233672"/>
+            <a:ext cx="420624" cy="420624"/>
           </a:xfrm>
           <a:prstGeom prst="ellipse">
             <a:avLst/>
@@ -30890,8 +30890,8 @@
         </p:blipFill>
         <p:spPr>
           <a:xfrm>
-            <a:off x="1746504" y="5559551"/>
-            <a:ext cx="438912" cy="438912"/>
+            <a:off x="1505102" y="4275734"/>
+            <a:ext cx="336499" cy="336499"/>
           </a:xfrm>
           <a:prstGeom prst="rect">
             <a:avLst/>
@@ -30906,8 +30906,8 @@
         </p:nvSpPr>
         <p:spPr>
           <a:xfrm>
-            <a:off x="2468880" y="5504688"/>
-            <a:ext cx="5943600" cy="365760"/>
+            <a:off x="2057400" y="4206240"/>
+            <a:ext cx="6035040" cy="292608"/>
           </a:xfrm>
           <a:prstGeom prst="rect">
             <a:avLst/>
@@ -30922,7 +30922,7 @@
           <a:p>
             <a:pPr algn="l"/>
             <a:r>
-              <a:rPr sz="1500" b="1" i="0">
+              <a:rPr sz="1400" b="1" i="0">
                 <a:solidFill>
                   <a:srgbClr val="FFFFFF"/>
                 </a:solidFill>
@@ -30941,8 +30941,8 @@
         </p:nvSpPr>
         <p:spPr>
           <a:xfrm>
-            <a:off x="2468880" y="5833872"/>
-            <a:ext cx="5943600" cy="274320"/>
+            <a:off x="2057400" y="4471416"/>
+            <a:ext cx="6035040" cy="237744"/>
           </a:xfrm>
           <a:prstGeom prst="rect">
             <a:avLst/>
@@ -30957,118 +30957,758 @@
           <a:p>
             <a:pPr algn="l"/>
             <a:r>
+              <a:rPr sz="900" b="0" i="0">
+                <a:solidFill>
+                  <a:srgbClr val="CADCFC"/>
+                </a:solidFill>
+                <a:latin typeface="Arial"/>
+              </a:rPr>
+              <a:t>Lexington · Kroger Field</a:t>
+            </a:r>
+          </a:p>
+        </p:txBody>
+      </p:sp>
+      <p:sp>
+        <p:nvSpPr>
+          <p:cNvPr id="47" name="TextBox 46"/>
+          <p:cNvSpPr txBox="1"/>
+          <p:nvPr/>
+        </p:nvSpPr>
+        <p:spPr>
+          <a:xfrm>
+            <a:off x="7772400" y="4215384"/>
+            <a:ext cx="3383280" cy="310896"/>
+          </a:xfrm>
+          <a:prstGeom prst="rect">
+            <a:avLst/>
+          </a:prstGeom>
+          <a:noFill/>
+        </p:spPr>
+        <p:txBody>
+          <a:bodyPr wrap="square" lIns="0" rIns="0" tIns="0" bIns="0">
+            <a:spAutoFit/>
+          </a:bodyPr>
+          <a:lstStyle/>
+          <a:p>
+            <a:pPr algn="r"/>
+            <a:r>
+              <a:rPr sz="1250" b="1" i="0">
+                <a:solidFill>
+                  <a:srgbClr val="F47321"/>
+                </a:solidFill>
+                <a:latin typeface="Arial"/>
+              </a:rPr>
+              <a:t>Alabama –13   ·   +10.5 / +10.5</a:t>
+            </a:r>
+          </a:p>
+        </p:txBody>
+      </p:sp>
+      <p:sp>
+        <p:nvSpPr>
+          <p:cNvPr id="48" name="TextBox 47"/>
+          <p:cNvSpPr txBox="1"/>
+          <p:nvPr/>
+        </p:nvSpPr>
+        <p:spPr>
+          <a:xfrm>
+            <a:off x="7772400" y="4489704"/>
+            <a:ext cx="3383280" cy="228600"/>
+          </a:xfrm>
+          <a:prstGeom prst="rect">
+            <a:avLst/>
+          </a:prstGeom>
+          <a:noFill/>
+        </p:spPr>
+        <p:txBody>
+          <a:bodyPr wrap="square" lIns="0" rIns="0" tIns="0" bIns="0">
+            <a:spAutoFit/>
+          </a:bodyPr>
+          <a:lstStyle/>
+          <a:p>
+            <a:pPr algn="r"/>
+            <a:r>
+              <a:rPr sz="850" b="0" i="0">
+                <a:solidFill>
+                  <a:srgbClr val="CADCFC"/>
+                </a:solidFill>
+                <a:latin typeface="Arial"/>
+              </a:rPr>
+              <a:t>machine · market</a:t>
+            </a:r>
+          </a:p>
+        </p:txBody>
+      </p:sp>
+      <p:sp>
+        <p:nvSpPr>
+          <p:cNvPr id="49" name="Rounded Rectangle 48"/>
+          <p:cNvSpPr/>
+          <p:nvPr/>
+        </p:nvSpPr>
+        <p:spPr>
+          <a:xfrm>
+            <a:off x="822960" y="4773168"/>
+            <a:ext cx="10515600" cy="548640"/>
+          </a:xfrm>
+          <a:prstGeom prst="roundRect">
+            <a:avLst/>
+          </a:prstGeom>
+          <a:solidFill>
+            <a:srgbClr val="123568"/>
+          </a:solidFill>
+          <a:ln>
+            <a:noFill/>
+          </a:ln>
+          <a:effectLst/>
+        </p:spPr>
+        <p:style>
+          <a:lnRef idx="1">
+            <a:schemeClr val="accent1"/>
+          </a:lnRef>
+          <a:fillRef idx="3">
+            <a:schemeClr val="accent1"/>
+          </a:fillRef>
+          <a:effectRef idx="2">
+            <a:schemeClr val="accent1"/>
+          </a:effectRef>
+          <a:fontRef idx="minor">
+            <a:schemeClr val="lt1"/>
+          </a:fontRef>
+        </p:style>
+        <p:txBody>
+          <a:bodyPr rtlCol="0" anchor="ctr"/>
+          <a:lstStyle/>
+          <a:p>
+            <a:pPr algn="ctr"/>
+          </a:p>
+        </p:txBody>
+      </p:sp>
+      <p:sp>
+        <p:nvSpPr>
+          <p:cNvPr id="50" name="Oval 49"/>
+          <p:cNvSpPr/>
+          <p:nvPr/>
+        </p:nvSpPr>
+        <p:spPr>
+          <a:xfrm>
+            <a:off x="960120" y="4837176"/>
+            <a:ext cx="420624" cy="420624"/>
+          </a:xfrm>
+          <a:prstGeom prst="ellipse">
+            <a:avLst/>
+          </a:prstGeom>
+          <a:solidFill>
+            <a:srgbClr val="FFFFFF"/>
+          </a:solidFill>
+          <a:ln>
+            <a:noFill/>
+          </a:ln>
+          <a:effectLst/>
+        </p:spPr>
+        <p:style>
+          <a:lnRef idx="1">
+            <a:schemeClr val="accent1"/>
+          </a:lnRef>
+          <a:fillRef idx="3">
+            <a:schemeClr val="accent1"/>
+          </a:fillRef>
+          <a:effectRef idx="2">
+            <a:schemeClr val="accent1"/>
+          </a:effectRef>
+          <a:fontRef idx="minor">
+            <a:schemeClr val="lt1"/>
+          </a:fontRef>
+        </p:style>
+        <p:txBody>
+          <a:bodyPr rtlCol="0" anchor="ctr"/>
+          <a:lstStyle/>
+          <a:p>
+            <a:pPr algn="ctr"/>
+          </a:p>
+        </p:txBody>
+      </p:sp>
+      <p:pic>
+        <p:nvPicPr>
+          <p:cNvPr id="51" name="Picture 50" descr="buffalo.png"/>
+          <p:cNvPicPr>
+            <a:picLocks noChangeAspect="1"/>
+          </p:cNvPicPr>
+          <p:nvPr/>
+        </p:nvPicPr>
+        <p:blipFill>
+          <a:blip r:embed="rId12"/>
+          <a:stretch>
+            <a:fillRect/>
+          </a:stretch>
+        </p:blipFill>
+        <p:spPr>
+          <a:xfrm>
+            <a:off x="1002182" y="4879238"/>
+            <a:ext cx="336499" cy="336499"/>
+          </a:xfrm>
+          <a:prstGeom prst="rect">
+            <a:avLst/>
+          </a:prstGeom>
+        </p:spPr>
+      </p:pic>
+      <p:sp>
+        <p:nvSpPr>
+          <p:cNvPr id="52" name="Oval 51"/>
+          <p:cNvSpPr/>
+          <p:nvPr/>
+        </p:nvSpPr>
+        <p:spPr>
+          <a:xfrm>
+            <a:off x="1463040" y="4837176"/>
+            <a:ext cx="420624" cy="420624"/>
+          </a:xfrm>
+          <a:prstGeom prst="ellipse">
+            <a:avLst/>
+          </a:prstGeom>
+          <a:solidFill>
+            <a:srgbClr val="FFFFFF"/>
+          </a:solidFill>
+          <a:ln>
+            <a:noFill/>
+          </a:ln>
+          <a:effectLst/>
+        </p:spPr>
+        <p:style>
+          <a:lnRef idx="1">
+            <a:schemeClr val="accent1"/>
+          </a:lnRef>
+          <a:fillRef idx="3">
+            <a:schemeClr val="accent1"/>
+          </a:fillRef>
+          <a:effectRef idx="2">
+            <a:schemeClr val="accent1"/>
+          </a:effectRef>
+          <a:fontRef idx="minor">
+            <a:schemeClr val="lt1"/>
+          </a:fontRef>
+        </p:style>
+        <p:txBody>
+          <a:bodyPr rtlCol="0" anchor="ctr"/>
+          <a:lstStyle/>
+          <a:p>
+            <a:pPr algn="ctr"/>
+          </a:p>
+        </p:txBody>
+      </p:sp>
+      <p:pic>
+        <p:nvPicPr>
+          <p:cNvPr id="53" name="Picture 52" descr="fiu.png"/>
+          <p:cNvPicPr>
+            <a:picLocks noChangeAspect="1"/>
+          </p:cNvPicPr>
+          <p:nvPr/>
+        </p:nvPicPr>
+        <p:blipFill>
+          <a:blip r:embed="rId13"/>
+          <a:stretch>
+            <a:fillRect/>
+          </a:stretch>
+        </p:blipFill>
+        <p:spPr>
+          <a:xfrm>
+            <a:off x="1505102" y="4879238"/>
+            <a:ext cx="336499" cy="336499"/>
+          </a:xfrm>
+          <a:prstGeom prst="rect">
+            <a:avLst/>
+          </a:prstGeom>
+        </p:spPr>
+      </p:pic>
+      <p:sp>
+        <p:nvSpPr>
+          <p:cNvPr id="54" name="TextBox 53"/>
+          <p:cNvSpPr txBox="1"/>
+          <p:nvPr/>
+        </p:nvSpPr>
+        <p:spPr>
+          <a:xfrm>
+            <a:off x="2057400" y="4809744"/>
+            <a:ext cx="6035040" cy="292608"/>
+          </a:xfrm>
+          <a:prstGeom prst="rect">
+            <a:avLst/>
+          </a:prstGeom>
+          <a:noFill/>
+        </p:spPr>
+        <p:txBody>
+          <a:bodyPr wrap="square" lIns="0" rIns="0" tIns="0" bIns="0">
+            <a:spAutoFit/>
+          </a:bodyPr>
+          <a:lstStyle/>
+          <a:p>
+            <a:pPr algn="l"/>
+            <a:r>
+              <a:rPr sz="1400" b="1" i="0">
+                <a:solidFill>
+                  <a:srgbClr val="FFFFFF"/>
+                </a:solidFill>
+                <a:latin typeface="Arial"/>
+              </a:rPr>
+              <a:t>Buffalo at Florida International</a:t>
+            </a:r>
+          </a:p>
+        </p:txBody>
+      </p:sp>
+      <p:sp>
+        <p:nvSpPr>
+          <p:cNvPr id="55" name="TextBox 54"/>
+          <p:cNvSpPr txBox="1"/>
+          <p:nvPr/>
+        </p:nvSpPr>
+        <p:spPr>
+          <a:xfrm>
+            <a:off x="2057400" y="5074920"/>
+            <a:ext cx="6035040" cy="237744"/>
+          </a:xfrm>
+          <a:prstGeom prst="rect">
+            <a:avLst/>
+          </a:prstGeom>
+          <a:noFill/>
+        </p:spPr>
+        <p:txBody>
+          <a:bodyPr wrap="square" lIns="0" rIns="0" tIns="0" bIns="0">
+            <a:spAutoFit/>
+          </a:bodyPr>
+          <a:lstStyle/>
+          <a:p>
+            <a:pPr algn="l"/>
+            <a:r>
+              <a:rPr sz="900" b="1" i="0">
+                <a:solidFill>
+                  <a:srgbClr val="F47321"/>
+                </a:solidFill>
+                <a:latin typeface="Arial"/>
+              </a:rPr>
+              <a:t>★ SUPERDOG — Buffalo +10.5 at Florida International · ML +340 · Sat Sep 12 · Pitbull Stadium</a:t>
+            </a:r>
+          </a:p>
+        </p:txBody>
+      </p:sp>
+      <p:sp>
+        <p:nvSpPr>
+          <p:cNvPr id="56" name="TextBox 55"/>
+          <p:cNvSpPr txBox="1"/>
+          <p:nvPr/>
+        </p:nvSpPr>
+        <p:spPr>
+          <a:xfrm>
+            <a:off x="7772400" y="4818888"/>
+            <a:ext cx="3383280" cy="310896"/>
+          </a:xfrm>
+          <a:prstGeom prst="rect">
+            <a:avLst/>
+          </a:prstGeom>
+          <a:noFill/>
+        </p:spPr>
+        <p:txBody>
+          <a:bodyPr wrap="square" lIns="0" rIns="0" tIns="0" bIns="0">
+            <a:spAutoFit/>
+          </a:bodyPr>
+          <a:lstStyle/>
+          <a:p>
+            <a:pPr algn="r"/>
+            <a:r>
+              <a:rPr sz="1250" b="1" i="0">
+                <a:solidFill>
+                  <a:srgbClr val="F47321"/>
+                </a:solidFill>
+                <a:latin typeface="Arial"/>
+              </a:rPr>
+              <a:t>Florida International –1.5   ·   –10.5 / –10</a:t>
+            </a:r>
+          </a:p>
+        </p:txBody>
+      </p:sp>
+      <p:sp>
+        <p:nvSpPr>
+          <p:cNvPr id="57" name="TextBox 56"/>
+          <p:cNvSpPr txBox="1"/>
+          <p:nvPr/>
+        </p:nvSpPr>
+        <p:spPr>
+          <a:xfrm>
+            <a:off x="7772400" y="5093208"/>
+            <a:ext cx="3383280" cy="228600"/>
+          </a:xfrm>
+          <a:prstGeom prst="rect">
+            <a:avLst/>
+          </a:prstGeom>
+          <a:noFill/>
+        </p:spPr>
+        <p:txBody>
+          <a:bodyPr wrap="square" lIns="0" rIns="0" tIns="0" bIns="0">
+            <a:spAutoFit/>
+          </a:bodyPr>
+          <a:lstStyle/>
+          <a:p>
+            <a:pPr algn="r"/>
+            <a:r>
+              <a:rPr sz="850" b="0" i="0">
+                <a:solidFill>
+                  <a:srgbClr val="CADCFC"/>
+                </a:solidFill>
+                <a:latin typeface="Arial"/>
+              </a:rPr>
+              <a:t>machine · market</a:t>
+            </a:r>
+          </a:p>
+        </p:txBody>
+      </p:sp>
+      <p:sp>
+        <p:nvSpPr>
+          <p:cNvPr id="58" name="Rounded Rectangle 57"/>
+          <p:cNvSpPr/>
+          <p:nvPr/>
+        </p:nvSpPr>
+        <p:spPr>
+          <a:xfrm>
+            <a:off x="822960" y="5376672"/>
+            <a:ext cx="10515600" cy="548640"/>
+          </a:xfrm>
+          <a:prstGeom prst="roundRect">
+            <a:avLst/>
+          </a:prstGeom>
+          <a:solidFill>
+            <a:srgbClr val="123568"/>
+          </a:solidFill>
+          <a:ln>
+            <a:noFill/>
+          </a:ln>
+          <a:effectLst/>
+        </p:spPr>
+        <p:style>
+          <a:lnRef idx="1">
+            <a:schemeClr val="accent1"/>
+          </a:lnRef>
+          <a:fillRef idx="3">
+            <a:schemeClr val="accent1"/>
+          </a:fillRef>
+          <a:effectRef idx="2">
+            <a:schemeClr val="accent1"/>
+          </a:effectRef>
+          <a:fontRef idx="minor">
+            <a:schemeClr val="lt1"/>
+          </a:fontRef>
+        </p:style>
+        <p:txBody>
+          <a:bodyPr rtlCol="0" anchor="ctr"/>
+          <a:lstStyle/>
+          <a:p>
+            <a:pPr algn="ctr"/>
+          </a:p>
+        </p:txBody>
+      </p:sp>
+      <p:sp>
+        <p:nvSpPr>
+          <p:cNvPr id="59" name="Oval 58"/>
+          <p:cNvSpPr/>
+          <p:nvPr/>
+        </p:nvSpPr>
+        <p:spPr>
+          <a:xfrm>
+            <a:off x="960120" y="5440680"/>
+            <a:ext cx="420624" cy="420624"/>
+          </a:xfrm>
+          <a:prstGeom prst="ellipse">
+            <a:avLst/>
+          </a:prstGeom>
+          <a:solidFill>
+            <a:srgbClr val="FFFFFF"/>
+          </a:solidFill>
+          <a:ln>
+            <a:noFill/>
+          </a:ln>
+          <a:effectLst/>
+        </p:spPr>
+        <p:style>
+          <a:lnRef idx="1">
+            <a:schemeClr val="accent1"/>
+          </a:lnRef>
+          <a:fillRef idx="3">
+            <a:schemeClr val="accent1"/>
+          </a:fillRef>
+          <a:effectRef idx="2">
+            <a:schemeClr val="accent1"/>
+          </a:effectRef>
+          <a:fontRef idx="minor">
+            <a:schemeClr val="lt1"/>
+          </a:fontRef>
+        </p:style>
+        <p:txBody>
+          <a:bodyPr rtlCol="0" anchor="ctr"/>
+          <a:lstStyle/>
+          <a:p>
+            <a:pPr algn="ctr"/>
+          </a:p>
+        </p:txBody>
+      </p:sp>
+      <p:pic>
+        <p:nvPicPr>
+          <p:cNvPr id="60" name="Picture 59" descr="arkansas.png"/>
+          <p:cNvPicPr>
+            <a:picLocks noChangeAspect="1"/>
+          </p:cNvPicPr>
+          <p:nvPr/>
+        </p:nvPicPr>
+        <p:blipFill>
+          <a:blip r:embed="rId14"/>
+          <a:stretch>
+            <a:fillRect/>
+          </a:stretch>
+        </p:blipFill>
+        <p:spPr>
+          <a:xfrm>
+            <a:off x="1002182" y="5482742"/>
+            <a:ext cx="336499" cy="336499"/>
+          </a:xfrm>
+          <a:prstGeom prst="rect">
+            <a:avLst/>
+          </a:prstGeom>
+        </p:spPr>
+      </p:pic>
+      <p:sp>
+        <p:nvSpPr>
+          <p:cNvPr id="61" name="Oval 60"/>
+          <p:cNvSpPr/>
+          <p:nvPr/>
+        </p:nvSpPr>
+        <p:spPr>
+          <a:xfrm>
+            <a:off x="1463040" y="5440680"/>
+            <a:ext cx="420624" cy="420624"/>
+          </a:xfrm>
+          <a:prstGeom prst="ellipse">
+            <a:avLst/>
+          </a:prstGeom>
+          <a:solidFill>
+            <a:srgbClr val="FFFFFF"/>
+          </a:solidFill>
+          <a:ln>
+            <a:noFill/>
+          </a:ln>
+          <a:effectLst/>
+        </p:spPr>
+        <p:style>
+          <a:lnRef idx="1">
+            <a:schemeClr val="accent1"/>
+          </a:lnRef>
+          <a:fillRef idx="3">
+            <a:schemeClr val="accent1"/>
+          </a:fillRef>
+          <a:effectRef idx="2">
+            <a:schemeClr val="accent1"/>
+          </a:effectRef>
+          <a:fontRef idx="minor">
+            <a:schemeClr val="lt1"/>
+          </a:fontRef>
+        </p:style>
+        <p:txBody>
+          <a:bodyPr rtlCol="0" anchor="ctr"/>
+          <a:lstStyle/>
+          <a:p>
+            <a:pPr algn="ctr"/>
+          </a:p>
+        </p:txBody>
+      </p:sp>
+      <p:pic>
+        <p:nvPicPr>
+          <p:cNvPr id="62" name="Picture 61" descr="utah.png"/>
+          <p:cNvPicPr>
+            <a:picLocks noChangeAspect="1"/>
+          </p:cNvPicPr>
+          <p:nvPr/>
+        </p:nvPicPr>
+        <p:blipFill>
+          <a:blip r:embed="rId15"/>
+          <a:stretch>
+            <a:fillRect/>
+          </a:stretch>
+        </p:blipFill>
+        <p:spPr>
+          <a:xfrm>
+            <a:off x="1505102" y="5482742"/>
+            <a:ext cx="336499" cy="336499"/>
+          </a:xfrm>
+          <a:prstGeom prst="rect">
+            <a:avLst/>
+          </a:prstGeom>
+        </p:spPr>
+      </p:pic>
+      <p:sp>
+        <p:nvSpPr>
+          <p:cNvPr id="63" name="TextBox 62"/>
+          <p:cNvSpPr txBox="1"/>
+          <p:nvPr/>
+        </p:nvSpPr>
+        <p:spPr>
+          <a:xfrm>
+            <a:off x="2057400" y="5413248"/>
+            <a:ext cx="6035040" cy="292608"/>
+          </a:xfrm>
+          <a:prstGeom prst="rect">
+            <a:avLst/>
+          </a:prstGeom>
+          <a:noFill/>
+        </p:spPr>
+        <p:txBody>
+          <a:bodyPr wrap="square" lIns="0" rIns="0" tIns="0" bIns="0">
+            <a:spAutoFit/>
+          </a:bodyPr>
+          <a:lstStyle/>
+          <a:p>
+            <a:pPr algn="l"/>
+            <a:r>
+              <a:rPr sz="1400" b="1" i="0">
+                <a:solidFill>
+                  <a:srgbClr val="FFFFFF"/>
+                </a:solidFill>
+                <a:latin typeface="Arial"/>
+              </a:rPr>
+              <a:t>Arkansas at Utah</a:t>
+            </a:r>
+          </a:p>
+        </p:txBody>
+      </p:sp>
+      <p:sp>
+        <p:nvSpPr>
+          <p:cNvPr id="64" name="TextBox 63"/>
+          <p:cNvSpPr txBox="1"/>
+          <p:nvPr/>
+        </p:nvSpPr>
+        <p:spPr>
+          <a:xfrm>
+            <a:off x="2057400" y="5678424"/>
+            <a:ext cx="6035040" cy="237744"/>
+          </a:xfrm>
+          <a:prstGeom prst="rect">
+            <a:avLst/>
+          </a:prstGeom>
+          <a:noFill/>
+        </p:spPr>
+        <p:txBody>
+          <a:bodyPr wrap="square" lIns="0" rIns="0" tIns="0" bIns="0">
+            <a:spAutoFit/>
+          </a:bodyPr>
+          <a:lstStyle/>
+          <a:p>
+            <a:pPr algn="l"/>
+            <a:r>
+              <a:rPr sz="900" b="1" i="0">
+                <a:solidFill>
+                  <a:srgbClr val="F47321"/>
+                </a:solidFill>
+                <a:latin typeface="Arial"/>
+              </a:rPr>
+              <a:t>★ GIANT KILLER — Arkansas +12.5 at #20 Utah · ML +390 · Sat Sep 12 · Rice-Eccles Stadium</a:t>
+            </a:r>
+          </a:p>
+        </p:txBody>
+      </p:sp>
+      <p:sp>
+        <p:nvSpPr>
+          <p:cNvPr id="65" name="TextBox 64"/>
+          <p:cNvSpPr txBox="1"/>
+          <p:nvPr/>
+        </p:nvSpPr>
+        <p:spPr>
+          <a:xfrm>
+            <a:off x="7772400" y="5422392"/>
+            <a:ext cx="3383280" cy="310896"/>
+          </a:xfrm>
+          <a:prstGeom prst="rect">
+            <a:avLst/>
+          </a:prstGeom>
+          <a:noFill/>
+        </p:spPr>
+        <p:txBody>
+          <a:bodyPr wrap="square" lIns="0" rIns="0" tIns="0" bIns="0">
+            <a:spAutoFit/>
+          </a:bodyPr>
+          <a:lstStyle/>
+          <a:p>
+            <a:pPr algn="r"/>
+            <a:r>
+              <a:rPr sz="1250" b="1" i="0">
+                <a:solidFill>
+                  <a:srgbClr val="F47321"/>
+                </a:solidFill>
+                <a:latin typeface="Arial"/>
+              </a:rPr>
+              <a:t>Utah –6.5   ·   –12.5 / –12.5</a:t>
+            </a:r>
+          </a:p>
+        </p:txBody>
+      </p:sp>
+      <p:sp>
+        <p:nvSpPr>
+          <p:cNvPr id="66" name="TextBox 65"/>
+          <p:cNvSpPr txBox="1"/>
+          <p:nvPr/>
+        </p:nvSpPr>
+        <p:spPr>
+          <a:xfrm>
+            <a:off x="7772400" y="5696712"/>
+            <a:ext cx="3383280" cy="228600"/>
+          </a:xfrm>
+          <a:prstGeom prst="rect">
+            <a:avLst/>
+          </a:prstGeom>
+          <a:noFill/>
+        </p:spPr>
+        <p:txBody>
+          <a:bodyPr wrap="square" lIns="0" rIns="0" tIns="0" bIns="0">
+            <a:spAutoFit/>
+          </a:bodyPr>
+          <a:lstStyle/>
+          <a:p>
+            <a:pPr algn="r"/>
+            <a:r>
+              <a:rPr sz="850" b="0" i="0">
+                <a:solidFill>
+                  <a:srgbClr val="CADCFC"/>
+                </a:solidFill>
+                <a:latin typeface="Arial"/>
+              </a:rPr>
+              <a:t>machine · market</a:t>
+            </a:r>
+          </a:p>
+        </p:txBody>
+      </p:sp>
+      <p:sp>
+        <p:nvSpPr>
+          <p:cNvPr id="67" name="TextBox 66"/>
+          <p:cNvSpPr txBox="1"/>
+          <p:nvPr/>
+        </p:nvSpPr>
+        <p:spPr>
+          <a:xfrm>
+            <a:off x="822960" y="6126480"/>
+            <a:ext cx="10515600" cy="457200"/>
+          </a:xfrm>
+          <a:prstGeom prst="rect">
+            <a:avLst/>
+          </a:prstGeom>
+          <a:noFill/>
+        </p:spPr>
+        <p:txBody>
+          <a:bodyPr wrap="square" lIns="0" rIns="0" tIns="0" bIns="0">
+            <a:spAutoFit/>
+          </a:bodyPr>
+          <a:lstStyle/>
+          <a:p>
+            <a:pPr algn="l"/>
+            <a:r>
               <a:rPr sz="1000" b="0" i="0">
                 <a:solidFill>
-                  <a:srgbClr val="CADCFC"/>
-                </a:solidFill>
-                <a:latin typeface="Arial"/>
-              </a:rPr>
-              <a:t>Lexington · Kroger Field</a:t>
-            </a:r>
-          </a:p>
-        </p:txBody>
-      </p:sp>
-      <p:sp>
-        <p:nvSpPr>
-          <p:cNvPr id="47" name="TextBox 46"/>
-          <p:cNvSpPr txBox="1"/>
-          <p:nvPr/>
-        </p:nvSpPr>
-        <p:spPr>
-          <a:xfrm>
-            <a:off x="7680960" y="5504688"/>
-            <a:ext cx="3474720" cy="365760"/>
-          </a:xfrm>
-          <a:prstGeom prst="rect">
-            <a:avLst/>
-          </a:prstGeom>
-          <a:noFill/>
-        </p:spPr>
-        <p:txBody>
-          <a:bodyPr wrap="square" lIns="0" rIns="0" tIns="0" bIns="0">
-            <a:spAutoFit/>
-          </a:bodyPr>
-          <a:lstStyle/>
-          <a:p>
-            <a:pPr algn="r"/>
-            <a:r>
-              <a:rPr sz="1350" b="1" i="0">
-                <a:solidFill>
-                  <a:srgbClr val="F47321"/>
-                </a:solidFill>
-                <a:latin typeface="Arial"/>
-              </a:rPr>
-              <a:t>Alabama –13   ·   +10.5 / +10.5</a:t>
-            </a:r>
-          </a:p>
-        </p:txBody>
-      </p:sp>
-      <p:sp>
-        <p:nvSpPr>
-          <p:cNvPr id="48" name="TextBox 47"/>
-          <p:cNvSpPr txBox="1"/>
-          <p:nvPr/>
-        </p:nvSpPr>
-        <p:spPr>
-          <a:xfrm>
-            <a:off x="7680960" y="5843016"/>
-            <a:ext cx="3474720" cy="274320"/>
-          </a:xfrm>
-          <a:prstGeom prst="rect">
-            <a:avLst/>
-          </a:prstGeom>
-          <a:noFill/>
-        </p:spPr>
-        <p:txBody>
-          <a:bodyPr wrap="square" lIns="0" rIns="0" tIns="0" bIns="0">
-            <a:spAutoFit/>
-          </a:bodyPr>
-          <a:lstStyle/>
-          <a:p>
-            <a:pPr algn="r"/>
-            <a:r>
-              <a:rPr sz="950" b="0" i="0">
-                <a:solidFill>
-                  <a:srgbClr val="CADCFC"/>
-                </a:solidFill>
-                <a:latin typeface="Arial"/>
-              </a:rPr>
-              <a:t>machine · market</a:t>
-            </a:r>
-          </a:p>
-        </p:txBody>
-      </p:sp>
-      <p:sp>
-        <p:nvSpPr>
-          <p:cNvPr id="49" name="TextBox 48"/>
-          <p:cNvSpPr txBox="1"/>
-          <p:nvPr/>
-        </p:nvSpPr>
-        <p:spPr>
-          <a:xfrm>
-            <a:off x="822960" y="6263640"/>
-            <a:ext cx="10515600" cy="457200"/>
-          </a:xfrm>
-          <a:prstGeom prst="rect">
-            <a:avLst/>
-          </a:prstGeom>
-          <a:noFill/>
-        </p:spPr>
-        <p:txBody>
-          <a:bodyPr wrap="square" lIns="0" rIns="0" tIns="0" bIns="0">
-            <a:spAutoFit/>
-          </a:bodyPr>
-          <a:lstStyle/>
-          <a:p>
-            <a:pPr algn="l"/>
-            <a:r>
-              <a:rPr sz="1050" b="0" i="0">
-                <a:solidFill>
                   <a:srgbClr val="8FA5C4"/>
                 </a:solidFill>
                 <a:latin typeface="Arial"/>
               </a:rPr>
-              <a:t>Machine = our in-season rating (ESPN preseason FPI prior + 2026 results, λ 3, cap ±28) + 2.5 HFA · empirical margin curve (σ 15.9) · lines as of Sep 9 · model plays graded vs first-seen lines</a:t>
+              <a:t>Machine = our in-season rating (ESPN preseason FPI prior + 2026 results, λ 3, cap ±28) + 2.5 HFA · empirical margin curve (σ 15.9) · lines as of Sep 9 · superdog rows = dog to win outright, points = the spread · model plays graded vs first-seen lines</a:t>
             </a:r>
           </a:p>
         </p:txBody>

</xml_diff>

<commit_message>
Revert "Ep3 card slide: 'Seven Games, One Card' - Superdog + Giant Killer rows from the live boards; notes table to match"
This reverts commit ebda5ebbc5652d3243265ce0ae607bcc71fb792e.
</commit_message>
<xml_diff>
--- a/decks/2026_Week2_Episode3.pptx
+++ b/decks/2026_Week2_Episode3.pptx
@@ -29376,8 +29376,8 @@
         </p:nvSpPr>
         <p:spPr>
           <a:xfrm>
-            <a:off x="822960" y="457200"/>
-            <a:ext cx="10515600" cy="365760"/>
+            <a:off x="822960" y="777240"/>
+            <a:ext cx="10515600" cy="411480"/>
           </a:xfrm>
           <a:prstGeom prst="rect">
             <a:avLst/>
@@ -29411,8 +29411,8 @@
         </p:nvSpPr>
         <p:spPr>
           <a:xfrm>
-            <a:off x="822960" y="749808"/>
-            <a:ext cx="10515600" cy="822960"/>
+            <a:off x="822960" y="1097280"/>
+            <a:ext cx="10515600" cy="1005840"/>
           </a:xfrm>
           <a:prstGeom prst="rect">
             <a:avLst/>
@@ -29427,13 +29427,13 @@
           <a:p>
             <a:pPr algn="l"/>
             <a:r>
-              <a:rPr sz="4000" b="1" i="0">
+              <a:rPr sz="4400" b="1" i="0">
                 <a:solidFill>
                   <a:srgbClr val="FFFFFF"/>
                 </a:solidFill>
                 <a:latin typeface="Arial"/>
               </a:rPr>
-              <a:t>Seven Games, One Card</a:t>
+              <a:t>Five Games, One Card</a:t>
             </a:r>
           </a:p>
         </p:txBody>
@@ -29446,8 +29446,8 @@
         </p:nvSpPr>
         <p:spPr>
           <a:xfrm>
-            <a:off x="822960" y="1755648"/>
-            <a:ext cx="10515600" cy="548640"/>
+            <a:off x="822960" y="2194560"/>
+            <a:ext cx="10515600" cy="731520"/>
           </a:xfrm>
           <a:prstGeom prst="roundRect">
             <a:avLst/>
@@ -29490,8 +29490,8 @@
         </p:nvSpPr>
         <p:spPr>
           <a:xfrm>
-            <a:off x="960120" y="1819656"/>
-            <a:ext cx="420624" cy="420624"/>
+            <a:off x="1005840" y="2286000"/>
+            <a:ext cx="548640" cy="548640"/>
           </a:xfrm>
           <a:prstGeom prst="ellipse">
             <a:avLst/>
@@ -29542,8 +29542,8 @@
         </p:blipFill>
         <p:spPr>
           <a:xfrm>
-            <a:off x="1002182" y="1861718"/>
-            <a:ext cx="336499" cy="336499"/>
+            <a:off x="1060704" y="2340864"/>
+            <a:ext cx="438912" cy="438912"/>
           </a:xfrm>
           <a:prstGeom prst="rect">
             <a:avLst/>
@@ -29558,8 +29558,8 @@
         </p:nvSpPr>
         <p:spPr>
           <a:xfrm>
-            <a:off x="1463040" y="1819656"/>
-            <a:ext cx="420624" cy="420624"/>
+            <a:off x="1691640" y="2286000"/>
+            <a:ext cx="548640" cy="548640"/>
           </a:xfrm>
           <a:prstGeom prst="ellipse">
             <a:avLst/>
@@ -29610,8 +29610,8 @@
         </p:blipFill>
         <p:spPr>
           <a:xfrm>
-            <a:off x="1505102" y="1861718"/>
-            <a:ext cx="336499" cy="336499"/>
+            <a:off x="1746504" y="2340864"/>
+            <a:ext cx="438912" cy="438912"/>
           </a:xfrm>
           <a:prstGeom prst="rect">
             <a:avLst/>
@@ -29626,8 +29626,8 @@
         </p:nvSpPr>
         <p:spPr>
           <a:xfrm>
-            <a:off x="2057400" y="1792224"/>
-            <a:ext cx="6035040" cy="292608"/>
+            <a:off x="2468880" y="2286000"/>
+            <a:ext cx="5943600" cy="365760"/>
           </a:xfrm>
           <a:prstGeom prst="rect">
             <a:avLst/>
@@ -29642,7 +29642,7 @@
           <a:p>
             <a:pPr algn="l"/>
             <a:r>
-              <a:rPr sz="1400" b="1" i="0">
+              <a:rPr sz="1500" b="1" i="0">
                 <a:solidFill>
                   <a:srgbClr val="FFFFFF"/>
                 </a:solidFill>
@@ -29661,8 +29661,8 @@
         </p:nvSpPr>
         <p:spPr>
           <a:xfrm>
-            <a:off x="2057400" y="2057400"/>
-            <a:ext cx="6035040" cy="237744"/>
+            <a:off x="2468880" y="2615184"/>
+            <a:ext cx="5943600" cy="274320"/>
           </a:xfrm>
           <a:prstGeom prst="rect">
             <a:avLst/>
@@ -29677,7 +29677,7 @@
           <a:p>
             <a:pPr algn="l"/>
             <a:r>
-              <a:rPr sz="900" b="0" i="0">
+              <a:rPr sz="1000" b="0" i="0">
                 <a:solidFill>
                   <a:srgbClr val="CADCFC"/>
                 </a:solidFill>
@@ -29696,8 +29696,8 @@
         </p:nvSpPr>
         <p:spPr>
           <a:xfrm>
-            <a:off x="7772400" y="1801368"/>
-            <a:ext cx="3383280" cy="310896"/>
+            <a:off x="7680960" y="2286000"/>
+            <a:ext cx="3474720" cy="365760"/>
           </a:xfrm>
           <a:prstGeom prst="rect">
             <a:avLst/>
@@ -29712,7 +29712,7 @@
           <a:p>
             <a:pPr algn="r"/>
             <a:r>
-              <a:rPr sz="1250" b="1" i="0">
+              <a:rPr sz="1350" b="1" i="0">
                 <a:solidFill>
                   <a:srgbClr val="F47321"/>
                 </a:solidFill>
@@ -29731,8 +29731,8 @@
         </p:nvSpPr>
         <p:spPr>
           <a:xfrm>
-            <a:off x="7772400" y="2075688"/>
-            <a:ext cx="3383280" cy="228600"/>
+            <a:off x="7680960" y="2624328"/>
+            <a:ext cx="3474720" cy="274320"/>
           </a:xfrm>
           <a:prstGeom prst="rect">
             <a:avLst/>
@@ -29747,7 +29747,7 @@
           <a:p>
             <a:pPr algn="r"/>
             <a:r>
-              <a:rPr sz="850" b="0" i="0">
+              <a:rPr sz="950" b="0" i="0">
                 <a:solidFill>
                   <a:srgbClr val="CADCFC"/>
                 </a:solidFill>
@@ -29766,8 +29766,8 @@
         </p:nvSpPr>
         <p:spPr>
           <a:xfrm>
-            <a:off x="822960" y="2359152"/>
-            <a:ext cx="10515600" cy="548640"/>
+            <a:off x="822960" y="2999232"/>
+            <a:ext cx="10515600" cy="731520"/>
           </a:xfrm>
           <a:prstGeom prst="roundRect">
             <a:avLst/>
@@ -29810,8 +29810,8 @@
         </p:nvSpPr>
         <p:spPr>
           <a:xfrm>
-            <a:off x="960120" y="2423160"/>
-            <a:ext cx="420624" cy="420624"/>
+            <a:off x="1005840" y="3090672"/>
+            <a:ext cx="548640" cy="548640"/>
           </a:xfrm>
           <a:prstGeom prst="ellipse">
             <a:avLst/>
@@ -29862,8 +29862,8 @@
         </p:blipFill>
         <p:spPr>
           <a:xfrm>
-            <a:off x="1002182" y="2465222"/>
-            <a:ext cx="336499" cy="336499"/>
+            <a:off x="1060704" y="3145536"/>
+            <a:ext cx="438912" cy="438912"/>
           </a:xfrm>
           <a:prstGeom prst="rect">
             <a:avLst/>
@@ -29878,8 +29878,8 @@
         </p:nvSpPr>
         <p:spPr>
           <a:xfrm>
-            <a:off x="1463040" y="2423160"/>
-            <a:ext cx="420624" cy="420624"/>
+            <a:off x="1691640" y="3090672"/>
+            <a:ext cx="548640" cy="548640"/>
           </a:xfrm>
           <a:prstGeom prst="ellipse">
             <a:avLst/>
@@ -29930,8 +29930,8 @@
         </p:blipFill>
         <p:spPr>
           <a:xfrm>
-            <a:off x="1505102" y="2465222"/>
-            <a:ext cx="336499" cy="336499"/>
+            <a:off x="1746504" y="3145536"/>
+            <a:ext cx="438912" cy="438912"/>
           </a:xfrm>
           <a:prstGeom prst="rect">
             <a:avLst/>
@@ -29946,8 +29946,8 @@
         </p:nvSpPr>
         <p:spPr>
           <a:xfrm>
-            <a:off x="2057400" y="2395728"/>
-            <a:ext cx="6035040" cy="292608"/>
+            <a:off x="2468880" y="3090672"/>
+            <a:ext cx="5943600" cy="365760"/>
           </a:xfrm>
           <a:prstGeom prst="rect">
             <a:avLst/>
@@ -29962,7 +29962,7 @@
           <a:p>
             <a:pPr algn="l"/>
             <a:r>
-              <a:rPr sz="1400" b="1" i="0">
+              <a:rPr sz="1500" b="1" i="0">
                 <a:solidFill>
                   <a:srgbClr val="FFFFFF"/>
                 </a:solidFill>
@@ -29981,8 +29981,8 @@
         </p:nvSpPr>
         <p:spPr>
           <a:xfrm>
-            <a:off x="2057400" y="2660904"/>
-            <a:ext cx="6035040" cy="237744"/>
+            <a:off x="2468880" y="3419856"/>
+            <a:ext cx="5943600" cy="274320"/>
           </a:xfrm>
           <a:prstGeom prst="rect">
             <a:avLst/>
@@ -29997,7 +29997,7 @@
           <a:p>
             <a:pPr algn="l"/>
             <a:r>
-              <a:rPr sz="900" b="0" i="0">
+              <a:rPr sz="1000" b="0" i="0">
                 <a:solidFill>
                   <a:srgbClr val="CADCFC"/>
                 </a:solidFill>
@@ -30016,8 +30016,8 @@
         </p:nvSpPr>
         <p:spPr>
           <a:xfrm>
-            <a:off x="7772400" y="2404872"/>
-            <a:ext cx="3383280" cy="310896"/>
+            <a:off x="7680960" y="3090672"/>
+            <a:ext cx="3474720" cy="365760"/>
           </a:xfrm>
           <a:prstGeom prst="rect">
             <a:avLst/>
@@ -30032,7 +30032,7 @@
           <a:p>
             <a:pPr algn="r"/>
             <a:r>
-              <a:rPr sz="1250" b="1" i="0">
+              <a:rPr sz="1350" b="1" i="0">
                 <a:solidFill>
                   <a:srgbClr val="F47321"/>
                 </a:solidFill>
@@ -30051,8 +30051,8 @@
         </p:nvSpPr>
         <p:spPr>
           <a:xfrm>
-            <a:off x="7772400" y="2679192"/>
-            <a:ext cx="3383280" cy="228600"/>
+            <a:off x="7680960" y="3429000"/>
+            <a:ext cx="3474720" cy="274320"/>
           </a:xfrm>
           <a:prstGeom prst="rect">
             <a:avLst/>
@@ -30067,7 +30067,7 @@
           <a:p>
             <a:pPr algn="r"/>
             <a:r>
-              <a:rPr sz="850" b="0" i="0">
+              <a:rPr sz="950" b="0" i="0">
                 <a:solidFill>
                   <a:srgbClr val="CADCFC"/>
                 </a:solidFill>
@@ -30086,8 +30086,8 @@
         </p:nvSpPr>
         <p:spPr>
           <a:xfrm>
-            <a:off x="822960" y="2962656"/>
-            <a:ext cx="10515600" cy="548640"/>
+            <a:off x="822960" y="3803904"/>
+            <a:ext cx="10515600" cy="731520"/>
           </a:xfrm>
           <a:prstGeom prst="roundRect">
             <a:avLst/>
@@ -30130,8 +30130,8 @@
         </p:nvSpPr>
         <p:spPr>
           <a:xfrm>
-            <a:off x="960120" y="3026664"/>
-            <a:ext cx="420624" cy="420624"/>
+            <a:off x="1005840" y="3895344"/>
+            <a:ext cx="548640" cy="548640"/>
           </a:xfrm>
           <a:prstGeom prst="ellipse">
             <a:avLst/>
@@ -30182,8 +30182,8 @@
         </p:blipFill>
         <p:spPr>
           <a:xfrm>
-            <a:off x="1002182" y="3068726"/>
-            <a:ext cx="336499" cy="336499"/>
+            <a:off x="1060704" y="3950207"/>
+            <a:ext cx="438912" cy="438912"/>
           </a:xfrm>
           <a:prstGeom prst="rect">
             <a:avLst/>
@@ -30198,8 +30198,8 @@
         </p:nvSpPr>
         <p:spPr>
           <a:xfrm>
-            <a:off x="1463040" y="3026664"/>
-            <a:ext cx="420624" cy="420624"/>
+            <a:off x="1691640" y="3895344"/>
+            <a:ext cx="548640" cy="548640"/>
           </a:xfrm>
           <a:prstGeom prst="ellipse">
             <a:avLst/>
@@ -30250,8 +30250,8 @@
         </p:blipFill>
         <p:spPr>
           <a:xfrm>
-            <a:off x="1505102" y="3068726"/>
-            <a:ext cx="336499" cy="336499"/>
+            <a:off x="1746504" y="3950207"/>
+            <a:ext cx="438912" cy="438912"/>
           </a:xfrm>
           <a:prstGeom prst="rect">
             <a:avLst/>
@@ -30266,8 +30266,8 @@
         </p:nvSpPr>
         <p:spPr>
           <a:xfrm>
-            <a:off x="2057400" y="2999232"/>
-            <a:ext cx="6035040" cy="292608"/>
+            <a:off x="2468880" y="3895344"/>
+            <a:ext cx="5943600" cy="365760"/>
           </a:xfrm>
           <a:prstGeom prst="rect">
             <a:avLst/>
@@ -30282,7 +30282,7 @@
           <a:p>
             <a:pPr algn="l"/>
             <a:r>
-              <a:rPr sz="1400" b="1" i="0">
+              <a:rPr sz="1500" b="1" i="0">
                 <a:solidFill>
                   <a:srgbClr val="FFFFFF"/>
                 </a:solidFill>
@@ -30301,8 +30301,8 @@
         </p:nvSpPr>
         <p:spPr>
           <a:xfrm>
-            <a:off x="2057400" y="3264408"/>
-            <a:ext cx="6035040" cy="237744"/>
+            <a:off x="2468880" y="4224528"/>
+            <a:ext cx="5943600" cy="274320"/>
           </a:xfrm>
           <a:prstGeom prst="rect">
             <a:avLst/>
@@ -30317,7 +30317,7 @@
           <a:p>
             <a:pPr algn="l"/>
             <a:r>
-              <a:rPr sz="900" b="0" i="0">
+              <a:rPr sz="1000" b="0" i="0">
                 <a:solidFill>
                   <a:srgbClr val="CADCFC"/>
                 </a:solidFill>
@@ -30336,8 +30336,8 @@
         </p:nvSpPr>
         <p:spPr>
           <a:xfrm>
-            <a:off x="7772400" y="3008376"/>
-            <a:ext cx="3383280" cy="310896"/>
+            <a:off x="7680960" y="3895344"/>
+            <a:ext cx="3474720" cy="365760"/>
           </a:xfrm>
           <a:prstGeom prst="rect">
             <a:avLst/>
@@ -30352,7 +30352,7 @@
           <a:p>
             <a:pPr algn="r"/>
             <a:r>
-              <a:rPr sz="1250" b="1" i="0">
+              <a:rPr sz="1350" b="1" i="0">
                 <a:solidFill>
                   <a:srgbClr val="F47321"/>
                 </a:solidFill>
@@ -30371,8 +30371,8 @@
         </p:nvSpPr>
         <p:spPr>
           <a:xfrm>
-            <a:off x="7772400" y="3282696"/>
-            <a:ext cx="3383280" cy="228600"/>
+            <a:off x="7680960" y="4233672"/>
+            <a:ext cx="3474720" cy="274320"/>
           </a:xfrm>
           <a:prstGeom prst="rect">
             <a:avLst/>
@@ -30387,7 +30387,7 @@
           <a:p>
             <a:pPr algn="r"/>
             <a:r>
-              <a:rPr sz="850" b="0" i="0">
+              <a:rPr sz="950" b="0" i="0">
                 <a:solidFill>
                   <a:srgbClr val="CADCFC"/>
                 </a:solidFill>
@@ -30406,8 +30406,8 @@
         </p:nvSpPr>
         <p:spPr>
           <a:xfrm>
-            <a:off x="822960" y="3566160"/>
-            <a:ext cx="10515600" cy="548640"/>
+            <a:off x="822960" y="4608576"/>
+            <a:ext cx="10515600" cy="731520"/>
           </a:xfrm>
           <a:prstGeom prst="roundRect">
             <a:avLst/>
@@ -30450,8 +30450,8 @@
         </p:nvSpPr>
         <p:spPr>
           <a:xfrm>
-            <a:off x="960120" y="3630168"/>
-            <a:ext cx="420624" cy="420624"/>
+            <a:off x="1005840" y="4700016"/>
+            <a:ext cx="548640" cy="548640"/>
           </a:xfrm>
           <a:prstGeom prst="ellipse">
             <a:avLst/>
@@ -30502,8 +30502,8 @@
         </p:blipFill>
         <p:spPr>
           <a:xfrm>
-            <a:off x="1002182" y="3672230"/>
-            <a:ext cx="336499" cy="336499"/>
+            <a:off x="1060704" y="4754879"/>
+            <a:ext cx="438912" cy="438912"/>
           </a:xfrm>
           <a:prstGeom prst="rect">
             <a:avLst/>
@@ -30518,8 +30518,8 @@
         </p:nvSpPr>
         <p:spPr>
           <a:xfrm>
-            <a:off x="1463040" y="3630168"/>
-            <a:ext cx="420624" cy="420624"/>
+            <a:off x="1691640" y="4700016"/>
+            <a:ext cx="548640" cy="548640"/>
           </a:xfrm>
           <a:prstGeom prst="ellipse">
             <a:avLst/>
@@ -30570,8 +30570,8 @@
         </p:blipFill>
         <p:spPr>
           <a:xfrm>
-            <a:off x="1505102" y="3672230"/>
-            <a:ext cx="336499" cy="336499"/>
+            <a:off x="1746504" y="4754879"/>
+            <a:ext cx="438912" cy="438912"/>
           </a:xfrm>
           <a:prstGeom prst="rect">
             <a:avLst/>
@@ -30586,8 +30586,8 @@
         </p:nvSpPr>
         <p:spPr>
           <a:xfrm>
-            <a:off x="2057400" y="3602736"/>
-            <a:ext cx="6035040" cy="292608"/>
+            <a:off x="2468880" y="4700016"/>
+            <a:ext cx="5943600" cy="365760"/>
           </a:xfrm>
           <a:prstGeom prst="rect">
             <a:avLst/>
@@ -30602,7 +30602,7 @@
           <a:p>
             <a:pPr algn="l"/>
             <a:r>
-              <a:rPr sz="1400" b="1" i="0">
+              <a:rPr sz="1500" b="1" i="0">
                 <a:solidFill>
                   <a:srgbClr val="FFFFFF"/>
                 </a:solidFill>
@@ -30621,8 +30621,8 @@
         </p:nvSpPr>
         <p:spPr>
           <a:xfrm>
-            <a:off x="2057400" y="3867912"/>
-            <a:ext cx="6035040" cy="237744"/>
+            <a:off x="2468880" y="5029200"/>
+            <a:ext cx="5943600" cy="274320"/>
           </a:xfrm>
           <a:prstGeom prst="rect">
             <a:avLst/>
@@ -30637,7 +30637,7 @@
           <a:p>
             <a:pPr algn="l"/>
             <a:r>
-              <a:rPr sz="900" b="0" i="0">
+              <a:rPr sz="1000" b="0" i="0">
                 <a:solidFill>
                   <a:srgbClr val="CADCFC"/>
                 </a:solidFill>
@@ -30656,8 +30656,8 @@
         </p:nvSpPr>
         <p:spPr>
           <a:xfrm>
-            <a:off x="7772400" y="3611880"/>
-            <a:ext cx="3383280" cy="310896"/>
+            <a:off x="7680960" y="4700016"/>
+            <a:ext cx="3474720" cy="365760"/>
           </a:xfrm>
           <a:prstGeom prst="rect">
             <a:avLst/>
@@ -30672,7 +30672,7 @@
           <a:p>
             <a:pPr algn="r"/>
             <a:r>
-              <a:rPr sz="1250" b="1" i="0">
+              <a:rPr sz="1350" b="1" i="0">
                 <a:solidFill>
                   <a:srgbClr val="F47321"/>
                 </a:solidFill>
@@ -30691,8 +30691,8 @@
         </p:nvSpPr>
         <p:spPr>
           <a:xfrm>
-            <a:off x="7772400" y="3886200"/>
-            <a:ext cx="3383280" cy="228600"/>
+            <a:off x="7680960" y="5038344"/>
+            <a:ext cx="3474720" cy="274320"/>
           </a:xfrm>
           <a:prstGeom prst="rect">
             <a:avLst/>
@@ -30707,7 +30707,7 @@
           <a:p>
             <a:pPr algn="r"/>
             <a:r>
-              <a:rPr sz="850" b="0" i="0">
+              <a:rPr sz="950" b="0" i="0">
                 <a:solidFill>
                   <a:srgbClr val="CADCFC"/>
                 </a:solidFill>
@@ -30726,8 +30726,8 @@
         </p:nvSpPr>
         <p:spPr>
           <a:xfrm>
-            <a:off x="822960" y="4169664"/>
-            <a:ext cx="10515600" cy="548640"/>
+            <a:off x="822960" y="5413248"/>
+            <a:ext cx="10515600" cy="731520"/>
           </a:xfrm>
           <a:prstGeom prst="roundRect">
             <a:avLst/>
@@ -30770,8 +30770,8 @@
         </p:nvSpPr>
         <p:spPr>
           <a:xfrm>
-            <a:off x="960120" y="4233672"/>
-            <a:ext cx="420624" cy="420624"/>
+            <a:off x="1005840" y="5504688"/>
+            <a:ext cx="548640" cy="548640"/>
           </a:xfrm>
           <a:prstGeom prst="ellipse">
             <a:avLst/>
@@ -30822,8 +30822,8 @@
         </p:blipFill>
         <p:spPr>
           <a:xfrm>
-            <a:off x="1002182" y="4275734"/>
-            <a:ext cx="336499" cy="336499"/>
+            <a:off x="1060704" y="5559551"/>
+            <a:ext cx="438912" cy="438912"/>
           </a:xfrm>
           <a:prstGeom prst="rect">
             <a:avLst/>
@@ -30838,8 +30838,8 @@
         </p:nvSpPr>
         <p:spPr>
           <a:xfrm>
-            <a:off x="1463040" y="4233672"/>
-            <a:ext cx="420624" cy="420624"/>
+            <a:off x="1691640" y="5504688"/>
+            <a:ext cx="548640" cy="548640"/>
           </a:xfrm>
           <a:prstGeom prst="ellipse">
             <a:avLst/>
@@ -30890,8 +30890,8 @@
         </p:blipFill>
         <p:spPr>
           <a:xfrm>
-            <a:off x="1505102" y="4275734"/>
-            <a:ext cx="336499" cy="336499"/>
+            <a:off x="1746504" y="5559551"/>
+            <a:ext cx="438912" cy="438912"/>
           </a:xfrm>
           <a:prstGeom prst="rect">
             <a:avLst/>
@@ -30906,8 +30906,8 @@
         </p:nvSpPr>
         <p:spPr>
           <a:xfrm>
-            <a:off x="2057400" y="4206240"/>
-            <a:ext cx="6035040" cy="292608"/>
+            <a:off x="2468880" y="5504688"/>
+            <a:ext cx="5943600" cy="365760"/>
           </a:xfrm>
           <a:prstGeom prst="rect">
             <a:avLst/>
@@ -30922,7 +30922,7 @@
           <a:p>
             <a:pPr algn="l"/>
             <a:r>
-              <a:rPr sz="1400" b="1" i="0">
+              <a:rPr sz="1500" b="1" i="0">
                 <a:solidFill>
                   <a:srgbClr val="FFFFFF"/>
                 </a:solidFill>
@@ -30941,8 +30941,8 @@
         </p:nvSpPr>
         <p:spPr>
           <a:xfrm>
-            <a:off x="2057400" y="4471416"/>
-            <a:ext cx="6035040" cy="237744"/>
+            <a:off x="2468880" y="5833872"/>
+            <a:ext cx="5943600" cy="274320"/>
           </a:xfrm>
           <a:prstGeom prst="rect">
             <a:avLst/>
@@ -30957,7 +30957,7 @@
           <a:p>
             <a:pPr algn="l"/>
             <a:r>
-              <a:rPr sz="900" b="0" i="0">
+              <a:rPr sz="1000" b="0" i="0">
                 <a:solidFill>
                   <a:srgbClr val="CADCFC"/>
                 </a:solidFill>
@@ -30976,8 +30976,8 @@
         </p:nvSpPr>
         <p:spPr>
           <a:xfrm>
-            <a:off x="7772400" y="4215384"/>
-            <a:ext cx="3383280" cy="310896"/>
+            <a:off x="7680960" y="5504688"/>
+            <a:ext cx="3474720" cy="365760"/>
           </a:xfrm>
           <a:prstGeom prst="rect">
             <a:avLst/>
@@ -30992,7 +30992,7 @@
           <a:p>
             <a:pPr algn="r"/>
             <a:r>
-              <a:rPr sz="1250" b="1" i="0">
+              <a:rPr sz="1350" b="1" i="0">
                 <a:solidFill>
                   <a:srgbClr val="F47321"/>
                 </a:solidFill>
@@ -31011,8 +31011,8 @@
         </p:nvSpPr>
         <p:spPr>
           <a:xfrm>
-            <a:off x="7772400" y="4489704"/>
-            <a:ext cx="3383280" cy="228600"/>
+            <a:off x="7680960" y="5843016"/>
+            <a:ext cx="3474720" cy="274320"/>
           </a:xfrm>
           <a:prstGeom prst="rect">
             <a:avLst/>
@@ -31027,7 +31027,7 @@
           <a:p>
             <a:pPr algn="r"/>
             <a:r>
-              <a:rPr sz="850" b="0" i="0">
+              <a:rPr sz="950" b="0" i="0">
                 <a:solidFill>
                   <a:srgbClr val="CADCFC"/>
                 </a:solidFill>
@@ -31040,194 +31040,14 @@
       </p:sp>
       <p:sp>
         <p:nvSpPr>
-          <p:cNvPr id="49" name="Rounded Rectangle 48"/>
-          <p:cNvSpPr/>
-          <p:nvPr/>
-        </p:nvSpPr>
-        <p:spPr>
-          <a:xfrm>
-            <a:off x="822960" y="4773168"/>
-            <a:ext cx="10515600" cy="548640"/>
-          </a:xfrm>
-          <a:prstGeom prst="roundRect">
-            <a:avLst/>
-          </a:prstGeom>
-          <a:solidFill>
-            <a:srgbClr val="123568"/>
-          </a:solidFill>
-          <a:ln>
-            <a:noFill/>
-          </a:ln>
-          <a:effectLst/>
-        </p:spPr>
-        <p:style>
-          <a:lnRef idx="1">
-            <a:schemeClr val="accent1"/>
-          </a:lnRef>
-          <a:fillRef idx="3">
-            <a:schemeClr val="accent1"/>
-          </a:fillRef>
-          <a:effectRef idx="2">
-            <a:schemeClr val="accent1"/>
-          </a:effectRef>
-          <a:fontRef idx="minor">
-            <a:schemeClr val="lt1"/>
-          </a:fontRef>
-        </p:style>
-        <p:txBody>
-          <a:bodyPr rtlCol="0" anchor="ctr"/>
-          <a:lstStyle/>
-          <a:p>
-            <a:pPr algn="ctr"/>
-          </a:p>
-        </p:txBody>
-      </p:sp>
-      <p:sp>
-        <p:nvSpPr>
-          <p:cNvPr id="50" name="Oval 49"/>
-          <p:cNvSpPr/>
-          <p:nvPr/>
-        </p:nvSpPr>
-        <p:spPr>
-          <a:xfrm>
-            <a:off x="960120" y="4837176"/>
-            <a:ext cx="420624" cy="420624"/>
-          </a:xfrm>
-          <a:prstGeom prst="ellipse">
-            <a:avLst/>
-          </a:prstGeom>
-          <a:solidFill>
-            <a:srgbClr val="FFFFFF"/>
-          </a:solidFill>
-          <a:ln>
-            <a:noFill/>
-          </a:ln>
-          <a:effectLst/>
-        </p:spPr>
-        <p:style>
-          <a:lnRef idx="1">
-            <a:schemeClr val="accent1"/>
-          </a:lnRef>
-          <a:fillRef idx="3">
-            <a:schemeClr val="accent1"/>
-          </a:fillRef>
-          <a:effectRef idx="2">
-            <a:schemeClr val="accent1"/>
-          </a:effectRef>
-          <a:fontRef idx="minor">
-            <a:schemeClr val="lt1"/>
-          </a:fontRef>
-        </p:style>
-        <p:txBody>
-          <a:bodyPr rtlCol="0" anchor="ctr"/>
-          <a:lstStyle/>
-          <a:p>
-            <a:pPr algn="ctr"/>
-          </a:p>
-        </p:txBody>
-      </p:sp>
-      <p:pic>
-        <p:nvPicPr>
-          <p:cNvPr id="51" name="Picture 50" descr="buffalo.png"/>
-          <p:cNvPicPr>
-            <a:picLocks noChangeAspect="1"/>
-          </p:cNvPicPr>
-          <p:nvPr/>
-        </p:nvPicPr>
-        <p:blipFill>
-          <a:blip r:embed="rId12"/>
-          <a:stretch>
-            <a:fillRect/>
-          </a:stretch>
-        </p:blipFill>
-        <p:spPr>
-          <a:xfrm>
-            <a:off x="1002182" y="4879238"/>
-            <a:ext cx="336499" cy="336499"/>
-          </a:xfrm>
-          <a:prstGeom prst="rect">
-            <a:avLst/>
-          </a:prstGeom>
-        </p:spPr>
-      </p:pic>
-      <p:sp>
-        <p:nvSpPr>
-          <p:cNvPr id="52" name="Oval 51"/>
-          <p:cNvSpPr/>
-          <p:nvPr/>
-        </p:nvSpPr>
-        <p:spPr>
-          <a:xfrm>
-            <a:off x="1463040" y="4837176"/>
-            <a:ext cx="420624" cy="420624"/>
-          </a:xfrm>
-          <a:prstGeom prst="ellipse">
-            <a:avLst/>
-          </a:prstGeom>
-          <a:solidFill>
-            <a:srgbClr val="FFFFFF"/>
-          </a:solidFill>
-          <a:ln>
-            <a:noFill/>
-          </a:ln>
-          <a:effectLst/>
-        </p:spPr>
-        <p:style>
-          <a:lnRef idx="1">
-            <a:schemeClr val="accent1"/>
-          </a:lnRef>
-          <a:fillRef idx="3">
-            <a:schemeClr val="accent1"/>
-          </a:fillRef>
-          <a:effectRef idx="2">
-            <a:schemeClr val="accent1"/>
-          </a:effectRef>
-          <a:fontRef idx="minor">
-            <a:schemeClr val="lt1"/>
-          </a:fontRef>
-        </p:style>
-        <p:txBody>
-          <a:bodyPr rtlCol="0" anchor="ctr"/>
-          <a:lstStyle/>
-          <a:p>
-            <a:pPr algn="ctr"/>
-          </a:p>
-        </p:txBody>
-      </p:sp>
-      <p:pic>
-        <p:nvPicPr>
-          <p:cNvPr id="53" name="Picture 52" descr="fiu.png"/>
-          <p:cNvPicPr>
-            <a:picLocks noChangeAspect="1"/>
-          </p:cNvPicPr>
-          <p:nvPr/>
-        </p:nvPicPr>
-        <p:blipFill>
-          <a:blip r:embed="rId13"/>
-          <a:stretch>
-            <a:fillRect/>
-          </a:stretch>
-        </p:blipFill>
-        <p:spPr>
-          <a:xfrm>
-            <a:off x="1505102" y="4879238"/>
-            <a:ext cx="336499" cy="336499"/>
-          </a:xfrm>
-          <a:prstGeom prst="rect">
-            <a:avLst/>
-          </a:prstGeom>
-        </p:spPr>
-      </p:pic>
-      <p:sp>
-        <p:nvSpPr>
-          <p:cNvPr id="54" name="TextBox 53"/>
-          <p:cNvSpPr txBox="1"/>
-          <p:nvPr/>
-        </p:nvSpPr>
-        <p:spPr>
-          <a:xfrm>
-            <a:off x="2057400" y="4809744"/>
-            <a:ext cx="6035040" cy="292608"/>
+          <p:cNvPr id="49" name="TextBox 48"/>
+          <p:cNvSpPr txBox="1"/>
+          <p:nvPr/>
+        </p:nvSpPr>
+        <p:spPr>
+          <a:xfrm>
+            <a:off x="822960" y="6263640"/>
+            <a:ext cx="10515600" cy="457200"/>
           </a:xfrm>
           <a:prstGeom prst="rect">
             <a:avLst/>
@@ -31242,473 +31062,13 @@
           <a:p>
             <a:pPr algn="l"/>
             <a:r>
-              <a:rPr sz="1400" b="1" i="0">
-                <a:solidFill>
-                  <a:srgbClr val="FFFFFF"/>
-                </a:solidFill>
-                <a:latin typeface="Arial"/>
-              </a:rPr>
-              <a:t>Buffalo at Florida International</a:t>
-            </a:r>
-          </a:p>
-        </p:txBody>
-      </p:sp>
-      <p:sp>
-        <p:nvSpPr>
-          <p:cNvPr id="55" name="TextBox 54"/>
-          <p:cNvSpPr txBox="1"/>
-          <p:nvPr/>
-        </p:nvSpPr>
-        <p:spPr>
-          <a:xfrm>
-            <a:off x="2057400" y="5074920"/>
-            <a:ext cx="6035040" cy="237744"/>
-          </a:xfrm>
-          <a:prstGeom prst="rect">
-            <a:avLst/>
-          </a:prstGeom>
-          <a:noFill/>
-        </p:spPr>
-        <p:txBody>
-          <a:bodyPr wrap="square" lIns="0" rIns="0" tIns="0" bIns="0">
-            <a:spAutoFit/>
-          </a:bodyPr>
-          <a:lstStyle/>
-          <a:p>
-            <a:pPr algn="l"/>
-            <a:r>
-              <a:rPr sz="900" b="1" i="0">
-                <a:solidFill>
-                  <a:srgbClr val="F47321"/>
-                </a:solidFill>
-                <a:latin typeface="Arial"/>
-              </a:rPr>
-              <a:t>★ SUPERDOG — Buffalo +10.5 at Florida International · ML +340 · Sat Sep 12 · Pitbull Stadium</a:t>
-            </a:r>
-          </a:p>
-        </p:txBody>
-      </p:sp>
-      <p:sp>
-        <p:nvSpPr>
-          <p:cNvPr id="56" name="TextBox 55"/>
-          <p:cNvSpPr txBox="1"/>
-          <p:nvPr/>
-        </p:nvSpPr>
-        <p:spPr>
-          <a:xfrm>
-            <a:off x="7772400" y="4818888"/>
-            <a:ext cx="3383280" cy="310896"/>
-          </a:xfrm>
-          <a:prstGeom prst="rect">
-            <a:avLst/>
-          </a:prstGeom>
-          <a:noFill/>
-        </p:spPr>
-        <p:txBody>
-          <a:bodyPr wrap="square" lIns="0" rIns="0" tIns="0" bIns="0">
-            <a:spAutoFit/>
-          </a:bodyPr>
-          <a:lstStyle/>
-          <a:p>
-            <a:pPr algn="r"/>
-            <a:r>
-              <a:rPr sz="1250" b="1" i="0">
-                <a:solidFill>
-                  <a:srgbClr val="F47321"/>
-                </a:solidFill>
-                <a:latin typeface="Arial"/>
-              </a:rPr>
-              <a:t>Florida International –1.5   ·   –10.5 / –10</a:t>
-            </a:r>
-          </a:p>
-        </p:txBody>
-      </p:sp>
-      <p:sp>
-        <p:nvSpPr>
-          <p:cNvPr id="57" name="TextBox 56"/>
-          <p:cNvSpPr txBox="1"/>
-          <p:nvPr/>
-        </p:nvSpPr>
-        <p:spPr>
-          <a:xfrm>
-            <a:off x="7772400" y="5093208"/>
-            <a:ext cx="3383280" cy="228600"/>
-          </a:xfrm>
-          <a:prstGeom prst="rect">
-            <a:avLst/>
-          </a:prstGeom>
-          <a:noFill/>
-        </p:spPr>
-        <p:txBody>
-          <a:bodyPr wrap="square" lIns="0" rIns="0" tIns="0" bIns="0">
-            <a:spAutoFit/>
-          </a:bodyPr>
-          <a:lstStyle/>
-          <a:p>
-            <a:pPr algn="r"/>
-            <a:r>
-              <a:rPr sz="850" b="0" i="0">
-                <a:solidFill>
-                  <a:srgbClr val="CADCFC"/>
-                </a:solidFill>
-                <a:latin typeface="Arial"/>
-              </a:rPr>
-              <a:t>machine · market</a:t>
-            </a:r>
-          </a:p>
-        </p:txBody>
-      </p:sp>
-      <p:sp>
-        <p:nvSpPr>
-          <p:cNvPr id="58" name="Rounded Rectangle 57"/>
-          <p:cNvSpPr/>
-          <p:nvPr/>
-        </p:nvSpPr>
-        <p:spPr>
-          <a:xfrm>
-            <a:off x="822960" y="5376672"/>
-            <a:ext cx="10515600" cy="548640"/>
-          </a:xfrm>
-          <a:prstGeom prst="roundRect">
-            <a:avLst/>
-          </a:prstGeom>
-          <a:solidFill>
-            <a:srgbClr val="123568"/>
-          </a:solidFill>
-          <a:ln>
-            <a:noFill/>
-          </a:ln>
-          <a:effectLst/>
-        </p:spPr>
-        <p:style>
-          <a:lnRef idx="1">
-            <a:schemeClr val="accent1"/>
-          </a:lnRef>
-          <a:fillRef idx="3">
-            <a:schemeClr val="accent1"/>
-          </a:fillRef>
-          <a:effectRef idx="2">
-            <a:schemeClr val="accent1"/>
-          </a:effectRef>
-          <a:fontRef idx="minor">
-            <a:schemeClr val="lt1"/>
-          </a:fontRef>
-        </p:style>
-        <p:txBody>
-          <a:bodyPr rtlCol="0" anchor="ctr"/>
-          <a:lstStyle/>
-          <a:p>
-            <a:pPr algn="ctr"/>
-          </a:p>
-        </p:txBody>
-      </p:sp>
-      <p:sp>
-        <p:nvSpPr>
-          <p:cNvPr id="59" name="Oval 58"/>
-          <p:cNvSpPr/>
-          <p:nvPr/>
-        </p:nvSpPr>
-        <p:spPr>
-          <a:xfrm>
-            <a:off x="960120" y="5440680"/>
-            <a:ext cx="420624" cy="420624"/>
-          </a:xfrm>
-          <a:prstGeom prst="ellipse">
-            <a:avLst/>
-          </a:prstGeom>
-          <a:solidFill>
-            <a:srgbClr val="FFFFFF"/>
-          </a:solidFill>
-          <a:ln>
-            <a:noFill/>
-          </a:ln>
-          <a:effectLst/>
-        </p:spPr>
-        <p:style>
-          <a:lnRef idx="1">
-            <a:schemeClr val="accent1"/>
-          </a:lnRef>
-          <a:fillRef idx="3">
-            <a:schemeClr val="accent1"/>
-          </a:fillRef>
-          <a:effectRef idx="2">
-            <a:schemeClr val="accent1"/>
-          </a:effectRef>
-          <a:fontRef idx="minor">
-            <a:schemeClr val="lt1"/>
-          </a:fontRef>
-        </p:style>
-        <p:txBody>
-          <a:bodyPr rtlCol="0" anchor="ctr"/>
-          <a:lstStyle/>
-          <a:p>
-            <a:pPr algn="ctr"/>
-          </a:p>
-        </p:txBody>
-      </p:sp>
-      <p:pic>
-        <p:nvPicPr>
-          <p:cNvPr id="60" name="Picture 59" descr="arkansas.png"/>
-          <p:cNvPicPr>
-            <a:picLocks noChangeAspect="1"/>
-          </p:cNvPicPr>
-          <p:nvPr/>
-        </p:nvPicPr>
-        <p:blipFill>
-          <a:blip r:embed="rId14"/>
-          <a:stretch>
-            <a:fillRect/>
-          </a:stretch>
-        </p:blipFill>
-        <p:spPr>
-          <a:xfrm>
-            <a:off x="1002182" y="5482742"/>
-            <a:ext cx="336499" cy="336499"/>
-          </a:xfrm>
-          <a:prstGeom prst="rect">
-            <a:avLst/>
-          </a:prstGeom>
-        </p:spPr>
-      </p:pic>
-      <p:sp>
-        <p:nvSpPr>
-          <p:cNvPr id="61" name="Oval 60"/>
-          <p:cNvSpPr/>
-          <p:nvPr/>
-        </p:nvSpPr>
-        <p:spPr>
-          <a:xfrm>
-            <a:off x="1463040" y="5440680"/>
-            <a:ext cx="420624" cy="420624"/>
-          </a:xfrm>
-          <a:prstGeom prst="ellipse">
-            <a:avLst/>
-          </a:prstGeom>
-          <a:solidFill>
-            <a:srgbClr val="FFFFFF"/>
-          </a:solidFill>
-          <a:ln>
-            <a:noFill/>
-          </a:ln>
-          <a:effectLst/>
-        </p:spPr>
-        <p:style>
-          <a:lnRef idx="1">
-            <a:schemeClr val="accent1"/>
-          </a:lnRef>
-          <a:fillRef idx="3">
-            <a:schemeClr val="accent1"/>
-          </a:fillRef>
-          <a:effectRef idx="2">
-            <a:schemeClr val="accent1"/>
-          </a:effectRef>
-          <a:fontRef idx="minor">
-            <a:schemeClr val="lt1"/>
-          </a:fontRef>
-        </p:style>
-        <p:txBody>
-          <a:bodyPr rtlCol="0" anchor="ctr"/>
-          <a:lstStyle/>
-          <a:p>
-            <a:pPr algn="ctr"/>
-          </a:p>
-        </p:txBody>
-      </p:sp>
-      <p:pic>
-        <p:nvPicPr>
-          <p:cNvPr id="62" name="Picture 61" descr="utah.png"/>
-          <p:cNvPicPr>
-            <a:picLocks noChangeAspect="1"/>
-          </p:cNvPicPr>
-          <p:nvPr/>
-        </p:nvPicPr>
-        <p:blipFill>
-          <a:blip r:embed="rId15"/>
-          <a:stretch>
-            <a:fillRect/>
-          </a:stretch>
-        </p:blipFill>
-        <p:spPr>
-          <a:xfrm>
-            <a:off x="1505102" y="5482742"/>
-            <a:ext cx="336499" cy="336499"/>
-          </a:xfrm>
-          <a:prstGeom prst="rect">
-            <a:avLst/>
-          </a:prstGeom>
-        </p:spPr>
-      </p:pic>
-      <p:sp>
-        <p:nvSpPr>
-          <p:cNvPr id="63" name="TextBox 62"/>
-          <p:cNvSpPr txBox="1"/>
-          <p:nvPr/>
-        </p:nvSpPr>
-        <p:spPr>
-          <a:xfrm>
-            <a:off x="2057400" y="5413248"/>
-            <a:ext cx="6035040" cy="292608"/>
-          </a:xfrm>
-          <a:prstGeom prst="rect">
-            <a:avLst/>
-          </a:prstGeom>
-          <a:noFill/>
-        </p:spPr>
-        <p:txBody>
-          <a:bodyPr wrap="square" lIns="0" rIns="0" tIns="0" bIns="0">
-            <a:spAutoFit/>
-          </a:bodyPr>
-          <a:lstStyle/>
-          <a:p>
-            <a:pPr algn="l"/>
-            <a:r>
-              <a:rPr sz="1400" b="1" i="0">
-                <a:solidFill>
-                  <a:srgbClr val="FFFFFF"/>
-                </a:solidFill>
-                <a:latin typeface="Arial"/>
-              </a:rPr>
-              <a:t>Arkansas at Utah</a:t>
-            </a:r>
-          </a:p>
-        </p:txBody>
-      </p:sp>
-      <p:sp>
-        <p:nvSpPr>
-          <p:cNvPr id="64" name="TextBox 63"/>
-          <p:cNvSpPr txBox="1"/>
-          <p:nvPr/>
-        </p:nvSpPr>
-        <p:spPr>
-          <a:xfrm>
-            <a:off x="2057400" y="5678424"/>
-            <a:ext cx="6035040" cy="237744"/>
-          </a:xfrm>
-          <a:prstGeom prst="rect">
-            <a:avLst/>
-          </a:prstGeom>
-          <a:noFill/>
-        </p:spPr>
-        <p:txBody>
-          <a:bodyPr wrap="square" lIns="0" rIns="0" tIns="0" bIns="0">
-            <a:spAutoFit/>
-          </a:bodyPr>
-          <a:lstStyle/>
-          <a:p>
-            <a:pPr algn="l"/>
-            <a:r>
-              <a:rPr sz="900" b="1" i="0">
-                <a:solidFill>
-                  <a:srgbClr val="F47321"/>
-                </a:solidFill>
-                <a:latin typeface="Arial"/>
-              </a:rPr>
-              <a:t>★ GIANT KILLER — Arkansas +12.5 at #20 Utah · ML +390 · Sat Sep 12 · Rice-Eccles Stadium</a:t>
-            </a:r>
-          </a:p>
-        </p:txBody>
-      </p:sp>
-      <p:sp>
-        <p:nvSpPr>
-          <p:cNvPr id="65" name="TextBox 64"/>
-          <p:cNvSpPr txBox="1"/>
-          <p:nvPr/>
-        </p:nvSpPr>
-        <p:spPr>
-          <a:xfrm>
-            <a:off x="7772400" y="5422392"/>
-            <a:ext cx="3383280" cy="310896"/>
-          </a:xfrm>
-          <a:prstGeom prst="rect">
-            <a:avLst/>
-          </a:prstGeom>
-          <a:noFill/>
-        </p:spPr>
-        <p:txBody>
-          <a:bodyPr wrap="square" lIns="0" rIns="0" tIns="0" bIns="0">
-            <a:spAutoFit/>
-          </a:bodyPr>
-          <a:lstStyle/>
-          <a:p>
-            <a:pPr algn="r"/>
-            <a:r>
-              <a:rPr sz="1250" b="1" i="0">
-                <a:solidFill>
-                  <a:srgbClr val="F47321"/>
-                </a:solidFill>
-                <a:latin typeface="Arial"/>
-              </a:rPr>
-              <a:t>Utah –6.5   ·   –12.5 / –12.5</a:t>
-            </a:r>
-          </a:p>
-        </p:txBody>
-      </p:sp>
-      <p:sp>
-        <p:nvSpPr>
-          <p:cNvPr id="66" name="TextBox 65"/>
-          <p:cNvSpPr txBox="1"/>
-          <p:nvPr/>
-        </p:nvSpPr>
-        <p:spPr>
-          <a:xfrm>
-            <a:off x="7772400" y="5696712"/>
-            <a:ext cx="3383280" cy="228600"/>
-          </a:xfrm>
-          <a:prstGeom prst="rect">
-            <a:avLst/>
-          </a:prstGeom>
-          <a:noFill/>
-        </p:spPr>
-        <p:txBody>
-          <a:bodyPr wrap="square" lIns="0" rIns="0" tIns="0" bIns="0">
-            <a:spAutoFit/>
-          </a:bodyPr>
-          <a:lstStyle/>
-          <a:p>
-            <a:pPr algn="r"/>
-            <a:r>
-              <a:rPr sz="850" b="0" i="0">
-                <a:solidFill>
-                  <a:srgbClr val="CADCFC"/>
-                </a:solidFill>
-                <a:latin typeface="Arial"/>
-              </a:rPr>
-              <a:t>machine · market</a:t>
-            </a:r>
-          </a:p>
-        </p:txBody>
-      </p:sp>
-      <p:sp>
-        <p:nvSpPr>
-          <p:cNvPr id="67" name="TextBox 66"/>
-          <p:cNvSpPr txBox="1"/>
-          <p:nvPr/>
-        </p:nvSpPr>
-        <p:spPr>
-          <a:xfrm>
-            <a:off x="822960" y="6126480"/>
-            <a:ext cx="10515600" cy="457200"/>
-          </a:xfrm>
-          <a:prstGeom prst="rect">
-            <a:avLst/>
-          </a:prstGeom>
-          <a:noFill/>
-        </p:spPr>
-        <p:txBody>
-          <a:bodyPr wrap="square" lIns="0" rIns="0" tIns="0" bIns="0">
-            <a:spAutoFit/>
-          </a:bodyPr>
-          <a:lstStyle/>
-          <a:p>
-            <a:pPr algn="l"/>
-            <a:r>
-              <a:rPr sz="1000" b="0" i="0">
+              <a:rPr sz="1050" b="0" i="0">
                 <a:solidFill>
                   <a:srgbClr val="8FA5C4"/>
                 </a:solidFill>
                 <a:latin typeface="Arial"/>
               </a:rPr>
-              <a:t>Machine = our in-season rating (ESPN preseason FPI prior + 2026 results, λ 3, cap ±28) + 2.5 HFA · empirical margin curve (σ 15.9) · lines as of Sep 9 · superdog rows = dog to win outright, points = the spread · model plays graded vs first-seen lines</a:t>
+              <a:t>Machine = our in-season rating (ESPN preseason FPI prior + 2026 results, λ 3, cap ±28) + 2.5 HFA · empirical margin curve (σ 15.9) · lines as of Sep 9 · model plays graded vs first-seen lines</a:t>
             </a:r>
           </a:p>
         </p:txBody>

</xml_diff>

<commit_message>
Ep3 receipts slide: Week 1 Superdog + Giant Killer rows, auto-graded from finals (SUPERDOG_RECAP); banner adds the superdog ledger
Co-Authored-By: Claude Fable 5.1 <noreply@anthropic.com>
</commit_message>
<xml_diff>
--- a/decks/2026_Week2_Episode3.pptx
+++ b/decks/2026_Week2_Episode3.pptx
@@ -31107,7 +31107,7 @@
         </p:nvSpPr>
         <p:spPr>
           <a:xfrm>
-            <a:off x="822960" y="457200"/>
+            <a:off x="822960" y="411480"/>
             <a:ext cx="10515600" cy="502920"/>
           </a:xfrm>
           <a:prstGeom prst="rect">
@@ -31142,7 +31142,7 @@
         </p:nvSpPr>
         <p:spPr>
           <a:xfrm>
-            <a:off x="822960" y="987552"/>
+            <a:off x="822960" y="914400"/>
             <a:ext cx="10515600" cy="274320"/>
           </a:xfrm>
           <a:prstGeom prst="rect">
@@ -31158,13 +31158,13 @@
           <a:p>
             <a:pPr algn="l"/>
             <a:r>
-              <a:rPr sz="1100" b="0" i="1">
+              <a:rPr sz="1050" b="0" i="1">
                 <a:solidFill>
                   <a:srgbClr val="5C6B7E"/>
                 </a:solidFill>
                 <a:latin typeface="Arial"/>
               </a:rPr>
-              <a:t>Our call frozen at the Ep2 recording · closing line = last pre-kick pull (Fri 5 PM ET · Mon 9:25 AM ET) · “off by” = miss vs the final margin</a:t>
+              <a:t>Our call frozen at the Ep2 recording · closing line = last pre-kick pull (Fri 5 PM ET · Mon 9:25 AM ET) · “off by” = miss vs the final margin · superdogs pay only on the outright win</a:t>
             </a:r>
           </a:p>
         </p:txBody>
@@ -31177,8 +31177,8 @@
         </p:nvSpPr>
         <p:spPr>
           <a:xfrm>
-            <a:off x="822960" y="1417320"/>
-            <a:ext cx="10515600" cy="786384"/>
+            <a:off x="822960" y="1298448"/>
+            <a:ext cx="10515600" cy="621792"/>
           </a:xfrm>
           <a:prstGeom prst="roundRect">
             <a:avLst/>
@@ -31229,8 +31229,8 @@
         </p:blipFill>
         <p:spPr>
           <a:xfrm>
-            <a:off x="1005840" y="1536192"/>
-            <a:ext cx="548640" cy="548640"/>
+            <a:off x="1005840" y="1380744"/>
+            <a:ext cx="457200" cy="457200"/>
           </a:xfrm>
           <a:prstGeom prst="rect">
             <a:avLst/>
@@ -31253,8 +31253,8 @@
         </p:blipFill>
         <p:spPr>
           <a:xfrm>
-            <a:off x="1645920" y="1536192"/>
-            <a:ext cx="548640" cy="548640"/>
+            <a:off x="1554480" y="1380744"/>
+            <a:ext cx="457200" cy="457200"/>
           </a:xfrm>
           <a:prstGeom prst="rect">
             <a:avLst/>
@@ -31269,23 +31269,23 @@
         </p:nvSpPr>
         <p:spPr>
           <a:xfrm>
-            <a:off x="2377440" y="1499616"/>
-            <a:ext cx="4389120" cy="320040"/>
-          </a:xfrm>
-          <a:prstGeom prst="rect">
-            <a:avLst/>
-          </a:prstGeom>
-          <a:noFill/>
-        </p:spPr>
-        <p:txBody>
-          <a:bodyPr wrap="square" lIns="0" rIns="0" tIns="0" bIns="0">
-            <a:spAutoFit/>
-          </a:bodyPr>
-          <a:lstStyle/>
-          <a:p>
-            <a:pPr algn="l"/>
-            <a:r>
-              <a:rPr sz="1350" b="1" i="0">
+            <a:off x="2194560" y="1344168"/>
+            <a:ext cx="4572000" cy="292608"/>
+          </a:xfrm>
+          <a:prstGeom prst="rect">
+            <a:avLst/>
+          </a:prstGeom>
+          <a:noFill/>
+        </p:spPr>
+        <p:txBody>
+          <a:bodyPr wrap="square" lIns="0" rIns="0" tIns="0" bIns="0">
+            <a:spAutoFit/>
+          </a:bodyPr>
+          <a:lstStyle/>
+          <a:p>
+            <a:pPr algn="l"/>
+            <a:r>
+              <a:rPr sz="1250" b="1" i="0">
                 <a:solidFill>
                   <a:srgbClr val="16273D"/>
                 </a:solidFill>
@@ -31304,23 +31304,23 @@
         </p:nvSpPr>
         <p:spPr>
           <a:xfrm>
-            <a:off x="2377440" y="1837944"/>
-            <a:ext cx="4480560" cy="274320"/>
-          </a:xfrm>
-          <a:prstGeom prst="rect">
-            <a:avLst/>
-          </a:prstGeom>
-          <a:noFill/>
-        </p:spPr>
-        <p:txBody>
-          <a:bodyPr wrap="square" lIns="0" rIns="0" tIns="0" bIns="0">
-            <a:spAutoFit/>
-          </a:bodyPr>
-          <a:lstStyle/>
-          <a:p>
-            <a:pPr algn="l"/>
-            <a:r>
-              <a:rPr sz="1050" b="0" i="0">
+            <a:off x="2194560" y="1627631"/>
+            <a:ext cx="4572000" cy="256032"/>
+          </a:xfrm>
+          <a:prstGeom prst="rect">
+            <a:avLst/>
+          </a:prstGeom>
+          <a:noFill/>
+        </p:spPr>
+        <p:txBody>
+          <a:bodyPr wrap="square" lIns="0" rIns="0" tIns="0" bIns="0">
+            <a:spAutoFit/>
+          </a:bodyPr>
+          <a:lstStyle/>
+          <a:p>
+            <a:pPr algn="l"/>
+            <a:r>
+              <a:rPr sz="1000" b="0" i="0">
                 <a:solidFill>
                   <a:srgbClr val="16273D"/>
                 </a:solidFill>
@@ -31339,23 +31339,23 @@
         </p:nvSpPr>
         <p:spPr>
           <a:xfrm>
-            <a:off x="6720840" y="1517904"/>
-            <a:ext cx="4389120" cy="274320"/>
-          </a:xfrm>
-          <a:prstGeom prst="rect">
-            <a:avLst/>
-          </a:prstGeom>
-          <a:noFill/>
-        </p:spPr>
-        <p:txBody>
-          <a:bodyPr wrap="square" lIns="0" rIns="0" tIns="0" bIns="0">
-            <a:spAutoFit/>
-          </a:bodyPr>
-          <a:lstStyle/>
-          <a:p>
-            <a:pPr algn="l"/>
-            <a:r>
-              <a:rPr sz="950" b="0" i="0">
+            <a:off x="6812280" y="1362456"/>
+            <a:ext cx="4389120" cy="256032"/>
+          </a:xfrm>
+          <a:prstGeom prst="rect">
+            <a:avLst/>
+          </a:prstGeom>
+          <a:noFill/>
+        </p:spPr>
+        <p:txBody>
+          <a:bodyPr wrap="square" lIns="0" rIns="0" tIns="0" bIns="0">
+            <a:spAutoFit/>
+          </a:bodyPr>
+          <a:lstStyle/>
+          <a:p>
+            <a:pPr algn="l"/>
+            <a:r>
+              <a:rPr sz="900" b="0" i="0">
                 <a:solidFill>
                   <a:srgbClr val="5C6B7E"/>
                 </a:solidFill>
@@ -31374,8 +31374,8 @@
         </p:nvSpPr>
         <p:spPr>
           <a:xfrm>
-            <a:off x="6720840" y="1819656"/>
-            <a:ext cx="4389120" cy="274320"/>
+            <a:off x="6812280" y="1618488"/>
+            <a:ext cx="4389120" cy="256032"/>
           </a:xfrm>
           <a:prstGeom prst="rect">
             <a:avLst/>
@@ -31409,8 +31409,8 @@
         </p:nvSpPr>
         <p:spPr>
           <a:xfrm>
-            <a:off x="822960" y="2276856"/>
-            <a:ext cx="10515600" cy="786384"/>
+            <a:off x="822960" y="1956815"/>
+            <a:ext cx="10515600" cy="621792"/>
           </a:xfrm>
           <a:prstGeom prst="roundRect">
             <a:avLst/>
@@ -31461,8 +31461,8 @@
         </p:blipFill>
         <p:spPr>
           <a:xfrm>
-            <a:off x="1005840" y="2395728"/>
-            <a:ext cx="548640" cy="548640"/>
+            <a:off x="1005840" y="2039111"/>
+            <a:ext cx="457200" cy="457200"/>
           </a:xfrm>
           <a:prstGeom prst="rect">
             <a:avLst/>
@@ -31485,8 +31485,8 @@
         </p:blipFill>
         <p:spPr>
           <a:xfrm>
-            <a:off x="1645920" y="2395728"/>
-            <a:ext cx="548640" cy="548640"/>
+            <a:off x="1554480" y="2039111"/>
+            <a:ext cx="457200" cy="457200"/>
           </a:xfrm>
           <a:prstGeom prst="rect">
             <a:avLst/>
@@ -31501,23 +31501,23 @@
         </p:nvSpPr>
         <p:spPr>
           <a:xfrm>
-            <a:off x="2377440" y="2359152"/>
-            <a:ext cx="4389120" cy="320040"/>
-          </a:xfrm>
-          <a:prstGeom prst="rect">
-            <a:avLst/>
-          </a:prstGeom>
-          <a:noFill/>
-        </p:spPr>
-        <p:txBody>
-          <a:bodyPr wrap="square" lIns="0" rIns="0" tIns="0" bIns="0">
-            <a:spAutoFit/>
-          </a:bodyPr>
-          <a:lstStyle/>
-          <a:p>
-            <a:pPr algn="l"/>
-            <a:r>
-              <a:rPr sz="1350" b="1" i="0">
+            <a:off x="2194560" y="2002535"/>
+            <a:ext cx="4572000" cy="292608"/>
+          </a:xfrm>
+          <a:prstGeom prst="rect">
+            <a:avLst/>
+          </a:prstGeom>
+          <a:noFill/>
+        </p:spPr>
+        <p:txBody>
+          <a:bodyPr wrap="square" lIns="0" rIns="0" tIns="0" bIns="0">
+            <a:spAutoFit/>
+          </a:bodyPr>
+          <a:lstStyle/>
+          <a:p>
+            <a:pPr algn="l"/>
+            <a:r>
+              <a:rPr sz="1250" b="1" i="0">
                 <a:solidFill>
                   <a:srgbClr val="16273D"/>
                 </a:solidFill>
@@ -31536,23 +31536,23 @@
         </p:nvSpPr>
         <p:spPr>
           <a:xfrm>
-            <a:off x="2377440" y="2697480"/>
-            <a:ext cx="4480560" cy="274320"/>
-          </a:xfrm>
-          <a:prstGeom prst="rect">
-            <a:avLst/>
-          </a:prstGeom>
-          <a:noFill/>
-        </p:spPr>
-        <p:txBody>
-          <a:bodyPr wrap="square" lIns="0" rIns="0" tIns="0" bIns="0">
-            <a:spAutoFit/>
-          </a:bodyPr>
-          <a:lstStyle/>
-          <a:p>
-            <a:pPr algn="l"/>
-            <a:r>
-              <a:rPr sz="1050" b="0" i="0">
+            <a:off x="2194560" y="2285999"/>
+            <a:ext cx="4572000" cy="256032"/>
+          </a:xfrm>
+          <a:prstGeom prst="rect">
+            <a:avLst/>
+          </a:prstGeom>
+          <a:noFill/>
+        </p:spPr>
+        <p:txBody>
+          <a:bodyPr wrap="square" lIns="0" rIns="0" tIns="0" bIns="0">
+            <a:spAutoFit/>
+          </a:bodyPr>
+          <a:lstStyle/>
+          <a:p>
+            <a:pPr algn="l"/>
+            <a:r>
+              <a:rPr sz="1000" b="0" i="0">
                 <a:solidFill>
                   <a:srgbClr val="16273D"/>
                 </a:solidFill>
@@ -31571,23 +31571,23 @@
         </p:nvSpPr>
         <p:spPr>
           <a:xfrm>
-            <a:off x="6720840" y="2377440"/>
-            <a:ext cx="4389120" cy="274320"/>
-          </a:xfrm>
-          <a:prstGeom prst="rect">
-            <a:avLst/>
-          </a:prstGeom>
-          <a:noFill/>
-        </p:spPr>
-        <p:txBody>
-          <a:bodyPr wrap="square" lIns="0" rIns="0" tIns="0" bIns="0">
-            <a:spAutoFit/>
-          </a:bodyPr>
-          <a:lstStyle/>
-          <a:p>
-            <a:pPr algn="l"/>
-            <a:r>
-              <a:rPr sz="950" b="0" i="0">
+            <a:off x="6812280" y="2020823"/>
+            <a:ext cx="4389120" cy="256032"/>
+          </a:xfrm>
+          <a:prstGeom prst="rect">
+            <a:avLst/>
+          </a:prstGeom>
+          <a:noFill/>
+        </p:spPr>
+        <p:txBody>
+          <a:bodyPr wrap="square" lIns="0" rIns="0" tIns="0" bIns="0">
+            <a:spAutoFit/>
+          </a:bodyPr>
+          <a:lstStyle/>
+          <a:p>
+            <a:pPr algn="l"/>
+            <a:r>
+              <a:rPr sz="900" b="0" i="0">
                 <a:solidFill>
                   <a:srgbClr val="5C6B7E"/>
                 </a:solidFill>
@@ -31606,8 +31606,8 @@
         </p:nvSpPr>
         <p:spPr>
           <a:xfrm>
-            <a:off x="6720840" y="2679192"/>
-            <a:ext cx="4389120" cy="274320"/>
+            <a:off x="6812280" y="2276856"/>
+            <a:ext cx="4389120" cy="256032"/>
           </a:xfrm>
           <a:prstGeom prst="rect">
             <a:avLst/>
@@ -31641,8 +31641,8 @@
         </p:nvSpPr>
         <p:spPr>
           <a:xfrm>
-            <a:off x="822960" y="3136392"/>
-            <a:ext cx="10515600" cy="786384"/>
+            <a:off x="822960" y="2615183"/>
+            <a:ext cx="10515600" cy="621792"/>
           </a:xfrm>
           <a:prstGeom prst="roundRect">
             <a:avLst/>
@@ -31693,8 +31693,8 @@
         </p:blipFill>
         <p:spPr>
           <a:xfrm>
-            <a:off x="1005840" y="3255264"/>
-            <a:ext cx="548640" cy="548640"/>
+            <a:off x="1005840" y="2697479"/>
+            <a:ext cx="457200" cy="457200"/>
           </a:xfrm>
           <a:prstGeom prst="rect">
             <a:avLst/>
@@ -31717,8 +31717,8 @@
         </p:blipFill>
         <p:spPr>
           <a:xfrm>
-            <a:off x="1645920" y="3255264"/>
-            <a:ext cx="548640" cy="548640"/>
+            <a:off x="1554480" y="2697479"/>
+            <a:ext cx="457200" cy="457200"/>
           </a:xfrm>
           <a:prstGeom prst="rect">
             <a:avLst/>
@@ -31733,23 +31733,23 @@
         </p:nvSpPr>
         <p:spPr>
           <a:xfrm>
-            <a:off x="2377440" y="3218688"/>
-            <a:ext cx="4389120" cy="320040"/>
-          </a:xfrm>
-          <a:prstGeom prst="rect">
-            <a:avLst/>
-          </a:prstGeom>
-          <a:noFill/>
-        </p:spPr>
-        <p:txBody>
-          <a:bodyPr wrap="square" lIns="0" rIns="0" tIns="0" bIns="0">
-            <a:spAutoFit/>
-          </a:bodyPr>
-          <a:lstStyle/>
-          <a:p>
-            <a:pPr algn="l"/>
-            <a:r>
-              <a:rPr sz="1350" b="1" i="0">
+            <a:off x="2194560" y="2660903"/>
+            <a:ext cx="4572000" cy="292608"/>
+          </a:xfrm>
+          <a:prstGeom prst="rect">
+            <a:avLst/>
+          </a:prstGeom>
+          <a:noFill/>
+        </p:spPr>
+        <p:txBody>
+          <a:bodyPr wrap="square" lIns="0" rIns="0" tIns="0" bIns="0">
+            <a:spAutoFit/>
+          </a:bodyPr>
+          <a:lstStyle/>
+          <a:p>
+            <a:pPr algn="l"/>
+            <a:r>
+              <a:rPr sz="1250" b="1" i="0">
                 <a:solidFill>
                   <a:srgbClr val="16273D"/>
                 </a:solidFill>
@@ -31768,23 +31768,23 @@
         </p:nvSpPr>
         <p:spPr>
           <a:xfrm>
-            <a:off x="2377440" y="3557016"/>
-            <a:ext cx="4480560" cy="274320"/>
-          </a:xfrm>
-          <a:prstGeom prst="rect">
-            <a:avLst/>
-          </a:prstGeom>
-          <a:noFill/>
-        </p:spPr>
-        <p:txBody>
-          <a:bodyPr wrap="square" lIns="0" rIns="0" tIns="0" bIns="0">
-            <a:spAutoFit/>
-          </a:bodyPr>
-          <a:lstStyle/>
-          <a:p>
-            <a:pPr algn="l"/>
-            <a:r>
-              <a:rPr sz="1050" b="0" i="0">
+            <a:off x="2194560" y="2944367"/>
+            <a:ext cx="4572000" cy="256032"/>
+          </a:xfrm>
+          <a:prstGeom prst="rect">
+            <a:avLst/>
+          </a:prstGeom>
+          <a:noFill/>
+        </p:spPr>
+        <p:txBody>
+          <a:bodyPr wrap="square" lIns="0" rIns="0" tIns="0" bIns="0">
+            <a:spAutoFit/>
+          </a:bodyPr>
+          <a:lstStyle/>
+          <a:p>
+            <a:pPr algn="l"/>
+            <a:r>
+              <a:rPr sz="1000" b="0" i="0">
                 <a:solidFill>
                   <a:srgbClr val="16273D"/>
                 </a:solidFill>
@@ -31803,23 +31803,23 @@
         </p:nvSpPr>
         <p:spPr>
           <a:xfrm>
-            <a:off x="6720840" y="3236976"/>
-            <a:ext cx="4389120" cy="274320"/>
-          </a:xfrm>
-          <a:prstGeom prst="rect">
-            <a:avLst/>
-          </a:prstGeom>
-          <a:noFill/>
-        </p:spPr>
-        <p:txBody>
-          <a:bodyPr wrap="square" lIns="0" rIns="0" tIns="0" bIns="0">
-            <a:spAutoFit/>
-          </a:bodyPr>
-          <a:lstStyle/>
-          <a:p>
-            <a:pPr algn="l"/>
-            <a:r>
-              <a:rPr sz="950" b="0" i="0">
+            <a:off x="6812280" y="2679191"/>
+            <a:ext cx="4389120" cy="256032"/>
+          </a:xfrm>
+          <a:prstGeom prst="rect">
+            <a:avLst/>
+          </a:prstGeom>
+          <a:noFill/>
+        </p:spPr>
+        <p:txBody>
+          <a:bodyPr wrap="square" lIns="0" rIns="0" tIns="0" bIns="0">
+            <a:spAutoFit/>
+          </a:bodyPr>
+          <a:lstStyle/>
+          <a:p>
+            <a:pPr algn="l"/>
+            <a:r>
+              <a:rPr sz="900" b="0" i="0">
                 <a:solidFill>
                   <a:srgbClr val="5C6B7E"/>
                 </a:solidFill>
@@ -31838,8 +31838,8 @@
         </p:nvSpPr>
         <p:spPr>
           <a:xfrm>
-            <a:off x="6720840" y="3538728"/>
-            <a:ext cx="4389120" cy="274320"/>
+            <a:off x="6812280" y="2935223"/>
+            <a:ext cx="4389120" cy="256032"/>
           </a:xfrm>
           <a:prstGeom prst="rect">
             <a:avLst/>
@@ -31873,8 +31873,8 @@
         </p:nvSpPr>
         <p:spPr>
           <a:xfrm>
-            <a:off x="822960" y="3995928"/>
-            <a:ext cx="10515600" cy="786384"/>
+            <a:off x="822960" y="3273551"/>
+            <a:ext cx="10515600" cy="621792"/>
           </a:xfrm>
           <a:prstGeom prst="roundRect">
             <a:avLst/>
@@ -31925,8 +31925,8 @@
         </p:blipFill>
         <p:spPr>
           <a:xfrm>
-            <a:off x="1005840" y="4114800"/>
-            <a:ext cx="548640" cy="548640"/>
+            <a:off x="1005840" y="3355847"/>
+            <a:ext cx="457200" cy="457200"/>
           </a:xfrm>
           <a:prstGeom prst="rect">
             <a:avLst/>
@@ -31949,8 +31949,8 @@
         </p:blipFill>
         <p:spPr>
           <a:xfrm>
-            <a:off x="1645920" y="4114800"/>
-            <a:ext cx="548640" cy="548640"/>
+            <a:off x="1554480" y="3355847"/>
+            <a:ext cx="457200" cy="457200"/>
           </a:xfrm>
           <a:prstGeom prst="rect">
             <a:avLst/>
@@ -31965,23 +31965,23 @@
         </p:nvSpPr>
         <p:spPr>
           <a:xfrm>
-            <a:off x="2377440" y="4078224"/>
-            <a:ext cx="4389120" cy="320040"/>
-          </a:xfrm>
-          <a:prstGeom prst="rect">
-            <a:avLst/>
-          </a:prstGeom>
-          <a:noFill/>
-        </p:spPr>
-        <p:txBody>
-          <a:bodyPr wrap="square" lIns="0" rIns="0" tIns="0" bIns="0">
-            <a:spAutoFit/>
-          </a:bodyPr>
-          <a:lstStyle/>
-          <a:p>
-            <a:pPr algn="l"/>
-            <a:r>
-              <a:rPr sz="1350" b="1" i="0">
+            <a:off x="2194560" y="3319271"/>
+            <a:ext cx="4572000" cy="292608"/>
+          </a:xfrm>
+          <a:prstGeom prst="rect">
+            <a:avLst/>
+          </a:prstGeom>
+          <a:noFill/>
+        </p:spPr>
+        <p:txBody>
+          <a:bodyPr wrap="square" lIns="0" rIns="0" tIns="0" bIns="0">
+            <a:spAutoFit/>
+          </a:bodyPr>
+          <a:lstStyle/>
+          <a:p>
+            <a:pPr algn="l"/>
+            <a:r>
+              <a:rPr sz="1250" b="1" i="0">
                 <a:solidFill>
                   <a:srgbClr val="16273D"/>
                 </a:solidFill>
@@ -32000,23 +32000,23 @@
         </p:nvSpPr>
         <p:spPr>
           <a:xfrm>
-            <a:off x="2377440" y="4416552"/>
-            <a:ext cx="4480560" cy="274320"/>
-          </a:xfrm>
-          <a:prstGeom prst="rect">
-            <a:avLst/>
-          </a:prstGeom>
-          <a:noFill/>
-        </p:spPr>
-        <p:txBody>
-          <a:bodyPr wrap="square" lIns="0" rIns="0" tIns="0" bIns="0">
-            <a:spAutoFit/>
-          </a:bodyPr>
-          <a:lstStyle/>
-          <a:p>
-            <a:pPr algn="l"/>
-            <a:r>
-              <a:rPr sz="1050" b="0" i="0">
+            <a:off x="2194560" y="3602735"/>
+            <a:ext cx="4572000" cy="256032"/>
+          </a:xfrm>
+          <a:prstGeom prst="rect">
+            <a:avLst/>
+          </a:prstGeom>
+          <a:noFill/>
+        </p:spPr>
+        <p:txBody>
+          <a:bodyPr wrap="square" lIns="0" rIns="0" tIns="0" bIns="0">
+            <a:spAutoFit/>
+          </a:bodyPr>
+          <a:lstStyle/>
+          <a:p>
+            <a:pPr algn="l"/>
+            <a:r>
+              <a:rPr sz="1000" b="0" i="0">
                 <a:solidFill>
                   <a:srgbClr val="16273D"/>
                 </a:solidFill>
@@ -32035,23 +32035,23 @@
         </p:nvSpPr>
         <p:spPr>
           <a:xfrm>
-            <a:off x="6720840" y="4096512"/>
-            <a:ext cx="4389120" cy="274320"/>
-          </a:xfrm>
-          <a:prstGeom prst="rect">
-            <a:avLst/>
-          </a:prstGeom>
-          <a:noFill/>
-        </p:spPr>
-        <p:txBody>
-          <a:bodyPr wrap="square" lIns="0" rIns="0" tIns="0" bIns="0">
-            <a:spAutoFit/>
-          </a:bodyPr>
-          <a:lstStyle/>
-          <a:p>
-            <a:pPr algn="l"/>
-            <a:r>
-              <a:rPr sz="950" b="0" i="0">
+            <a:off x="6812280" y="3337559"/>
+            <a:ext cx="4389120" cy="256032"/>
+          </a:xfrm>
+          <a:prstGeom prst="rect">
+            <a:avLst/>
+          </a:prstGeom>
+          <a:noFill/>
+        </p:spPr>
+        <p:txBody>
+          <a:bodyPr wrap="square" lIns="0" rIns="0" tIns="0" bIns="0">
+            <a:spAutoFit/>
+          </a:bodyPr>
+          <a:lstStyle/>
+          <a:p>
+            <a:pPr algn="l"/>
+            <a:r>
+              <a:rPr sz="900" b="0" i="0">
                 <a:solidFill>
                   <a:srgbClr val="5C6B7E"/>
                 </a:solidFill>
@@ -32070,8 +32070,8 @@
         </p:nvSpPr>
         <p:spPr>
           <a:xfrm>
-            <a:off x="6720840" y="4398264"/>
-            <a:ext cx="4389120" cy="274320"/>
+            <a:off x="6812280" y="3593591"/>
+            <a:ext cx="4389120" cy="256032"/>
           </a:xfrm>
           <a:prstGeom prst="rect">
             <a:avLst/>
@@ -32105,8 +32105,8 @@
         </p:nvSpPr>
         <p:spPr>
           <a:xfrm>
-            <a:off x="822960" y="4855464"/>
-            <a:ext cx="10515600" cy="786384"/>
+            <a:off x="822960" y="3931919"/>
+            <a:ext cx="10515600" cy="621792"/>
           </a:xfrm>
           <a:prstGeom prst="roundRect">
             <a:avLst/>
@@ -32157,8 +32157,8 @@
         </p:blipFill>
         <p:spPr>
           <a:xfrm>
-            <a:off x="1005840" y="4974336"/>
-            <a:ext cx="548640" cy="548640"/>
+            <a:off x="1005840" y="4014215"/>
+            <a:ext cx="457200" cy="457200"/>
           </a:xfrm>
           <a:prstGeom prst="rect">
             <a:avLst/>
@@ -32181,8 +32181,8 @@
         </p:blipFill>
         <p:spPr>
           <a:xfrm>
-            <a:off x="1645920" y="4974336"/>
-            <a:ext cx="548640" cy="548640"/>
+            <a:off x="1554480" y="4014215"/>
+            <a:ext cx="457200" cy="457200"/>
           </a:xfrm>
           <a:prstGeom prst="rect">
             <a:avLst/>
@@ -32197,23 +32197,23 @@
         </p:nvSpPr>
         <p:spPr>
           <a:xfrm>
-            <a:off x="2377440" y="4937760"/>
-            <a:ext cx="4389120" cy="320040"/>
-          </a:xfrm>
-          <a:prstGeom prst="rect">
-            <a:avLst/>
-          </a:prstGeom>
-          <a:noFill/>
-        </p:spPr>
-        <p:txBody>
-          <a:bodyPr wrap="square" lIns="0" rIns="0" tIns="0" bIns="0">
-            <a:spAutoFit/>
-          </a:bodyPr>
-          <a:lstStyle/>
-          <a:p>
-            <a:pPr algn="l"/>
-            <a:r>
-              <a:rPr sz="1350" b="1" i="0">
+            <a:off x="2194560" y="3977639"/>
+            <a:ext cx="4572000" cy="292608"/>
+          </a:xfrm>
+          <a:prstGeom prst="rect">
+            <a:avLst/>
+          </a:prstGeom>
+          <a:noFill/>
+        </p:spPr>
+        <p:txBody>
+          <a:bodyPr wrap="square" lIns="0" rIns="0" tIns="0" bIns="0">
+            <a:spAutoFit/>
+          </a:bodyPr>
+          <a:lstStyle/>
+          <a:p>
+            <a:pPr algn="l"/>
+            <a:r>
+              <a:rPr sz="1250" b="1" i="0">
                 <a:solidFill>
                   <a:srgbClr val="16273D"/>
                 </a:solidFill>
@@ -32232,23 +32232,23 @@
         </p:nvSpPr>
         <p:spPr>
           <a:xfrm>
-            <a:off x="2377440" y="5276088"/>
-            <a:ext cx="4480560" cy="274320"/>
-          </a:xfrm>
-          <a:prstGeom prst="rect">
-            <a:avLst/>
-          </a:prstGeom>
-          <a:noFill/>
-        </p:spPr>
-        <p:txBody>
-          <a:bodyPr wrap="square" lIns="0" rIns="0" tIns="0" bIns="0">
-            <a:spAutoFit/>
-          </a:bodyPr>
-          <a:lstStyle/>
-          <a:p>
-            <a:pPr algn="l"/>
-            <a:r>
-              <a:rPr sz="1050" b="0" i="0">
+            <a:off x="2194560" y="4261103"/>
+            <a:ext cx="4572000" cy="256032"/>
+          </a:xfrm>
+          <a:prstGeom prst="rect">
+            <a:avLst/>
+          </a:prstGeom>
+          <a:noFill/>
+        </p:spPr>
+        <p:txBody>
+          <a:bodyPr wrap="square" lIns="0" rIns="0" tIns="0" bIns="0">
+            <a:spAutoFit/>
+          </a:bodyPr>
+          <a:lstStyle/>
+          <a:p>
+            <a:pPr algn="l"/>
+            <a:r>
+              <a:rPr sz="1000" b="0" i="0">
                 <a:solidFill>
                   <a:srgbClr val="16273D"/>
                 </a:solidFill>
@@ -32267,23 +32267,23 @@
         </p:nvSpPr>
         <p:spPr>
           <a:xfrm>
-            <a:off x="6720840" y="4956048"/>
-            <a:ext cx="4389120" cy="274320"/>
-          </a:xfrm>
-          <a:prstGeom prst="rect">
-            <a:avLst/>
-          </a:prstGeom>
-          <a:noFill/>
-        </p:spPr>
-        <p:txBody>
-          <a:bodyPr wrap="square" lIns="0" rIns="0" tIns="0" bIns="0">
-            <a:spAutoFit/>
-          </a:bodyPr>
-          <a:lstStyle/>
-          <a:p>
-            <a:pPr algn="l"/>
-            <a:r>
-              <a:rPr sz="950" b="0" i="0">
+            <a:off x="6812280" y="3995927"/>
+            <a:ext cx="4389120" cy="256032"/>
+          </a:xfrm>
+          <a:prstGeom prst="rect">
+            <a:avLst/>
+          </a:prstGeom>
+          <a:noFill/>
+        </p:spPr>
+        <p:txBody>
+          <a:bodyPr wrap="square" lIns="0" rIns="0" tIns="0" bIns="0">
+            <a:spAutoFit/>
+          </a:bodyPr>
+          <a:lstStyle/>
+          <a:p>
+            <a:pPr algn="l"/>
+            <a:r>
+              <a:rPr sz="900" b="0" i="0">
                 <a:solidFill>
                   <a:srgbClr val="5C6B7E"/>
                 </a:solidFill>
@@ -32302,8 +32302,8 @@
         </p:nvSpPr>
         <p:spPr>
           <a:xfrm>
-            <a:off x="6720840" y="5257800"/>
-            <a:ext cx="4389120" cy="274320"/>
+            <a:off x="6812280" y="4251959"/>
+            <a:ext cx="4389120" cy="256032"/>
           </a:xfrm>
           <a:prstGeom prst="rect">
             <a:avLst/>
@@ -32337,8 +32337,472 @@
         </p:nvSpPr>
         <p:spPr>
           <a:xfrm>
-            <a:off x="822960" y="5760720"/>
-            <a:ext cx="10515600" cy="777240"/>
+            <a:off x="822960" y="4590287"/>
+            <a:ext cx="10515600" cy="621792"/>
+          </a:xfrm>
+          <a:prstGeom prst="roundRect">
+            <a:avLst/>
+          </a:prstGeom>
+          <a:solidFill>
+            <a:srgbClr val="EAF0F8"/>
+          </a:solidFill>
+          <a:ln>
+            <a:noFill/>
+          </a:ln>
+          <a:effectLst/>
+        </p:spPr>
+        <p:style>
+          <a:lnRef idx="1">
+            <a:schemeClr val="accent1"/>
+          </a:lnRef>
+          <a:fillRef idx="3">
+            <a:schemeClr val="accent1"/>
+          </a:fillRef>
+          <a:effectRef idx="2">
+            <a:schemeClr val="accent1"/>
+          </a:effectRef>
+          <a:fontRef idx="minor">
+            <a:schemeClr val="lt1"/>
+          </a:fontRef>
+        </p:style>
+        <p:txBody>
+          <a:bodyPr rtlCol="0" anchor="ctr"/>
+          <a:lstStyle/>
+          <a:p>
+            <a:pPr algn="ctr"/>
+          </a:p>
+        </p:txBody>
+      </p:sp>
+      <p:pic>
+        <p:nvPicPr>
+          <p:cNvPr id="40" name="Picture 39" descr="coastalcarolina.png"/>
+          <p:cNvPicPr>
+            <a:picLocks noChangeAspect="1"/>
+          </p:cNvPicPr>
+          <p:nvPr/>
+        </p:nvPicPr>
+        <p:blipFill>
+          <a:blip r:embed="rId12"/>
+          <a:stretch>
+            <a:fillRect/>
+          </a:stretch>
+        </p:blipFill>
+        <p:spPr>
+          <a:xfrm>
+            <a:off x="1005840" y="4672583"/>
+            <a:ext cx="457200" cy="457200"/>
+          </a:xfrm>
+          <a:prstGeom prst="rect">
+            <a:avLst/>
+          </a:prstGeom>
+        </p:spPr>
+      </p:pic>
+      <p:pic>
+        <p:nvPicPr>
+          <p:cNvPr id="41" name="Picture 40" descr="westvirginia.png"/>
+          <p:cNvPicPr>
+            <a:picLocks noChangeAspect="1"/>
+          </p:cNvPicPr>
+          <p:nvPr/>
+        </p:nvPicPr>
+        <p:blipFill>
+          <a:blip r:embed="rId13"/>
+          <a:stretch>
+            <a:fillRect/>
+          </a:stretch>
+        </p:blipFill>
+        <p:spPr>
+          <a:xfrm>
+            <a:off x="1554480" y="4672583"/>
+            <a:ext cx="457200" cy="457200"/>
+          </a:xfrm>
+          <a:prstGeom prst="rect">
+            <a:avLst/>
+          </a:prstGeom>
+        </p:spPr>
+      </p:pic>
+      <p:sp>
+        <p:nvSpPr>
+          <p:cNvPr id="42" name="TextBox 41"/>
+          <p:cNvSpPr txBox="1"/>
+          <p:nvPr/>
+        </p:nvSpPr>
+        <p:spPr>
+          <a:xfrm>
+            <a:off x="2194560" y="4636007"/>
+            <a:ext cx="4572000" cy="292608"/>
+          </a:xfrm>
+          <a:prstGeom prst="rect">
+            <a:avLst/>
+          </a:prstGeom>
+          <a:noFill/>
+        </p:spPr>
+        <p:txBody>
+          <a:bodyPr wrap="square" lIns="0" rIns="0" tIns="0" bIns="0">
+            <a:spAutoFit/>
+          </a:bodyPr>
+          <a:lstStyle/>
+          <a:p>
+            <a:pPr algn="l"/>
+            <a:r>
+              <a:rPr sz="1250" b="1" i="0">
+                <a:solidFill>
+                  <a:srgbClr val="16273D"/>
+                </a:solidFill>
+                <a:latin typeface="Arial"/>
+              </a:rPr>
+              <a:t>★ SUPERDOG · Coastal +21 at West Virginia</a:t>
+            </a:r>
+          </a:p>
+        </p:txBody>
+      </p:sp>
+      <p:sp>
+        <p:nvSpPr>
+          <p:cNvPr id="43" name="TextBox 42"/>
+          <p:cNvSpPr txBox="1"/>
+          <p:nvPr/>
+        </p:nvSpPr>
+        <p:spPr>
+          <a:xfrm>
+            <a:off x="2194560" y="4919471"/>
+            <a:ext cx="4572000" cy="256032"/>
+          </a:xfrm>
+          <a:prstGeom prst="rect">
+            <a:avLst/>
+          </a:prstGeom>
+          <a:noFill/>
+        </p:spPr>
+        <p:txBody>
+          <a:bodyPr wrap="square" lIns="0" rIns="0" tIns="0" bIns="0">
+            <a:spAutoFit/>
+          </a:bodyPr>
+          <a:lstStyle/>
+          <a:p>
+            <a:pPr algn="l"/>
+            <a:r>
+              <a:rPr sz="1000" b="0" i="0">
+                <a:solidFill>
+                  <a:srgbClr val="16273D"/>
+                </a:solidFill>
+                <a:latin typeface="Arial"/>
+              </a:rPr>
+              <a:t>we took Coastal Carolina +21 (ML +950) · FINAL West Virginia 31–24</a:t>
+            </a:r>
+          </a:p>
+        </p:txBody>
+      </p:sp>
+      <p:sp>
+        <p:nvSpPr>
+          <p:cNvPr id="44" name="TextBox 43"/>
+          <p:cNvSpPr txBox="1"/>
+          <p:nvPr/>
+        </p:nvSpPr>
+        <p:spPr>
+          <a:xfrm>
+            <a:off x="6812280" y="4654295"/>
+            <a:ext cx="4389120" cy="256032"/>
+          </a:xfrm>
+          <a:prstGeom prst="rect">
+            <a:avLst/>
+          </a:prstGeom>
+          <a:noFill/>
+        </p:spPr>
+        <p:txBody>
+          <a:bodyPr wrap="square" lIns="0" rIns="0" tIns="0" bIns="0">
+            <a:spAutoFit/>
+          </a:bodyPr>
+          <a:lstStyle/>
+          <a:p>
+            <a:pPr algn="l"/>
+            <a:r>
+              <a:rPr sz="900" b="0" i="0">
+                <a:solidFill>
+                  <a:srgbClr val="5C6B7E"/>
+                </a:solidFill>
+                <a:latin typeface="Arial"/>
+              </a:rPr>
+              <a:t>machine 23% to win outright · market 10% · pays only on the win</a:t>
+            </a:r>
+          </a:p>
+        </p:txBody>
+      </p:sp>
+      <p:sp>
+        <p:nvSpPr>
+          <p:cNvPr id="45" name="TextBox 44"/>
+          <p:cNvSpPr txBox="1"/>
+          <p:nvPr/>
+        </p:nvSpPr>
+        <p:spPr>
+          <a:xfrm>
+            <a:off x="6812280" y="4910327"/>
+            <a:ext cx="4389120" cy="256032"/>
+          </a:xfrm>
+          <a:prstGeom prst="rect">
+            <a:avLst/>
+          </a:prstGeom>
+          <a:noFill/>
+        </p:spPr>
+        <p:txBody>
+          <a:bodyPr wrap="square" lIns="0" rIns="0" tIns="0" bIns="0">
+            <a:spAutoFit/>
+          </a:bodyPr>
+          <a:lstStyle/>
+          <a:p>
+            <a:pPr algn="l"/>
+            <a:r>
+              <a:rPr sz="1000" b="1" i="0">
+                <a:solidFill>
+                  <a:srgbClr val="B5121B"/>
+                </a:solidFill>
+                <a:latin typeface="Arial"/>
+              </a:rPr>
+              <a:t>lost by 7 · covered by 14 — 0 points</a:t>
+            </a:r>
+          </a:p>
+        </p:txBody>
+      </p:sp>
+      <p:sp>
+        <p:nvSpPr>
+          <p:cNvPr id="46" name="Rounded Rectangle 45"/>
+          <p:cNvSpPr/>
+          <p:nvPr/>
+        </p:nvSpPr>
+        <p:spPr>
+          <a:xfrm>
+            <a:off x="822960" y="5248655"/>
+            <a:ext cx="10515600" cy="621792"/>
+          </a:xfrm>
+          <a:prstGeom prst="roundRect">
+            <a:avLst/>
+          </a:prstGeom>
+          <a:solidFill>
+            <a:srgbClr val="EAF0F8"/>
+          </a:solidFill>
+          <a:ln>
+            <a:noFill/>
+          </a:ln>
+          <a:effectLst/>
+        </p:spPr>
+        <p:style>
+          <a:lnRef idx="1">
+            <a:schemeClr val="accent1"/>
+          </a:lnRef>
+          <a:fillRef idx="3">
+            <a:schemeClr val="accent1"/>
+          </a:fillRef>
+          <a:effectRef idx="2">
+            <a:schemeClr val="accent1"/>
+          </a:effectRef>
+          <a:fontRef idx="minor">
+            <a:schemeClr val="lt1"/>
+          </a:fontRef>
+        </p:style>
+        <p:txBody>
+          <a:bodyPr rtlCol="0" anchor="ctr"/>
+          <a:lstStyle/>
+          <a:p>
+            <a:pPr algn="ctr"/>
+          </a:p>
+        </p:txBody>
+      </p:sp>
+      <p:pic>
+        <p:nvPicPr>
+          <p:cNvPr id="47" name="Picture 46" descr="washingtonstate.png"/>
+          <p:cNvPicPr>
+            <a:picLocks noChangeAspect="1"/>
+          </p:cNvPicPr>
+          <p:nvPr/>
+        </p:nvPicPr>
+        <p:blipFill>
+          <a:blip r:embed="rId14"/>
+          <a:stretch>
+            <a:fillRect/>
+          </a:stretch>
+        </p:blipFill>
+        <p:spPr>
+          <a:xfrm>
+            <a:off x="1005840" y="5330951"/>
+            <a:ext cx="457200" cy="457200"/>
+          </a:xfrm>
+          <a:prstGeom prst="rect">
+            <a:avLst/>
+          </a:prstGeom>
+        </p:spPr>
+      </p:pic>
+      <p:pic>
+        <p:nvPicPr>
+          <p:cNvPr id="48" name="Picture 47" descr="washington.png"/>
+          <p:cNvPicPr>
+            <a:picLocks noChangeAspect="1"/>
+          </p:cNvPicPr>
+          <p:nvPr/>
+        </p:nvPicPr>
+        <p:blipFill>
+          <a:blip r:embed="rId15"/>
+          <a:stretch>
+            <a:fillRect/>
+          </a:stretch>
+        </p:blipFill>
+        <p:spPr>
+          <a:xfrm>
+            <a:off x="1554480" y="5330951"/>
+            <a:ext cx="457200" cy="457200"/>
+          </a:xfrm>
+          <a:prstGeom prst="rect">
+            <a:avLst/>
+          </a:prstGeom>
+        </p:spPr>
+      </p:pic>
+      <p:sp>
+        <p:nvSpPr>
+          <p:cNvPr id="49" name="TextBox 48"/>
+          <p:cNvSpPr txBox="1"/>
+          <p:nvPr/>
+        </p:nvSpPr>
+        <p:spPr>
+          <a:xfrm>
+            <a:off x="2194560" y="5294375"/>
+            <a:ext cx="4572000" cy="292608"/>
+          </a:xfrm>
+          <a:prstGeom prst="rect">
+            <a:avLst/>
+          </a:prstGeom>
+          <a:noFill/>
+        </p:spPr>
+        <p:txBody>
+          <a:bodyPr wrap="square" lIns="0" rIns="0" tIns="0" bIns="0">
+            <a:spAutoFit/>
+          </a:bodyPr>
+          <a:lstStyle/>
+          <a:p>
+            <a:pPr algn="l"/>
+            <a:r>
+              <a:rPr sz="1250" b="1" i="0">
+                <a:solidFill>
+                  <a:srgbClr val="16273D"/>
+                </a:solidFill>
+                <a:latin typeface="Arial"/>
+              </a:rPr>
+              <a:t>★ GIANT KILLER · Wazzu +23.5 at #17 Washington</a:t>
+            </a:r>
+          </a:p>
+        </p:txBody>
+      </p:sp>
+      <p:sp>
+        <p:nvSpPr>
+          <p:cNvPr id="50" name="TextBox 49"/>
+          <p:cNvSpPr txBox="1"/>
+          <p:nvPr/>
+        </p:nvSpPr>
+        <p:spPr>
+          <a:xfrm>
+            <a:off x="2194560" y="5577839"/>
+            <a:ext cx="4572000" cy="256032"/>
+          </a:xfrm>
+          <a:prstGeom prst="rect">
+            <a:avLst/>
+          </a:prstGeom>
+          <a:noFill/>
+        </p:spPr>
+        <p:txBody>
+          <a:bodyPr wrap="square" lIns="0" rIns="0" tIns="0" bIns="0">
+            <a:spAutoFit/>
+          </a:bodyPr>
+          <a:lstStyle/>
+          <a:p>
+            <a:pPr algn="l"/>
+            <a:r>
+              <a:rPr sz="1000" b="0" i="0">
+                <a:solidFill>
+                  <a:srgbClr val="16273D"/>
+                </a:solidFill>
+                <a:latin typeface="Arial"/>
+              </a:rPr>
+              <a:t>we took Washington State +23.5 (ML +1300) · FINAL Washington 24–10</a:t>
+            </a:r>
+          </a:p>
+        </p:txBody>
+      </p:sp>
+      <p:sp>
+        <p:nvSpPr>
+          <p:cNvPr id="51" name="TextBox 50"/>
+          <p:cNvSpPr txBox="1"/>
+          <p:nvPr/>
+        </p:nvSpPr>
+        <p:spPr>
+          <a:xfrm>
+            <a:off x="6812280" y="5312663"/>
+            <a:ext cx="4389120" cy="256032"/>
+          </a:xfrm>
+          <a:prstGeom prst="rect">
+            <a:avLst/>
+          </a:prstGeom>
+          <a:noFill/>
+        </p:spPr>
+        <p:txBody>
+          <a:bodyPr wrap="square" lIns="0" rIns="0" tIns="0" bIns="0">
+            <a:spAutoFit/>
+          </a:bodyPr>
+          <a:lstStyle/>
+          <a:p>
+            <a:pPr algn="l"/>
+            <a:r>
+              <a:rPr sz="900" b="0" i="0">
+                <a:solidFill>
+                  <a:srgbClr val="5C6B7E"/>
+                </a:solidFill>
+                <a:latin typeface="Arial"/>
+              </a:rPr>
+              <a:t>machine 17% to win outright · market 7% · pays only on the win</a:t>
+            </a:r>
+          </a:p>
+        </p:txBody>
+      </p:sp>
+      <p:sp>
+        <p:nvSpPr>
+          <p:cNvPr id="52" name="TextBox 51"/>
+          <p:cNvSpPr txBox="1"/>
+          <p:nvPr/>
+        </p:nvSpPr>
+        <p:spPr>
+          <a:xfrm>
+            <a:off x="6812280" y="5568695"/>
+            <a:ext cx="4389120" cy="256032"/>
+          </a:xfrm>
+          <a:prstGeom prst="rect">
+            <a:avLst/>
+          </a:prstGeom>
+          <a:noFill/>
+        </p:spPr>
+        <p:txBody>
+          <a:bodyPr wrap="square" lIns="0" rIns="0" tIns="0" bIns="0">
+            <a:spAutoFit/>
+          </a:bodyPr>
+          <a:lstStyle/>
+          <a:p>
+            <a:pPr algn="l"/>
+            <a:r>
+              <a:rPr sz="1000" b="1" i="0">
+                <a:solidFill>
+                  <a:srgbClr val="B5121B"/>
+                </a:solidFill>
+                <a:latin typeface="Arial"/>
+              </a:rPr>
+              <a:t>lost by 14 · covered by 9.5 — 0 points</a:t>
+            </a:r>
+          </a:p>
+        </p:txBody>
+      </p:sp>
+      <p:sp>
+        <p:nvSpPr>
+          <p:cNvPr id="53" name="Rounded Rectangle 52"/>
+          <p:cNvSpPr/>
+          <p:nvPr/>
+        </p:nvSpPr>
+        <p:spPr>
+          <a:xfrm>
+            <a:off x="822960" y="5943599"/>
+            <a:ext cx="10515600" cy="713232"/>
           </a:xfrm>
           <a:prstGeom prst="roundRect">
             <a:avLst/>
@@ -32375,13 +32839,13 @@
       </p:sp>
       <p:sp>
         <p:nvSpPr>
-          <p:cNvPr id="40" name="TextBox 39"/>
-          <p:cNvSpPr txBox="1"/>
-          <p:nvPr/>
-        </p:nvSpPr>
-        <p:spPr>
-          <a:xfrm>
-            <a:off x="1051560" y="5870448"/>
+          <p:cNvPr id="54" name="TextBox 53"/>
+          <p:cNvSpPr txBox="1"/>
+          <p:nvPr/>
+        </p:nvSpPr>
+        <p:spPr>
+          <a:xfrm>
+            <a:off x="1051560" y="6016751"/>
             <a:ext cx="10058400" cy="594360"/>
           </a:xfrm>
           <a:prstGeom prst="rect">
@@ -32397,13 +32861,13 @@
           <a:p>
             <a:pPr algn="l"/>
             <a:r>
-              <a:rPr sz="1050" b="0" i="0">
+              <a:rPr sz="1000" b="0" i="0">
                 <a:solidFill>
                   <a:srgbClr val="FFFFFF"/>
                 </a:solidFill>
                 <a:latin typeface="Arial"/>
               </a:rPr>
-              <a:t>Total miss across 5 graded games: machine 50.5 points, closing market 49.0 — machine closer in 2, market in 2, 1 tie. Stated positions 2–0: Baylor +7.5 covered and the MONSTER UNDER on 59.5 cashed (33 total). Two weeks in: machine 120.5 vs market 119.0 across 10 games — still a coin flip with Vegas. Stated leans 3–2 on the season.</a:t>
+              <a:t>Games: machine miss 50.5 points, closing market 49.0 — machine closer in 2, market in 2, 1 tie; two weeks in machine 120.5 vs market 119.0 across 10 games, still a coin flip. Stated positions 2–0 (Baylor +7.5 covered, MONSTER UNDER 59.5 cashed) — leans 3–2 on the season. Superdogs: 0-for-2 outright, 2-for-2 against the spread — 0 points banked. Right about the price, paid on the win.</a:t>
             </a:r>
           </a:p>
         </p:txBody>

</xml_diff>

<commit_message>
Revert "Ep3 receipts slide: Week 1 Superdog + Giant Killer rows, auto-graded from finals (SUPERDOG_RECAP); banner adds the superdog ledger"
This reverts commit a847c5655357f5506f13e9e02e0f23ab04e8abb5.
</commit_message>
<xml_diff>
--- a/decks/2026_Week2_Episode3.pptx
+++ b/decks/2026_Week2_Episode3.pptx
@@ -31107,7 +31107,7 @@
         </p:nvSpPr>
         <p:spPr>
           <a:xfrm>
-            <a:off x="822960" y="411480"/>
+            <a:off x="822960" y="457200"/>
             <a:ext cx="10515600" cy="502920"/>
           </a:xfrm>
           <a:prstGeom prst="rect">
@@ -31142,7 +31142,7 @@
         </p:nvSpPr>
         <p:spPr>
           <a:xfrm>
-            <a:off x="822960" y="914400"/>
+            <a:off x="822960" y="987552"/>
             <a:ext cx="10515600" cy="274320"/>
           </a:xfrm>
           <a:prstGeom prst="rect">
@@ -31158,13 +31158,13 @@
           <a:p>
             <a:pPr algn="l"/>
             <a:r>
-              <a:rPr sz="1050" b="0" i="1">
+              <a:rPr sz="1100" b="0" i="1">
                 <a:solidFill>
                   <a:srgbClr val="5C6B7E"/>
                 </a:solidFill>
                 <a:latin typeface="Arial"/>
               </a:rPr>
-              <a:t>Our call frozen at the Ep2 recording · closing line = last pre-kick pull (Fri 5 PM ET · Mon 9:25 AM ET) · “off by” = miss vs the final margin · superdogs pay only on the outright win</a:t>
+              <a:t>Our call frozen at the Ep2 recording · closing line = last pre-kick pull (Fri 5 PM ET · Mon 9:25 AM ET) · “off by” = miss vs the final margin</a:t>
             </a:r>
           </a:p>
         </p:txBody>
@@ -31177,8 +31177,8 @@
         </p:nvSpPr>
         <p:spPr>
           <a:xfrm>
-            <a:off x="822960" y="1298448"/>
-            <a:ext cx="10515600" cy="621792"/>
+            <a:off x="822960" y="1417320"/>
+            <a:ext cx="10515600" cy="786384"/>
           </a:xfrm>
           <a:prstGeom prst="roundRect">
             <a:avLst/>
@@ -31229,8 +31229,8 @@
         </p:blipFill>
         <p:spPr>
           <a:xfrm>
-            <a:off x="1005840" y="1380744"/>
-            <a:ext cx="457200" cy="457200"/>
+            <a:off x="1005840" y="1536192"/>
+            <a:ext cx="548640" cy="548640"/>
           </a:xfrm>
           <a:prstGeom prst="rect">
             <a:avLst/>
@@ -31253,8 +31253,8 @@
         </p:blipFill>
         <p:spPr>
           <a:xfrm>
-            <a:off x="1554480" y="1380744"/>
-            <a:ext cx="457200" cy="457200"/>
+            <a:off x="1645920" y="1536192"/>
+            <a:ext cx="548640" cy="548640"/>
           </a:xfrm>
           <a:prstGeom prst="rect">
             <a:avLst/>
@@ -31269,8 +31269,8 @@
         </p:nvSpPr>
         <p:spPr>
           <a:xfrm>
-            <a:off x="2194560" y="1344168"/>
-            <a:ext cx="4572000" cy="292608"/>
+            <a:off x="2377440" y="1499616"/>
+            <a:ext cx="4389120" cy="320040"/>
           </a:xfrm>
           <a:prstGeom prst="rect">
             <a:avLst/>
@@ -31285,7 +31285,7 @@
           <a:p>
             <a:pPr algn="l"/>
             <a:r>
-              <a:rPr sz="1250" b="1" i="0">
+              <a:rPr sz="1350" b="1" i="0">
                 <a:solidFill>
                   <a:srgbClr val="16273D"/>
                 </a:solidFill>
@@ -31304,8 +31304,8 @@
         </p:nvSpPr>
         <p:spPr>
           <a:xfrm>
-            <a:off x="2194560" y="1627631"/>
-            <a:ext cx="4572000" cy="256032"/>
+            <a:off x="2377440" y="1837944"/>
+            <a:ext cx="4480560" cy="274320"/>
           </a:xfrm>
           <a:prstGeom prst="rect">
             <a:avLst/>
@@ -31320,7 +31320,7 @@
           <a:p>
             <a:pPr algn="l"/>
             <a:r>
-              <a:rPr sz="1000" b="0" i="0">
+              <a:rPr sz="1050" b="0" i="0">
                 <a:solidFill>
                   <a:srgbClr val="16273D"/>
                 </a:solidFill>
@@ -31339,8 +31339,8 @@
         </p:nvSpPr>
         <p:spPr>
           <a:xfrm>
-            <a:off x="6812280" y="1362456"/>
-            <a:ext cx="4389120" cy="256032"/>
+            <a:off x="6720840" y="1517904"/>
+            <a:ext cx="4389120" cy="274320"/>
           </a:xfrm>
           <a:prstGeom prst="rect">
             <a:avLst/>
@@ -31355,7 +31355,7 @@
           <a:p>
             <a:pPr algn="l"/>
             <a:r>
-              <a:rPr sz="900" b="0" i="0">
+              <a:rPr sz="950" b="0" i="0">
                 <a:solidFill>
                   <a:srgbClr val="5C6B7E"/>
                 </a:solidFill>
@@ -31374,8 +31374,8 @@
         </p:nvSpPr>
         <p:spPr>
           <a:xfrm>
-            <a:off x="6812280" y="1618488"/>
-            <a:ext cx="4389120" cy="256032"/>
+            <a:off x="6720840" y="1819656"/>
+            <a:ext cx="4389120" cy="274320"/>
           </a:xfrm>
           <a:prstGeom prst="rect">
             <a:avLst/>
@@ -31409,8 +31409,8 @@
         </p:nvSpPr>
         <p:spPr>
           <a:xfrm>
-            <a:off x="822960" y="1956815"/>
-            <a:ext cx="10515600" cy="621792"/>
+            <a:off x="822960" y="2276856"/>
+            <a:ext cx="10515600" cy="786384"/>
           </a:xfrm>
           <a:prstGeom prst="roundRect">
             <a:avLst/>
@@ -31461,8 +31461,8 @@
         </p:blipFill>
         <p:spPr>
           <a:xfrm>
-            <a:off x="1005840" y="2039111"/>
-            <a:ext cx="457200" cy="457200"/>
+            <a:off x="1005840" y="2395728"/>
+            <a:ext cx="548640" cy="548640"/>
           </a:xfrm>
           <a:prstGeom prst="rect">
             <a:avLst/>
@@ -31485,8 +31485,8 @@
         </p:blipFill>
         <p:spPr>
           <a:xfrm>
-            <a:off x="1554480" y="2039111"/>
-            <a:ext cx="457200" cy="457200"/>
+            <a:off x="1645920" y="2395728"/>
+            <a:ext cx="548640" cy="548640"/>
           </a:xfrm>
           <a:prstGeom prst="rect">
             <a:avLst/>
@@ -31501,8 +31501,8 @@
         </p:nvSpPr>
         <p:spPr>
           <a:xfrm>
-            <a:off x="2194560" y="2002535"/>
-            <a:ext cx="4572000" cy="292608"/>
+            <a:off x="2377440" y="2359152"/>
+            <a:ext cx="4389120" cy="320040"/>
           </a:xfrm>
           <a:prstGeom prst="rect">
             <a:avLst/>
@@ -31517,7 +31517,7 @@
           <a:p>
             <a:pPr algn="l"/>
             <a:r>
-              <a:rPr sz="1250" b="1" i="0">
+              <a:rPr sz="1350" b="1" i="0">
                 <a:solidFill>
                   <a:srgbClr val="16273D"/>
                 </a:solidFill>
@@ -31536,8 +31536,8 @@
         </p:nvSpPr>
         <p:spPr>
           <a:xfrm>
-            <a:off x="2194560" y="2285999"/>
-            <a:ext cx="4572000" cy="256032"/>
+            <a:off x="2377440" y="2697480"/>
+            <a:ext cx="4480560" cy="274320"/>
           </a:xfrm>
           <a:prstGeom prst="rect">
             <a:avLst/>
@@ -31552,7 +31552,7 @@
           <a:p>
             <a:pPr algn="l"/>
             <a:r>
-              <a:rPr sz="1000" b="0" i="0">
+              <a:rPr sz="1050" b="0" i="0">
                 <a:solidFill>
                   <a:srgbClr val="16273D"/>
                 </a:solidFill>
@@ -31571,8 +31571,8 @@
         </p:nvSpPr>
         <p:spPr>
           <a:xfrm>
-            <a:off x="6812280" y="2020823"/>
-            <a:ext cx="4389120" cy="256032"/>
+            <a:off x="6720840" y="2377440"/>
+            <a:ext cx="4389120" cy="274320"/>
           </a:xfrm>
           <a:prstGeom prst="rect">
             <a:avLst/>
@@ -31587,7 +31587,7 @@
           <a:p>
             <a:pPr algn="l"/>
             <a:r>
-              <a:rPr sz="900" b="0" i="0">
+              <a:rPr sz="950" b="0" i="0">
                 <a:solidFill>
                   <a:srgbClr val="5C6B7E"/>
                 </a:solidFill>
@@ -31606,8 +31606,8 @@
         </p:nvSpPr>
         <p:spPr>
           <a:xfrm>
-            <a:off x="6812280" y="2276856"/>
-            <a:ext cx="4389120" cy="256032"/>
+            <a:off x="6720840" y="2679192"/>
+            <a:ext cx="4389120" cy="274320"/>
           </a:xfrm>
           <a:prstGeom prst="rect">
             <a:avLst/>
@@ -31641,8 +31641,8 @@
         </p:nvSpPr>
         <p:spPr>
           <a:xfrm>
-            <a:off x="822960" y="2615183"/>
-            <a:ext cx="10515600" cy="621792"/>
+            <a:off x="822960" y="3136392"/>
+            <a:ext cx="10515600" cy="786384"/>
           </a:xfrm>
           <a:prstGeom prst="roundRect">
             <a:avLst/>
@@ -31693,8 +31693,8 @@
         </p:blipFill>
         <p:spPr>
           <a:xfrm>
-            <a:off x="1005840" y="2697479"/>
-            <a:ext cx="457200" cy="457200"/>
+            <a:off x="1005840" y="3255264"/>
+            <a:ext cx="548640" cy="548640"/>
           </a:xfrm>
           <a:prstGeom prst="rect">
             <a:avLst/>
@@ -31717,8 +31717,8 @@
         </p:blipFill>
         <p:spPr>
           <a:xfrm>
-            <a:off x="1554480" y="2697479"/>
-            <a:ext cx="457200" cy="457200"/>
+            <a:off x="1645920" y="3255264"/>
+            <a:ext cx="548640" cy="548640"/>
           </a:xfrm>
           <a:prstGeom prst="rect">
             <a:avLst/>
@@ -31733,8 +31733,8 @@
         </p:nvSpPr>
         <p:spPr>
           <a:xfrm>
-            <a:off x="2194560" y="2660903"/>
-            <a:ext cx="4572000" cy="292608"/>
+            <a:off x="2377440" y="3218688"/>
+            <a:ext cx="4389120" cy="320040"/>
           </a:xfrm>
           <a:prstGeom prst="rect">
             <a:avLst/>
@@ -31749,7 +31749,7 @@
           <a:p>
             <a:pPr algn="l"/>
             <a:r>
-              <a:rPr sz="1250" b="1" i="0">
+              <a:rPr sz="1350" b="1" i="0">
                 <a:solidFill>
                   <a:srgbClr val="16273D"/>
                 </a:solidFill>
@@ -31768,8 +31768,8 @@
         </p:nvSpPr>
         <p:spPr>
           <a:xfrm>
-            <a:off x="2194560" y="2944367"/>
-            <a:ext cx="4572000" cy="256032"/>
+            <a:off x="2377440" y="3557016"/>
+            <a:ext cx="4480560" cy="274320"/>
           </a:xfrm>
           <a:prstGeom prst="rect">
             <a:avLst/>
@@ -31784,7 +31784,7 @@
           <a:p>
             <a:pPr algn="l"/>
             <a:r>
-              <a:rPr sz="1000" b="0" i="0">
+              <a:rPr sz="1050" b="0" i="0">
                 <a:solidFill>
                   <a:srgbClr val="16273D"/>
                 </a:solidFill>
@@ -31803,8 +31803,8 @@
         </p:nvSpPr>
         <p:spPr>
           <a:xfrm>
-            <a:off x="6812280" y="2679191"/>
-            <a:ext cx="4389120" cy="256032"/>
+            <a:off x="6720840" y="3236976"/>
+            <a:ext cx="4389120" cy="274320"/>
           </a:xfrm>
           <a:prstGeom prst="rect">
             <a:avLst/>
@@ -31819,7 +31819,7 @@
           <a:p>
             <a:pPr algn="l"/>
             <a:r>
-              <a:rPr sz="900" b="0" i="0">
+              <a:rPr sz="950" b="0" i="0">
                 <a:solidFill>
                   <a:srgbClr val="5C6B7E"/>
                 </a:solidFill>
@@ -31838,8 +31838,8 @@
         </p:nvSpPr>
         <p:spPr>
           <a:xfrm>
-            <a:off x="6812280" y="2935223"/>
-            <a:ext cx="4389120" cy="256032"/>
+            <a:off x="6720840" y="3538728"/>
+            <a:ext cx="4389120" cy="274320"/>
           </a:xfrm>
           <a:prstGeom prst="rect">
             <a:avLst/>
@@ -31873,8 +31873,8 @@
         </p:nvSpPr>
         <p:spPr>
           <a:xfrm>
-            <a:off x="822960" y="3273551"/>
-            <a:ext cx="10515600" cy="621792"/>
+            <a:off x="822960" y="3995928"/>
+            <a:ext cx="10515600" cy="786384"/>
           </a:xfrm>
           <a:prstGeom prst="roundRect">
             <a:avLst/>
@@ -31925,8 +31925,8 @@
         </p:blipFill>
         <p:spPr>
           <a:xfrm>
-            <a:off x="1005840" y="3355847"/>
-            <a:ext cx="457200" cy="457200"/>
+            <a:off x="1005840" y="4114800"/>
+            <a:ext cx="548640" cy="548640"/>
           </a:xfrm>
           <a:prstGeom prst="rect">
             <a:avLst/>
@@ -31949,8 +31949,8 @@
         </p:blipFill>
         <p:spPr>
           <a:xfrm>
-            <a:off x="1554480" y="3355847"/>
-            <a:ext cx="457200" cy="457200"/>
+            <a:off x="1645920" y="4114800"/>
+            <a:ext cx="548640" cy="548640"/>
           </a:xfrm>
           <a:prstGeom prst="rect">
             <a:avLst/>
@@ -31965,8 +31965,8 @@
         </p:nvSpPr>
         <p:spPr>
           <a:xfrm>
-            <a:off x="2194560" y="3319271"/>
-            <a:ext cx="4572000" cy="292608"/>
+            <a:off x="2377440" y="4078224"/>
+            <a:ext cx="4389120" cy="320040"/>
           </a:xfrm>
           <a:prstGeom prst="rect">
             <a:avLst/>
@@ -31981,7 +31981,7 @@
           <a:p>
             <a:pPr algn="l"/>
             <a:r>
-              <a:rPr sz="1250" b="1" i="0">
+              <a:rPr sz="1350" b="1" i="0">
                 <a:solidFill>
                   <a:srgbClr val="16273D"/>
                 </a:solidFill>
@@ -32000,8 +32000,8 @@
         </p:nvSpPr>
         <p:spPr>
           <a:xfrm>
-            <a:off x="2194560" y="3602735"/>
-            <a:ext cx="4572000" cy="256032"/>
+            <a:off x="2377440" y="4416552"/>
+            <a:ext cx="4480560" cy="274320"/>
           </a:xfrm>
           <a:prstGeom prst="rect">
             <a:avLst/>
@@ -32016,7 +32016,7 @@
           <a:p>
             <a:pPr algn="l"/>
             <a:r>
-              <a:rPr sz="1000" b="0" i="0">
+              <a:rPr sz="1050" b="0" i="0">
                 <a:solidFill>
                   <a:srgbClr val="16273D"/>
                 </a:solidFill>
@@ -32035,8 +32035,8 @@
         </p:nvSpPr>
         <p:spPr>
           <a:xfrm>
-            <a:off x="6812280" y="3337559"/>
-            <a:ext cx="4389120" cy="256032"/>
+            <a:off x="6720840" y="4096512"/>
+            <a:ext cx="4389120" cy="274320"/>
           </a:xfrm>
           <a:prstGeom prst="rect">
             <a:avLst/>
@@ -32051,7 +32051,7 @@
           <a:p>
             <a:pPr algn="l"/>
             <a:r>
-              <a:rPr sz="900" b="0" i="0">
+              <a:rPr sz="950" b="0" i="0">
                 <a:solidFill>
                   <a:srgbClr val="5C6B7E"/>
                 </a:solidFill>
@@ -32070,8 +32070,8 @@
         </p:nvSpPr>
         <p:spPr>
           <a:xfrm>
-            <a:off x="6812280" y="3593591"/>
-            <a:ext cx="4389120" cy="256032"/>
+            <a:off x="6720840" y="4398264"/>
+            <a:ext cx="4389120" cy="274320"/>
           </a:xfrm>
           <a:prstGeom prst="rect">
             <a:avLst/>
@@ -32105,8 +32105,8 @@
         </p:nvSpPr>
         <p:spPr>
           <a:xfrm>
-            <a:off x="822960" y="3931919"/>
-            <a:ext cx="10515600" cy="621792"/>
+            <a:off x="822960" y="4855464"/>
+            <a:ext cx="10515600" cy="786384"/>
           </a:xfrm>
           <a:prstGeom prst="roundRect">
             <a:avLst/>
@@ -32157,8 +32157,8 @@
         </p:blipFill>
         <p:spPr>
           <a:xfrm>
-            <a:off x="1005840" y="4014215"/>
-            <a:ext cx="457200" cy="457200"/>
+            <a:off x="1005840" y="4974336"/>
+            <a:ext cx="548640" cy="548640"/>
           </a:xfrm>
           <a:prstGeom prst="rect">
             <a:avLst/>
@@ -32181,8 +32181,8 @@
         </p:blipFill>
         <p:spPr>
           <a:xfrm>
-            <a:off x="1554480" y="4014215"/>
-            <a:ext cx="457200" cy="457200"/>
+            <a:off x="1645920" y="4974336"/>
+            <a:ext cx="548640" cy="548640"/>
           </a:xfrm>
           <a:prstGeom prst="rect">
             <a:avLst/>
@@ -32197,8 +32197,8 @@
         </p:nvSpPr>
         <p:spPr>
           <a:xfrm>
-            <a:off x="2194560" y="3977639"/>
-            <a:ext cx="4572000" cy="292608"/>
+            <a:off x="2377440" y="4937760"/>
+            <a:ext cx="4389120" cy="320040"/>
           </a:xfrm>
           <a:prstGeom prst="rect">
             <a:avLst/>
@@ -32213,7 +32213,7 @@
           <a:p>
             <a:pPr algn="l"/>
             <a:r>
-              <a:rPr sz="1250" b="1" i="0">
+              <a:rPr sz="1350" b="1" i="0">
                 <a:solidFill>
                   <a:srgbClr val="16273D"/>
                 </a:solidFill>
@@ -32232,8 +32232,8 @@
         </p:nvSpPr>
         <p:spPr>
           <a:xfrm>
-            <a:off x="2194560" y="4261103"/>
-            <a:ext cx="4572000" cy="256032"/>
+            <a:off x="2377440" y="5276088"/>
+            <a:ext cx="4480560" cy="274320"/>
           </a:xfrm>
           <a:prstGeom prst="rect">
             <a:avLst/>
@@ -32248,7 +32248,7 @@
           <a:p>
             <a:pPr algn="l"/>
             <a:r>
-              <a:rPr sz="1000" b="0" i="0">
+              <a:rPr sz="1050" b="0" i="0">
                 <a:solidFill>
                   <a:srgbClr val="16273D"/>
                 </a:solidFill>
@@ -32267,8 +32267,8 @@
         </p:nvSpPr>
         <p:spPr>
           <a:xfrm>
-            <a:off x="6812280" y="3995927"/>
-            <a:ext cx="4389120" cy="256032"/>
+            <a:off x="6720840" y="4956048"/>
+            <a:ext cx="4389120" cy="274320"/>
           </a:xfrm>
           <a:prstGeom prst="rect">
             <a:avLst/>
@@ -32283,7 +32283,7 @@
           <a:p>
             <a:pPr algn="l"/>
             <a:r>
-              <a:rPr sz="900" b="0" i="0">
+              <a:rPr sz="950" b="0" i="0">
                 <a:solidFill>
                   <a:srgbClr val="5C6B7E"/>
                 </a:solidFill>
@@ -32302,8 +32302,8 @@
         </p:nvSpPr>
         <p:spPr>
           <a:xfrm>
-            <a:off x="6812280" y="4251959"/>
-            <a:ext cx="4389120" cy="256032"/>
+            <a:off x="6720840" y="5257800"/>
+            <a:ext cx="4389120" cy="274320"/>
           </a:xfrm>
           <a:prstGeom prst="rect">
             <a:avLst/>
@@ -32337,472 +32337,8 @@
         </p:nvSpPr>
         <p:spPr>
           <a:xfrm>
-            <a:off x="822960" y="4590287"/>
-            <a:ext cx="10515600" cy="621792"/>
-          </a:xfrm>
-          <a:prstGeom prst="roundRect">
-            <a:avLst/>
-          </a:prstGeom>
-          <a:solidFill>
-            <a:srgbClr val="EAF0F8"/>
-          </a:solidFill>
-          <a:ln>
-            <a:noFill/>
-          </a:ln>
-          <a:effectLst/>
-        </p:spPr>
-        <p:style>
-          <a:lnRef idx="1">
-            <a:schemeClr val="accent1"/>
-          </a:lnRef>
-          <a:fillRef idx="3">
-            <a:schemeClr val="accent1"/>
-          </a:fillRef>
-          <a:effectRef idx="2">
-            <a:schemeClr val="accent1"/>
-          </a:effectRef>
-          <a:fontRef idx="minor">
-            <a:schemeClr val="lt1"/>
-          </a:fontRef>
-        </p:style>
-        <p:txBody>
-          <a:bodyPr rtlCol="0" anchor="ctr"/>
-          <a:lstStyle/>
-          <a:p>
-            <a:pPr algn="ctr"/>
-          </a:p>
-        </p:txBody>
-      </p:sp>
-      <p:pic>
-        <p:nvPicPr>
-          <p:cNvPr id="40" name="Picture 39" descr="coastalcarolina.png"/>
-          <p:cNvPicPr>
-            <a:picLocks noChangeAspect="1"/>
-          </p:cNvPicPr>
-          <p:nvPr/>
-        </p:nvPicPr>
-        <p:blipFill>
-          <a:blip r:embed="rId12"/>
-          <a:stretch>
-            <a:fillRect/>
-          </a:stretch>
-        </p:blipFill>
-        <p:spPr>
-          <a:xfrm>
-            <a:off x="1005840" y="4672583"/>
-            <a:ext cx="457200" cy="457200"/>
-          </a:xfrm>
-          <a:prstGeom prst="rect">
-            <a:avLst/>
-          </a:prstGeom>
-        </p:spPr>
-      </p:pic>
-      <p:pic>
-        <p:nvPicPr>
-          <p:cNvPr id="41" name="Picture 40" descr="westvirginia.png"/>
-          <p:cNvPicPr>
-            <a:picLocks noChangeAspect="1"/>
-          </p:cNvPicPr>
-          <p:nvPr/>
-        </p:nvPicPr>
-        <p:blipFill>
-          <a:blip r:embed="rId13"/>
-          <a:stretch>
-            <a:fillRect/>
-          </a:stretch>
-        </p:blipFill>
-        <p:spPr>
-          <a:xfrm>
-            <a:off x="1554480" y="4672583"/>
-            <a:ext cx="457200" cy="457200"/>
-          </a:xfrm>
-          <a:prstGeom prst="rect">
-            <a:avLst/>
-          </a:prstGeom>
-        </p:spPr>
-      </p:pic>
-      <p:sp>
-        <p:nvSpPr>
-          <p:cNvPr id="42" name="TextBox 41"/>
-          <p:cNvSpPr txBox="1"/>
-          <p:nvPr/>
-        </p:nvSpPr>
-        <p:spPr>
-          <a:xfrm>
-            <a:off x="2194560" y="4636007"/>
-            <a:ext cx="4572000" cy="292608"/>
-          </a:xfrm>
-          <a:prstGeom prst="rect">
-            <a:avLst/>
-          </a:prstGeom>
-          <a:noFill/>
-        </p:spPr>
-        <p:txBody>
-          <a:bodyPr wrap="square" lIns="0" rIns="0" tIns="0" bIns="0">
-            <a:spAutoFit/>
-          </a:bodyPr>
-          <a:lstStyle/>
-          <a:p>
-            <a:pPr algn="l"/>
-            <a:r>
-              <a:rPr sz="1250" b="1" i="0">
-                <a:solidFill>
-                  <a:srgbClr val="16273D"/>
-                </a:solidFill>
-                <a:latin typeface="Arial"/>
-              </a:rPr>
-              <a:t>★ SUPERDOG · Coastal +21 at West Virginia</a:t>
-            </a:r>
-          </a:p>
-        </p:txBody>
-      </p:sp>
-      <p:sp>
-        <p:nvSpPr>
-          <p:cNvPr id="43" name="TextBox 42"/>
-          <p:cNvSpPr txBox="1"/>
-          <p:nvPr/>
-        </p:nvSpPr>
-        <p:spPr>
-          <a:xfrm>
-            <a:off x="2194560" y="4919471"/>
-            <a:ext cx="4572000" cy="256032"/>
-          </a:xfrm>
-          <a:prstGeom prst="rect">
-            <a:avLst/>
-          </a:prstGeom>
-          <a:noFill/>
-        </p:spPr>
-        <p:txBody>
-          <a:bodyPr wrap="square" lIns="0" rIns="0" tIns="0" bIns="0">
-            <a:spAutoFit/>
-          </a:bodyPr>
-          <a:lstStyle/>
-          <a:p>
-            <a:pPr algn="l"/>
-            <a:r>
-              <a:rPr sz="1000" b="0" i="0">
-                <a:solidFill>
-                  <a:srgbClr val="16273D"/>
-                </a:solidFill>
-                <a:latin typeface="Arial"/>
-              </a:rPr>
-              <a:t>we took Coastal Carolina +21 (ML +950) · FINAL West Virginia 31–24</a:t>
-            </a:r>
-          </a:p>
-        </p:txBody>
-      </p:sp>
-      <p:sp>
-        <p:nvSpPr>
-          <p:cNvPr id="44" name="TextBox 43"/>
-          <p:cNvSpPr txBox="1"/>
-          <p:nvPr/>
-        </p:nvSpPr>
-        <p:spPr>
-          <a:xfrm>
-            <a:off x="6812280" y="4654295"/>
-            <a:ext cx="4389120" cy="256032"/>
-          </a:xfrm>
-          <a:prstGeom prst="rect">
-            <a:avLst/>
-          </a:prstGeom>
-          <a:noFill/>
-        </p:spPr>
-        <p:txBody>
-          <a:bodyPr wrap="square" lIns="0" rIns="0" tIns="0" bIns="0">
-            <a:spAutoFit/>
-          </a:bodyPr>
-          <a:lstStyle/>
-          <a:p>
-            <a:pPr algn="l"/>
-            <a:r>
-              <a:rPr sz="900" b="0" i="0">
-                <a:solidFill>
-                  <a:srgbClr val="5C6B7E"/>
-                </a:solidFill>
-                <a:latin typeface="Arial"/>
-              </a:rPr>
-              <a:t>machine 23% to win outright · market 10% · pays only on the win</a:t>
-            </a:r>
-          </a:p>
-        </p:txBody>
-      </p:sp>
-      <p:sp>
-        <p:nvSpPr>
-          <p:cNvPr id="45" name="TextBox 44"/>
-          <p:cNvSpPr txBox="1"/>
-          <p:nvPr/>
-        </p:nvSpPr>
-        <p:spPr>
-          <a:xfrm>
-            <a:off x="6812280" y="4910327"/>
-            <a:ext cx="4389120" cy="256032"/>
-          </a:xfrm>
-          <a:prstGeom prst="rect">
-            <a:avLst/>
-          </a:prstGeom>
-          <a:noFill/>
-        </p:spPr>
-        <p:txBody>
-          <a:bodyPr wrap="square" lIns="0" rIns="0" tIns="0" bIns="0">
-            <a:spAutoFit/>
-          </a:bodyPr>
-          <a:lstStyle/>
-          <a:p>
-            <a:pPr algn="l"/>
-            <a:r>
-              <a:rPr sz="1000" b="1" i="0">
-                <a:solidFill>
-                  <a:srgbClr val="B5121B"/>
-                </a:solidFill>
-                <a:latin typeface="Arial"/>
-              </a:rPr>
-              <a:t>lost by 7 · covered by 14 — 0 points</a:t>
-            </a:r>
-          </a:p>
-        </p:txBody>
-      </p:sp>
-      <p:sp>
-        <p:nvSpPr>
-          <p:cNvPr id="46" name="Rounded Rectangle 45"/>
-          <p:cNvSpPr/>
-          <p:nvPr/>
-        </p:nvSpPr>
-        <p:spPr>
-          <a:xfrm>
-            <a:off x="822960" y="5248655"/>
-            <a:ext cx="10515600" cy="621792"/>
-          </a:xfrm>
-          <a:prstGeom prst="roundRect">
-            <a:avLst/>
-          </a:prstGeom>
-          <a:solidFill>
-            <a:srgbClr val="EAF0F8"/>
-          </a:solidFill>
-          <a:ln>
-            <a:noFill/>
-          </a:ln>
-          <a:effectLst/>
-        </p:spPr>
-        <p:style>
-          <a:lnRef idx="1">
-            <a:schemeClr val="accent1"/>
-          </a:lnRef>
-          <a:fillRef idx="3">
-            <a:schemeClr val="accent1"/>
-          </a:fillRef>
-          <a:effectRef idx="2">
-            <a:schemeClr val="accent1"/>
-          </a:effectRef>
-          <a:fontRef idx="minor">
-            <a:schemeClr val="lt1"/>
-          </a:fontRef>
-        </p:style>
-        <p:txBody>
-          <a:bodyPr rtlCol="0" anchor="ctr"/>
-          <a:lstStyle/>
-          <a:p>
-            <a:pPr algn="ctr"/>
-          </a:p>
-        </p:txBody>
-      </p:sp>
-      <p:pic>
-        <p:nvPicPr>
-          <p:cNvPr id="47" name="Picture 46" descr="washingtonstate.png"/>
-          <p:cNvPicPr>
-            <a:picLocks noChangeAspect="1"/>
-          </p:cNvPicPr>
-          <p:nvPr/>
-        </p:nvPicPr>
-        <p:blipFill>
-          <a:blip r:embed="rId14"/>
-          <a:stretch>
-            <a:fillRect/>
-          </a:stretch>
-        </p:blipFill>
-        <p:spPr>
-          <a:xfrm>
-            <a:off x="1005840" y="5330951"/>
-            <a:ext cx="457200" cy="457200"/>
-          </a:xfrm>
-          <a:prstGeom prst="rect">
-            <a:avLst/>
-          </a:prstGeom>
-        </p:spPr>
-      </p:pic>
-      <p:pic>
-        <p:nvPicPr>
-          <p:cNvPr id="48" name="Picture 47" descr="washington.png"/>
-          <p:cNvPicPr>
-            <a:picLocks noChangeAspect="1"/>
-          </p:cNvPicPr>
-          <p:nvPr/>
-        </p:nvPicPr>
-        <p:blipFill>
-          <a:blip r:embed="rId15"/>
-          <a:stretch>
-            <a:fillRect/>
-          </a:stretch>
-        </p:blipFill>
-        <p:spPr>
-          <a:xfrm>
-            <a:off x="1554480" y="5330951"/>
-            <a:ext cx="457200" cy="457200"/>
-          </a:xfrm>
-          <a:prstGeom prst="rect">
-            <a:avLst/>
-          </a:prstGeom>
-        </p:spPr>
-      </p:pic>
-      <p:sp>
-        <p:nvSpPr>
-          <p:cNvPr id="49" name="TextBox 48"/>
-          <p:cNvSpPr txBox="1"/>
-          <p:nvPr/>
-        </p:nvSpPr>
-        <p:spPr>
-          <a:xfrm>
-            <a:off x="2194560" y="5294375"/>
-            <a:ext cx="4572000" cy="292608"/>
-          </a:xfrm>
-          <a:prstGeom prst="rect">
-            <a:avLst/>
-          </a:prstGeom>
-          <a:noFill/>
-        </p:spPr>
-        <p:txBody>
-          <a:bodyPr wrap="square" lIns="0" rIns="0" tIns="0" bIns="0">
-            <a:spAutoFit/>
-          </a:bodyPr>
-          <a:lstStyle/>
-          <a:p>
-            <a:pPr algn="l"/>
-            <a:r>
-              <a:rPr sz="1250" b="1" i="0">
-                <a:solidFill>
-                  <a:srgbClr val="16273D"/>
-                </a:solidFill>
-                <a:latin typeface="Arial"/>
-              </a:rPr>
-              <a:t>★ GIANT KILLER · Wazzu +23.5 at #17 Washington</a:t>
-            </a:r>
-          </a:p>
-        </p:txBody>
-      </p:sp>
-      <p:sp>
-        <p:nvSpPr>
-          <p:cNvPr id="50" name="TextBox 49"/>
-          <p:cNvSpPr txBox="1"/>
-          <p:nvPr/>
-        </p:nvSpPr>
-        <p:spPr>
-          <a:xfrm>
-            <a:off x="2194560" y="5577839"/>
-            <a:ext cx="4572000" cy="256032"/>
-          </a:xfrm>
-          <a:prstGeom prst="rect">
-            <a:avLst/>
-          </a:prstGeom>
-          <a:noFill/>
-        </p:spPr>
-        <p:txBody>
-          <a:bodyPr wrap="square" lIns="0" rIns="0" tIns="0" bIns="0">
-            <a:spAutoFit/>
-          </a:bodyPr>
-          <a:lstStyle/>
-          <a:p>
-            <a:pPr algn="l"/>
-            <a:r>
-              <a:rPr sz="1000" b="0" i="0">
-                <a:solidFill>
-                  <a:srgbClr val="16273D"/>
-                </a:solidFill>
-                <a:latin typeface="Arial"/>
-              </a:rPr>
-              <a:t>we took Washington State +23.5 (ML +1300) · FINAL Washington 24–10</a:t>
-            </a:r>
-          </a:p>
-        </p:txBody>
-      </p:sp>
-      <p:sp>
-        <p:nvSpPr>
-          <p:cNvPr id="51" name="TextBox 50"/>
-          <p:cNvSpPr txBox="1"/>
-          <p:nvPr/>
-        </p:nvSpPr>
-        <p:spPr>
-          <a:xfrm>
-            <a:off x="6812280" y="5312663"/>
-            <a:ext cx="4389120" cy="256032"/>
-          </a:xfrm>
-          <a:prstGeom prst="rect">
-            <a:avLst/>
-          </a:prstGeom>
-          <a:noFill/>
-        </p:spPr>
-        <p:txBody>
-          <a:bodyPr wrap="square" lIns="0" rIns="0" tIns="0" bIns="0">
-            <a:spAutoFit/>
-          </a:bodyPr>
-          <a:lstStyle/>
-          <a:p>
-            <a:pPr algn="l"/>
-            <a:r>
-              <a:rPr sz="900" b="0" i="0">
-                <a:solidFill>
-                  <a:srgbClr val="5C6B7E"/>
-                </a:solidFill>
-                <a:latin typeface="Arial"/>
-              </a:rPr>
-              <a:t>machine 17% to win outright · market 7% · pays only on the win</a:t>
-            </a:r>
-          </a:p>
-        </p:txBody>
-      </p:sp>
-      <p:sp>
-        <p:nvSpPr>
-          <p:cNvPr id="52" name="TextBox 51"/>
-          <p:cNvSpPr txBox="1"/>
-          <p:nvPr/>
-        </p:nvSpPr>
-        <p:spPr>
-          <a:xfrm>
-            <a:off x="6812280" y="5568695"/>
-            <a:ext cx="4389120" cy="256032"/>
-          </a:xfrm>
-          <a:prstGeom prst="rect">
-            <a:avLst/>
-          </a:prstGeom>
-          <a:noFill/>
-        </p:spPr>
-        <p:txBody>
-          <a:bodyPr wrap="square" lIns="0" rIns="0" tIns="0" bIns="0">
-            <a:spAutoFit/>
-          </a:bodyPr>
-          <a:lstStyle/>
-          <a:p>
-            <a:pPr algn="l"/>
-            <a:r>
-              <a:rPr sz="1000" b="1" i="0">
-                <a:solidFill>
-                  <a:srgbClr val="B5121B"/>
-                </a:solidFill>
-                <a:latin typeface="Arial"/>
-              </a:rPr>
-              <a:t>lost by 14 · covered by 9.5 — 0 points</a:t>
-            </a:r>
-          </a:p>
-        </p:txBody>
-      </p:sp>
-      <p:sp>
-        <p:nvSpPr>
-          <p:cNvPr id="53" name="Rounded Rectangle 52"/>
-          <p:cNvSpPr/>
-          <p:nvPr/>
-        </p:nvSpPr>
-        <p:spPr>
-          <a:xfrm>
-            <a:off x="822960" y="5943599"/>
-            <a:ext cx="10515600" cy="713232"/>
+            <a:off x="822960" y="5760720"/>
+            <a:ext cx="10515600" cy="777240"/>
           </a:xfrm>
           <a:prstGeom prst="roundRect">
             <a:avLst/>
@@ -32839,13 +32375,13 @@
       </p:sp>
       <p:sp>
         <p:nvSpPr>
-          <p:cNvPr id="54" name="TextBox 53"/>
-          <p:cNvSpPr txBox="1"/>
-          <p:nvPr/>
-        </p:nvSpPr>
-        <p:spPr>
-          <a:xfrm>
-            <a:off x="1051560" y="6016751"/>
+          <p:cNvPr id="40" name="TextBox 39"/>
+          <p:cNvSpPr txBox="1"/>
+          <p:nvPr/>
+        </p:nvSpPr>
+        <p:spPr>
+          <a:xfrm>
+            <a:off x="1051560" y="5870448"/>
             <a:ext cx="10058400" cy="594360"/>
           </a:xfrm>
           <a:prstGeom prst="rect">
@@ -32861,13 +32397,13 @@
           <a:p>
             <a:pPr algn="l"/>
             <a:r>
-              <a:rPr sz="1000" b="0" i="0">
+              <a:rPr sz="1050" b="0" i="0">
                 <a:solidFill>
                   <a:srgbClr val="FFFFFF"/>
                 </a:solidFill>
                 <a:latin typeface="Arial"/>
               </a:rPr>
-              <a:t>Games: machine miss 50.5 points, closing market 49.0 — machine closer in 2, market in 2, 1 tie; two weeks in machine 120.5 vs market 119.0 across 10 games, still a coin flip. Stated positions 2–0 (Baylor +7.5 covered, MONSTER UNDER 59.5 cashed) — leans 3–2 on the season. Superdogs: 0-for-2 outright, 2-for-2 against the spread — 0 points banked. Right about the price, paid on the win.</a:t>
+              <a:t>Total miss across 5 graded games: machine 50.5 points, closing market 49.0 — machine closer in 2, market in 2, 1 tie. Stated positions 2–0: Baylor +7.5 covered and the MONSTER UNDER on 59.5 cashed (33 total). Two weeks in: machine 120.5 vs market 119.0 across 10 games — still a coin flip with Vegas. Stated leans 3–2 on the season.</a:t>
             </a:r>
           </a:p>
         </p:txBody>

</xml_diff>

<commit_message>
Ep3: Ohio State-Texas moved to the end of the game order (deck source + notes renumbered); no push (freeze)
Co-Authored-By: Claude Fable 5.1 <noreply@anthropic.com>
</commit_message>
<xml_diff>
--- a/decks/2026_Week2_Episode3.pptx
+++ b/decks/2026_Week2_Episode3.pptx
@@ -10220,7 +10220,7 @@
       <p:grpSpPr/>
       <p:pic>
         <p:nvPicPr>
-          <p:cNvPr id="2" name="Picture 1" descr="oklahoma.png"/>
+          <p:cNvPr id="2" name="Picture 1" descr="arizonastate.png"/>
           <p:cNvPicPr>
             <a:picLocks noChangeAspect="1"/>
           </p:cNvPicPr>
@@ -10272,7 +10272,7 @@
                 </a:solidFill>
                 <a:latin typeface="Arial"/>
               </a:rPr>
-              <a:t>Oklahoma</a:t>
+              <a:t>Arizona State</a:t>
             </a:r>
           </a:p>
         </p:txBody>
@@ -10307,7 +10307,7 @@
                 </a:solidFill>
                 <a:latin typeface="Arial"/>
               </a:rPr>
-              <a:t>What it takes to win · Oklahoma at Michigan</a:t>
+              <a:t>What it takes to win · Arizona State at Texas A&amp;M</a:t>
             </a:r>
           </a:p>
         </p:txBody>
@@ -10421,7 +10421,7 @@
                 </a:solidFill>
                 <a:latin typeface="Arial"/>
               </a:rPr>
-              <a:t>Venables, year 5 — calls the defense himself; OC Arbuckle year two</a:t>
+              <a:t>Dillingham, year 4 — a full reset after the injury-shredded 2025</a:t>
             </a:r>
           </a:p>
         </p:txBody>
@@ -10491,7 +10491,7 @@
                 </a:solidFill>
                 <a:latin typeface="Arial"/>
               </a:rPr>
-              <a:t>RETURNS — John Mateer, senior; new throwing motion after the 2025 thumb injury</a:t>
+              <a:t>NEW — Cutter Boley (Kentucky), won a four-way derby; 387 yards, 6 TDs in the debut</a:t>
             </a:r>
           </a:p>
         </p:txBody>
@@ -10561,7 +10561,7 @@
                 </a:solidFill>
                 <a:latin typeface="Arial"/>
               </a:rPr>
-              <a:t>63% back · 16 portal adds — five OL transfers, WR room rebuilt around Sategna</a:t>
+              <a:t>16% back — least on the card · 24 portal adds · 11 of 34 regulars return</a:t>
             </a:r>
           </a:p>
         </p:txBody>
@@ -10640,7 +10640,7 @@
                 </a:solidFill>
                 <a:latin typeface="Arial"/>
               </a:rPr>
-              <a:t>Mateer's legs vs Jay Hill's sim pressures — the designed QB run (8 TDs in 2025) is the answer to a blitz-heavy front that punishes hesitation</a:t>
+              <a:t>Tempo the transfer defensive line — five new starters up front are the one A&amp;M unit that hasn't played together; 4-of-5 on fourth down says Dillingham will push it</a:t>
             </a:r>
           </a:p>
         </p:txBody>
@@ -10719,7 +10719,7 @@
                 </a:solidFill>
                 <a:latin typeface="Arial"/>
               </a:rPr>
-              <a:t>The five-transfer OL vs Michigan's DL two-deep — 2025's run game ranked 124th in yards per carry; 170 at 4.4 against UTEP proved nothing</a:t>
+              <a:t>Boley's second start against real disguise: Ricks, Ratcliffe, Brooks and portal corner Gibson rotate late — the six-touchdown debut came against Morgan State</a:t>
             </a:r>
           </a:p>
         </p:txBody>
@@ -10798,7 +10798,7 @@
                 </a:solidFill>
                 <a:latin typeface="Arial"/>
               </a:rPr>
-              <a:t>Erase the bad-QB day: Underwood went 12-of-22 with a pick — Venables' back seven (Guillory, the Bowens) has to cash on the road at noon</a:t>
+              <a:t>Contain before you gamble: the 3-3-5 is undersized by design, and Reed's designed run in the red zone is exactly what it concedes</a:t>
             </a:r>
           </a:p>
         </p:txBody>
@@ -10877,7 +10877,7 @@
                 </a:solidFill>
                 <a:latin typeface="Arial"/>
               </a:rPr>
-              <a:t>Hidden yards travel: 115 punt-return yards and a defensive score last week — special teams is how a 2-point machine number becomes a cover</a:t>
+              <a:t>Fix special teams (No. 125 last year) — at Kyle Field a +14.5 cover lives or dies in field position</a:t>
             </a:r>
           </a:p>
         </p:txBody>
@@ -10912,7 +10912,7 @@
                 </a:solidFill>
                 <a:latin typeface="Arial"/>
               </a:rPr>
-              <a:t>EP 3 · WEEK 2 · Oklahoma at Michigan</a:t>
+              <a:t>EP 3 · WEEK 2 · Arizona State at Texas A&amp;M</a:t>
             </a:r>
           </a:p>
         </p:txBody>
@@ -10945,7 +10945,7 @@
       <p:grpSpPr/>
       <p:pic>
         <p:nvPicPr>
-          <p:cNvPr id="2" name="Picture 1" descr="michigan.png"/>
+          <p:cNvPr id="2" name="Picture 1" descr="texasam.png"/>
           <p:cNvPicPr>
             <a:picLocks noChangeAspect="1"/>
           </p:cNvPicPr>
@@ -10997,7 +10997,7 @@
                 </a:solidFill>
                 <a:latin typeface="Arial"/>
               </a:rPr>
-              <a:t>Michigan</a:t>
+              <a:t>Texas A&amp;M</a:t>
             </a:r>
           </a:p>
         </p:txBody>
@@ -11032,7 +11032,7 @@
                 </a:solidFill>
                 <a:latin typeface="Arial"/>
               </a:rPr>
-              <a:t>What it takes to win · Oklahoma at Michigan</a:t>
+              <a:t>What it takes to win · Arizona State at Texas A&amp;M</a:t>
             </a:r>
           </a:p>
         </p:txBody>
@@ -11146,7 +11146,7 @@
                 </a:solidFill>
                 <a:latin typeface="Arial"/>
               </a:rPr>
-              <a:t>NEW — Kyle Whittingham (Utah, 177 wins) after Moore's December firing; Beck OC, Hill DC</a:t>
+              <a:t>Elko, year 3 — two NEW coordinators (Wiggins OC, Hemphill DC)</a:t>
             </a:r>
           </a:p>
         </p:txBody>
@@ -11216,7 +11216,7 @@
                 </a:solidFill>
                 <a:latin typeface="Arial"/>
               </a:rPr>
-              <a:t>RETURNS — Bryce Underwood, year two: the No. 1 recruit's Heisman-track season</a:t>
+              <a:t>RETURNS — Marcel Reed: 3,000 pass / 550 rush in 2025, and 12 interceptions</a:t>
             </a:r>
           </a:p>
         </p:txBody>
@@ -11286,7 +11286,7 @@
                 </a:solidFill>
                 <a:latin typeface="Arial"/>
               </a:rPr>
-              <a:t>69% back · 17 portal adds — the Utah pipeline (Daley, Snowden, Lea'ea, Buchanan)</a:t>
+              <a:t>73% back · 19 portal adds — skill talent kept, both trenches rebuilt</a:t>
             </a:r>
           </a:p>
         </p:txBody>
@@ -11365,7 +11365,7 @@
                 </a:solidFill>
                 <a:latin typeface="Arial"/>
               </a:rPr>
-              <a:t>Own the ball — 19:52 of possession and three turnovers against a MAC team; Beck's system is built on 30-minute halves and zero gifts</a:t>
+              <a:t>Reed's ball security — 12 picks last year, four in the two losses; a gambling defense wants the hero throw, take the checkdown</a:t>
             </a:r>
           </a:p>
         </p:txBody>
@@ -11444,7 +11444,7 @@
                 </a:solidFill>
                 <a:latin typeface="Arial"/>
               </a:rPr>
-              <a:t>Run Underwood like Dampier: 47 yards on nine carries was the first look — the QB-run leverage is the identity Whittingham imported from Utah</a:t>
+              <a:t>Prove the portal OL: 236 rushing yards at 5.0 and 43 minutes of possession last week — run it 45 times again against a light front</a:t>
             </a:r>
           </a:p>
         </p:txBody>
@@ -11523,7 +11523,7 @@
                 </a:solidFill>
                 <a:latin typeface="Arial"/>
               </a:rPr>
-              <a:t>Find receiver No. 2: Buchanan's 126 yards was the whole passing game — Marsh has to be a real target or Venables squeezes one side</a:t>
+              <a:t>Havoc from the new front — Saka (12.5% pressure rate) and Henderson vs a QB making his second start</a:t>
             </a:r>
           </a:p>
         </p:txBody>
@@ -11602,7 +11602,7 @@
                 </a:solidFill>
                 <a:latin typeface="Arial"/>
               </a:rPr>
-              <a:t>Hill's defense allowed 221 yards and 4.2 per pass to WMU — bring that to Mateer's Air Raid without the explosive concessions the pressure invites</a:t>
+              <a:t>Finish drives and cut the flags (8 for 75 last week) — style points are the whole game when the spread is 14.5</a:t>
             </a:r>
           </a:p>
         </p:txBody>
@@ -11637,7 +11637,7 @@
                 </a:solidFill>
                 <a:latin typeface="Arial"/>
               </a:rPr>
-              <a:t>EP 3 · WEEK 2 · Oklahoma at Michigan</a:t>
+              <a:t>EP 3 · WEEK 2 · Arizona State at Texas A&amp;M</a:t>
             </a:r>
           </a:p>
         </p:txBody>
@@ -11670,7 +11670,7 @@
       <p:grpSpPr/>
       <p:pic>
         <p:nvPicPr>
-          <p:cNvPr id="2" name="Picture 1" descr="arizonastate.png"/>
+          <p:cNvPr id="2" name="Picture 1" descr="arizona.png"/>
           <p:cNvPicPr>
             <a:picLocks noChangeAspect="1"/>
           </p:cNvPicPr>
@@ -11729,7 +11729,7 @@
       </p:sp>
       <p:pic>
         <p:nvPicPr>
-          <p:cNvPr id="4" name="Picture 3" descr="texasam.png"/>
+          <p:cNvPr id="4" name="Picture 3" descr="byu.png"/>
           <p:cNvPicPr>
             <a:picLocks noChangeAspect="1"/>
           </p:cNvPicPr>
@@ -11781,7 +11781,7 @@
                 </a:solidFill>
                 <a:latin typeface="Arial"/>
               </a:rPr>
-              <a:t>Arizona State at Texas A&amp;M</a:t>
+              <a:t>Arizona at BYU</a:t>
             </a:r>
           </a:p>
         </p:txBody>
@@ -11816,7 +11816,7 @@
                 </a:solidFill>
                 <a:latin typeface="Arial"/>
               </a:rPr>
-              <a:t>Sat Sep 12 · 12:00 ET · Boley's second start vs an SEC secondary · Elko's portal-built trenches get a tempo test</a:t>
+              <a:t>Sat Sep 12 · 3:30 ET · Big 12 opener · BYU has won three straight in the series (33–27 in Tucson last year) · Fifita's final tour</a:t>
             </a:r>
           </a:p>
         </p:txBody>
@@ -11930,7 +11930,7 @@
                 </a:solidFill>
                 <a:latin typeface="Arial"/>
               </a:rPr>
-              <a:t>Dillingham's post-Leavitt reboot (16% of production back — the least on the card, 24 transfers) meets an 11-win Aggie roster that kept its skill talent and rebuilt both trenches through the portal</a:t>
+              <a:t>The Big 12's continuity kings: BYU returns 79% of its production and 177 starts — most in the league — with Bachmeier in year two; Arizona returns the QB (Fifita, 9,183 career yards) and eleven defensive starters</a:t>
             </a:r>
           </a:p>
         </p:txBody>
@@ -12009,7 +12009,7 @@
                 </a:solidFill>
                 <a:latin typeface="Arial"/>
               </a:rPr>
-              <a:t>Cutter Boley's debut was 21-of-27 for 387 and six touchdowns — against Morgan State; Kyle Field at noon with Elko's disguises is the real audition</a:t>
+              <a:t>Provo's biggest home game in program memory until Notre Dame arrives: a 12-win team that lost twice, both to Texas Tech, opens the league with the one opponent that 'plays everybody'</a:t>
             </a:r>
           </a:p>
         </p:txBody>
@@ -12088,7 +12088,7 @@
                 </a:solidFill>
                 <a:latin typeface="Arial"/>
               </a:rPr>
-              <a:t>A&amp;M's story is its lines: six of the top seven OL and five of seven DL are gone, replaced by transfers with 42 combined SEC starts — a tempo offense is the stress test they'd choose least</a:t>
+              <a:t>The coordinator change is BYU's: Jay Hill took the 3-3-5 to Michigan and Poppinga inherits ten rotation defenders — Fifita is the first quarterback who can make that matter</a:t>
             </a:r>
           </a:p>
         </p:txBody>
@@ -12167,7 +12167,7 @@
                 </a:solidFill>
                 <a:latin typeface="Arial"/>
               </a:rPr>
-              <a:t>Neither rating has a 2026 snap in it: both teams beat FCS opponents the machine doesn't rate, so this number is July's prior plus home field — and the market agrees within two points</a:t>
+              <a:t>Week 1 receipts: BYU ran for 308 at 6.7 and forced four turnovers; Arizona put up 520 yards but coughed it up three times — the exact ledger this spread is built on</a:t>
             </a:r>
           </a:p>
         </p:txBody>
@@ -12246,7 +12246,7 @@
                 </a:solidFill>
                 <a:latin typeface="Arial"/>
               </a:rPr>
-              <a:t>Machine –16.7, market –14.5: two points apart on a 14-point spread is agreement. The 70–7 and 50–0 scores are zero evidence — FCS opponents aren't rated, so neither team's number moved. The scouting risk the prior can't price is Reed's turnover habit (four picks in last year's two losses) against a 3-3-5 that gambles for exactly that.</a:t>
+              <a:t>Machine –8.4, market –7.5: agreement. Both ratings are still the July prior — Utah Tech and Northern Arizona aren't rated, so 63–7 and 35–7 moved nothing. BYU has won three straight in the series and the honest lean is that its 79% continuity is the most reliable number on this card; the caveat is a first-time coordinator on the side of the ball that made BYU's last two years.</a:t>
             </a:r>
           </a:p>
         </p:txBody>
@@ -12360,7 +12360,7 @@
                 </a:solidFill>
                 <a:latin typeface="Arial"/>
               </a:rPr>
-              <a:t>Texas A&amp;M –16.5</a:t>
+              <a:t>BYU –8.5</a:t>
             </a:r>
           </a:p>
         </p:txBody>
@@ -12395,7 +12395,7 @@
                 </a:solidFill>
                 <a:latin typeface="Arial"/>
               </a:rPr>
-              <a:t>Texas A&amp;M –560 · Arizona State +560</a:t>
+              <a:t>BYU –239 · Arizona +239</a:t>
             </a:r>
           </a:p>
         </p:txBody>
@@ -12430,7 +12430,7 @@
                 </a:solidFill>
                 <a:latin typeface="Arial"/>
               </a:rPr>
-              <a:t>machine line · fair odds, no vig · raw margin Texas A&amp;M +16.7</a:t>
+              <a:t>machine line · fair odds, no vig · raw margin BYU +8.4</a:t>
             </a:r>
           </a:p>
         </p:txBody>
@@ -12465,7 +12465,7 @@
                 </a:solidFill>
                 <a:latin typeface="Arial"/>
               </a:rPr>
-              <a:t>–14.5 / –14</a:t>
+              <a:t>–7.5 / –7.5</a:t>
             </a:r>
           </a:p>
         </p:txBody>
@@ -12500,7 +12500,7 @@
                 </a:solidFill>
                 <a:latin typeface="Arial"/>
               </a:rPr>
-              <a:t>market (DK / Bovada) · DK Texas A&amp;M -650 / Arizona State +470 · Bov Texas A&amp;M -650 / Arizona State +450</a:t>
+              <a:t>market (DK / Bovada) · DK BYU -290 / Arizona +235 · Bov BYU -310 / Arizona +255</a:t>
             </a:r>
           </a:p>
         </p:txBody>
@@ -12529,13 +12529,13 @@
           <a:p>
             <a:pPr algn="l"/>
             <a:r>
-              <a:rPr sz="1300" b="1" i="0">
+              <a:rPr sz="1500" b="1" i="0">
                 <a:solidFill>
                   <a:srgbClr val="F47321"/>
                 </a:solidFill>
                 <a:latin typeface="Arial"/>
               </a:rPr>
-              <a:t>Texas A&amp;M 34 – Arizona State 17</a:t>
+              <a:t>BYU 28 – Arizona 20</a:t>
             </a:r>
           </a:p>
         </p:txBody>
@@ -12590,7 +12590,7 @@
             <a:avLst/>
           </a:prstGeom>
           <a:solidFill>
-            <a:srgbClr val="8C1D40"/>
+            <a:srgbClr val="0C234B"/>
           </a:solidFill>
           <a:ln>
             <a:noFill/>
@@ -12628,13 +12628,13 @@
         <p:spPr>
           <a:xfrm>
             <a:off x="8046720" y="4754880"/>
-            <a:ext cx="2564892" cy="365760"/>
+            <a:ext cx="2112264" cy="365760"/>
           </a:xfrm>
           <a:prstGeom prst="roundRect">
             <a:avLst/>
           </a:prstGeom>
           <a:solidFill>
-            <a:srgbClr val="500000"/>
+            <a:srgbClr val="0022E0"/>
           </a:solidFill>
           <a:ln>
             <a:noFill/>
@@ -12693,7 +12693,7 @@
                 </a:solidFill>
                 <a:latin typeface="Arial"/>
               </a:rPr>
-              <a:t>TAMU 85%</a:t>
+              <a:t>BYU 70%</a:t>
             </a:r>
           </a:p>
         </p:txBody>
@@ -12728,7 +12728,7 @@
                 </a:solidFill>
                 <a:latin typeface="Arial"/>
               </a:rPr>
-              <a:t>15% ASU</a:t>
+              <a:t>30% ARIZ</a:t>
             </a:r>
           </a:p>
         </p:txBody>
@@ -12798,7 +12798,7 @@
                 </a:solidFill>
                 <a:latin typeface="Arial"/>
               </a:rPr>
-              <a:t>LINE MOVE  –14.5 → –14.5</a:t>
+              <a:t>LINE MOVE  –7 → –7.5 · CLV +0.5</a:t>
             </a:r>
           </a:p>
         </p:txBody>
@@ -12833,7 +12833,7 @@
                 </a:solidFill>
                 <a:latin typeface="Arial"/>
               </a:rPr>
-              <a:t>Line movement: first-seen –14.5 (Aug 23) → now –14.5 · CLV +0</a:t>
+              <a:t>Line movement: first-seen –7 (Sep 4) → now –7.5 · opened –6.5 · CLV +0.5</a:t>
             </a:r>
           </a:p>
         </p:txBody>
@@ -12866,7 +12866,7 @@
       <p:grpSpPr/>
       <p:pic>
         <p:nvPicPr>
-          <p:cNvPr id="2" name="Picture 1" descr="arizonastate.png"/>
+          <p:cNvPr id="2" name="Picture 1" descr="arizona.png"/>
           <p:cNvPicPr>
             <a:picLocks noChangeAspect="1"/>
           </p:cNvPicPr>
@@ -12918,7 +12918,7 @@
                 </a:solidFill>
                 <a:latin typeface="Arial"/>
               </a:rPr>
-              <a:t>Arizona State</a:t>
+              <a:t>Arizona</a:t>
             </a:r>
           </a:p>
         </p:txBody>
@@ -12953,7 +12953,7 @@
                 </a:solidFill>
                 <a:latin typeface="Arial"/>
               </a:rPr>
-              <a:t>What it takes to win · Arizona State at Texas A&amp;M</a:t>
+              <a:t>What it takes to win · Arizona at BYU</a:t>
             </a:r>
           </a:p>
         </p:txBody>
@@ -13067,7 +13067,7 @@
                 </a:solidFill>
                 <a:latin typeface="Arial"/>
               </a:rPr>
-              <a:t>Dillingham, year 4 — a full reset after the injury-shredded 2025</a:t>
+              <a:t>Brennan, year 3 — DC Danny Gonzales returns eleven 2025 starters</a:t>
             </a:r>
           </a:p>
         </p:txBody>
@@ -13137,7 +13137,7 @@
                 </a:solidFill>
                 <a:latin typeface="Arial"/>
               </a:rPr>
-              <a:t>NEW — Cutter Boley (Kentucky), won a four-way derby; 387 yards, 6 TDs in the debut</a:t>
+              <a:t>RETURNS — Noah Fifita, year four as the starter: 9,183 yards, 73 TDs</a:t>
             </a:r>
           </a:p>
         </p:txBody>
@@ -13207,7 +13207,7 @@
                 </a:solidFill>
                 <a:latin typeface="Arial"/>
               </a:rPr>
-              <a:t>16% back — least on the card · 24 portal adds · 11 of 34 regulars return</a:t>
+              <a:t>65% back · 22 portal adds — leading rusher and top two receivers gone</a:t>
             </a:r>
           </a:p>
         </p:txBody>
@@ -13286,7 +13286,7 @@
                 </a:solidFill>
                 <a:latin typeface="Arial"/>
               </a:rPr>
-              <a:t>Tempo the transfer defensive line — five new starters up front are the one A&amp;M unit that hasn't played together; 4-of-5 on fourth down says Dillingham will push it</a:t>
+              <a:t>Attack Poppinga's first game plan — hit the corners early with Fifita's quick game before the disguises settle in</a:t>
             </a:r>
           </a:p>
         </p:txBody>
@@ -13365,7 +13365,7 @@
                 </a:solidFill>
                 <a:latin typeface="Arial"/>
               </a:rPr>
-              <a:t>Boley's second start against real disguise: Ricks, Ratcliffe, Brooks and portal corner Gibson rotate late — the six-touchdown debut came against Morgan State</a:t>
+              <a:t>Front-six physicality: BYU ran for 308 last week and LJ Martin is a 1,300-yard back — the rebuilt front has to hold the line or the play-action never gets tested</a:t>
             </a:r>
           </a:p>
         </p:txBody>
@@ -13444,7 +13444,7 @@
                 </a:solidFill>
                 <a:latin typeface="Arial"/>
               </a:rPr>
-              <a:t>Contain before you gamble: the 3-3-5 is undersized by design, and Reed's designed run in the red zone is exactly what it concedes</a:t>
+              <a:t>Ball security — three giveaways against Northern Arizona; BYU's defense manufactured four takeaways and a touchdown last week</a:t>
             </a:r>
           </a:p>
         </p:txBody>
@@ -13523,7 +13523,7 @@
                 </a:solidFill>
                 <a:latin typeface="Arial"/>
               </a:rPr>
-              <a:t>Fix special teams (No. 125 last year) — at Kyle Field a +14.5 cover lives or dies in field position</a:t>
+              <a:t>Play the field-position game Brennan wins — a top-tier secondary, fourth-down aggression, and the hidden yards decide a 7.5-point spread in Provo</a:t>
             </a:r>
           </a:p>
         </p:txBody>
@@ -13558,7 +13558,7 @@
                 </a:solidFill>
                 <a:latin typeface="Arial"/>
               </a:rPr>
-              <a:t>EP 3 · WEEK 2 · Arizona State at Texas A&amp;M</a:t>
+              <a:t>EP 3 · WEEK 2 · Arizona at BYU</a:t>
             </a:r>
           </a:p>
         </p:txBody>
@@ -13591,7 +13591,7 @@
       <p:grpSpPr/>
       <p:pic>
         <p:nvPicPr>
-          <p:cNvPr id="2" name="Picture 1" descr="texasam.png"/>
+          <p:cNvPr id="2" name="Picture 1" descr="byu.png"/>
           <p:cNvPicPr>
             <a:picLocks noChangeAspect="1"/>
           </p:cNvPicPr>
@@ -13643,7 +13643,7 @@
                 </a:solidFill>
                 <a:latin typeface="Arial"/>
               </a:rPr>
-              <a:t>Texas A&amp;M</a:t>
+              <a:t>BYU</a:t>
             </a:r>
           </a:p>
         </p:txBody>
@@ -13678,7 +13678,7 @@
                 </a:solidFill>
                 <a:latin typeface="Arial"/>
               </a:rPr>
-              <a:t>What it takes to win · Arizona State at Texas A&amp;M</a:t>
+              <a:t>What it takes to win · Arizona at BYU</a:t>
             </a:r>
           </a:p>
         </p:txBody>
@@ -13792,7 +13792,7 @@
                 </a:solidFill>
                 <a:latin typeface="Arial"/>
               </a:rPr>
-              <a:t>Elko, year 3 — two NEW coordinators (Wiggins OC, Hemphill DC)</a:t>
+              <a:t>Sitake, year 11 — NEW DC Kelly Poppinga (Hill left for Michigan)</a:t>
             </a:r>
           </a:p>
         </p:txBody>
@@ -13862,7 +13862,7 @@
                 </a:solidFill>
                 <a:latin typeface="Arial"/>
               </a:rPr>
-              <a:t>RETURNS — Marcel Reed: 3,000 pass / 550 rush in 2025, and 12 interceptions</a:t>
+              <a:t>RETURNS — Bear Bachmeier, year two: the Big 12's safest QB bet</a:t>
             </a:r>
           </a:p>
         </p:txBody>
@@ -13932,7 +13932,7 @@
                 </a:solidFill>
                 <a:latin typeface="Arial"/>
               </a:rPr>
-              <a:t>73% back · 19 portal adds — skill talent kept, both trenches rebuilt</a:t>
+              <a:t>79% back — most on the card · 9 portal adds · 177 returning starts</a:t>
             </a:r>
           </a:p>
         </p:txBody>
@@ -14011,7 +14011,7 @@
                 </a:solidFill>
                 <a:latin typeface="Arial"/>
               </a:rPr>
-              <a:t>Reed's ball security — 12 picks last year, four in the two losses; a gambling defense wants the hero throw, take the checkdown</a:t>
+              <a:t>Run first, then punish: Bachmeier's QB-run and deep play-action beat single-high all last year — Arizona's secondary is the first one that will make him earn it</a:t>
             </a:r>
           </a:p>
         </p:txBody>
@@ -14090,7 +14090,7 @@
                 </a:solidFill>
                 <a:latin typeface="Arial"/>
               </a:rPr>
-              <a:t>Prove the portal OL: 236 rushing yards at 5.0 and 43 minutes of possession last week — run it 45 times again against a light front</a:t>
+              <a:t>Martin and Eka behind four returning linemen — 6.7 a carry last week; this is where the continuity edge shows up on the field</a:t>
             </a:r>
           </a:p>
         </p:txBody>
@@ -14169,7 +14169,7 @@
                 </a:solidFill>
                 <a:latin typeface="Arial"/>
               </a:rPr>
-              <a:t>Havoc from the new front — Saka (12.5% pressure rate) and Henderson vs a QB making his second start</a:t>
+              <a:t>Prove the new receivers: Glasker (65 yards, two scores) and Kasper stepped in for the departed top three — a real secondary is the first real test</a:t>
             </a:r>
           </a:p>
         </p:txBody>
@@ -14248,7 +14248,7 @@
                 </a:solidFill>
                 <a:latin typeface="Arial"/>
               </a:rPr>
-              <a:t>Finish drives and cut the flags (8 for 75 last week) — style points are the whole game when the spread is 14.5</a:t>
+              <a:t>Win the hidden margin — 183 return yards and a defensive score last week; against a team that turned it over three times, takeaways are the cover</a:t>
             </a:r>
           </a:p>
         </p:txBody>
@@ -14283,7 +14283,7 @@
                 </a:solidFill>
                 <a:latin typeface="Arial"/>
               </a:rPr>
-              <a:t>EP 3 · WEEK 2 · Arizona State at Texas A&amp;M</a:t>
+              <a:t>EP 3 · WEEK 2 · Arizona at BYU</a:t>
             </a:r>
           </a:p>
         </p:txBody>
@@ -14316,7 +14316,7 @@
       <p:grpSpPr/>
       <p:pic>
         <p:nvPicPr>
-          <p:cNvPr id="2" name="Picture 1" descr="arizona.png"/>
+          <p:cNvPr id="2" name="Picture 1" descr="alabama.png"/>
           <p:cNvPicPr>
             <a:picLocks noChangeAspect="1"/>
           </p:cNvPicPr>
@@ -14375,7 +14375,7 @@
       </p:sp>
       <p:pic>
         <p:nvPicPr>
-          <p:cNvPr id="4" name="Picture 3" descr="byu.png"/>
+          <p:cNvPr id="4" name="Picture 3" descr="kentucky.png"/>
           <p:cNvPicPr>
             <a:picLocks noChangeAspect="1"/>
           </p:cNvPicPr>
@@ -14427,7 +14427,7 @@
                 </a:solidFill>
                 <a:latin typeface="Arial"/>
               </a:rPr>
-              <a:t>Arizona at BYU</a:t>
+              <a:t>Alabama at Kentucky</a:t>
             </a:r>
           </a:p>
         </p:txBody>
@@ -14462,7 +14462,7 @@
                 </a:solidFill>
                 <a:latin typeface="Arial"/>
               </a:rPr>
-              <a:t>Sat Sep 12 · 3:30 ET · Big 12 opener · BYU has won three straight in the series (33–27 in Tucson last year) · Fifita's final tour</a:t>
+              <a:t>Sat Sep 12 · 3:30 ET · SEC opener · Keelon Russell's first road start · Will Stein's first SEC game · Kentucky hasn't beaten Alabama since 1997</a:t>
             </a:r>
           </a:p>
         </p:txBody>
@@ -14576,7 +14576,7 @@
                 </a:solidFill>
                 <a:latin typeface="Arial"/>
               </a:rPr>
-              <a:t>The Big 12's continuity kings: BYU returns 79% of its production and 177 starts — most in the league — with Bachmeier in year two; Arizona returns the QB (Fifita, 9,183 career yards) and eleven defensive starters</a:t>
+              <a:t>DeBoer's referendum year opens on the road with a redshirt-freshman quarterback: Russell went 18-of-30 for 256 with zero touchdowns in the opener — the offense scored five rushing TDs instead</a:t>
             </a:r>
           </a:p>
         </p:txBody>
@@ -14655,7 +14655,7 @@
                 </a:solidFill>
                 <a:latin typeface="Arial"/>
               </a:rPr>
-              <a:t>Provo's biggest home game in program memory until Notre Dame arrives: a 12-win team that lost twice, both to Texas Tech, opens the league with the one opponent that 'plays everybody'</a:t>
+              <a:t>Will Stein's Kentucky is the anti-Stoops: motion, pace, a Notre Dame transfer QB (Minchey: 301 yards, four TDs in the debut) behind six transfer linemen averaging 6-5, 323</a:t>
             </a:r>
           </a:p>
         </p:txBody>
@@ -14734,7 +14734,7 @@
                 </a:solidFill>
                 <a:latin typeface="Arial"/>
               </a:rPr>
-              <a:t>The coordinator change is BYU's: Jay Hill took the 3-3-5 to Michigan and Poppinga inherits ten rotation defenders — Fifita is the first quarterback who can make that matter</a:t>
+              <a:t>Continuity is the card's lowest on both sides: Alabama returns 26% of its offensive production, Kentucky 19% — 31 transfers in Lexington, the most of anyone we cover this week</a:t>
             </a:r>
           </a:p>
         </p:txBody>
@@ -14813,7 +14813,7 @@
                 </a:solidFill>
                 <a:latin typeface="Arial"/>
               </a:rPr>
-              <a:t>Week 1 receipts: BYU ran for 308 at 6.7 and forced four turnovers; Arizona put up 520 yards but coughed it up three times — the exact ledger this spread is built on</a:t>
+              <a:t>The market's early landmine: the deep dive called Kentucky Week 2 one of three early traps — Alabama lost its opener a year ago and DeBoer has lost as many games in two years as Saban did in five</a:t>
             </a:r>
           </a:p>
         </p:txBody>
@@ -14892,7 +14892,7 @@
                 </a:solidFill>
                 <a:latin typeface="Arial"/>
               </a:rPr>
-              <a:t>Machine –8.4, market –7.5: agreement. Both ratings are still the July prior — Utah Tech and Northern Arizona aren't rated, so 63–7 and 35–7 moved nothing. BYU has won three straight in the series and the honest lean is that its 79% continuity is the most reliable number on this card; the caveat is a first-time coordinator on the side of the ball that made BYU's last two years.</a:t>
+              <a:t>Machine –13.2, market –10.5: 2.7 to Alabama sits right at the noise line, and it comes with the two hedges a prior can't price — a teenager's first road start and a year-one head coach whose rating has zero 2026 snaps in it (Youngstown State isn't rated). Treat it as a quibble; the real information arrives at 3:30.</a:t>
             </a:r>
           </a:p>
         </p:txBody>
@@ -15006,7 +15006,7 @@
                 </a:solidFill>
                 <a:latin typeface="Arial"/>
               </a:rPr>
-              <a:t>BYU –8.5</a:t>
+              <a:t>Alabama –13</a:t>
             </a:r>
           </a:p>
         </p:txBody>
@@ -15041,7 +15041,7 @@
                 </a:solidFill>
                 <a:latin typeface="Arial"/>
               </a:rPr>
-              <a:t>BYU –239 · Arizona +239</a:t>
+              <a:t>Kentucky +380 · Alabama –380</a:t>
             </a:r>
           </a:p>
         </p:txBody>
@@ -15076,7 +15076,7 @@
                 </a:solidFill>
                 <a:latin typeface="Arial"/>
               </a:rPr>
-              <a:t>machine line · fair odds, no vig · raw margin BYU +8.4</a:t>
+              <a:t>machine line · fair odds, no vig · raw margin Alabama +13.2</a:t>
             </a:r>
           </a:p>
         </p:txBody>
@@ -15111,7 +15111,7 @@
                 </a:solidFill>
                 <a:latin typeface="Arial"/>
               </a:rPr>
-              <a:t>–7.5 / –7.5</a:t>
+              <a:t>+10.5 / +10.5</a:t>
             </a:r>
           </a:p>
         </p:txBody>
@@ -15146,7 +15146,7 @@
                 </a:solidFill>
                 <a:latin typeface="Arial"/>
               </a:rPr>
-              <a:t>market (DK / Bovada) · DK BYU -290 / Arizona +235 · Bov BYU -310 / Arizona +255</a:t>
+              <a:t>market (DK / Bovada) · DK Kentucky +330 / Alabama -425 · Bov Kentucky +320 / Alabama -430</a:t>
             </a:r>
           </a:p>
         </p:txBody>
@@ -15175,13 +15175,13 @@
           <a:p>
             <a:pPr algn="l"/>
             <a:r>
-              <a:rPr sz="1500" b="1" i="0">
+              <a:rPr sz="1300" b="1" i="0">
                 <a:solidFill>
                   <a:srgbClr val="F47321"/>
                 </a:solidFill>
                 <a:latin typeface="Arial"/>
               </a:rPr>
-              <a:t>BYU 28 – Arizona 20</a:t>
+              <a:t>Alabama 31 – Kentucky 18</a:t>
             </a:r>
           </a:p>
         </p:txBody>
@@ -15236,7 +15236,7 @@
             <a:avLst/>
           </a:prstGeom>
           <a:solidFill>
-            <a:srgbClr val="0C234B"/>
+            <a:srgbClr val="9E1632"/>
           </a:solidFill>
           <a:ln>
             <a:noFill/>
@@ -15274,13 +15274,13 @@
         <p:spPr>
           <a:xfrm>
             <a:off x="8046720" y="4754880"/>
-            <a:ext cx="2112264" cy="365760"/>
+            <a:ext cx="633679" cy="365760"/>
           </a:xfrm>
           <a:prstGeom prst="roundRect">
             <a:avLst/>
           </a:prstGeom>
           <a:solidFill>
-            <a:srgbClr val="0022E0"/>
+            <a:srgbClr val="0033A0"/>
           </a:solidFill>
           <a:ln>
             <a:noFill/>
@@ -15339,7 +15339,7 @@
                 </a:solidFill>
                 <a:latin typeface="Arial"/>
               </a:rPr>
-              <a:t>BYU 70%</a:t>
+              <a:t>UK 21%</a:t>
             </a:r>
           </a:p>
         </p:txBody>
@@ -15374,7 +15374,7 @@
                 </a:solidFill>
                 <a:latin typeface="Arial"/>
               </a:rPr>
-              <a:t>30% ARIZ</a:t>
+              <a:t>79% BAMA</a:t>
             </a:r>
           </a:p>
         </p:txBody>
@@ -15444,7 +15444,7 @@
                 </a:solidFill>
                 <a:latin typeface="Arial"/>
               </a:rPr>
-              <a:t>LINE MOVE  –7 → –7.5 · CLV +0.5</a:t>
+              <a:t>LINE MOVE  +10.5 → +10.5</a:t>
             </a:r>
           </a:p>
         </p:txBody>
@@ -15479,7 +15479,7 @@
                 </a:solidFill>
                 <a:latin typeface="Arial"/>
               </a:rPr>
-              <a:t>Line movement: first-seen –7 (Sep 4) → now –7.5 · opened –6.5 · CLV +0.5</a:t>
+              <a:t>Line movement: first-seen +10.5 (Sep 4) → now +10.5 · CLV +0</a:t>
             </a:r>
           </a:p>
         </p:txBody>
@@ -15512,7 +15512,7 @@
       <p:grpSpPr/>
       <p:pic>
         <p:nvPicPr>
-          <p:cNvPr id="2" name="Picture 1" descr="arizona.png"/>
+          <p:cNvPr id="2" name="Picture 1" descr="alabama.png"/>
           <p:cNvPicPr>
             <a:picLocks noChangeAspect="1"/>
           </p:cNvPicPr>
@@ -15564,7 +15564,7 @@
                 </a:solidFill>
                 <a:latin typeface="Arial"/>
               </a:rPr>
-              <a:t>Arizona</a:t>
+              <a:t>Alabama</a:t>
             </a:r>
           </a:p>
         </p:txBody>
@@ -15599,7 +15599,7 @@
                 </a:solidFill>
                 <a:latin typeface="Arial"/>
               </a:rPr>
-              <a:t>What it takes to win · Arizona at BYU</a:t>
+              <a:t>What it takes to win · Alabama at Kentucky</a:t>
             </a:r>
           </a:p>
         </p:txBody>
@@ -15713,7 +15713,7 @@
                 </a:solidFill>
                 <a:latin typeface="Arial"/>
               </a:rPr>
-              <a:t>Brennan, year 3 — DC Danny Gonzales returns eleven 2025 starters</a:t>
+              <a:t>DeBoer, year 3 — the referendum season; Wommack year 3 on defense</a:t>
             </a:r>
           </a:p>
         </p:txBody>
@@ -15783,7 +15783,7 @@
                 </a:solidFill>
                 <a:latin typeface="Arial"/>
               </a:rPr>
-              <a:t>RETURNS — Noah Fifita, year four as the starter: 9,183 yards, 73 TDs</a:t>
+              <a:t>NEW — Keelon Russell, RS freshman, the No. 2 recruit in the 2025 class</a:t>
             </a:r>
           </a:p>
         </p:txBody>
@@ -15853,7 +15853,7 @@
                 </a:solidFill>
                 <a:latin typeface="Arial"/>
               </a:rPr>
-              <a:t>65% back · 22 portal adds — leading rusher and top two receivers gone</a:t>
+              <a:t>26% back · 17 portal adds — six of the top seven OL gone, QB gone</a:t>
             </a:r>
           </a:p>
         </p:txBody>
@@ -15932,7 +15932,7 @@
                 </a:solidFill>
                 <a:latin typeface="Arial"/>
               </a:rPr>
-              <a:t>Attack Poppinga's first game plan — hit the corners early with Fifita's quick game before the disguises settle in</a:t>
+              <a:t>Russell's first road start — zero passing touchdowns against ECU; DeBoer's rhythm game needs him to attack the intermediate middle, not just survive</a:t>
             </a:r>
           </a:p>
         </p:txBody>
@@ -16011,7 +16011,7 @@
                 </a:solidFill>
                 <a:latin typeface="Arial"/>
               </a:rPr>
-              <a:t>Front-six physicality: BYU ran for 308 last week and LJ Martin is a 1,300-yard back — the rebuilt front has to hold the line or the play-action never gets tested</a:t>
+              <a:t>Run it 49 times again: 227 yards and five rushing scores last week — the rebuilt OL vs Kentucky's returning front is where an SEC road game is decided</a:t>
             </a:r>
           </a:p>
         </p:txBody>
@@ -16090,7 +16090,7 @@
                 </a:solidFill>
                 <a:latin typeface="Arial"/>
               </a:rPr>
-              <a:t>Ball security — three giveaways against Northern Arizona; BYU's defense manufactured four takeaways and a touchdown last week</a:t>
+              <a:t>Wommack's secondary (Brown, Lee, Sabb) vs the receiver room the deep dive called a void — make Minchey hold the ball</a:t>
             </a:r>
           </a:p>
         </p:txBody>
@@ -16169,7 +16169,7 @@
                 </a:solidFill>
                 <a:latin typeface="Arial"/>
               </a:rPr>
-              <a:t>Play the field-position game Brennan wins — a top-tier secondary, fourth-down aggression, and the hidden yards decide a 7.5-point spread in Provo</a:t>
+              <a:t>Special teams: 107th last year and projected 109th — a 10.5-point spread at Kroger dies in hidden yards</a:t>
             </a:r>
           </a:p>
         </p:txBody>
@@ -16204,7 +16204,7 @@
                 </a:solidFill>
                 <a:latin typeface="Arial"/>
               </a:rPr>
-              <a:t>EP 3 · WEEK 2 · Arizona at BYU</a:t>
+              <a:t>EP 3 · WEEK 2 · Alabama at Kentucky</a:t>
             </a:r>
           </a:p>
         </p:txBody>
@@ -16237,7 +16237,7 @@
       <p:grpSpPr/>
       <p:pic>
         <p:nvPicPr>
-          <p:cNvPr id="2" name="Picture 1" descr="byu.png"/>
+          <p:cNvPr id="2" name="Picture 1" descr="kentucky.png"/>
           <p:cNvPicPr>
             <a:picLocks noChangeAspect="1"/>
           </p:cNvPicPr>
@@ -16289,7 +16289,7 @@
                 </a:solidFill>
                 <a:latin typeface="Arial"/>
               </a:rPr>
-              <a:t>BYU</a:t>
+              <a:t>Kentucky</a:t>
             </a:r>
           </a:p>
         </p:txBody>
@@ -16324,7 +16324,7 @@
                 </a:solidFill>
                 <a:latin typeface="Arial"/>
               </a:rPr>
-              <a:t>What it takes to win · Arizona at BYU</a:t>
+              <a:t>What it takes to win · Alabama at Kentucky</a:t>
             </a:r>
           </a:p>
         </p:txBody>
@@ -16438,7 +16438,7 @@
                 </a:solidFill>
                 <a:latin typeface="Arial"/>
               </a:rPr>
-              <a:t>Sitake, year 11 — NEW DC Kelly Poppinga (Hill left for Michigan)</a:t>
+              <a:t>NEW — Will Stein (Oregon OC) after the Stoops era ended at 5–7</a:t>
             </a:r>
           </a:p>
         </p:txBody>
@@ -16508,7 +16508,7 @@
                 </a:solidFill>
                 <a:latin typeface="Arial"/>
               </a:rPr>
-              <a:t>RETURNS — Bear Bachmeier, year two: the Big 12's safest QB bet</a:t>
+              <a:t>NEW — Kenny Minchey (Notre Dame): accurate, mobile, one start of proof</a:t>
             </a:r>
           </a:p>
         </p:txBody>
@@ -16578,7 +16578,7 @@
                 </a:solidFill>
                 <a:latin typeface="Arial"/>
               </a:rPr>
-              <a:t>79% back — most on the card · 9 portal adds · 177 returning starts</a:t>
+              <a:t>19% back · 31 portal adds — most on the card; six transfer OL, ten defensive starters back</a:t>
             </a:r>
           </a:p>
         </p:txBody>
@@ -16657,7 +16657,7 @@
                 </a:solidFill>
                 <a:latin typeface="Arial"/>
               </a:rPr>
-              <a:t>Run first, then punish: Bachmeier's QB-run and deep play-action beat single-high all last year — Arizona's secondary is the first one that will make him earn it</a:t>
+              <a:t>The mauling line: six transfers, 49 FBS starts, three all-conference — vs an Alabama interior that lost four of its top five tackles; Baxter and Patterson downhill</a:t>
             </a:r>
           </a:p>
         </p:txBody>
@@ -16736,7 +16736,7 @@
                 </a:solidFill>
                 <a:latin typeface="Arial"/>
               </a:rPr>
-              <a:t>Martin and Eka behind four returning linemen — 6.7 a carry last week; this is where the continuity edge shows up on the field</a:t>
+              <a:t>Minchey's profile: four touchdowns, no picks, 11.1 a throw — keep it clean against the best secondary in America and the spread is in play all afternoon</a:t>
             </a:r>
           </a:p>
         </p:txBody>
@@ -16815,7 +16815,7 @@
                 </a:solidFill>
                 <a:latin typeface="Arial"/>
               </a:rPr>
-              <a:t>Prove the new receivers: Glasker (65 yards, two scores) and Kasper stepped in for the departed top three — a real secondary is the first real test</a:t>
+              <a:t>The defense is the strength — ten of nineteen starters back plus Castell; make Russell win from the pocket on third-and-long</a:t>
             </a:r>
           </a:p>
         </p:txBody>
@@ -16894,7 +16894,7 @@
                 </a:solidFill>
                 <a:latin typeface="Arial"/>
               </a:rPr>
-              <a:t>Win the hidden margin — 183 return yards and a defensive score last week; against a team that turned it over three times, takeaways are the cover</a:t>
+              <a:t>Clean up the two Week 1 leaks: 3-of-8 on third down and six penalties for 70 — those are the stats that lose to Alabama</a:t>
             </a:r>
           </a:p>
         </p:txBody>
@@ -16929,7 +16929,7 @@
                 </a:solidFill>
                 <a:latin typeface="Arial"/>
               </a:rPr>
-              <a:t>EP 3 · WEEK 2 · Arizona at BYU</a:t>
+              <a:t>EP 3 · WEEK 2 · Alabama at Kentucky</a:t>
             </a:r>
           </a:p>
         </p:txBody>
@@ -16962,7 +16962,7 @@
       <p:grpSpPr/>
       <p:pic>
         <p:nvPicPr>
-          <p:cNvPr id="2" name="Picture 1" descr="alabama.png"/>
+          <p:cNvPr id="2" name="Picture 1" descr="ohiostate.png"/>
           <p:cNvPicPr>
             <a:picLocks noChangeAspect="1"/>
           </p:cNvPicPr>
@@ -17021,7 +17021,7 @@
       </p:sp>
       <p:pic>
         <p:nvPicPr>
-          <p:cNvPr id="4" name="Picture 3" descr="kentucky.png"/>
+          <p:cNvPr id="4" name="Picture 3" descr="texas.png"/>
           <p:cNvPicPr>
             <a:picLocks noChangeAspect="1"/>
           </p:cNvPicPr>
@@ -17073,7 +17073,7 @@
                 </a:solidFill>
                 <a:latin typeface="Arial"/>
               </a:rPr>
-              <a:t>Alabama at Kentucky</a:t>
+              <a:t>Ohio State at Texas</a:t>
             </a:r>
           </a:p>
         </p:txBody>
@@ -17108,7 +17108,7 @@
                 </a:solidFill>
                 <a:latin typeface="Arial"/>
               </a:rPr>
-              <a:t>Sat Sep 12 · 3:30 ET · SEC opener · Keelon Russell's first road start · Will Stein's first SEC game · Kentucky hasn't beaten Alabama since 1997</a:t>
+              <a:t>Sat Sep 12 · 7:30 ET · No. 1 at No. 4 · the 2025 opener rematch (OSU 14–7) · Arch's last tour vs Sayin-to-Smith</a:t>
             </a:r>
           </a:p>
         </p:txBody>
@@ -17222,7 +17222,7 @@
                 </a:solidFill>
                 <a:latin typeface="Arial"/>
               </a:rPr>
-              <a:t>DeBoer's referendum year opens on the road with a redshirt-freshman quarterback: Russell went 18-of-30 for 256 with zero touchdowns in the opener — the offense scored five rushing TDs instead</a:t>
+              <a:t>The rematch of the year: Ohio State won last year's opener 14–7 in Columbus and the 2024 CFP semifinal — Texas gets it at home, at night, with Arch Manning in what is almost certainly his last season</a:t>
             </a:r>
           </a:p>
         </p:txBody>
@@ -17301,7 +17301,7 @@
                 </a:solidFill>
                 <a:latin typeface="Arial"/>
               </a:rPr>
-              <a:t>Will Stein's Kentucky is the anti-Stoops: motion, pace, a Notre Dame transfer QB (Minchey: 301 yards, four TDs in the debut) behind six transfer linemen averaging 6-5, 323</a:t>
+              <a:t>Two title-or-bust rosters and one coordinator gamble each: Arthur Smith installing an NFL run game around Sayin–Smith, Will Muschamp replacing the coordinator whose defense outranked Sark's offense two years running</a:t>
             </a:r>
           </a:p>
         </p:txBody>
@@ -17380,7 +17380,7 @@
                 </a:solidFill>
                 <a:latin typeface="Arial"/>
               </a:rPr>
-              <a:t>Continuity is the card's lowest on both sides: Alabama returns 26% of its offensive production, Kentucky 19% — 31 transfers in Lexington, the most of anyone we cover this week</a:t>
+              <a:t>Continuity edge is Texas: 72% of its offensive production back plus the sport's most talked-about portal class (Coleman, Smothers, Biles); Ohio State returns 68% on offense but only two of nine defensive starters</a:t>
             </a:r>
           </a:p>
         </p:txBody>
@@ -17459,7 +17459,7 @@
                 </a:solidFill>
                 <a:latin typeface="Arial"/>
               </a:rPr>
-              <a:t>The market's early landmine: the deep dive called Kentucky Week 2 one of three early traps — Alabama lost its opener a year ago and DeBoer has lost as many games in two years as Saban did in five</a:t>
+              <a:t>Week 1 said nothing and everything: 56–3 and 59–7 — Sayin 21-of-25, Arch 4 touchdowns — but Texas allowed 349 yards to Texas State and Ohio State took nine flags</a:t>
             </a:r>
           </a:p>
         </p:txBody>
@@ -17538,7 +17538,7 @@
                 </a:solidFill>
                 <a:latin typeface="Arial"/>
               </a:rPr>
-              <a:t>Machine –13.2, market –10.5: 2.7 to Alabama sits right at the noise line, and it comes with the two hedges a prior can't price — a teenager's first road start and a year-one head coach whose rating has zero 2026 snaps in it (Youngstown State isn't rated). Treat it as a quibble; the real information arrives at 3:30.</a:t>
+              <a:t>The machine says Texas by 3.7; the market says 1.5; ESPN's own live FPI says 0.7. Three points of our number are bookkeeping — the ±28 margin cap turned 56–3 into an 'underperformance' and docked Ohio State 4.1 rating points for winning by 53. Strip the artifact and this is a pick'em plus home field, which is exactly what everyone else says. No position.</a:t>
             </a:r>
           </a:p>
         </p:txBody>
@@ -17652,7 +17652,7 @@
                 </a:solidFill>
                 <a:latin typeface="Arial"/>
               </a:rPr>
-              <a:t>Alabama –13</a:t>
+              <a:t>Texas –3.5</a:t>
             </a:r>
           </a:p>
         </p:txBody>
@@ -17687,7 +17687,7 @@
                 </a:solidFill>
                 <a:latin typeface="Arial"/>
               </a:rPr>
-              <a:t>Kentucky +380 · Alabama –380</a:t>
+              <a:t>Texas –150 · Ohio State +150</a:t>
             </a:r>
           </a:p>
         </p:txBody>
@@ -17722,7 +17722,7 @@
                 </a:solidFill>
                 <a:latin typeface="Arial"/>
               </a:rPr>
-              <a:t>machine line · fair odds, no vig · raw margin Alabama +13.2</a:t>
+              <a:t>machine line · fair odds, no vig · raw margin Texas +3.7</a:t>
             </a:r>
           </a:p>
         </p:txBody>
@@ -17757,7 +17757,7 @@
                 </a:solidFill>
                 <a:latin typeface="Arial"/>
               </a:rPr>
-              <a:t>+10.5 / +10.5</a:t>
+              <a:t>–1.5 / –2</a:t>
             </a:r>
           </a:p>
         </p:txBody>
@@ -17792,7 +17792,7 @@
                 </a:solidFill>
                 <a:latin typeface="Arial"/>
               </a:rPr>
-              <a:t>market (DK / Bovada) · DK Kentucky +330 / Alabama -425 · Bov Kentucky +320 / Alabama -430</a:t>
+              <a:t>market (DK / Bovada) · DK Texas -122 / Ohio State +102 · Bov Texas -110 / Ohio State -110</a:t>
             </a:r>
           </a:p>
         </p:txBody>
@@ -17827,7 +17827,7 @@
                 </a:solidFill>
                 <a:latin typeface="Arial"/>
               </a:rPr>
-              <a:t>Alabama 31 – Kentucky 18</a:t>
+              <a:t>Texas 27 – Ohio State 23</a:t>
             </a:r>
           </a:p>
         </p:txBody>
@@ -17882,7 +17882,7 @@
             <a:avLst/>
           </a:prstGeom>
           <a:solidFill>
-            <a:srgbClr val="9E1632"/>
+            <a:srgbClr val="BB0000"/>
           </a:solidFill>
           <a:ln>
             <a:noFill/>
@@ -17920,13 +17920,13 @@
         <p:spPr>
           <a:xfrm>
             <a:off x="8046720" y="4754880"/>
-            <a:ext cx="633679" cy="365760"/>
+            <a:ext cx="1810512" cy="365760"/>
           </a:xfrm>
           <a:prstGeom prst="roundRect">
             <a:avLst/>
           </a:prstGeom>
           <a:solidFill>
-            <a:srgbClr val="0033A0"/>
+            <a:srgbClr val="BF5700"/>
           </a:solidFill>
           <a:ln>
             <a:noFill/>
@@ -17985,7 +17985,7 @@
                 </a:solidFill>
                 <a:latin typeface="Arial"/>
               </a:rPr>
-              <a:t>UK 21%</a:t>
+              <a:t>TEX 60%</a:t>
             </a:r>
           </a:p>
         </p:txBody>
@@ -18020,7 +18020,7 @@
                 </a:solidFill>
                 <a:latin typeface="Arial"/>
               </a:rPr>
-              <a:t>79% BAMA</a:t>
+              <a:t>40% OSU</a:t>
             </a:r>
           </a:p>
         </p:txBody>
@@ -18090,7 +18090,7 @@
                 </a:solidFill>
                 <a:latin typeface="Arial"/>
               </a:rPr>
-              <a:t>LINE MOVE  +10.5 → +10.5</a:t>
+              <a:t>LINE MOVE  –1.5 → –1.5</a:t>
             </a:r>
           </a:p>
         </p:txBody>
@@ -18125,7 +18125,7 @@
                 </a:solidFill>
                 <a:latin typeface="Arial"/>
               </a:rPr>
-              <a:t>Line movement: first-seen +10.5 (Sep 4) → now +10.5 · CLV +0</a:t>
+              <a:t>Line movement: first-seen –1.5 (Aug 18) → now –1.5 · opened –2.5 · CLV +0</a:t>
             </a:r>
           </a:p>
         </p:txBody>
@@ -18158,7 +18158,7 @@
       <p:grpSpPr/>
       <p:pic>
         <p:nvPicPr>
-          <p:cNvPr id="2" name="Picture 1" descr="alabama.png"/>
+          <p:cNvPr id="2" name="Picture 1" descr="ohiostate.png"/>
           <p:cNvPicPr>
             <a:picLocks noChangeAspect="1"/>
           </p:cNvPicPr>
@@ -18210,7 +18210,7 @@
                 </a:solidFill>
                 <a:latin typeface="Arial"/>
               </a:rPr>
-              <a:t>Alabama</a:t>
+              <a:t>Ohio State</a:t>
             </a:r>
           </a:p>
         </p:txBody>
@@ -18245,7 +18245,7 @@
                 </a:solidFill>
                 <a:latin typeface="Arial"/>
               </a:rPr>
-              <a:t>What it takes to win · Alabama at Kentucky</a:t>
+              <a:t>What it takes to win · Ohio State at Texas</a:t>
             </a:r>
           </a:p>
         </p:txBody>
@@ -18359,7 +18359,7 @@
                 </a:solidFill>
                 <a:latin typeface="Arial"/>
               </a:rPr>
-              <a:t>DeBoer, year 3 — the referendum season; Wommack year 3 on defense</a:t>
+              <a:t>Day, year 8 — NEW OC Arthur Smith (ex-Falcons HC); Patricia year two on defense</a:t>
             </a:r>
           </a:p>
         </p:txBody>
@@ -18429,7 +18429,7 @@
                 </a:solidFill>
                 <a:latin typeface="Arial"/>
               </a:rPr>
-              <a:t>NEW — Keelon Russell, RS freshman, the No. 2 recruit in the 2025 class</a:t>
+              <a:t>RETURNS — Julian Sayin, year two: No. 1 in success rate as a freshman</a:t>
             </a:r>
           </a:p>
         </p:txBody>
@@ -18499,7 +18499,7 @@
                 </a:solidFill>
                 <a:latin typeface="Arial"/>
               </a:rPr>
-              <a:t>26% back · 17 portal adds — six of the top seven OL gone, QB gone</a:t>
+              <a:t>68% of offensive production back · 17 portal adds — but 2 of 9 defensive starters return</a:t>
             </a:r>
           </a:p>
         </p:txBody>
@@ -18578,7 +18578,7 @@
                 </a:solidFill>
                 <a:latin typeface="Arial"/>
               </a:rPr>
-              <a:t>Russell's first road start — zero passing touchdowns against ECU; DeBoer's rhythm game needs him to attack the intermediate middle, not just survive</a:t>
+              <a:t>Make Arthur Smith's run game real — 237 yards at 6.8 a carry last week; if wide zone travels, Sayin plays on schedule instead of in a phone booth</a:t>
             </a:r>
           </a:p>
         </p:txBody>
@@ -18657,7 +18657,7 @@
                 </a:solidFill>
                 <a:latin typeface="Arial"/>
               </a:rPr>
-              <a:t>Run it 49 times again: 227 yards and five rushing scores last week — the rebuilt OL vs Kentucky's returning front is where an SEC road game is decided</a:t>
+              <a:t>Sayin-to-Smith vs the back end Kwiatkowski built and Muschamp inherited: McDonald, Littleton and portal corner Mascoe held this offense to 14 last year</a:t>
             </a:r>
           </a:p>
         </p:txBody>
@@ -18736,7 +18736,7 @@
                 </a:solidFill>
                 <a:latin typeface="Arial"/>
               </a:rPr>
-              <a:t>Wommack's secondary (Brown, Lee, Sabb) vs the receiver room the deep dive called a void — make Minchey hold the ball</a:t>
+              <a:t>Prove the eight-transfer defense — Russaw, Smith, Moore, Little — against the deepest skill corps in the sport; two of nine starters back is the season's real question</a:t>
             </a:r>
           </a:p>
         </p:txBody>
@@ -18815,7 +18815,7 @@
                 </a:solidFill>
                 <a:latin typeface="Arial"/>
               </a:rPr>
-              <a:t>Special teams: 107th last year and projected 109th — a 10.5-point spread at Kroger dies in hidden yards</a:t>
+              <a:t>Urgency: last year's slow-tempo offense died in the two games that mattered — play with pace, and cut the nine penalties from Week 1</a:t>
             </a:r>
           </a:p>
         </p:txBody>
@@ -18850,7 +18850,7 @@
                 </a:solidFill>
                 <a:latin typeface="Arial"/>
               </a:rPr>
-              <a:t>EP 3 · WEEK 2 · Alabama at Kentucky</a:t>
+              <a:t>EP 3 · WEEK 2 · Ohio State at Texas</a:t>
             </a:r>
           </a:p>
         </p:txBody>
@@ -23843,7 +23843,7 @@
       <p:grpSpPr/>
       <p:pic>
         <p:nvPicPr>
-          <p:cNvPr id="2" name="Picture 1" descr="kentucky.png"/>
+          <p:cNvPr id="2" name="Picture 1" descr="texas.png"/>
           <p:cNvPicPr>
             <a:picLocks noChangeAspect="1"/>
           </p:cNvPicPr>
@@ -23895,7 +23895,7 @@
                 </a:solidFill>
                 <a:latin typeface="Arial"/>
               </a:rPr>
-              <a:t>Kentucky</a:t>
+              <a:t>Texas</a:t>
             </a:r>
           </a:p>
         </p:txBody>
@@ -23930,7 +23930,7 @@
                 </a:solidFill>
                 <a:latin typeface="Arial"/>
               </a:rPr>
-              <a:t>What it takes to win · Alabama at Kentucky</a:t>
+              <a:t>What it takes to win · Ohio State at Texas</a:t>
             </a:r>
           </a:p>
         </p:txBody>
@@ -24044,7 +24044,7 @@
                 </a:solidFill>
                 <a:latin typeface="Arial"/>
               </a:rPr>
-              <a:t>NEW — Will Stein (Oregon OC) after the Stoops era ended at 5–7</a:t>
+              <a:t>Sarkisian, year 6 — NEW DC Will Muschamp (the league's riskiest coordinator swap)</a:t>
             </a:r>
           </a:p>
         </p:txBody>
@@ -24114,7 +24114,7 @@
                 </a:solidFill>
                 <a:latin typeface="Arial"/>
               </a:rPr>
-              <a:t>NEW — Kenny Minchey (Notre Dame): accurate, mobile, one start of proof</a:t>
+              <a:t>RETURNS — Arch Manning, year two as the starter; final season, Heisman favorite</a:t>
             </a:r>
           </a:p>
         </p:txBody>
@@ -24184,7 +24184,7 @@
                 </a:solidFill>
                 <a:latin typeface="Arial"/>
               </a:rPr>
-              <a:t>19% back · 31 portal adds — most on the card; six transfer OL, ten defensive starters back</a:t>
+              <a:t>72% back · 22 portal adds — the headline portal class (Coleman, Smothers, Biles, Siani)</a:t>
             </a:r>
           </a:p>
         </p:txBody>
@@ -24263,7 +24263,7 @@
                 </a:solidFill>
                 <a:latin typeface="Arial"/>
               </a:rPr>
-              <a:t>The mauling line: six transfers, 49 FBS starts, three all-conference — vs an Alabama interior that lost four of its top five tackles; Baxter and Patterson downhill</a:t>
+              <a:t>Arch on the move: designed movement is Sark's 2026 wrinkle and accuracy on the run is Arch's last flaw — Patricia's disguises will test exactly that</a:t>
             </a:r>
           </a:p>
         </p:txBody>
@@ -24342,7 +24342,7 @@
                 </a:solidFill>
                 <a:latin typeface="Arial"/>
               </a:rPr>
-              <a:t>Minchey's profile: four touchdowns, no picks, 11.1 a throw — keep it clean against the best secondary in America and the spread is in play all afternoon</a:t>
+              <a:t>Protect the interior — the 2025 OL regression was the whole story of a preseason No. 1 that missed the CFP; Ohio State's transfer front arrives Saturday</a:t>
             </a:r>
           </a:p>
         </p:txBody>
@@ -24421,7 +24421,7 @@
                 </a:solidFill>
                 <a:latin typeface="Arial"/>
               </a:rPr>
-              <a:t>The defense is the strength — ten of nineteen starters back plus Castell; make Russell win from the pocket on third-and-long</a:t>
+              <a:t>Explosives over efficiency: Coleman, Wingo, Smothers (4.4 yards after contact) vs a rally-tackle defense that squeezes chunk plays — win the big-play count</a:t>
             </a:r>
           </a:p>
         </p:txBody>
@@ -24500,7 +24500,7 @@
                 </a:solidFill>
                 <a:latin typeface="Arial"/>
               </a:rPr>
-              <a:t>Clean up the two Week 1 leaks: 3-of-8 on third down and six penalties for 70 — those are the stats that lose to Alabama</a:t>
+              <a:t>Muschamp's first real test: 349 yards allowed to Texas State is a flag; Simmons off the edge and Biles inside have to make Sayin uncomfortable early</a:t>
             </a:r>
           </a:p>
         </p:txBody>
@@ -24535,7 +24535,7 @@
                 </a:solidFill>
                 <a:latin typeface="Arial"/>
               </a:rPr>
-              <a:t>EP 3 · WEEK 2 · Alabama at Kentucky</a:t>
+              <a:t>EP 3 · WEEK 2 · Ohio State at Texas</a:t>
             </a:r>
           </a:p>
         </p:txBody>
@@ -24726,7 +24726,7 @@
       </p:sp>
       <p:pic>
         <p:nvPicPr>
-          <p:cNvPr id="6" name="Picture 5" descr="ohiostate.png"/>
+          <p:cNvPr id="6" name="Picture 5" descr="oklahoma.png"/>
           <p:cNvPicPr>
             <a:picLocks noChangeAspect="1"/>
           </p:cNvPicPr>
@@ -24794,7 +24794,7 @@
       </p:sp>
       <p:pic>
         <p:nvPicPr>
-          <p:cNvPr id="8" name="Picture 7" descr="texas.png"/>
+          <p:cNvPr id="8" name="Picture 7" descr="michigan.png"/>
           <p:cNvPicPr>
             <a:picLocks noChangeAspect="1"/>
           </p:cNvPicPr>
@@ -24846,7 +24846,7 @@
                 </a:solidFill>
                 <a:latin typeface="Arial"/>
               </a:rPr>
-              <a:t>Ohio State at Texas</a:t>
+              <a:t>Oklahoma at Michigan</a:t>
             </a:r>
           </a:p>
         </p:txBody>
@@ -24881,7 +24881,7 @@
                 </a:solidFill>
                 <a:latin typeface="Arial"/>
               </a:rPr>
-              <a:t>Texas 27 – Ohio State 23</a:t>
+              <a:t>Oklahoma 23 – Michigan 21</a:t>
             </a:r>
           </a:p>
         </p:txBody>
@@ -24916,7 +24916,7 @@
                 </a:solidFill>
                 <a:latin typeface="Arial"/>
               </a:rPr>
-              <a:t>market –1.5 / –2</a:t>
+              <a:t>market +5.5 / +5.5</a:t>
             </a:r>
           </a:p>
         </p:txBody>
@@ -25011,7 +25011,7 @@
       </p:sp>
       <p:pic>
         <p:nvPicPr>
-          <p:cNvPr id="14" name="Picture 13" descr="oklahoma.png"/>
+          <p:cNvPr id="14" name="Picture 13" descr="arizonastate.png"/>
           <p:cNvPicPr>
             <a:picLocks noChangeAspect="1"/>
           </p:cNvPicPr>
@@ -25079,7 +25079,7 @@
       </p:sp>
       <p:pic>
         <p:nvPicPr>
-          <p:cNvPr id="16" name="Picture 15" descr="michigan.png"/>
+          <p:cNvPr id="16" name="Picture 15" descr="texasam.png"/>
           <p:cNvPicPr>
             <a:picLocks noChangeAspect="1"/>
           </p:cNvPicPr>
@@ -25131,7 +25131,7 @@
                 </a:solidFill>
                 <a:latin typeface="Arial"/>
               </a:rPr>
-              <a:t>Oklahoma at Michigan</a:t>
+              <a:t>Arizona State at Texas A&amp;M</a:t>
             </a:r>
           </a:p>
         </p:txBody>
@@ -25166,7 +25166,7 @@
                 </a:solidFill>
                 <a:latin typeface="Arial"/>
               </a:rPr>
-              <a:t>Oklahoma 23 – Michigan 21</a:t>
+              <a:t>Texas A&amp;M 34 – Arizona State 17</a:t>
             </a:r>
           </a:p>
         </p:txBody>
@@ -25201,7 +25201,7 @@
                 </a:solidFill>
                 <a:latin typeface="Arial"/>
               </a:rPr>
-              <a:t>market +5.5 / +5.5</a:t>
+              <a:t>market –14.5 / –14</a:t>
             </a:r>
           </a:p>
         </p:txBody>
@@ -25296,7 +25296,7 @@
       </p:sp>
       <p:pic>
         <p:nvPicPr>
-          <p:cNvPr id="22" name="Picture 21" descr="arizonastate.png"/>
+          <p:cNvPr id="22" name="Picture 21" descr="arizona.png"/>
           <p:cNvPicPr>
             <a:picLocks noChangeAspect="1"/>
           </p:cNvPicPr>
@@ -25364,7 +25364,7 @@
       </p:sp>
       <p:pic>
         <p:nvPicPr>
-          <p:cNvPr id="24" name="Picture 23" descr="texasam.png"/>
+          <p:cNvPr id="24" name="Picture 23" descr="byu.png"/>
           <p:cNvPicPr>
             <a:picLocks noChangeAspect="1"/>
           </p:cNvPicPr>
@@ -25416,7 +25416,7 @@
                 </a:solidFill>
                 <a:latin typeface="Arial"/>
               </a:rPr>
-              <a:t>Arizona State at Texas A&amp;M</a:t>
+              <a:t>Arizona at BYU</a:t>
             </a:r>
           </a:p>
         </p:txBody>
@@ -25451,7 +25451,7 @@
                 </a:solidFill>
                 <a:latin typeface="Arial"/>
               </a:rPr>
-              <a:t>Texas A&amp;M 34 – Arizona State 17</a:t>
+              <a:t>BYU 28 – Arizona 20</a:t>
             </a:r>
           </a:p>
         </p:txBody>
@@ -25486,7 +25486,7 @@
                 </a:solidFill>
                 <a:latin typeface="Arial"/>
               </a:rPr>
-              <a:t>market –14.5 / –14</a:t>
+              <a:t>market –7.5 / –7.5</a:t>
             </a:r>
           </a:p>
         </p:txBody>
@@ -25581,7 +25581,7 @@
       </p:sp>
       <p:pic>
         <p:nvPicPr>
-          <p:cNvPr id="30" name="Picture 29" descr="arizona.png"/>
+          <p:cNvPr id="30" name="Picture 29" descr="alabama.png"/>
           <p:cNvPicPr>
             <a:picLocks noChangeAspect="1"/>
           </p:cNvPicPr>
@@ -25649,7 +25649,7 @@
       </p:sp>
       <p:pic>
         <p:nvPicPr>
-          <p:cNvPr id="32" name="Picture 31" descr="byu.png"/>
+          <p:cNvPr id="32" name="Picture 31" descr="kentucky.png"/>
           <p:cNvPicPr>
             <a:picLocks noChangeAspect="1"/>
           </p:cNvPicPr>
@@ -25701,7 +25701,7 @@
                 </a:solidFill>
                 <a:latin typeface="Arial"/>
               </a:rPr>
-              <a:t>Arizona at BYU</a:t>
+              <a:t>Alabama at Kentucky</a:t>
             </a:r>
           </a:p>
         </p:txBody>
@@ -25736,7 +25736,7 @@
                 </a:solidFill>
                 <a:latin typeface="Arial"/>
               </a:rPr>
-              <a:t>BYU 28 – Arizona 20</a:t>
+              <a:t>Alabama 31 – Kentucky 18</a:t>
             </a:r>
           </a:p>
         </p:txBody>
@@ -25771,7 +25771,7 @@
                 </a:solidFill>
                 <a:latin typeface="Arial"/>
               </a:rPr>
-              <a:t>market –7.5 / –7.5</a:t>
+              <a:t>market +10.5 / +10.5</a:t>
             </a:r>
           </a:p>
         </p:txBody>
@@ -25866,7 +25866,7 @@
       </p:sp>
       <p:pic>
         <p:nvPicPr>
-          <p:cNvPr id="38" name="Picture 37" descr="alabama.png"/>
+          <p:cNvPr id="38" name="Picture 37" descr="ohiostate.png"/>
           <p:cNvPicPr>
             <a:picLocks noChangeAspect="1"/>
           </p:cNvPicPr>
@@ -25934,7 +25934,7 @@
       </p:sp>
       <p:pic>
         <p:nvPicPr>
-          <p:cNvPr id="40" name="Picture 39" descr="kentucky.png"/>
+          <p:cNvPr id="40" name="Picture 39" descr="texas.png"/>
           <p:cNvPicPr>
             <a:picLocks noChangeAspect="1"/>
           </p:cNvPicPr>
@@ -25986,7 +25986,7 @@
                 </a:solidFill>
                 <a:latin typeface="Arial"/>
               </a:rPr>
-              <a:t>Alabama at Kentucky</a:t>
+              <a:t>Ohio State at Texas</a:t>
             </a:r>
           </a:p>
         </p:txBody>
@@ -26021,7 +26021,7 @@
                 </a:solidFill>
                 <a:latin typeface="Arial"/>
               </a:rPr>
-              <a:t>Alabama 31 – Kentucky 18</a:t>
+              <a:t>Texas 27 – Ohio State 23</a:t>
             </a:r>
           </a:p>
         </p:txBody>
@@ -26056,7 +26056,7 @@
                 </a:solidFill>
                 <a:latin typeface="Arial"/>
               </a:rPr>
-              <a:t>market +10.5 / +10.5</a:t>
+              <a:t>market –1.5 / –2</a:t>
             </a:r>
           </a:p>
         </p:txBody>
@@ -29528,7 +29528,7 @@
       </p:sp>
       <p:pic>
         <p:nvPicPr>
-          <p:cNvPr id="6" name="Picture 5" descr="ohiostate.png"/>
+          <p:cNvPr id="6" name="Picture 5" descr="oklahoma.png"/>
           <p:cNvPicPr>
             <a:picLocks noChangeAspect="1"/>
           </p:cNvPicPr>
@@ -29596,7 +29596,7 @@
       </p:sp>
       <p:pic>
         <p:nvPicPr>
-          <p:cNvPr id="8" name="Picture 7" descr="texas.png"/>
+          <p:cNvPr id="8" name="Picture 7" descr="michigan.png"/>
           <p:cNvPicPr>
             <a:picLocks noChangeAspect="1"/>
           </p:cNvPicPr>
@@ -29648,7 +29648,7 @@
                 </a:solidFill>
                 <a:latin typeface="Arial"/>
               </a:rPr>
-              <a:t>Ohio State at Texas</a:t>
+              <a:t>Oklahoma at Michigan</a:t>
             </a:r>
           </a:p>
         </p:txBody>
@@ -29683,7 +29683,7 @@
                 </a:solidFill>
                 <a:latin typeface="Arial"/>
               </a:rPr>
-              <a:t>Austin · DKR–Texas Memorial Stadium</a:t>
+              <a:t>Ann Arbor · Michigan Stadium</a:t>
             </a:r>
           </a:p>
         </p:txBody>
@@ -29718,7 +29718,7 @@
                 </a:solidFill>
                 <a:latin typeface="Arial"/>
               </a:rPr>
-              <a:t>Texas –3.5   ·   –1.5 / –2</a:t>
+              <a:t>Oklahoma –2   ·   +5.5 / +5.5</a:t>
             </a:r>
           </a:p>
         </p:txBody>
@@ -29848,7 +29848,7 @@
       </p:sp>
       <p:pic>
         <p:nvPicPr>
-          <p:cNvPr id="15" name="Picture 14" descr="oklahoma.png"/>
+          <p:cNvPr id="15" name="Picture 14" descr="arizonastate.png"/>
           <p:cNvPicPr>
             <a:picLocks noChangeAspect="1"/>
           </p:cNvPicPr>
@@ -29916,7 +29916,7 @@
       </p:sp>
       <p:pic>
         <p:nvPicPr>
-          <p:cNvPr id="17" name="Picture 16" descr="michigan.png"/>
+          <p:cNvPr id="17" name="Picture 16" descr="texasam.png"/>
           <p:cNvPicPr>
             <a:picLocks noChangeAspect="1"/>
           </p:cNvPicPr>
@@ -29968,7 +29968,7 @@
                 </a:solidFill>
                 <a:latin typeface="Arial"/>
               </a:rPr>
-              <a:t>Oklahoma at Michigan</a:t>
+              <a:t>Arizona State at Texas A&amp;M</a:t>
             </a:r>
           </a:p>
         </p:txBody>
@@ -30003,7 +30003,7 @@
                 </a:solidFill>
                 <a:latin typeface="Arial"/>
               </a:rPr>
-              <a:t>Ann Arbor · Michigan Stadium</a:t>
+              <a:t>College Station · Kyle Field</a:t>
             </a:r>
           </a:p>
         </p:txBody>
@@ -30038,7 +30038,7 @@
                 </a:solidFill>
                 <a:latin typeface="Arial"/>
               </a:rPr>
-              <a:t>Oklahoma –2   ·   +5.5 / +5.5</a:t>
+              <a:t>Texas A&amp;M –16.5   ·   –14.5 / –14</a:t>
             </a:r>
           </a:p>
         </p:txBody>
@@ -30168,7 +30168,7 @@
       </p:sp>
       <p:pic>
         <p:nvPicPr>
-          <p:cNvPr id="24" name="Picture 23" descr="arizonastate.png"/>
+          <p:cNvPr id="24" name="Picture 23" descr="arizona.png"/>
           <p:cNvPicPr>
             <a:picLocks noChangeAspect="1"/>
           </p:cNvPicPr>
@@ -30236,7 +30236,7 @@
       </p:sp>
       <p:pic>
         <p:nvPicPr>
-          <p:cNvPr id="26" name="Picture 25" descr="texasam.png"/>
+          <p:cNvPr id="26" name="Picture 25" descr="byu.png"/>
           <p:cNvPicPr>
             <a:picLocks noChangeAspect="1"/>
           </p:cNvPicPr>
@@ -30288,7 +30288,7 @@
                 </a:solidFill>
                 <a:latin typeface="Arial"/>
               </a:rPr>
-              <a:t>Arizona State at Texas A&amp;M</a:t>
+              <a:t>Arizona at BYU</a:t>
             </a:r>
           </a:p>
         </p:txBody>
@@ -30323,7 +30323,7 @@
                 </a:solidFill>
                 <a:latin typeface="Arial"/>
               </a:rPr>
-              <a:t>College Station · Kyle Field</a:t>
+              <a:t>Provo · LaVell Edwards Stadium</a:t>
             </a:r>
           </a:p>
         </p:txBody>
@@ -30358,7 +30358,7 @@
                 </a:solidFill>
                 <a:latin typeface="Arial"/>
               </a:rPr>
-              <a:t>Texas A&amp;M –16.5   ·   –14.5 / –14</a:t>
+              <a:t>BYU –8.5   ·   –7.5 / –7.5</a:t>
             </a:r>
           </a:p>
         </p:txBody>
@@ -30488,7 +30488,7 @@
       </p:sp>
       <p:pic>
         <p:nvPicPr>
-          <p:cNvPr id="33" name="Picture 32" descr="arizona.png"/>
+          <p:cNvPr id="33" name="Picture 32" descr="alabama.png"/>
           <p:cNvPicPr>
             <a:picLocks noChangeAspect="1"/>
           </p:cNvPicPr>
@@ -30556,7 +30556,7 @@
       </p:sp>
       <p:pic>
         <p:nvPicPr>
-          <p:cNvPr id="35" name="Picture 34" descr="byu.png"/>
+          <p:cNvPr id="35" name="Picture 34" descr="kentucky.png"/>
           <p:cNvPicPr>
             <a:picLocks noChangeAspect="1"/>
           </p:cNvPicPr>
@@ -30608,7 +30608,7 @@
                 </a:solidFill>
                 <a:latin typeface="Arial"/>
               </a:rPr>
-              <a:t>Arizona at BYU</a:t>
+              <a:t>Alabama at Kentucky</a:t>
             </a:r>
           </a:p>
         </p:txBody>
@@ -30643,7 +30643,7 @@
                 </a:solidFill>
                 <a:latin typeface="Arial"/>
               </a:rPr>
-              <a:t>Provo · LaVell Edwards Stadium</a:t>
+              <a:t>Lexington · Kroger Field</a:t>
             </a:r>
           </a:p>
         </p:txBody>
@@ -30678,7 +30678,7 @@
                 </a:solidFill>
                 <a:latin typeface="Arial"/>
               </a:rPr>
-              <a:t>BYU –8.5   ·   –7.5 / –7.5</a:t>
+              <a:t>Alabama –13   ·   +10.5 / +10.5</a:t>
             </a:r>
           </a:p>
         </p:txBody>
@@ -30808,7 +30808,7 @@
       </p:sp>
       <p:pic>
         <p:nvPicPr>
-          <p:cNvPr id="42" name="Picture 41" descr="alabama.png"/>
+          <p:cNvPr id="42" name="Picture 41" descr="ohiostate.png"/>
           <p:cNvPicPr>
             <a:picLocks noChangeAspect="1"/>
           </p:cNvPicPr>
@@ -30876,7 +30876,7 @@
       </p:sp>
       <p:pic>
         <p:nvPicPr>
-          <p:cNvPr id="44" name="Picture 43" descr="kentucky.png"/>
+          <p:cNvPr id="44" name="Picture 43" descr="texas.png"/>
           <p:cNvPicPr>
             <a:picLocks noChangeAspect="1"/>
           </p:cNvPicPr>
@@ -30928,7 +30928,7 @@
                 </a:solidFill>
                 <a:latin typeface="Arial"/>
               </a:rPr>
-              <a:t>Alabama at Kentucky</a:t>
+              <a:t>Ohio State at Texas</a:t>
             </a:r>
           </a:p>
         </p:txBody>
@@ -30963,7 +30963,7 @@
                 </a:solidFill>
                 <a:latin typeface="Arial"/>
               </a:rPr>
-              <a:t>Lexington · Kroger Field</a:t>
+              <a:t>Austin · DKR–Texas Memorial Stadium</a:t>
             </a:r>
           </a:p>
         </p:txBody>
@@ -30998,7 +30998,7 @@
                 </a:solidFill>
                 <a:latin typeface="Arial"/>
               </a:rPr>
-              <a:t>Alabama –13   ·   +10.5 / +10.5</a:t>
+              <a:t>Texas –3.5   ·   –1.5 / –2</a:t>
             </a:r>
           </a:p>
         </p:txBody>
@@ -32436,7 +32436,7 @@
       <p:grpSpPr/>
       <p:pic>
         <p:nvPicPr>
-          <p:cNvPr id="2" name="Picture 1" descr="ohiostate.png"/>
+          <p:cNvPr id="2" name="Picture 1" descr="oklahoma.png"/>
           <p:cNvPicPr>
             <a:picLocks noChangeAspect="1"/>
           </p:cNvPicPr>
@@ -32495,7 +32495,7 @@
       </p:sp>
       <p:pic>
         <p:nvPicPr>
-          <p:cNvPr id="4" name="Picture 3" descr="texas.png"/>
+          <p:cNvPr id="4" name="Picture 3" descr="michigan.png"/>
           <p:cNvPicPr>
             <a:picLocks noChangeAspect="1"/>
           </p:cNvPicPr>
@@ -32547,7 +32547,7 @@
                 </a:solidFill>
                 <a:latin typeface="Arial"/>
               </a:rPr>
-              <a:t>Ohio State at Texas</a:t>
+              <a:t>Oklahoma at Michigan</a:t>
             </a:r>
           </a:p>
         </p:txBody>
@@ -32582,7 +32582,7 @@
                 </a:solidFill>
                 <a:latin typeface="Arial"/>
               </a:rPr>
-              <a:t>Sat Sep 12 · 7:30 ET · No. 1 at No. 4 · the 2025 opener rematch (OSU 14–7) · Arch's last tour vs Sayin-to-Smith</a:t>
+              <a:t>Sat Sep 12 · 12:00 ET · rematch of OU's 24–13 win in Norman · Whittingham's first Big House test · the card's biggest machine-market gap</a:t>
             </a:r>
           </a:p>
         </p:txBody>
@@ -32696,7 +32696,7 @@
                 </a:solidFill>
                 <a:latin typeface="Arial"/>
               </a:rPr>
-              <a:t>The rematch of the year: Ohio State won last year's opener 14–7 in Columbus and the 2024 CFP semifinal — Texas gets it at home, at night, with Arch Manning in what is almost certainly his last season</a:t>
+              <a:t>The line swung eight points in a week: Michigan opened –1.5, survived Western Michigan 13–12 (three turnovers, 19:52 of possession) and is now +5.5 — the market re-priced a program; the machine moved 4.3</a:t>
             </a:r>
           </a:p>
         </p:txBody>
@@ -32775,7 +32775,7 @@
                 </a:solidFill>
                 <a:latin typeface="Arial"/>
               </a:rPr>
-              <a:t>Two title-or-bust rosters and one coordinator gamble each: Arthur Smith installing an NFL run game around Sayin–Smith, Will Muschamp replacing the coordinator whose defense outranked Sark's offense two years running</a:t>
+              <a:t>Two rebuilds at opposite speeds: Whittingham's Utah operating system (OC Beck, DC Hill, three Utah starters) is one game old; Venables' defense is in year five and was the SEC's best in 2025</a:t>
             </a:r>
           </a:p>
         </p:txBody>
@@ -32854,7 +32854,7 @@
                 </a:solidFill>
                 <a:latin typeface="Arial"/>
               </a:rPr>
-              <a:t>Continuity edge is Texas: 72% of its offensive production back plus the sport's most talked-about portal class (Coleman, Smothers, Biles); Ohio State returns 68% on offense but only two of nine defensive starters</a:t>
+              <a:t>The QB question is the whole show: Underwood's year-two leap (12-of-22 last week) vs Mateer's rebuilt throwing motion (11-of-17, three TDs) — both offenses are built around their QB's legs</a:t>
             </a:r>
           </a:p>
         </p:txBody>
@@ -32933,7 +32933,7 @@
                 </a:solidFill>
                 <a:latin typeface="Arial"/>
               </a:rPr>
-              <a:t>Week 1 said nothing and everything: 56–3 and 59–7 — Sayin 21-of-25, Arch 4 touchdowns — but Texas allowed 349 yards to Texas State and Ohio State took nine flags</a:t>
+              <a:t>Payback with stakes: OU won 24–13 in Norman last September; a Michigan loss at home to open Whittingham's era puts an 8–4 program's floor in play by mid-September</a:t>
             </a:r>
           </a:p>
         </p:txBody>
@@ -33012,7 +33012,7 @@
                 </a:solidFill>
                 <a:latin typeface="Arial"/>
               </a:rPr>
-              <a:t>The machine says Texas by 3.7; the market says 1.5; ESPN's own live FPI says 0.7. Three points of our number are bookkeeping — the ±28 margin cap turned 56–3 into an 'underperformance' and docked Ohio State 4.1 rating points for winning by 53. Strip the artifact and this is a pick'em plus home field, which is exactly what everyone else says. No position.</a:t>
+              <a:t>The market moved seven points on one MAC game; the pre-registered machine moved 4.3 — that gap is the entire 'edge'. It is a bet that 13–12 was noise, made about a first-year head coach and a year-two QB the July prior can't see. Lean Michigan +5.5 as research; the backtest never rewarded us for chasing chaos.</a:t>
             </a:r>
           </a:p>
         </p:txBody>
@@ -33126,7 +33126,7 @@
                 </a:solidFill>
                 <a:latin typeface="Arial"/>
               </a:rPr>
-              <a:t>Texas –3.5</a:t>
+              <a:t>Oklahoma –2</a:t>
             </a:r>
           </a:p>
         </p:txBody>
@@ -33161,7 +33161,7 @@
                 </a:solidFill>
                 <a:latin typeface="Arial"/>
               </a:rPr>
-              <a:t>Texas –150 · Ohio State +150</a:t>
+              <a:t>Michigan +118 · Oklahoma –118</a:t>
             </a:r>
           </a:p>
         </p:txBody>
@@ -33196,7 +33196,7 @@
                 </a:solidFill>
                 <a:latin typeface="Arial"/>
               </a:rPr>
-              <a:t>machine line · fair odds, no vig · raw margin Texas +3.7</a:t>
+              <a:t>machine line · fair odds, no vig · raw margin Oklahoma +1.9</a:t>
             </a:r>
           </a:p>
         </p:txBody>
@@ -33231,7 +33231,7 @@
                 </a:solidFill>
                 <a:latin typeface="Arial"/>
               </a:rPr>
-              <a:t>–1.5 / –2</a:t>
+              <a:t>+5.5 / +5.5</a:t>
             </a:r>
           </a:p>
         </p:txBody>
@@ -33266,7 +33266,7 @@
                 </a:solidFill>
                 <a:latin typeface="Arial"/>
               </a:rPr>
-              <a:t>market (DK / Bovada) · DK Texas -122 / Ohio State +102 · Bov Texas -110 / Ohio State -110</a:t>
+              <a:t>market (DK / Bovada) · DK Michigan +190 / Oklahoma -230 · Bov Michigan +175 / Oklahoma -210</a:t>
             </a:r>
           </a:p>
         </p:txBody>
@@ -33301,7 +33301,7 @@
                 </a:solidFill>
                 <a:latin typeface="Arial"/>
               </a:rPr>
-              <a:t>Texas 27 – Ohio State 23</a:t>
+              <a:t>Oklahoma 23 – Michigan 21</a:t>
             </a:r>
           </a:p>
         </p:txBody>
@@ -33356,7 +33356,7 @@
             <a:avLst/>
           </a:prstGeom>
           <a:solidFill>
-            <a:srgbClr val="BB0000"/>
+            <a:srgbClr val="841617"/>
           </a:solidFill>
           <a:ln>
             <a:noFill/>
@@ -33394,13 +33394,13 @@
         <p:spPr>
           <a:xfrm>
             <a:off x="8046720" y="4754880"/>
-            <a:ext cx="1810512" cy="365760"/>
+            <a:ext cx="1388059" cy="365760"/>
           </a:xfrm>
           <a:prstGeom prst="roundRect">
             <a:avLst/>
           </a:prstGeom>
           <a:solidFill>
-            <a:srgbClr val="BF5700"/>
+            <a:srgbClr val="00274C"/>
           </a:solidFill>
           <a:ln>
             <a:noFill/>
@@ -33459,7 +33459,7 @@
                 </a:solidFill>
                 <a:latin typeface="Arial"/>
               </a:rPr>
-              <a:t>TEX 60%</a:t>
+              <a:t>MICH 46%</a:t>
             </a:r>
           </a:p>
         </p:txBody>
@@ -33494,7 +33494,7 @@
                 </a:solidFill>
                 <a:latin typeface="Arial"/>
               </a:rPr>
-              <a:t>40% OSU</a:t>
+              <a:t>54% OU</a:t>
             </a:r>
           </a:p>
         </p:txBody>
@@ -33564,7 +33564,7 @@
                 </a:solidFill>
                 <a:latin typeface="Arial"/>
               </a:rPr>
-              <a:t>LINE MOVE  –1.5 → –1.5</a:t>
+              <a:t>LINE MOVE  –2.5 → +5.5 · CLV +8</a:t>
             </a:r>
           </a:p>
         </p:txBody>
@@ -33599,7 +33599,7 @@
                 </a:solidFill>
                 <a:latin typeface="Arial"/>
               </a:rPr>
-              <a:t>Line movement: first-seen –1.5 (Aug 18) → now –1.5 · opened –2.5 · CLV +0</a:t>
+              <a:t>Line movement: first-seen –2.5 (Aug 18) → now +5.5 · opened –1.5 · CLV +8</a:t>
             </a:r>
           </a:p>
         </p:txBody>
@@ -33632,7 +33632,7 @@
       <p:grpSpPr/>
       <p:pic>
         <p:nvPicPr>
-          <p:cNvPr id="2" name="Picture 1" descr="ohiostate.png"/>
+          <p:cNvPr id="2" name="Picture 1" descr="oklahoma.png"/>
           <p:cNvPicPr>
             <a:picLocks noChangeAspect="1"/>
           </p:cNvPicPr>
@@ -33684,7 +33684,7 @@
                 </a:solidFill>
                 <a:latin typeface="Arial"/>
               </a:rPr>
-              <a:t>Ohio State</a:t>
+              <a:t>Oklahoma</a:t>
             </a:r>
           </a:p>
         </p:txBody>
@@ -33719,7 +33719,7 @@
                 </a:solidFill>
                 <a:latin typeface="Arial"/>
               </a:rPr>
-              <a:t>What it takes to win · Ohio State at Texas</a:t>
+              <a:t>What it takes to win · Oklahoma at Michigan</a:t>
             </a:r>
           </a:p>
         </p:txBody>
@@ -33833,7 +33833,7 @@
                 </a:solidFill>
                 <a:latin typeface="Arial"/>
               </a:rPr>
-              <a:t>Day, year 8 — NEW OC Arthur Smith (ex-Falcons HC); Patricia year two on defense</a:t>
+              <a:t>Venables, year 5 — calls the defense himself; OC Arbuckle year two</a:t>
             </a:r>
           </a:p>
         </p:txBody>
@@ -33903,7 +33903,7 @@
                 </a:solidFill>
                 <a:latin typeface="Arial"/>
               </a:rPr>
-              <a:t>RETURNS — Julian Sayin, year two: No. 1 in success rate as a freshman</a:t>
+              <a:t>RETURNS — John Mateer, senior; new throwing motion after the 2025 thumb injury</a:t>
             </a:r>
           </a:p>
         </p:txBody>
@@ -33973,7 +33973,7 @@
                 </a:solidFill>
                 <a:latin typeface="Arial"/>
               </a:rPr>
-              <a:t>68% of offensive production back · 17 portal adds — but 2 of 9 defensive starters return</a:t>
+              <a:t>63% back · 16 portal adds — five OL transfers, WR room rebuilt around Sategna</a:t>
             </a:r>
           </a:p>
         </p:txBody>
@@ -34052,7 +34052,7 @@
                 </a:solidFill>
                 <a:latin typeface="Arial"/>
               </a:rPr>
-              <a:t>Make Arthur Smith's run game real — 237 yards at 6.8 a carry last week; if wide zone travels, Sayin plays on schedule instead of in a phone booth</a:t>
+              <a:t>Mateer's legs vs Jay Hill's sim pressures — the designed QB run (8 TDs in 2025) is the answer to a blitz-heavy front that punishes hesitation</a:t>
             </a:r>
           </a:p>
         </p:txBody>
@@ -34131,7 +34131,7 @@
                 </a:solidFill>
                 <a:latin typeface="Arial"/>
               </a:rPr>
-              <a:t>Sayin-to-Smith vs the back end Kwiatkowski built and Muschamp inherited: McDonald, Littleton and portal corner Mascoe held this offense to 14 last year</a:t>
+              <a:t>The five-transfer OL vs Michigan's DL two-deep — 2025's run game ranked 124th in yards per carry; 170 at 4.4 against UTEP proved nothing</a:t>
             </a:r>
           </a:p>
         </p:txBody>
@@ -34210,7 +34210,7 @@
                 </a:solidFill>
                 <a:latin typeface="Arial"/>
               </a:rPr>
-              <a:t>Prove the eight-transfer defense — Russaw, Smith, Moore, Little — against the deepest skill corps in the sport; two of nine starters back is the season's real question</a:t>
+              <a:t>Erase the bad-QB day: Underwood went 12-of-22 with a pick — Venables' back seven (Guillory, the Bowens) has to cash on the road at noon</a:t>
             </a:r>
           </a:p>
         </p:txBody>
@@ -34289,7 +34289,7 @@
                 </a:solidFill>
                 <a:latin typeface="Arial"/>
               </a:rPr>
-              <a:t>Urgency: last year's slow-tempo offense died in the two games that mattered — play with pace, and cut the nine penalties from Week 1</a:t>
+              <a:t>Hidden yards travel: 115 punt-return yards and a defensive score last week — special teams is how a 2-point machine number becomes a cover</a:t>
             </a:r>
           </a:p>
         </p:txBody>
@@ -34324,7 +34324,7 @@
                 </a:solidFill>
                 <a:latin typeface="Arial"/>
               </a:rPr>
-              <a:t>EP 3 · WEEK 2 · Ohio State at Texas</a:t>
+              <a:t>EP 3 · WEEK 2 · Oklahoma at Michigan</a:t>
             </a:r>
           </a:p>
         </p:txBody>
@@ -34357,7 +34357,7 @@
       <p:grpSpPr/>
       <p:pic>
         <p:nvPicPr>
-          <p:cNvPr id="2" name="Picture 1" descr="texas.png"/>
+          <p:cNvPr id="2" name="Picture 1" descr="michigan.png"/>
           <p:cNvPicPr>
             <a:picLocks noChangeAspect="1"/>
           </p:cNvPicPr>
@@ -34409,7 +34409,7 @@
                 </a:solidFill>
                 <a:latin typeface="Arial"/>
               </a:rPr>
-              <a:t>Texas</a:t>
+              <a:t>Michigan</a:t>
             </a:r>
           </a:p>
         </p:txBody>
@@ -34444,7 +34444,7 @@
                 </a:solidFill>
                 <a:latin typeface="Arial"/>
               </a:rPr>
-              <a:t>What it takes to win · Ohio State at Texas</a:t>
+              <a:t>What it takes to win · Oklahoma at Michigan</a:t>
             </a:r>
           </a:p>
         </p:txBody>
@@ -34558,7 +34558,7 @@
                 </a:solidFill>
                 <a:latin typeface="Arial"/>
               </a:rPr>
-              <a:t>Sarkisian, year 6 — NEW DC Will Muschamp (the league's riskiest coordinator swap)</a:t>
+              <a:t>NEW — Kyle Whittingham (Utah, 177 wins) after Moore's December firing; Beck OC, Hill DC</a:t>
             </a:r>
           </a:p>
         </p:txBody>
@@ -34628,7 +34628,7 @@
                 </a:solidFill>
                 <a:latin typeface="Arial"/>
               </a:rPr>
-              <a:t>RETURNS — Arch Manning, year two as the starter; final season, Heisman favorite</a:t>
+              <a:t>RETURNS — Bryce Underwood, year two: the No. 1 recruit's Heisman-track season</a:t>
             </a:r>
           </a:p>
         </p:txBody>
@@ -34698,7 +34698,7 @@
                 </a:solidFill>
                 <a:latin typeface="Arial"/>
               </a:rPr>
-              <a:t>72% back · 22 portal adds — the headline portal class (Coleman, Smothers, Biles, Siani)</a:t>
+              <a:t>69% back · 17 portal adds — the Utah pipeline (Daley, Snowden, Lea'ea, Buchanan)</a:t>
             </a:r>
           </a:p>
         </p:txBody>
@@ -34777,7 +34777,7 @@
                 </a:solidFill>
                 <a:latin typeface="Arial"/>
               </a:rPr>
-              <a:t>Arch on the move: designed movement is Sark's 2026 wrinkle and accuracy on the run is Arch's last flaw — Patricia's disguises will test exactly that</a:t>
+              <a:t>Own the ball — 19:52 of possession and three turnovers against a MAC team; Beck's system is built on 30-minute halves and zero gifts</a:t>
             </a:r>
           </a:p>
         </p:txBody>
@@ -34856,7 +34856,7 @@
                 </a:solidFill>
                 <a:latin typeface="Arial"/>
               </a:rPr>
-              <a:t>Protect the interior — the 2025 OL regression was the whole story of a preseason No. 1 that missed the CFP; Ohio State's transfer front arrives Saturday</a:t>
+              <a:t>Run Underwood like Dampier: 47 yards on nine carries was the first look — the QB-run leverage is the identity Whittingham imported from Utah</a:t>
             </a:r>
           </a:p>
         </p:txBody>
@@ -34935,7 +34935,7 @@
                 </a:solidFill>
                 <a:latin typeface="Arial"/>
               </a:rPr>
-              <a:t>Explosives over efficiency: Coleman, Wingo, Smothers (4.4 yards after contact) vs a rally-tackle defense that squeezes chunk plays — win the big-play count</a:t>
+              <a:t>Find receiver No. 2: Buchanan's 126 yards was the whole passing game — Marsh has to be a real target or Venables squeezes one side</a:t>
             </a:r>
           </a:p>
         </p:txBody>
@@ -35014,7 +35014,7 @@
                 </a:solidFill>
                 <a:latin typeface="Arial"/>
               </a:rPr>
-              <a:t>Muschamp's first real test: 349 yards allowed to Texas State is a flag; Simmons off the edge and Biles inside have to make Sayin uncomfortable early</a:t>
+              <a:t>Hill's defense allowed 221 yards and 4.2 per pass to WMU — bring that to Mateer's Air Raid without the explosive concessions the pressure invites</a:t>
             </a:r>
           </a:p>
         </p:txBody>
@@ -35049,7 +35049,7 @@
                 </a:solidFill>
                 <a:latin typeface="Arial"/>
               </a:rPr>
-              <a:t>EP 3 · WEEK 2 · Ohio State at Texas</a:t>
+              <a:t>EP 3 · WEEK 2 · Oklahoma at Michigan</a:t>
             </a:r>
           </a:p>
         </p:txBody>
@@ -35082,7 +35082,7 @@
       <p:grpSpPr/>
       <p:pic>
         <p:nvPicPr>
-          <p:cNvPr id="2" name="Picture 1" descr="oklahoma.png"/>
+          <p:cNvPr id="2" name="Picture 1" descr="arizonastate.png"/>
           <p:cNvPicPr>
             <a:picLocks noChangeAspect="1"/>
           </p:cNvPicPr>
@@ -35141,7 +35141,7 @@
       </p:sp>
       <p:pic>
         <p:nvPicPr>
-          <p:cNvPr id="4" name="Picture 3" descr="michigan.png"/>
+          <p:cNvPr id="4" name="Picture 3" descr="texasam.png"/>
           <p:cNvPicPr>
             <a:picLocks noChangeAspect="1"/>
           </p:cNvPicPr>
@@ -35193,7 +35193,7 @@
                 </a:solidFill>
                 <a:latin typeface="Arial"/>
               </a:rPr>
-              <a:t>Oklahoma at Michigan</a:t>
+              <a:t>Arizona State at Texas A&amp;M</a:t>
             </a:r>
           </a:p>
         </p:txBody>
@@ -35228,7 +35228,7 @@
                 </a:solidFill>
                 <a:latin typeface="Arial"/>
               </a:rPr>
-              <a:t>Sat Sep 12 · 12:00 ET · rematch of OU's 24–13 win in Norman · Whittingham's first Big House test · the card's biggest machine-market gap</a:t>
+              <a:t>Sat Sep 12 · 12:00 ET · Boley's second start vs an SEC secondary · Elko's portal-built trenches get a tempo test</a:t>
             </a:r>
           </a:p>
         </p:txBody>
@@ -35342,7 +35342,7 @@
                 </a:solidFill>
                 <a:latin typeface="Arial"/>
               </a:rPr>
-              <a:t>The line swung eight points in a week: Michigan opened –1.5, survived Western Michigan 13–12 (three turnovers, 19:52 of possession) and is now +5.5 — the market re-priced a program; the machine moved 4.3</a:t>
+              <a:t>Dillingham's post-Leavitt reboot (16% of production back — the least on the card, 24 transfers) meets an 11-win Aggie roster that kept its skill talent and rebuilt both trenches through the portal</a:t>
             </a:r>
           </a:p>
         </p:txBody>
@@ -35421,7 +35421,7 @@
                 </a:solidFill>
                 <a:latin typeface="Arial"/>
               </a:rPr>
-              <a:t>Two rebuilds at opposite speeds: Whittingham's Utah operating system (OC Beck, DC Hill, three Utah starters) is one game old; Venables' defense is in year five and was the SEC's best in 2025</a:t>
+              <a:t>Cutter Boley's debut was 21-of-27 for 387 and six touchdowns — against Morgan State; Kyle Field at noon with Elko's disguises is the real audition</a:t>
             </a:r>
           </a:p>
         </p:txBody>
@@ -35500,7 +35500,7 @@
                 </a:solidFill>
                 <a:latin typeface="Arial"/>
               </a:rPr>
-              <a:t>The QB question is the whole show: Underwood's year-two leap (12-of-22 last week) vs Mateer's rebuilt throwing motion (11-of-17, three TDs) — both offenses are built around their QB's legs</a:t>
+              <a:t>A&amp;M's story is its lines: six of the top seven OL and five of seven DL are gone, replaced by transfers with 42 combined SEC starts — a tempo offense is the stress test they'd choose least</a:t>
             </a:r>
           </a:p>
         </p:txBody>
@@ -35579,7 +35579,7 @@
                 </a:solidFill>
                 <a:latin typeface="Arial"/>
               </a:rPr>
-              <a:t>Payback with stakes: OU won 24–13 in Norman last September; a Michigan loss at home to open Whittingham's era puts an 8–4 program's floor in play by mid-September</a:t>
+              <a:t>Neither rating has a 2026 snap in it: both teams beat FCS opponents the machine doesn't rate, so this number is July's prior plus home field — and the market agrees within two points</a:t>
             </a:r>
           </a:p>
         </p:txBody>
@@ -35658,7 +35658,7 @@
                 </a:solidFill>
                 <a:latin typeface="Arial"/>
               </a:rPr>
-              <a:t>The market moved seven points on one MAC game; the pre-registered machine moved 4.3 — that gap is the entire 'edge'. It is a bet that 13–12 was noise, made about a first-year head coach and a year-two QB the July prior can't see. Lean Michigan +5.5 as research; the backtest never rewarded us for chasing chaos.</a:t>
+              <a:t>Machine –16.7, market –14.5: two points apart on a 14-point spread is agreement. The 70–7 and 50–0 scores are zero evidence — FCS opponents aren't rated, so neither team's number moved. The scouting risk the prior can't price is Reed's turnover habit (four picks in last year's two losses) against a 3-3-5 that gambles for exactly that.</a:t>
             </a:r>
           </a:p>
         </p:txBody>
@@ -35772,7 +35772,7 @@
                 </a:solidFill>
                 <a:latin typeface="Arial"/>
               </a:rPr>
-              <a:t>Oklahoma –2</a:t>
+              <a:t>Texas A&amp;M –16.5</a:t>
             </a:r>
           </a:p>
         </p:txBody>
@@ -35807,7 +35807,7 @@
                 </a:solidFill>
                 <a:latin typeface="Arial"/>
               </a:rPr>
-              <a:t>Michigan +118 · Oklahoma –118</a:t>
+              <a:t>Texas A&amp;M –560 · Arizona State +560</a:t>
             </a:r>
           </a:p>
         </p:txBody>
@@ -35842,7 +35842,7 @@
                 </a:solidFill>
                 <a:latin typeface="Arial"/>
               </a:rPr>
-              <a:t>machine line · fair odds, no vig · raw margin Oklahoma +1.9</a:t>
+              <a:t>machine line · fair odds, no vig · raw margin Texas A&amp;M +16.7</a:t>
             </a:r>
           </a:p>
         </p:txBody>
@@ -35877,7 +35877,7 @@
                 </a:solidFill>
                 <a:latin typeface="Arial"/>
               </a:rPr>
-              <a:t>+5.5 / +5.5</a:t>
+              <a:t>–14.5 / –14</a:t>
             </a:r>
           </a:p>
         </p:txBody>
@@ -35912,7 +35912,7 @@
                 </a:solidFill>
                 <a:latin typeface="Arial"/>
               </a:rPr>
-              <a:t>market (DK / Bovada) · DK Michigan +190 / Oklahoma -230 · Bov Michigan +175 / Oklahoma -210</a:t>
+              <a:t>market (DK / Bovada) · DK Texas A&amp;M -650 / Arizona State +470 · Bov Texas A&amp;M -650 / Arizona State +450</a:t>
             </a:r>
           </a:p>
         </p:txBody>
@@ -35947,7 +35947,7 @@
                 </a:solidFill>
                 <a:latin typeface="Arial"/>
               </a:rPr>
-              <a:t>Oklahoma 23 – Michigan 21</a:t>
+              <a:t>Texas A&amp;M 34 – Arizona State 17</a:t>
             </a:r>
           </a:p>
         </p:txBody>
@@ -36002,7 +36002,7 @@
             <a:avLst/>
           </a:prstGeom>
           <a:solidFill>
-            <a:srgbClr val="841617"/>
+            <a:srgbClr val="8C1D40"/>
           </a:solidFill>
           <a:ln>
             <a:noFill/>
@@ -36040,13 +36040,13 @@
         <p:spPr>
           <a:xfrm>
             <a:off x="8046720" y="4754880"/>
-            <a:ext cx="1388059" cy="365760"/>
+            <a:ext cx="2564892" cy="365760"/>
           </a:xfrm>
           <a:prstGeom prst="roundRect">
             <a:avLst/>
           </a:prstGeom>
           <a:solidFill>
-            <a:srgbClr val="00274C"/>
+            <a:srgbClr val="500000"/>
           </a:solidFill>
           <a:ln>
             <a:noFill/>
@@ -36105,7 +36105,7 @@
                 </a:solidFill>
                 <a:latin typeface="Arial"/>
               </a:rPr>
-              <a:t>MICH 46%</a:t>
+              <a:t>TAMU 85%</a:t>
             </a:r>
           </a:p>
         </p:txBody>
@@ -36140,7 +36140,7 @@
                 </a:solidFill>
                 <a:latin typeface="Arial"/>
               </a:rPr>
-              <a:t>54% OU</a:t>
+              <a:t>15% ASU</a:t>
             </a:r>
           </a:p>
         </p:txBody>
@@ -36210,7 +36210,7 @@
                 </a:solidFill>
                 <a:latin typeface="Arial"/>
               </a:rPr>
-              <a:t>LINE MOVE  –2.5 → +5.5 · CLV +8</a:t>
+              <a:t>LINE MOVE  –14.5 → –14.5</a:t>
             </a:r>
           </a:p>
         </p:txBody>
@@ -36245,7 +36245,7 @@
                 </a:solidFill>
                 <a:latin typeface="Arial"/>
               </a:rPr>
-              <a:t>Line movement: first-seen –2.5 (Aug 18) → now +5.5 · opened –1.5 · CLV +8</a:t>
+              <a:t>Line movement: first-seen –14.5 (Aug 23) → now –14.5 · CLV +0</a:t>
             </a:r>
           </a:p>
         </p:txBody>

</xml_diff>

<commit_message>
Deck template: slide text is the headline only (SHORT overlay per game; 24pt keys, one-line WHY IT MATTERS, one-sentence honesty box); long form stays in GAMES + notes. Local rebuild only - Ep3 Slides file is the record
Co-Authored-By: Claude Fable 5.1 <noreply@anthropic.com>
</commit_message>
<xml_diff>
--- a/decks/2026_Week2_Episode3.pptx
+++ b/decks/2026_Week2_Episode3.pptx
@@ -10574,7 +10574,7 @@
         </p:nvSpPr>
         <p:spPr>
           <a:xfrm>
-            <a:off x="914400" y="3218688"/>
+            <a:off x="914400" y="3291840"/>
             <a:ext cx="137160" cy="137160"/>
           </a:xfrm>
           <a:prstGeom prst="ellipse">
@@ -10634,13 +10634,13 @@
           <a:p>
             <a:pPr algn="l"/>
             <a:r>
-              <a:rPr sz="1550" b="0" i="0">
+              <a:rPr sz="2400" b="1" i="0">
                 <a:solidFill>
                   <a:srgbClr val="16273D"/>
                 </a:solidFill>
                 <a:latin typeface="Arial"/>
               </a:rPr>
-              <a:t>Tempo the transfer defensive line — five new starters up front are the one A&amp;M unit that hasn't played together; 4-of-5 on fourth down says Dillingham will push it</a:t>
+              <a:t>Tempo the transfer front</a:t>
             </a:r>
           </a:p>
         </p:txBody>
@@ -10653,7 +10653,7 @@
         </p:nvSpPr>
         <p:spPr>
           <a:xfrm>
-            <a:off x="914400" y="4059936"/>
+            <a:off x="914400" y="4133088"/>
             <a:ext cx="137160" cy="137160"/>
           </a:xfrm>
           <a:prstGeom prst="ellipse">
@@ -10713,13 +10713,13 @@
           <a:p>
             <a:pPr algn="l"/>
             <a:r>
-              <a:rPr sz="1550" b="0" i="0">
+              <a:rPr sz="2400" b="1" i="0">
                 <a:solidFill>
                   <a:srgbClr val="16273D"/>
                 </a:solidFill>
                 <a:latin typeface="Arial"/>
               </a:rPr>
-              <a:t>Boley's second start against real disguise: Ricks, Ratcliffe, Brooks and portal corner Gibson rotate late — the six-touchdown debut came against Morgan State</a:t>
+              <a:t>Boley vs real disguise</a:t>
             </a:r>
           </a:p>
         </p:txBody>
@@ -10732,7 +10732,7 @@
         </p:nvSpPr>
         <p:spPr>
           <a:xfrm>
-            <a:off x="914400" y="4901184"/>
+            <a:off x="914400" y="4974336"/>
             <a:ext cx="137160" cy="137160"/>
           </a:xfrm>
           <a:prstGeom prst="ellipse">
@@ -10792,13 +10792,13 @@
           <a:p>
             <a:pPr algn="l"/>
             <a:r>
-              <a:rPr sz="1550" b="0" i="0">
+              <a:rPr sz="2400" b="1" i="0">
                 <a:solidFill>
                   <a:srgbClr val="16273D"/>
                 </a:solidFill>
                 <a:latin typeface="Arial"/>
               </a:rPr>
-              <a:t>Contain before you gamble: the 3-3-5 is undersized by design, and Reed's designed run in the red zone is exactly what it concedes</a:t>
+              <a:t>Contain before you gamble</a:t>
             </a:r>
           </a:p>
         </p:txBody>
@@ -10811,7 +10811,7 @@
         </p:nvSpPr>
         <p:spPr>
           <a:xfrm>
-            <a:off x="914400" y="5742432"/>
+            <a:off x="914400" y="5815584"/>
             <a:ext cx="137160" cy="137160"/>
           </a:xfrm>
           <a:prstGeom prst="ellipse">
@@ -10871,13 +10871,13 @@
           <a:p>
             <a:pPr algn="l"/>
             <a:r>
-              <a:rPr sz="1550" b="0" i="0">
+              <a:rPr sz="2400" b="1" i="0">
                 <a:solidFill>
                   <a:srgbClr val="16273D"/>
                 </a:solidFill>
                 <a:latin typeface="Arial"/>
               </a:rPr>
-              <a:t>Fix special teams (No. 125 last year) — at Kyle Field a +14.5 cover lives or dies in field position</a:t>
+              <a:t>Fix special teams</a:t>
             </a:r>
           </a:p>
         </p:txBody>
@@ -11299,7 +11299,7 @@
         </p:nvSpPr>
         <p:spPr>
           <a:xfrm>
-            <a:off x="914400" y="3218688"/>
+            <a:off x="914400" y="3291840"/>
             <a:ext cx="137160" cy="137160"/>
           </a:xfrm>
           <a:prstGeom prst="ellipse">
@@ -11359,13 +11359,13 @@
           <a:p>
             <a:pPr algn="l"/>
             <a:r>
-              <a:rPr sz="1550" b="0" i="0">
+              <a:rPr sz="2400" b="1" i="0">
                 <a:solidFill>
                   <a:srgbClr val="16273D"/>
                 </a:solidFill>
                 <a:latin typeface="Arial"/>
               </a:rPr>
-              <a:t>Reed's ball security — 12 picks last year, four in the two losses; a gambling defense wants the hero throw, take the checkdown</a:t>
+              <a:t>Reed's ball security</a:t>
             </a:r>
           </a:p>
         </p:txBody>
@@ -11378,7 +11378,7 @@
         </p:nvSpPr>
         <p:spPr>
           <a:xfrm>
-            <a:off x="914400" y="4059936"/>
+            <a:off x="914400" y="4133088"/>
             <a:ext cx="137160" cy="137160"/>
           </a:xfrm>
           <a:prstGeom prst="ellipse">
@@ -11438,13 +11438,13 @@
           <a:p>
             <a:pPr algn="l"/>
             <a:r>
-              <a:rPr sz="1550" b="0" i="0">
+              <a:rPr sz="2400" b="1" i="0">
                 <a:solidFill>
                   <a:srgbClr val="16273D"/>
                 </a:solidFill>
                 <a:latin typeface="Arial"/>
               </a:rPr>
-              <a:t>Prove the portal OL: 236 rushing yards at 5.0 and 43 minutes of possession last week — run it 45 times again against a light front</a:t>
+              <a:t>Prove the portal line</a:t>
             </a:r>
           </a:p>
         </p:txBody>
@@ -11457,7 +11457,7 @@
         </p:nvSpPr>
         <p:spPr>
           <a:xfrm>
-            <a:off x="914400" y="4901184"/>
+            <a:off x="914400" y="4974336"/>
             <a:ext cx="137160" cy="137160"/>
           </a:xfrm>
           <a:prstGeom prst="ellipse">
@@ -11517,13 +11517,13 @@
           <a:p>
             <a:pPr algn="l"/>
             <a:r>
-              <a:rPr sz="1550" b="0" i="0">
+              <a:rPr sz="2400" b="1" i="0">
                 <a:solidFill>
                   <a:srgbClr val="16273D"/>
                 </a:solidFill>
                 <a:latin typeface="Arial"/>
               </a:rPr>
-              <a:t>Havoc from the new front — Saka (12.5% pressure rate) and Henderson vs a QB making his second start</a:t>
+              <a:t>Havoc from the new front</a:t>
             </a:r>
           </a:p>
         </p:txBody>
@@ -11536,7 +11536,7 @@
         </p:nvSpPr>
         <p:spPr>
           <a:xfrm>
-            <a:off x="914400" y="5742432"/>
+            <a:off x="914400" y="5815584"/>
             <a:ext cx="137160" cy="137160"/>
           </a:xfrm>
           <a:prstGeom prst="ellipse">
@@ -11596,13 +11596,13 @@
           <a:p>
             <a:pPr algn="l"/>
             <a:r>
-              <a:rPr sz="1550" b="0" i="0">
+              <a:rPr sz="2400" b="1" i="0">
                 <a:solidFill>
                   <a:srgbClr val="16273D"/>
                 </a:solidFill>
                 <a:latin typeface="Arial"/>
               </a:rPr>
-              <a:t>Finish drives and cut the flags (8 for 75 last week) — style points are the whole game when the spread is 14.5</a:t>
+              <a:t>Finish drives, cut the flags</a:t>
             </a:r>
           </a:p>
         </p:txBody>
@@ -11864,7 +11864,7 @@
         </p:nvSpPr>
         <p:spPr>
           <a:xfrm>
-            <a:off x="868680" y="2139696"/>
+            <a:off x="868680" y="2176272"/>
             <a:ext cx="128016" cy="128016"/>
           </a:xfrm>
           <a:prstGeom prst="ellipse">
@@ -11924,13 +11924,13 @@
           <a:p>
             <a:pPr algn="l"/>
             <a:r>
-              <a:rPr sz="1350" b="0" i="0">
+              <a:rPr sz="1600" b="0" i="0">
                 <a:solidFill>
                   <a:srgbClr val="16273D"/>
                 </a:solidFill>
                 <a:latin typeface="Arial"/>
               </a:rPr>
-              <a:t>The Big 12's continuity kings: BYU returns 79% of its production and 177 starts — most in the league — with Bachmeier in year two; Arizona returns the QB (Fifita, 9,183 career yards) and eleven defensive starters</a:t>
+              <a:t>The Big 12's continuity kings: 79% back, 177 starts</a:t>
             </a:r>
           </a:p>
         </p:txBody>
@@ -11943,7 +11943,7 @@
         </p:nvSpPr>
         <p:spPr>
           <a:xfrm>
-            <a:off x="868680" y="2852928"/>
+            <a:off x="868680" y="2889504"/>
             <a:ext cx="128016" cy="128016"/>
           </a:xfrm>
           <a:prstGeom prst="ellipse">
@@ -12003,13 +12003,13 @@
           <a:p>
             <a:pPr algn="l"/>
             <a:r>
-              <a:rPr sz="1350" b="0" i="0">
+              <a:rPr sz="1600" b="0" i="0">
                 <a:solidFill>
                   <a:srgbClr val="16273D"/>
                 </a:solidFill>
                 <a:latin typeface="Arial"/>
               </a:rPr>
-              <a:t>Provo's biggest home game in program memory until Notre Dame arrives: a 12-win team that lost twice, both to Texas Tech, opens the league with the one opponent that 'plays everybody'</a:t>
+              <a:t>Provo's biggest home game until Notre Dame</a:t>
             </a:r>
           </a:p>
         </p:txBody>
@@ -12022,7 +12022,7 @@
         </p:nvSpPr>
         <p:spPr>
           <a:xfrm>
-            <a:off x="868680" y="3566160"/>
+            <a:off x="868680" y="3602736"/>
             <a:ext cx="128016" cy="128016"/>
           </a:xfrm>
           <a:prstGeom prst="ellipse">
@@ -12082,13 +12082,13 @@
           <a:p>
             <a:pPr algn="l"/>
             <a:r>
-              <a:rPr sz="1350" b="0" i="0">
+              <a:rPr sz="1600" b="0" i="0">
                 <a:solidFill>
                   <a:srgbClr val="16273D"/>
                 </a:solidFill>
                 <a:latin typeface="Arial"/>
               </a:rPr>
-              <a:t>The coordinator change is BYU's: Jay Hill took the 3-3-5 to Michigan and Poppinga inherits ten rotation defenders — Fifita is the first quarterback who can make that matter</a:t>
+              <a:t>BYU's coordinator change: Poppinga replaces Hill</a:t>
             </a:r>
           </a:p>
         </p:txBody>
@@ -12101,7 +12101,7 @@
         </p:nvSpPr>
         <p:spPr>
           <a:xfrm>
-            <a:off x="868680" y="4279392"/>
+            <a:off x="868680" y="4315968"/>
             <a:ext cx="128016" cy="128016"/>
           </a:xfrm>
           <a:prstGeom prst="ellipse">
@@ -12161,13 +12161,13 @@
           <a:p>
             <a:pPr algn="l"/>
             <a:r>
-              <a:rPr sz="1350" b="0" i="0">
+              <a:rPr sz="1600" b="0" i="0">
                 <a:solidFill>
                   <a:srgbClr val="16273D"/>
                 </a:solidFill>
                 <a:latin typeface="Arial"/>
               </a:rPr>
-              <a:t>Week 1 receipts: BYU ran for 308 at 6.7 and forced four turnovers; Arizona put up 520 yards but coughed it up three times — the exact ledger this spread is built on</a:t>
+              <a:t>Week 1: BYU ran for 308 and took four; Arizona gave three away</a:t>
             </a:r>
           </a:p>
         </p:txBody>
@@ -12240,13 +12240,13 @@
           <a:p>
             <a:pPr algn="l"/>
             <a:r>
-              <a:rPr sz="1150" b="0" i="1">
+              <a:rPr sz="1300" b="0" i="1">
                 <a:solidFill>
                   <a:srgbClr val="5C6B7E"/>
                 </a:solidFill>
                 <a:latin typeface="Arial"/>
               </a:rPr>
-              <a:t>Machine –8.4, market –7.5: agreement. Both ratings are still the July prior — Utah Tech and Northern Arizona aren't rated, so 63–7 and 35–7 moved nothing. BYU has won three straight in the series and the honest lean is that its 79% continuity is the most reliable number on this card; the caveat is a first-time coordinator on the side of the ball that made BYU's last two years.</a:t>
+              <a:t>Machine 8.4, market 7.5, both still the July prior — no play.</a:t>
             </a:r>
           </a:p>
         </p:txBody>
@@ -13220,7 +13220,7 @@
         </p:nvSpPr>
         <p:spPr>
           <a:xfrm>
-            <a:off x="914400" y="3218688"/>
+            <a:off x="914400" y="3291840"/>
             <a:ext cx="137160" cy="137160"/>
           </a:xfrm>
           <a:prstGeom prst="ellipse">
@@ -13280,13 +13280,13 @@
           <a:p>
             <a:pPr algn="l"/>
             <a:r>
-              <a:rPr sz="1550" b="0" i="0">
+              <a:rPr sz="2400" b="1" i="0">
                 <a:solidFill>
                   <a:srgbClr val="16273D"/>
                 </a:solidFill>
                 <a:latin typeface="Arial"/>
               </a:rPr>
-              <a:t>Attack Poppinga's first game plan — hit the corners early with Fifita's quick game before the disguises settle in</a:t>
+              <a:t>Attack Poppinga early</a:t>
             </a:r>
           </a:p>
         </p:txBody>
@@ -13299,7 +13299,7 @@
         </p:nvSpPr>
         <p:spPr>
           <a:xfrm>
-            <a:off x="914400" y="4059936"/>
+            <a:off x="914400" y="4133088"/>
             <a:ext cx="137160" cy="137160"/>
           </a:xfrm>
           <a:prstGeom prst="ellipse">
@@ -13359,13 +13359,13 @@
           <a:p>
             <a:pPr algn="l"/>
             <a:r>
-              <a:rPr sz="1550" b="0" i="0">
+              <a:rPr sz="2400" b="1" i="0">
                 <a:solidFill>
                   <a:srgbClr val="16273D"/>
                 </a:solidFill>
                 <a:latin typeface="Arial"/>
               </a:rPr>
-              <a:t>Front-six physicality: BYU ran for 308 last week and LJ Martin is a 1,300-yard back — the rebuilt front has to hold the line or the play-action never gets tested</a:t>
+              <a:t>Hold the line vs Martin</a:t>
             </a:r>
           </a:p>
         </p:txBody>
@@ -13378,7 +13378,7 @@
         </p:nvSpPr>
         <p:spPr>
           <a:xfrm>
-            <a:off x="914400" y="4901184"/>
+            <a:off x="914400" y="4974336"/>
             <a:ext cx="137160" cy="137160"/>
           </a:xfrm>
           <a:prstGeom prst="ellipse">
@@ -13438,13 +13438,13 @@
           <a:p>
             <a:pPr algn="l"/>
             <a:r>
-              <a:rPr sz="1550" b="0" i="0">
+              <a:rPr sz="2400" b="1" i="0">
                 <a:solidFill>
                   <a:srgbClr val="16273D"/>
                 </a:solidFill>
                 <a:latin typeface="Arial"/>
               </a:rPr>
-              <a:t>Ball security — three giveaways against Northern Arizona; BYU's defense manufactured four takeaways and a touchdown last week</a:t>
+              <a:t>Ball security</a:t>
             </a:r>
           </a:p>
         </p:txBody>
@@ -13457,7 +13457,7 @@
         </p:nvSpPr>
         <p:spPr>
           <a:xfrm>
-            <a:off x="914400" y="5742432"/>
+            <a:off x="914400" y="5815584"/>
             <a:ext cx="137160" cy="137160"/>
           </a:xfrm>
           <a:prstGeom prst="ellipse">
@@ -13517,13 +13517,13 @@
           <a:p>
             <a:pPr algn="l"/>
             <a:r>
-              <a:rPr sz="1550" b="0" i="0">
+              <a:rPr sz="2400" b="1" i="0">
                 <a:solidFill>
                   <a:srgbClr val="16273D"/>
                 </a:solidFill>
                 <a:latin typeface="Arial"/>
               </a:rPr>
-              <a:t>Play the field-position game Brennan wins — a top-tier secondary, fourth-down aggression, and the hidden yards decide a 7.5-point spread in Provo</a:t>
+              <a:t>Win field position</a:t>
             </a:r>
           </a:p>
         </p:txBody>
@@ -13945,7 +13945,7 @@
         </p:nvSpPr>
         <p:spPr>
           <a:xfrm>
-            <a:off x="914400" y="3218688"/>
+            <a:off x="914400" y="3291840"/>
             <a:ext cx="137160" cy="137160"/>
           </a:xfrm>
           <a:prstGeom prst="ellipse">
@@ -14005,13 +14005,13 @@
           <a:p>
             <a:pPr algn="l"/>
             <a:r>
-              <a:rPr sz="1550" b="0" i="0">
+              <a:rPr sz="2400" b="1" i="0">
                 <a:solidFill>
                   <a:srgbClr val="16273D"/>
                 </a:solidFill>
                 <a:latin typeface="Arial"/>
               </a:rPr>
-              <a:t>Run first, then punish: Bachmeier's QB-run and deep play-action beat single-high all last year — Arizona's secondary is the first one that will make him earn it</a:t>
+              <a:t>Run first, then punish</a:t>
             </a:r>
           </a:p>
         </p:txBody>
@@ -14024,7 +14024,7 @@
         </p:nvSpPr>
         <p:spPr>
           <a:xfrm>
-            <a:off x="914400" y="4059936"/>
+            <a:off x="914400" y="4133088"/>
             <a:ext cx="137160" cy="137160"/>
           </a:xfrm>
           <a:prstGeom prst="ellipse">
@@ -14084,13 +14084,13 @@
           <a:p>
             <a:pPr algn="l"/>
             <a:r>
-              <a:rPr sz="1550" b="0" i="0">
+              <a:rPr sz="2400" b="1" i="0">
                 <a:solidFill>
                   <a:srgbClr val="16273D"/>
                 </a:solidFill>
                 <a:latin typeface="Arial"/>
               </a:rPr>
-              <a:t>Martin and Eka behind four returning linemen — 6.7 a carry last week; this is where the continuity edge shows up on the field</a:t>
+              <a:t>Martin and Eka behind the veterans</a:t>
             </a:r>
           </a:p>
         </p:txBody>
@@ -14103,7 +14103,7 @@
         </p:nvSpPr>
         <p:spPr>
           <a:xfrm>
-            <a:off x="914400" y="4901184"/>
+            <a:off x="914400" y="4974336"/>
             <a:ext cx="137160" cy="137160"/>
           </a:xfrm>
           <a:prstGeom prst="ellipse">
@@ -14163,13 +14163,13 @@
           <a:p>
             <a:pPr algn="l"/>
             <a:r>
-              <a:rPr sz="1550" b="0" i="0">
+              <a:rPr sz="2400" b="1" i="0">
                 <a:solidFill>
                   <a:srgbClr val="16273D"/>
                 </a:solidFill>
                 <a:latin typeface="Arial"/>
               </a:rPr>
-              <a:t>Prove the new receivers: Glasker (65 yards, two scores) and Kasper stepped in for the departed top three — a real secondary is the first real test</a:t>
+              <a:t>Prove the new receivers</a:t>
             </a:r>
           </a:p>
         </p:txBody>
@@ -14182,7 +14182,7 @@
         </p:nvSpPr>
         <p:spPr>
           <a:xfrm>
-            <a:off x="914400" y="5742432"/>
+            <a:off x="914400" y="5815584"/>
             <a:ext cx="137160" cy="137160"/>
           </a:xfrm>
           <a:prstGeom prst="ellipse">
@@ -14242,13 +14242,13 @@
           <a:p>
             <a:pPr algn="l"/>
             <a:r>
-              <a:rPr sz="1550" b="0" i="0">
+              <a:rPr sz="2400" b="1" i="0">
                 <a:solidFill>
                   <a:srgbClr val="16273D"/>
                 </a:solidFill>
                 <a:latin typeface="Arial"/>
               </a:rPr>
-              <a:t>Win the hidden margin — 183 return yards and a defensive score last week; against a team that turned it over three times, takeaways are the cover</a:t>
+              <a:t>Win the hidden margin</a:t>
             </a:r>
           </a:p>
         </p:txBody>
@@ -14510,7 +14510,7 @@
         </p:nvSpPr>
         <p:spPr>
           <a:xfrm>
-            <a:off x="868680" y="2139696"/>
+            <a:off x="868680" y="2176272"/>
             <a:ext cx="128016" cy="128016"/>
           </a:xfrm>
           <a:prstGeom prst="ellipse">
@@ -14570,13 +14570,13 @@
           <a:p>
             <a:pPr algn="l"/>
             <a:r>
-              <a:rPr sz="1350" b="0" i="0">
+              <a:rPr sz="1600" b="0" i="0">
                 <a:solidFill>
                   <a:srgbClr val="16273D"/>
                 </a:solidFill>
                 <a:latin typeface="Arial"/>
               </a:rPr>
-              <a:t>DeBoer's referendum year opens on the road with a redshirt-freshman quarterback: Russell went 18-of-30 for 256 with zero touchdowns in the opener — the offense scored five rushing TDs instead</a:t>
+              <a:t>DeBoer's referendum year opens on the road with a freshman QB</a:t>
             </a:r>
           </a:p>
         </p:txBody>
@@ -14589,7 +14589,7 @@
         </p:nvSpPr>
         <p:spPr>
           <a:xfrm>
-            <a:off x="868680" y="2852928"/>
+            <a:off x="868680" y="2889504"/>
             <a:ext cx="128016" cy="128016"/>
           </a:xfrm>
           <a:prstGeom prst="ellipse">
@@ -14649,13 +14649,13 @@
           <a:p>
             <a:pPr algn="l"/>
             <a:r>
-              <a:rPr sz="1350" b="0" i="0">
+              <a:rPr sz="1600" b="0" i="0">
                 <a:solidFill>
                   <a:srgbClr val="16273D"/>
                 </a:solidFill>
                 <a:latin typeface="Arial"/>
               </a:rPr>
-              <a:t>Will Stein's Kentucky is the anti-Stoops: motion, pace, a Notre Dame transfer QB (Minchey: 301 yards, four TDs in the debut) behind six transfer linemen averaging 6-5, 323</a:t>
+              <a:t>Stein's anti-Stoops: pace, motion, a transfer line</a:t>
             </a:r>
           </a:p>
         </p:txBody>
@@ -14668,7 +14668,7 @@
         </p:nvSpPr>
         <p:spPr>
           <a:xfrm>
-            <a:off x="868680" y="3566160"/>
+            <a:off x="868680" y="3602736"/>
             <a:ext cx="128016" cy="128016"/>
           </a:xfrm>
           <a:prstGeom prst="ellipse">
@@ -14728,13 +14728,13 @@
           <a:p>
             <a:pPr algn="l"/>
             <a:r>
-              <a:rPr sz="1350" b="0" i="0">
+              <a:rPr sz="1600" b="0" i="0">
                 <a:solidFill>
                   <a:srgbClr val="16273D"/>
                 </a:solidFill>
                 <a:latin typeface="Arial"/>
               </a:rPr>
-              <a:t>Continuity is the card's lowest on both sides: Alabama returns 26% of its offensive production, Kentucky 19% — 31 transfers in Lexington, the most of anyone we cover this week</a:t>
+              <a:t>Lowest continuity on the card, both sides</a:t>
             </a:r>
           </a:p>
         </p:txBody>
@@ -14747,7 +14747,7 @@
         </p:nvSpPr>
         <p:spPr>
           <a:xfrm>
-            <a:off x="868680" y="4279392"/>
+            <a:off x="868680" y="4315968"/>
             <a:ext cx="128016" cy="128016"/>
           </a:xfrm>
           <a:prstGeom prst="ellipse">
@@ -14807,13 +14807,13 @@
           <a:p>
             <a:pPr algn="l"/>
             <a:r>
-              <a:rPr sz="1350" b="0" i="0">
+              <a:rPr sz="1600" b="0" i="0">
                 <a:solidFill>
                   <a:srgbClr val="16273D"/>
                 </a:solidFill>
                 <a:latin typeface="Arial"/>
               </a:rPr>
-              <a:t>The market's early landmine: the deep dive called Kentucky Week 2 one of three early traps — Alabama lost its opener a year ago and DeBoer has lost as many games in two years as Saban did in five</a:t>
+              <a:t>The deep dive called this an early landmine</a:t>
             </a:r>
           </a:p>
         </p:txBody>
@@ -14886,13 +14886,13 @@
           <a:p>
             <a:pPr algn="l"/>
             <a:r>
-              <a:rPr sz="1150" b="0" i="1">
+              <a:rPr sz="1300" b="0" i="1">
                 <a:solidFill>
                   <a:srgbClr val="5C6B7E"/>
                 </a:solidFill>
                 <a:latin typeface="Arial"/>
               </a:rPr>
-              <a:t>Machine –13.2, market –10.5: 2.7 to Alabama sits right at the noise line, and it comes with the two hedges a prior can't price — a teenager's first road start and a year-one head coach whose rating has zero 2026 snaps in it (Youngstown State isn't rated). Treat it as a quibble; the real information arrives at 3:30.</a:t>
+              <a:t>2.7 to Alabama sits right at the noise line — quibble, not a position.</a:t>
             </a:r>
           </a:p>
         </p:txBody>
@@ -15866,7 +15866,7 @@
         </p:nvSpPr>
         <p:spPr>
           <a:xfrm>
-            <a:off x="914400" y="3218688"/>
+            <a:off x="914400" y="3291840"/>
             <a:ext cx="137160" cy="137160"/>
           </a:xfrm>
           <a:prstGeom prst="ellipse">
@@ -15926,13 +15926,13 @@
           <a:p>
             <a:pPr algn="l"/>
             <a:r>
-              <a:rPr sz="1550" b="0" i="0">
+              <a:rPr sz="2400" b="1" i="0">
                 <a:solidFill>
                   <a:srgbClr val="16273D"/>
                 </a:solidFill>
                 <a:latin typeface="Arial"/>
               </a:rPr>
-              <a:t>Russell's first road start — zero passing touchdowns against ECU; DeBoer's rhythm game needs him to attack the intermediate middle, not just survive</a:t>
+              <a:t>Russell's first road start</a:t>
             </a:r>
           </a:p>
         </p:txBody>
@@ -15945,7 +15945,7 @@
         </p:nvSpPr>
         <p:spPr>
           <a:xfrm>
-            <a:off x="914400" y="4059936"/>
+            <a:off x="914400" y="4133088"/>
             <a:ext cx="137160" cy="137160"/>
           </a:xfrm>
           <a:prstGeom prst="ellipse">
@@ -16005,13 +16005,13 @@
           <a:p>
             <a:pPr algn="l"/>
             <a:r>
-              <a:rPr sz="1550" b="0" i="0">
+              <a:rPr sz="2400" b="1" i="0">
                 <a:solidFill>
                   <a:srgbClr val="16273D"/>
                 </a:solidFill>
                 <a:latin typeface="Arial"/>
               </a:rPr>
-              <a:t>Run it 49 times again: 227 yards and five rushing scores last week — the rebuilt OL vs Kentucky's returning front is where an SEC road game is decided</a:t>
+              <a:t>Run it 49 times again</a:t>
             </a:r>
           </a:p>
         </p:txBody>
@@ -16024,7 +16024,7 @@
         </p:nvSpPr>
         <p:spPr>
           <a:xfrm>
-            <a:off x="914400" y="4901184"/>
+            <a:off x="914400" y="4974336"/>
             <a:ext cx="137160" cy="137160"/>
           </a:xfrm>
           <a:prstGeom prst="ellipse">
@@ -16084,13 +16084,13 @@
           <a:p>
             <a:pPr algn="l"/>
             <a:r>
-              <a:rPr sz="1550" b="0" i="0">
+              <a:rPr sz="2400" b="1" i="0">
                 <a:solidFill>
                   <a:srgbClr val="16273D"/>
                 </a:solidFill>
                 <a:latin typeface="Arial"/>
               </a:rPr>
-              <a:t>Wommack's secondary (Brown, Lee, Sabb) vs the receiver room the deep dive called a void — make Minchey hold the ball</a:t>
+              <a:t>Wommack's secondary vs the void</a:t>
             </a:r>
           </a:p>
         </p:txBody>
@@ -16103,7 +16103,7 @@
         </p:nvSpPr>
         <p:spPr>
           <a:xfrm>
-            <a:off x="914400" y="5742432"/>
+            <a:off x="914400" y="5815584"/>
             <a:ext cx="137160" cy="137160"/>
           </a:xfrm>
           <a:prstGeom prst="ellipse">
@@ -16163,13 +16163,13 @@
           <a:p>
             <a:pPr algn="l"/>
             <a:r>
-              <a:rPr sz="1550" b="0" i="0">
+              <a:rPr sz="2400" b="1" i="0">
                 <a:solidFill>
                   <a:srgbClr val="16273D"/>
                 </a:solidFill>
                 <a:latin typeface="Arial"/>
               </a:rPr>
-              <a:t>Special teams: 107th last year and projected 109th — a 10.5-point spread at Kroger dies in hidden yards</a:t>
+              <a:t>Special teams can't leak</a:t>
             </a:r>
           </a:p>
         </p:txBody>
@@ -16591,7 +16591,7 @@
         </p:nvSpPr>
         <p:spPr>
           <a:xfrm>
-            <a:off x="914400" y="3218688"/>
+            <a:off x="914400" y="3291840"/>
             <a:ext cx="137160" cy="137160"/>
           </a:xfrm>
           <a:prstGeom prst="ellipse">
@@ -16651,13 +16651,13 @@
           <a:p>
             <a:pPr algn="l"/>
             <a:r>
-              <a:rPr sz="1550" b="0" i="0">
+              <a:rPr sz="2400" b="1" i="0">
                 <a:solidFill>
                   <a:srgbClr val="16273D"/>
                 </a:solidFill>
                 <a:latin typeface="Arial"/>
               </a:rPr>
-              <a:t>The mauling line: six transfers, 49 FBS starts, three all-conference — vs an Alabama interior that lost four of its top five tackles; Baxter and Patterson downhill</a:t>
+              <a:t>The mauling line</a:t>
             </a:r>
           </a:p>
         </p:txBody>
@@ -16670,7 +16670,7 @@
         </p:nvSpPr>
         <p:spPr>
           <a:xfrm>
-            <a:off x="914400" y="4059936"/>
+            <a:off x="914400" y="4133088"/>
             <a:ext cx="137160" cy="137160"/>
           </a:xfrm>
           <a:prstGeom prst="ellipse">
@@ -16730,13 +16730,13 @@
           <a:p>
             <a:pPr algn="l"/>
             <a:r>
-              <a:rPr sz="1550" b="0" i="0">
+              <a:rPr sz="2400" b="1" i="0">
                 <a:solidFill>
                   <a:srgbClr val="16273D"/>
                 </a:solidFill>
                 <a:latin typeface="Arial"/>
               </a:rPr>
-              <a:t>Minchey's profile: four touchdowns, no picks, 11.1 a throw — keep it clean against the best secondary in America and the spread is in play all afternoon</a:t>
+              <a:t>Minchey keeps it clean</a:t>
             </a:r>
           </a:p>
         </p:txBody>
@@ -16749,7 +16749,7 @@
         </p:nvSpPr>
         <p:spPr>
           <a:xfrm>
-            <a:off x="914400" y="4901184"/>
+            <a:off x="914400" y="4974336"/>
             <a:ext cx="137160" cy="137160"/>
           </a:xfrm>
           <a:prstGeom prst="ellipse">
@@ -16809,13 +16809,13 @@
           <a:p>
             <a:pPr algn="l"/>
             <a:r>
-              <a:rPr sz="1550" b="0" i="0">
+              <a:rPr sz="2400" b="1" i="0">
                 <a:solidFill>
                   <a:srgbClr val="16273D"/>
                 </a:solidFill>
                 <a:latin typeface="Arial"/>
               </a:rPr>
-              <a:t>The defense is the strength — ten of nineteen starters back plus Castell; make Russell win from the pocket on third-and-long</a:t>
+              <a:t>The defense is the strength</a:t>
             </a:r>
           </a:p>
         </p:txBody>
@@ -16828,7 +16828,7 @@
         </p:nvSpPr>
         <p:spPr>
           <a:xfrm>
-            <a:off x="914400" y="5742432"/>
+            <a:off x="914400" y="5815584"/>
             <a:ext cx="137160" cy="137160"/>
           </a:xfrm>
           <a:prstGeom prst="ellipse">
@@ -16888,13 +16888,13 @@
           <a:p>
             <a:pPr algn="l"/>
             <a:r>
-              <a:rPr sz="1550" b="0" i="0">
+              <a:rPr sz="2400" b="1" i="0">
                 <a:solidFill>
                   <a:srgbClr val="16273D"/>
                 </a:solidFill>
                 <a:latin typeface="Arial"/>
               </a:rPr>
-              <a:t>Clean up the two Week 1 leaks: 3-of-8 on third down and six penalties for 70 — those are the stats that lose to Alabama</a:t>
+              <a:t>Fix third down and the flags</a:t>
             </a:r>
           </a:p>
         </p:txBody>
@@ -17156,7 +17156,7 @@
         </p:nvSpPr>
         <p:spPr>
           <a:xfrm>
-            <a:off x="868680" y="2139696"/>
+            <a:off x="868680" y="2176272"/>
             <a:ext cx="128016" cy="128016"/>
           </a:xfrm>
           <a:prstGeom prst="ellipse">
@@ -17216,13 +17216,13 @@
           <a:p>
             <a:pPr algn="l"/>
             <a:r>
-              <a:rPr sz="1350" b="0" i="0">
+              <a:rPr sz="1600" b="0" i="0">
                 <a:solidFill>
                   <a:srgbClr val="16273D"/>
                 </a:solidFill>
                 <a:latin typeface="Arial"/>
               </a:rPr>
-              <a:t>The rematch of the year: Ohio State won last year's opener 14–7 in Columbus and the 2024 CFP semifinal — Texas gets it at home, at night, with Arch Manning in what is almost certainly his last season</a:t>
+              <a:t>The rematch: OSU won 14–7 last year and the 2024 semifinal</a:t>
             </a:r>
           </a:p>
         </p:txBody>
@@ -17235,7 +17235,7 @@
         </p:nvSpPr>
         <p:spPr>
           <a:xfrm>
-            <a:off x="868680" y="2852928"/>
+            <a:off x="868680" y="2889504"/>
             <a:ext cx="128016" cy="128016"/>
           </a:xfrm>
           <a:prstGeom prst="ellipse">
@@ -17295,13 +17295,13 @@
           <a:p>
             <a:pPr algn="l"/>
             <a:r>
-              <a:rPr sz="1350" b="0" i="0">
+              <a:rPr sz="1600" b="0" i="0">
                 <a:solidFill>
                   <a:srgbClr val="16273D"/>
                 </a:solidFill>
                 <a:latin typeface="Arial"/>
               </a:rPr>
-              <a:t>Two title-or-bust rosters and one coordinator gamble each: Arthur Smith installing an NFL run game around Sayin–Smith, Will Muschamp replacing the coordinator whose defense outranked Sark's offense two years running</a:t>
+              <a:t>Two title rosters, one coordinator gamble each</a:t>
             </a:r>
           </a:p>
         </p:txBody>
@@ -17314,7 +17314,7 @@
         </p:nvSpPr>
         <p:spPr>
           <a:xfrm>
-            <a:off x="868680" y="3566160"/>
+            <a:off x="868680" y="3602736"/>
             <a:ext cx="128016" cy="128016"/>
           </a:xfrm>
           <a:prstGeom prst="ellipse">
@@ -17374,13 +17374,13 @@
           <a:p>
             <a:pPr algn="l"/>
             <a:r>
-              <a:rPr sz="1350" b="0" i="0">
+              <a:rPr sz="1600" b="0" i="0">
                 <a:solidFill>
                   <a:srgbClr val="16273D"/>
                 </a:solidFill>
                 <a:latin typeface="Arial"/>
               </a:rPr>
-              <a:t>Continuity edge is Texas: 72% of its offensive production back plus the sport's most talked-about portal class (Coleman, Smothers, Biles); Ohio State returns 68% on offense but only two of nine defensive starters</a:t>
+              <a:t>Texas has the continuity edge — 72% back plus the portal class</a:t>
             </a:r>
           </a:p>
         </p:txBody>
@@ -17393,7 +17393,7 @@
         </p:nvSpPr>
         <p:spPr>
           <a:xfrm>
-            <a:off x="868680" y="4279392"/>
+            <a:off x="868680" y="4315968"/>
             <a:ext cx="128016" cy="128016"/>
           </a:xfrm>
           <a:prstGeom prst="ellipse">
@@ -17453,13 +17453,13 @@
           <a:p>
             <a:pPr algn="l"/>
             <a:r>
-              <a:rPr sz="1350" b="0" i="0">
+              <a:rPr sz="1600" b="0" i="0">
                 <a:solidFill>
                   <a:srgbClr val="16273D"/>
                 </a:solidFill>
                 <a:latin typeface="Arial"/>
               </a:rPr>
-              <a:t>Week 1 said nothing and everything: 56–3 and 59–7 — Sayin 21-of-25, Arch 4 touchdowns — but Texas allowed 349 yards to Texas State and Ohio State took nine flags</a:t>
+              <a:t>Week 1: 56–3 and 59–7, with nine flags and 349 allowed underneath</a:t>
             </a:r>
           </a:p>
         </p:txBody>
@@ -17532,13 +17532,13 @@
           <a:p>
             <a:pPr algn="l"/>
             <a:r>
-              <a:rPr sz="1150" b="0" i="1">
+              <a:rPr sz="1300" b="0" i="1">
                 <a:solidFill>
                   <a:srgbClr val="5C6B7E"/>
                 </a:solidFill>
                 <a:latin typeface="Arial"/>
               </a:rPr>
-              <a:t>The machine says Texas by 3.7; the market says 1.5; ESPN's own live FPI says 0.7. Three points of our number are bookkeeping — the ±28 margin cap turned 56–3 into an 'underperformance' and docked Ohio State 4.1 rating points for winning by 53. Strip the artifact and this is a pick'em plus home field, which is exactly what everyone else says. No position.</a:t>
+              <a:t>Machine 3.7, market 1.5, ESPN 0.7 — three points of ours is the cap artifact. No position.</a:t>
             </a:r>
           </a:p>
         </p:txBody>
@@ -18512,7 +18512,7 @@
         </p:nvSpPr>
         <p:spPr>
           <a:xfrm>
-            <a:off x="914400" y="3218688"/>
+            <a:off x="914400" y="3291840"/>
             <a:ext cx="137160" cy="137160"/>
           </a:xfrm>
           <a:prstGeom prst="ellipse">
@@ -18572,13 +18572,13 @@
           <a:p>
             <a:pPr algn="l"/>
             <a:r>
-              <a:rPr sz="1550" b="0" i="0">
+              <a:rPr sz="2400" b="1" i="0">
                 <a:solidFill>
                   <a:srgbClr val="16273D"/>
                 </a:solidFill>
                 <a:latin typeface="Arial"/>
               </a:rPr>
-              <a:t>Make Arthur Smith's run game real — 237 yards at 6.8 a carry last week; if wide zone travels, Sayin plays on schedule instead of in a phone booth</a:t>
+              <a:t>Make the run game real</a:t>
             </a:r>
           </a:p>
         </p:txBody>
@@ -18591,7 +18591,7 @@
         </p:nvSpPr>
         <p:spPr>
           <a:xfrm>
-            <a:off x="914400" y="4059936"/>
+            <a:off x="914400" y="4133088"/>
             <a:ext cx="137160" cy="137160"/>
           </a:xfrm>
           <a:prstGeom prst="ellipse">
@@ -18651,13 +18651,13 @@
           <a:p>
             <a:pPr algn="l"/>
             <a:r>
-              <a:rPr sz="1550" b="0" i="0">
+              <a:rPr sz="2400" b="1" i="0">
                 <a:solidFill>
                   <a:srgbClr val="16273D"/>
                 </a:solidFill>
                 <a:latin typeface="Arial"/>
               </a:rPr>
-              <a:t>Sayin-to-Smith vs the back end Kwiatkowski built and Muschamp inherited: McDonald, Littleton and portal corner Mascoe held this offense to 14 last year</a:t>
+              <a:t>Sayin-to-Smith vs the back end</a:t>
             </a:r>
           </a:p>
         </p:txBody>
@@ -18670,7 +18670,7 @@
         </p:nvSpPr>
         <p:spPr>
           <a:xfrm>
-            <a:off x="914400" y="4901184"/>
+            <a:off x="914400" y="4974336"/>
             <a:ext cx="137160" cy="137160"/>
           </a:xfrm>
           <a:prstGeom prst="ellipse">
@@ -18730,13 +18730,13 @@
           <a:p>
             <a:pPr algn="l"/>
             <a:r>
-              <a:rPr sz="1550" b="0" i="0">
+              <a:rPr sz="2400" b="1" i="0">
                 <a:solidFill>
                   <a:srgbClr val="16273D"/>
                 </a:solidFill>
                 <a:latin typeface="Arial"/>
               </a:rPr>
-              <a:t>Prove the eight-transfer defense — Russaw, Smith, Moore, Little — against the deepest skill corps in the sport; two of nine starters back is the season's real question</a:t>
+              <a:t>Prove the eight-transfer defense</a:t>
             </a:r>
           </a:p>
         </p:txBody>
@@ -18749,7 +18749,7 @@
         </p:nvSpPr>
         <p:spPr>
           <a:xfrm>
-            <a:off x="914400" y="5742432"/>
+            <a:off x="914400" y="5815584"/>
             <a:ext cx="137160" cy="137160"/>
           </a:xfrm>
           <a:prstGeom prst="ellipse">
@@ -18809,13 +18809,13 @@
           <a:p>
             <a:pPr algn="l"/>
             <a:r>
-              <a:rPr sz="1550" b="0" i="0">
+              <a:rPr sz="2400" b="1" i="0">
                 <a:solidFill>
                   <a:srgbClr val="16273D"/>
                 </a:solidFill>
                 <a:latin typeface="Arial"/>
               </a:rPr>
-              <a:t>Urgency: last year's slow-tempo offense died in the two games that mattered — play with pace, and cut the nine penalties from Week 1</a:t>
+              <a:t>Play with pace, cut the flags</a:t>
             </a:r>
           </a:p>
         </p:txBody>
@@ -24197,7 +24197,7 @@
         </p:nvSpPr>
         <p:spPr>
           <a:xfrm>
-            <a:off x="914400" y="3218688"/>
+            <a:off x="914400" y="3291840"/>
             <a:ext cx="137160" cy="137160"/>
           </a:xfrm>
           <a:prstGeom prst="ellipse">
@@ -24257,13 +24257,13 @@
           <a:p>
             <a:pPr algn="l"/>
             <a:r>
-              <a:rPr sz="1550" b="0" i="0">
+              <a:rPr sz="2400" b="1" i="0">
                 <a:solidFill>
                   <a:srgbClr val="16273D"/>
                 </a:solidFill>
                 <a:latin typeface="Arial"/>
               </a:rPr>
-              <a:t>Arch on the move: designed movement is Sark's 2026 wrinkle and accuracy on the run is Arch's last flaw — Patricia's disguises will test exactly that</a:t>
+              <a:t>Arch on the move</a:t>
             </a:r>
           </a:p>
         </p:txBody>
@@ -24276,7 +24276,7 @@
         </p:nvSpPr>
         <p:spPr>
           <a:xfrm>
-            <a:off x="914400" y="4059936"/>
+            <a:off x="914400" y="4133088"/>
             <a:ext cx="137160" cy="137160"/>
           </a:xfrm>
           <a:prstGeom prst="ellipse">
@@ -24336,13 +24336,13 @@
           <a:p>
             <a:pPr algn="l"/>
             <a:r>
-              <a:rPr sz="1550" b="0" i="0">
+              <a:rPr sz="2400" b="1" i="0">
                 <a:solidFill>
                   <a:srgbClr val="16273D"/>
                 </a:solidFill>
                 <a:latin typeface="Arial"/>
               </a:rPr>
-              <a:t>Protect the interior — the 2025 OL regression was the whole story of a preseason No. 1 that missed the CFP; Ohio State's transfer front arrives Saturday</a:t>
+              <a:t>Protect the interior</a:t>
             </a:r>
           </a:p>
         </p:txBody>
@@ -24355,7 +24355,7 @@
         </p:nvSpPr>
         <p:spPr>
           <a:xfrm>
-            <a:off x="914400" y="4901184"/>
+            <a:off x="914400" y="4974336"/>
             <a:ext cx="137160" cy="137160"/>
           </a:xfrm>
           <a:prstGeom prst="ellipse">
@@ -24415,13 +24415,13 @@
           <a:p>
             <a:pPr algn="l"/>
             <a:r>
-              <a:rPr sz="1550" b="0" i="0">
+              <a:rPr sz="2400" b="1" i="0">
                 <a:solidFill>
                   <a:srgbClr val="16273D"/>
                 </a:solidFill>
                 <a:latin typeface="Arial"/>
               </a:rPr>
-              <a:t>Explosives over efficiency: Coleman, Wingo, Smothers (4.4 yards after contact) vs a rally-tackle defense that squeezes chunk plays — win the big-play count</a:t>
+              <a:t>Explosives over efficiency</a:t>
             </a:r>
           </a:p>
         </p:txBody>
@@ -24434,7 +24434,7 @@
         </p:nvSpPr>
         <p:spPr>
           <a:xfrm>
-            <a:off x="914400" y="5742432"/>
+            <a:off x="914400" y="5815584"/>
             <a:ext cx="137160" cy="137160"/>
           </a:xfrm>
           <a:prstGeom prst="ellipse">
@@ -24494,13 +24494,13 @@
           <a:p>
             <a:pPr algn="l"/>
             <a:r>
-              <a:rPr sz="1550" b="0" i="0">
+              <a:rPr sz="2400" b="1" i="0">
                 <a:solidFill>
                   <a:srgbClr val="16273D"/>
                 </a:solidFill>
                 <a:latin typeface="Arial"/>
               </a:rPr>
-              <a:t>Muschamp's first real test: 349 yards allowed to Texas State is a flag; Simmons off the edge and Biles inside have to make Sayin uncomfortable early</a:t>
+              <a:t>Muschamp's first real test</a:t>
             </a:r>
           </a:p>
         </p:txBody>
@@ -32630,7 +32630,7 @@
         </p:nvSpPr>
         <p:spPr>
           <a:xfrm>
-            <a:off x="868680" y="2139696"/>
+            <a:off x="868680" y="2176272"/>
             <a:ext cx="128016" cy="128016"/>
           </a:xfrm>
           <a:prstGeom prst="ellipse">
@@ -32690,13 +32690,13 @@
           <a:p>
             <a:pPr algn="l"/>
             <a:r>
-              <a:rPr sz="1350" b="0" i="0">
+              <a:rPr sz="1600" b="0" i="0">
                 <a:solidFill>
                   <a:srgbClr val="16273D"/>
                 </a:solidFill>
                 <a:latin typeface="Arial"/>
               </a:rPr>
-              <a:t>The line swung eight points in a week: Michigan opened –1.5, survived Western Michigan 13–12 (three turnovers, 19:52 of possession) and is now +5.5 — the market re-priced a program; the machine moved 4.3</a:t>
+              <a:t>The line swung eight points on one MAC game</a:t>
             </a:r>
           </a:p>
         </p:txBody>
@@ -32709,7 +32709,7 @@
         </p:nvSpPr>
         <p:spPr>
           <a:xfrm>
-            <a:off x="868680" y="2852928"/>
+            <a:off x="868680" y="2889504"/>
             <a:ext cx="128016" cy="128016"/>
           </a:xfrm>
           <a:prstGeom prst="ellipse">
@@ -32769,13 +32769,13 @@
           <a:p>
             <a:pPr algn="l"/>
             <a:r>
-              <a:rPr sz="1350" b="0" i="0">
+              <a:rPr sz="1600" b="0" i="0">
                 <a:solidFill>
                   <a:srgbClr val="16273D"/>
                 </a:solidFill>
                 <a:latin typeface="Arial"/>
               </a:rPr>
-              <a:t>Two rebuilds at opposite speeds: Whittingham's Utah operating system (OC Beck, DC Hill, three Utah starters) is one game old; Venables' defense is in year five and was the SEC's best in 2025</a:t>
+              <a:t>Whittingham's Utah system, one game old, vs Venables' year-five defense</a:t>
             </a:r>
           </a:p>
         </p:txBody>
@@ -32788,7 +32788,7 @@
         </p:nvSpPr>
         <p:spPr>
           <a:xfrm>
-            <a:off x="868680" y="3566160"/>
+            <a:off x="868680" y="3602736"/>
             <a:ext cx="128016" cy="128016"/>
           </a:xfrm>
           <a:prstGeom prst="ellipse">
@@ -32848,13 +32848,13 @@
           <a:p>
             <a:pPr algn="l"/>
             <a:r>
-              <a:rPr sz="1350" b="0" i="0">
+              <a:rPr sz="1600" b="0" i="0">
                 <a:solidFill>
                   <a:srgbClr val="16273D"/>
                 </a:solidFill>
                 <a:latin typeface="Arial"/>
               </a:rPr>
-              <a:t>The QB question is the whole show: Underwood's year-two leap (12-of-22 last week) vs Mateer's rebuilt throwing motion (11-of-17, three TDs) — both offenses are built around their QB's legs</a:t>
+              <a:t>Underwood's year two vs Mateer's rebuilt motion</a:t>
             </a:r>
           </a:p>
         </p:txBody>
@@ -32867,7 +32867,7 @@
         </p:nvSpPr>
         <p:spPr>
           <a:xfrm>
-            <a:off x="868680" y="4279392"/>
+            <a:off x="868680" y="4315968"/>
             <a:ext cx="128016" cy="128016"/>
           </a:xfrm>
           <a:prstGeom prst="ellipse">
@@ -32927,13 +32927,13 @@
           <a:p>
             <a:pPr algn="l"/>
             <a:r>
-              <a:rPr sz="1350" b="0" i="0">
+              <a:rPr sz="1600" b="0" i="0">
                 <a:solidFill>
                   <a:srgbClr val="16273D"/>
                 </a:solidFill>
                 <a:latin typeface="Arial"/>
               </a:rPr>
-              <a:t>Payback with stakes: OU won 24–13 in Norman last September; a Michigan loss at home to open Whittingham's era puts an 8–4 program's floor in play by mid-September</a:t>
+              <a:t>Payback: OU won 24–13 in Norman last year</a:t>
             </a:r>
           </a:p>
         </p:txBody>
@@ -33006,13 +33006,13 @@
           <a:p>
             <a:pPr algn="l"/>
             <a:r>
-              <a:rPr sz="1150" b="0" i="1">
+              <a:rPr sz="1300" b="0" i="1">
                 <a:solidFill>
                   <a:srgbClr val="5C6B7E"/>
                 </a:solidFill>
                 <a:latin typeface="Arial"/>
               </a:rPr>
-              <a:t>The market moved seven points on one MAC game; the pre-registered machine moved 4.3 — that gap is the entire 'edge'. It is a bet that 13–12 was noise, made about a first-year head coach and a year-two QB the July prior can't see. Lean Michigan +5.5 as research; the backtest never rewarded us for chasing chaos.</a:t>
+              <a:t>The market moved 7, the machine moved 4.3 — lean Michigan +5.5 as research, not a position.</a:t>
             </a:r>
           </a:p>
         </p:txBody>
@@ -33986,7 +33986,7 @@
         </p:nvSpPr>
         <p:spPr>
           <a:xfrm>
-            <a:off x="914400" y="3218688"/>
+            <a:off x="914400" y="3291840"/>
             <a:ext cx="137160" cy="137160"/>
           </a:xfrm>
           <a:prstGeom prst="ellipse">
@@ -34046,13 +34046,13 @@
           <a:p>
             <a:pPr algn="l"/>
             <a:r>
-              <a:rPr sz="1550" b="0" i="0">
+              <a:rPr sz="2400" b="1" i="0">
                 <a:solidFill>
                   <a:srgbClr val="16273D"/>
                 </a:solidFill>
                 <a:latin typeface="Arial"/>
               </a:rPr>
-              <a:t>Mateer's legs vs Jay Hill's sim pressures — the designed QB run (8 TDs in 2025) is the answer to a blitz-heavy front that punishes hesitation</a:t>
+              <a:t>Mateer's legs vs Hill's pressure</a:t>
             </a:r>
           </a:p>
         </p:txBody>
@@ -34065,7 +34065,7 @@
         </p:nvSpPr>
         <p:spPr>
           <a:xfrm>
-            <a:off x="914400" y="4059936"/>
+            <a:off x="914400" y="4133088"/>
             <a:ext cx="137160" cy="137160"/>
           </a:xfrm>
           <a:prstGeom prst="ellipse">
@@ -34125,13 +34125,13 @@
           <a:p>
             <a:pPr algn="l"/>
             <a:r>
-              <a:rPr sz="1550" b="0" i="0">
+              <a:rPr sz="2400" b="1" i="0">
                 <a:solidFill>
                   <a:srgbClr val="16273D"/>
                 </a:solidFill>
                 <a:latin typeface="Arial"/>
               </a:rPr>
-              <a:t>The five-transfer OL vs Michigan's DL two-deep — 2025's run game ranked 124th in yards per carry; 170 at 4.4 against UTEP proved nothing</a:t>
+              <a:t>The portal line has to prove it</a:t>
             </a:r>
           </a:p>
         </p:txBody>
@@ -34144,7 +34144,7 @@
         </p:nvSpPr>
         <p:spPr>
           <a:xfrm>
-            <a:off x="914400" y="4901184"/>
+            <a:off x="914400" y="4974336"/>
             <a:ext cx="137160" cy="137160"/>
           </a:xfrm>
           <a:prstGeom prst="ellipse">
@@ -34204,13 +34204,13 @@
           <a:p>
             <a:pPr algn="l"/>
             <a:r>
-              <a:rPr sz="1550" b="0" i="0">
+              <a:rPr sz="2400" b="1" i="0">
                 <a:solidFill>
                   <a:srgbClr val="16273D"/>
                 </a:solidFill>
                 <a:latin typeface="Arial"/>
               </a:rPr>
-              <a:t>Erase the bad-QB day: Underwood went 12-of-22 with a pick — Venables' back seven (Guillory, the Bowens) has to cash on the road at noon</a:t>
+              <a:t>Erase Underwood's bad day</a:t>
             </a:r>
           </a:p>
         </p:txBody>
@@ -34223,7 +34223,7 @@
         </p:nvSpPr>
         <p:spPr>
           <a:xfrm>
-            <a:off x="914400" y="5742432"/>
+            <a:off x="914400" y="5815584"/>
             <a:ext cx="137160" cy="137160"/>
           </a:xfrm>
           <a:prstGeom prst="ellipse">
@@ -34283,13 +34283,13 @@
           <a:p>
             <a:pPr algn="l"/>
             <a:r>
-              <a:rPr sz="1550" b="0" i="0">
+              <a:rPr sz="2400" b="1" i="0">
                 <a:solidFill>
                   <a:srgbClr val="16273D"/>
                 </a:solidFill>
                 <a:latin typeface="Arial"/>
               </a:rPr>
-              <a:t>Hidden yards travel: 115 punt-return yards and a defensive score last week — special teams is how a 2-point machine number becomes a cover</a:t>
+              <a:t>Win the hidden yards</a:t>
             </a:r>
           </a:p>
         </p:txBody>
@@ -34711,7 +34711,7 @@
         </p:nvSpPr>
         <p:spPr>
           <a:xfrm>
-            <a:off x="914400" y="3218688"/>
+            <a:off x="914400" y="3291840"/>
             <a:ext cx="137160" cy="137160"/>
           </a:xfrm>
           <a:prstGeom prst="ellipse">
@@ -34771,13 +34771,13 @@
           <a:p>
             <a:pPr algn="l"/>
             <a:r>
-              <a:rPr sz="1550" b="0" i="0">
+              <a:rPr sz="2400" b="1" i="0">
                 <a:solidFill>
                   <a:srgbClr val="16273D"/>
                 </a:solidFill>
                 <a:latin typeface="Arial"/>
               </a:rPr>
-              <a:t>Own the ball — 19:52 of possession and three turnovers against a MAC team; Beck's system is built on 30-minute halves and zero gifts</a:t>
+              <a:t>Own the ball</a:t>
             </a:r>
           </a:p>
         </p:txBody>
@@ -34790,7 +34790,7 @@
         </p:nvSpPr>
         <p:spPr>
           <a:xfrm>
-            <a:off x="914400" y="4059936"/>
+            <a:off x="914400" y="4133088"/>
             <a:ext cx="137160" cy="137160"/>
           </a:xfrm>
           <a:prstGeom prst="ellipse">
@@ -34850,13 +34850,13 @@
           <a:p>
             <a:pPr algn="l"/>
             <a:r>
-              <a:rPr sz="1550" b="0" i="0">
+              <a:rPr sz="2400" b="1" i="0">
                 <a:solidFill>
                   <a:srgbClr val="16273D"/>
                 </a:solidFill>
                 <a:latin typeface="Arial"/>
               </a:rPr>
-              <a:t>Run Underwood like Dampier: 47 yards on nine carries was the first look — the QB-run leverage is the identity Whittingham imported from Utah</a:t>
+              <a:t>Run Underwood like Dampier</a:t>
             </a:r>
           </a:p>
         </p:txBody>
@@ -34869,7 +34869,7 @@
         </p:nvSpPr>
         <p:spPr>
           <a:xfrm>
-            <a:off x="914400" y="4901184"/>
+            <a:off x="914400" y="4974336"/>
             <a:ext cx="137160" cy="137160"/>
           </a:xfrm>
           <a:prstGeom prst="ellipse">
@@ -34929,13 +34929,13 @@
           <a:p>
             <a:pPr algn="l"/>
             <a:r>
-              <a:rPr sz="1550" b="0" i="0">
+              <a:rPr sz="2400" b="1" i="0">
                 <a:solidFill>
                   <a:srgbClr val="16273D"/>
                 </a:solidFill>
                 <a:latin typeface="Arial"/>
               </a:rPr>
-              <a:t>Find receiver No. 2: Buchanan's 126 yards was the whole passing game — Marsh has to be a real target or Venables squeezes one side</a:t>
+              <a:t>Find receiver No. 2</a:t>
             </a:r>
           </a:p>
         </p:txBody>
@@ -34948,7 +34948,7 @@
         </p:nvSpPr>
         <p:spPr>
           <a:xfrm>
-            <a:off x="914400" y="5742432"/>
+            <a:off x="914400" y="5815584"/>
             <a:ext cx="137160" cy="137160"/>
           </a:xfrm>
           <a:prstGeom prst="ellipse">
@@ -35008,13 +35008,13 @@
           <a:p>
             <a:pPr algn="l"/>
             <a:r>
-              <a:rPr sz="1550" b="0" i="0">
+              <a:rPr sz="2400" b="1" i="0">
                 <a:solidFill>
                   <a:srgbClr val="16273D"/>
                 </a:solidFill>
                 <a:latin typeface="Arial"/>
               </a:rPr>
-              <a:t>Hill's defense allowed 221 yards and 4.2 per pass to WMU — bring that to Mateer's Air Raid without the explosive concessions the pressure invites</a:t>
+              <a:t>Pressure without the busts</a:t>
             </a:r>
           </a:p>
         </p:txBody>
@@ -35276,7 +35276,7 @@
         </p:nvSpPr>
         <p:spPr>
           <a:xfrm>
-            <a:off x="868680" y="2139696"/>
+            <a:off x="868680" y="2176272"/>
             <a:ext cx="128016" cy="128016"/>
           </a:xfrm>
           <a:prstGeom prst="ellipse">
@@ -35336,13 +35336,13 @@
           <a:p>
             <a:pPr algn="l"/>
             <a:r>
-              <a:rPr sz="1350" b="0" i="0">
+              <a:rPr sz="1600" b="0" i="0">
                 <a:solidFill>
                   <a:srgbClr val="16273D"/>
                 </a:solidFill>
                 <a:latin typeface="Arial"/>
               </a:rPr>
-              <a:t>Dillingham's post-Leavitt reboot (16% of production back — the least on the card, 24 transfers) meets an 11-win Aggie roster that kept its skill talent and rebuilt both trenches through the portal</a:t>
+              <a:t>Dillingham's 16%-back reboot vs an 11-win roster</a:t>
             </a:r>
           </a:p>
         </p:txBody>
@@ -35355,7 +35355,7 @@
         </p:nvSpPr>
         <p:spPr>
           <a:xfrm>
-            <a:off x="868680" y="2852928"/>
+            <a:off x="868680" y="2889504"/>
             <a:ext cx="128016" cy="128016"/>
           </a:xfrm>
           <a:prstGeom prst="ellipse">
@@ -35415,13 +35415,13 @@
           <a:p>
             <a:pPr algn="l"/>
             <a:r>
-              <a:rPr sz="1350" b="0" i="0">
+              <a:rPr sz="1600" b="0" i="0">
                 <a:solidFill>
                   <a:srgbClr val="16273D"/>
                 </a:solidFill>
                 <a:latin typeface="Arial"/>
               </a:rPr>
-              <a:t>Cutter Boley's debut was 21-of-27 for 387 and six touchdowns — against Morgan State; Kyle Field at noon with Elko's disguises is the real audition</a:t>
+              <a:t>Boley's six-TD debut came against Morgan State</a:t>
             </a:r>
           </a:p>
         </p:txBody>
@@ -35434,7 +35434,7 @@
         </p:nvSpPr>
         <p:spPr>
           <a:xfrm>
-            <a:off x="868680" y="3566160"/>
+            <a:off x="868680" y="3602736"/>
             <a:ext cx="128016" cy="128016"/>
           </a:xfrm>
           <a:prstGeom prst="ellipse">
@@ -35494,13 +35494,13 @@
           <a:p>
             <a:pPr algn="l"/>
             <a:r>
-              <a:rPr sz="1350" b="0" i="0">
+              <a:rPr sz="1600" b="0" i="0">
                 <a:solidFill>
                   <a:srgbClr val="16273D"/>
                 </a:solidFill>
                 <a:latin typeface="Arial"/>
               </a:rPr>
-              <a:t>A&amp;M's story is its lines: six of the top seven OL and five of seven DL are gone, replaced by transfers with 42 combined SEC starts — a tempo offense is the stress test they'd choose least</a:t>
+              <a:t>A&amp;M's story is its portal-built lines</a:t>
             </a:r>
           </a:p>
         </p:txBody>
@@ -35513,7 +35513,7 @@
         </p:nvSpPr>
         <p:spPr>
           <a:xfrm>
-            <a:off x="868680" y="4279392"/>
+            <a:off x="868680" y="4315968"/>
             <a:ext cx="128016" cy="128016"/>
           </a:xfrm>
           <a:prstGeom prst="ellipse">
@@ -35573,13 +35573,13 @@
           <a:p>
             <a:pPr algn="l"/>
             <a:r>
-              <a:rPr sz="1350" b="0" i="0">
+              <a:rPr sz="1600" b="0" i="0">
                 <a:solidFill>
                   <a:srgbClr val="16273D"/>
                 </a:solidFill>
                 <a:latin typeface="Arial"/>
               </a:rPr>
-              <a:t>Neither rating has a 2026 snap in it: both teams beat FCS opponents the machine doesn't rate, so this number is July's prior plus home field — and the market agrees within two points</a:t>
+              <a:t>Neither rating has a 2026 snap in it</a:t>
             </a:r>
           </a:p>
         </p:txBody>
@@ -35652,13 +35652,13 @@
           <a:p>
             <a:pPr algn="l"/>
             <a:r>
-              <a:rPr sz="1150" b="0" i="1">
+              <a:rPr sz="1300" b="0" i="1">
                 <a:solidFill>
                   <a:srgbClr val="5C6B7E"/>
                 </a:solidFill>
                 <a:latin typeface="Arial"/>
               </a:rPr>
-              <a:t>Machine –16.7, market –14.5: two points apart on a 14-point spread is agreement. The 70–7 and 50–0 scores are zero evidence — FCS opponents aren't rated, so neither team's number moved. The scouting risk the prior can't price is Reed's turnover habit (four picks in last year's two losses) against a 3-3-5 that gambles for exactly that.</a:t>
+              <a:t>Two points apart on a 14-point spread is agreement — no play.</a:t>
             </a:r>
           </a:p>
         </p:txBody>

</xml_diff>

<commit_message>
Deck template: WHY IT MATTERS bullets in headline form (2-6 words, 21pt bold) on every game
Co-Authored-By: Claude Fable 5.1 <noreply@anthropic.com>
</commit_message>
<xml_diff>
--- a/decks/2026_Week2_Episode3.pptx
+++ b/decks/2026_Week2_Episode3.pptx
@@ -11864,7 +11864,7 @@
         </p:nvSpPr>
         <p:spPr>
           <a:xfrm>
-            <a:off x="868680" y="2176272"/>
+            <a:off x="868680" y="2212848"/>
             <a:ext cx="128016" cy="128016"/>
           </a:xfrm>
           <a:prstGeom prst="ellipse">
@@ -11924,13 +11924,13 @@
           <a:p>
             <a:pPr algn="l"/>
             <a:r>
-              <a:rPr sz="1600" b="0" i="0">
+              <a:rPr sz="2100" b="1" i="0">
                 <a:solidFill>
                   <a:srgbClr val="16273D"/>
                 </a:solidFill>
                 <a:latin typeface="Arial"/>
               </a:rPr>
-              <a:t>The Big 12's continuity kings: 79% back, 177 starts</a:t>
+              <a:t>The Big 12's continuity kings</a:t>
             </a:r>
           </a:p>
         </p:txBody>
@@ -11943,7 +11943,7 @@
         </p:nvSpPr>
         <p:spPr>
           <a:xfrm>
-            <a:off x="868680" y="2889504"/>
+            <a:off x="868680" y="2926080"/>
             <a:ext cx="128016" cy="128016"/>
           </a:xfrm>
           <a:prstGeom prst="ellipse">
@@ -12003,13 +12003,13 @@
           <a:p>
             <a:pPr algn="l"/>
             <a:r>
-              <a:rPr sz="1600" b="0" i="0">
+              <a:rPr sz="2100" b="1" i="0">
                 <a:solidFill>
                   <a:srgbClr val="16273D"/>
                 </a:solidFill>
                 <a:latin typeface="Arial"/>
               </a:rPr>
-              <a:t>Provo's biggest home game until Notre Dame</a:t>
+              <a:t>Provo's biggest game until Notre Dame</a:t>
             </a:r>
           </a:p>
         </p:txBody>
@@ -12022,7 +12022,7 @@
         </p:nvSpPr>
         <p:spPr>
           <a:xfrm>
-            <a:off x="868680" y="3602736"/>
+            <a:off x="868680" y="3639312"/>
             <a:ext cx="128016" cy="128016"/>
           </a:xfrm>
           <a:prstGeom prst="ellipse">
@@ -12082,13 +12082,13 @@
           <a:p>
             <a:pPr algn="l"/>
             <a:r>
-              <a:rPr sz="1600" b="0" i="0">
+              <a:rPr sz="2100" b="1" i="0">
                 <a:solidFill>
                   <a:srgbClr val="16273D"/>
                 </a:solidFill>
                 <a:latin typeface="Arial"/>
               </a:rPr>
-              <a:t>BYU's coordinator change: Poppinga replaces Hill</a:t>
+              <a:t>Poppinga replaces Hill</a:t>
             </a:r>
           </a:p>
         </p:txBody>
@@ -12101,7 +12101,7 @@
         </p:nvSpPr>
         <p:spPr>
           <a:xfrm>
-            <a:off x="868680" y="4315968"/>
+            <a:off x="868680" y="4352544"/>
             <a:ext cx="128016" cy="128016"/>
           </a:xfrm>
           <a:prstGeom prst="ellipse">
@@ -12161,13 +12161,13 @@
           <a:p>
             <a:pPr algn="l"/>
             <a:r>
-              <a:rPr sz="1600" b="0" i="0">
+              <a:rPr sz="2100" b="1" i="0">
                 <a:solidFill>
                   <a:srgbClr val="16273D"/>
                 </a:solidFill>
                 <a:latin typeface="Arial"/>
               </a:rPr>
-              <a:t>Week 1: BYU ran for 308 and took four; Arizona gave three away</a:t>
+              <a:t>BYU took four, Arizona gave three</a:t>
             </a:r>
           </a:p>
         </p:txBody>
@@ -14510,7 +14510,7 @@
         </p:nvSpPr>
         <p:spPr>
           <a:xfrm>
-            <a:off x="868680" y="2176272"/>
+            <a:off x="868680" y="2212848"/>
             <a:ext cx="128016" cy="128016"/>
           </a:xfrm>
           <a:prstGeom prst="ellipse">
@@ -14570,13 +14570,13 @@
           <a:p>
             <a:pPr algn="l"/>
             <a:r>
-              <a:rPr sz="1600" b="0" i="0">
+              <a:rPr sz="2100" b="1" i="0">
                 <a:solidFill>
                   <a:srgbClr val="16273D"/>
                 </a:solidFill>
                 <a:latin typeface="Arial"/>
               </a:rPr>
-              <a:t>DeBoer's referendum year opens on the road with a freshman QB</a:t>
+              <a:t>DeBoer's referendum, on the road</a:t>
             </a:r>
           </a:p>
         </p:txBody>
@@ -14589,7 +14589,7 @@
         </p:nvSpPr>
         <p:spPr>
           <a:xfrm>
-            <a:off x="868680" y="2889504"/>
+            <a:off x="868680" y="2926080"/>
             <a:ext cx="128016" cy="128016"/>
           </a:xfrm>
           <a:prstGeom prst="ellipse">
@@ -14649,13 +14649,13 @@
           <a:p>
             <a:pPr algn="l"/>
             <a:r>
-              <a:rPr sz="1600" b="0" i="0">
+              <a:rPr sz="2100" b="1" i="0">
                 <a:solidFill>
                   <a:srgbClr val="16273D"/>
                 </a:solidFill>
                 <a:latin typeface="Arial"/>
               </a:rPr>
-              <a:t>Stein's anti-Stoops: pace, motion, a transfer line</a:t>
+              <a:t>Stein's anti-Stoops</a:t>
             </a:r>
           </a:p>
         </p:txBody>
@@ -14668,7 +14668,7 @@
         </p:nvSpPr>
         <p:spPr>
           <a:xfrm>
-            <a:off x="868680" y="3602736"/>
+            <a:off x="868680" y="3639312"/>
             <a:ext cx="128016" cy="128016"/>
           </a:xfrm>
           <a:prstGeom prst="ellipse">
@@ -14728,13 +14728,13 @@
           <a:p>
             <a:pPr algn="l"/>
             <a:r>
-              <a:rPr sz="1600" b="0" i="0">
+              <a:rPr sz="2100" b="1" i="0">
                 <a:solidFill>
                   <a:srgbClr val="16273D"/>
                 </a:solidFill>
                 <a:latin typeface="Arial"/>
               </a:rPr>
-              <a:t>Lowest continuity on the card, both sides</a:t>
+              <a:t>Lowest continuity on the card</a:t>
             </a:r>
           </a:p>
         </p:txBody>
@@ -14747,7 +14747,7 @@
         </p:nvSpPr>
         <p:spPr>
           <a:xfrm>
-            <a:off x="868680" y="4315968"/>
+            <a:off x="868680" y="4352544"/>
             <a:ext cx="128016" cy="128016"/>
           </a:xfrm>
           <a:prstGeom prst="ellipse">
@@ -14807,13 +14807,13 @@
           <a:p>
             <a:pPr algn="l"/>
             <a:r>
-              <a:rPr sz="1600" b="0" i="0">
+              <a:rPr sz="2100" b="1" i="0">
                 <a:solidFill>
                   <a:srgbClr val="16273D"/>
                 </a:solidFill>
                 <a:latin typeface="Arial"/>
               </a:rPr>
-              <a:t>The deep dive called this an early landmine</a:t>
+              <a:t>The early landmine</a:t>
             </a:r>
           </a:p>
         </p:txBody>
@@ -17156,7 +17156,7 @@
         </p:nvSpPr>
         <p:spPr>
           <a:xfrm>
-            <a:off x="868680" y="2176272"/>
+            <a:off x="868680" y="2212848"/>
             <a:ext cx="128016" cy="128016"/>
           </a:xfrm>
           <a:prstGeom prst="ellipse">
@@ -17216,13 +17216,13 @@
           <a:p>
             <a:pPr algn="l"/>
             <a:r>
-              <a:rPr sz="1600" b="0" i="0">
+              <a:rPr sz="2100" b="1" i="0">
                 <a:solidFill>
                   <a:srgbClr val="16273D"/>
                 </a:solidFill>
                 <a:latin typeface="Arial"/>
               </a:rPr>
-              <a:t>The rematch: OSU won 14–7 last year and the 2024 semifinal</a:t>
+              <a:t>The rematch</a:t>
             </a:r>
           </a:p>
         </p:txBody>
@@ -17235,7 +17235,7 @@
         </p:nvSpPr>
         <p:spPr>
           <a:xfrm>
-            <a:off x="868680" y="2889504"/>
+            <a:off x="868680" y="2926080"/>
             <a:ext cx="128016" cy="128016"/>
           </a:xfrm>
           <a:prstGeom prst="ellipse">
@@ -17295,13 +17295,13 @@
           <a:p>
             <a:pPr algn="l"/>
             <a:r>
-              <a:rPr sz="1600" b="0" i="0">
+              <a:rPr sz="2100" b="1" i="0">
                 <a:solidFill>
                   <a:srgbClr val="16273D"/>
                 </a:solidFill>
                 <a:latin typeface="Arial"/>
               </a:rPr>
-              <a:t>Two title rosters, one coordinator gamble each</a:t>
+              <a:t>One coordinator gamble each</a:t>
             </a:r>
           </a:p>
         </p:txBody>
@@ -17314,7 +17314,7 @@
         </p:nvSpPr>
         <p:spPr>
           <a:xfrm>
-            <a:off x="868680" y="3602736"/>
+            <a:off x="868680" y="3639312"/>
             <a:ext cx="128016" cy="128016"/>
           </a:xfrm>
           <a:prstGeom prst="ellipse">
@@ -17374,13 +17374,13 @@
           <a:p>
             <a:pPr algn="l"/>
             <a:r>
-              <a:rPr sz="1600" b="0" i="0">
+              <a:rPr sz="2100" b="1" i="0">
                 <a:solidFill>
                   <a:srgbClr val="16273D"/>
                 </a:solidFill>
                 <a:latin typeface="Arial"/>
               </a:rPr>
-              <a:t>Texas has the continuity edge — 72% back plus the portal class</a:t>
+              <a:t>Texas has the continuity edge</a:t>
             </a:r>
           </a:p>
         </p:txBody>
@@ -17393,7 +17393,7 @@
         </p:nvSpPr>
         <p:spPr>
           <a:xfrm>
-            <a:off x="868680" y="4315968"/>
+            <a:off x="868680" y="4352544"/>
             <a:ext cx="128016" cy="128016"/>
           </a:xfrm>
           <a:prstGeom prst="ellipse">
@@ -17453,13 +17453,13 @@
           <a:p>
             <a:pPr algn="l"/>
             <a:r>
-              <a:rPr sz="1600" b="0" i="0">
+              <a:rPr sz="2100" b="1" i="0">
                 <a:solidFill>
                   <a:srgbClr val="16273D"/>
                 </a:solidFill>
                 <a:latin typeface="Arial"/>
               </a:rPr>
-              <a:t>Week 1: 56–3 and 59–7, with nine flags and 349 allowed underneath</a:t>
+              <a:t>Week 1 proved nothing yet</a:t>
             </a:r>
           </a:p>
         </p:txBody>
@@ -32630,7 +32630,7 @@
         </p:nvSpPr>
         <p:spPr>
           <a:xfrm>
-            <a:off x="868680" y="2176272"/>
+            <a:off x="868680" y="2212848"/>
             <a:ext cx="128016" cy="128016"/>
           </a:xfrm>
           <a:prstGeom prst="ellipse">
@@ -32690,13 +32690,13 @@
           <a:p>
             <a:pPr algn="l"/>
             <a:r>
-              <a:rPr sz="1600" b="0" i="0">
+              <a:rPr sz="2100" b="1" i="0">
                 <a:solidFill>
                   <a:srgbClr val="16273D"/>
                 </a:solidFill>
                 <a:latin typeface="Arial"/>
               </a:rPr>
-              <a:t>The line swung eight points on one MAC game</a:t>
+              <a:t>An eight-point line swing</a:t>
             </a:r>
           </a:p>
         </p:txBody>
@@ -32709,7 +32709,7 @@
         </p:nvSpPr>
         <p:spPr>
           <a:xfrm>
-            <a:off x="868680" y="2889504"/>
+            <a:off x="868680" y="2926080"/>
             <a:ext cx="128016" cy="128016"/>
           </a:xfrm>
           <a:prstGeom prst="ellipse">
@@ -32769,13 +32769,13 @@
           <a:p>
             <a:pPr algn="l"/>
             <a:r>
-              <a:rPr sz="1600" b="0" i="0">
+              <a:rPr sz="2100" b="1" i="0">
                 <a:solidFill>
                   <a:srgbClr val="16273D"/>
                 </a:solidFill>
                 <a:latin typeface="Arial"/>
               </a:rPr>
-              <a:t>Whittingham's Utah system, one game old, vs Venables' year-five defense</a:t>
+              <a:t>Whittingham's first Big House test</a:t>
             </a:r>
           </a:p>
         </p:txBody>
@@ -32788,7 +32788,7 @@
         </p:nvSpPr>
         <p:spPr>
           <a:xfrm>
-            <a:off x="868680" y="3602736"/>
+            <a:off x="868680" y="3639312"/>
             <a:ext cx="128016" cy="128016"/>
           </a:xfrm>
           <a:prstGeom prst="ellipse">
@@ -32848,13 +32848,13 @@
           <a:p>
             <a:pPr algn="l"/>
             <a:r>
-              <a:rPr sz="1600" b="0" i="0">
+              <a:rPr sz="2100" b="1" i="0">
                 <a:solidFill>
                   <a:srgbClr val="16273D"/>
                 </a:solidFill>
                 <a:latin typeface="Arial"/>
               </a:rPr>
-              <a:t>Underwood's year two vs Mateer's rebuilt motion</a:t>
+              <a:t>Underwood vs Mateer</a:t>
             </a:r>
           </a:p>
         </p:txBody>
@@ -32867,7 +32867,7 @@
         </p:nvSpPr>
         <p:spPr>
           <a:xfrm>
-            <a:off x="868680" y="4315968"/>
+            <a:off x="868680" y="4352544"/>
             <a:ext cx="128016" cy="128016"/>
           </a:xfrm>
           <a:prstGeom prst="ellipse">
@@ -32927,13 +32927,13 @@
           <a:p>
             <a:pPr algn="l"/>
             <a:r>
-              <a:rPr sz="1600" b="0" i="0">
+              <a:rPr sz="2100" b="1" i="0">
                 <a:solidFill>
                   <a:srgbClr val="16273D"/>
                 </a:solidFill>
                 <a:latin typeface="Arial"/>
               </a:rPr>
-              <a:t>Payback: OU won 24–13 in Norman last year</a:t>
+              <a:t>Payback for 24–13</a:t>
             </a:r>
           </a:p>
         </p:txBody>
@@ -35276,7 +35276,7 @@
         </p:nvSpPr>
         <p:spPr>
           <a:xfrm>
-            <a:off x="868680" y="2176272"/>
+            <a:off x="868680" y="2212848"/>
             <a:ext cx="128016" cy="128016"/>
           </a:xfrm>
           <a:prstGeom prst="ellipse">
@@ -35336,13 +35336,13 @@
           <a:p>
             <a:pPr algn="l"/>
             <a:r>
-              <a:rPr sz="1600" b="0" i="0">
+              <a:rPr sz="2100" b="1" i="0">
                 <a:solidFill>
                   <a:srgbClr val="16273D"/>
                 </a:solidFill>
                 <a:latin typeface="Arial"/>
               </a:rPr>
-              <a:t>Dillingham's 16%-back reboot vs an 11-win roster</a:t>
+              <a:t>Dillingham's reboot vs an 11-win roster</a:t>
             </a:r>
           </a:p>
         </p:txBody>
@@ -35355,7 +35355,7 @@
         </p:nvSpPr>
         <p:spPr>
           <a:xfrm>
-            <a:off x="868680" y="2889504"/>
+            <a:off x="868680" y="2926080"/>
             <a:ext cx="128016" cy="128016"/>
           </a:xfrm>
           <a:prstGeom prst="ellipse">
@@ -35415,13 +35415,13 @@
           <a:p>
             <a:pPr algn="l"/>
             <a:r>
-              <a:rPr sz="1600" b="0" i="0">
+              <a:rPr sz="2100" b="1" i="0">
                 <a:solidFill>
                   <a:srgbClr val="16273D"/>
                 </a:solidFill>
                 <a:latin typeface="Arial"/>
               </a:rPr>
-              <a:t>Boley's six-TD debut came against Morgan State</a:t>
+              <a:t>Boley's second start</a:t>
             </a:r>
           </a:p>
         </p:txBody>
@@ -35434,7 +35434,7 @@
         </p:nvSpPr>
         <p:spPr>
           <a:xfrm>
-            <a:off x="868680" y="3602736"/>
+            <a:off x="868680" y="3639312"/>
             <a:ext cx="128016" cy="128016"/>
           </a:xfrm>
           <a:prstGeom prst="ellipse">
@@ -35494,13 +35494,13 @@
           <a:p>
             <a:pPr algn="l"/>
             <a:r>
-              <a:rPr sz="1600" b="0" i="0">
+              <a:rPr sz="2100" b="1" i="0">
                 <a:solidFill>
                   <a:srgbClr val="16273D"/>
                 </a:solidFill>
                 <a:latin typeface="Arial"/>
               </a:rPr>
-              <a:t>A&amp;M's story is its portal-built lines</a:t>
+              <a:t>A&amp;M's portal-built lines</a:t>
             </a:r>
           </a:p>
         </p:txBody>
@@ -35513,7 +35513,7 @@
         </p:nvSpPr>
         <p:spPr>
           <a:xfrm>
-            <a:off x="868680" y="4315968"/>
+            <a:off x="868680" y="4352544"/>
             <a:ext cx="128016" cy="128016"/>
           </a:xfrm>
           <a:prstGeom prst="ellipse">
@@ -35573,13 +35573,13 @@
           <a:p>
             <a:pPr algn="l"/>
             <a:r>
-              <a:rPr sz="1600" b="0" i="0">
+              <a:rPr sz="2100" b="1" i="0">
                 <a:solidFill>
                   <a:srgbClr val="16273D"/>
                 </a:solidFill>
                 <a:latin typeface="Arial"/>
               </a:rPr>
-              <a:t>Neither rating has a 2026 snap in it</a:t>
+              <a:t>No 2026 snaps in the number</a:t>
             </a:r>
           </a:p>
         </p:txBody>

</xml_diff>

<commit_message>
Deck template: COACH/QB/ROSTER band in headline form (15pt bold) on every team slide
Co-Authored-By: Claude Fable 5.1 <noreply@anthropic.com>
</commit_message>
<xml_diff>
--- a/decks/2026_Week2_Episode3.pptx
+++ b/decks/2026_Week2_Episode3.pptx
@@ -10415,13 +10415,13 @@
           <a:p>
             <a:pPr algn="l"/>
             <a:r>
-              <a:rPr sz="1050" b="0" i="0">
+              <a:rPr sz="1500" b="1" i="0">
                 <a:solidFill>
                   <a:srgbClr val="16273D"/>
                 </a:solidFill>
                 <a:latin typeface="Arial"/>
               </a:rPr>
-              <a:t>Dillingham, year 4 — a full reset after the injury-shredded 2025</a:t>
+              <a:t>Dillingham, year 4</a:t>
             </a:r>
           </a:p>
         </p:txBody>
@@ -10485,13 +10485,13 @@
           <a:p>
             <a:pPr algn="l"/>
             <a:r>
-              <a:rPr sz="1050" b="0" i="0">
+              <a:rPr sz="1500" b="1" i="0">
                 <a:solidFill>
                   <a:srgbClr val="16273D"/>
                 </a:solidFill>
                 <a:latin typeface="Arial"/>
               </a:rPr>
-              <a:t>NEW — Cutter Boley (Kentucky), won a four-way derby; 387 yards, 6 TDs in the debut</a:t>
+              <a:t>NEW — Cutter Boley</a:t>
             </a:r>
           </a:p>
         </p:txBody>
@@ -10555,13 +10555,13 @@
           <a:p>
             <a:pPr algn="l"/>
             <a:r>
-              <a:rPr sz="1050" b="0" i="0">
+              <a:rPr sz="1500" b="1" i="0">
                 <a:solidFill>
                   <a:srgbClr val="16273D"/>
                 </a:solidFill>
                 <a:latin typeface="Arial"/>
               </a:rPr>
-              <a:t>16% back — least on the card · 24 portal adds · 11 of 34 regulars return</a:t>
+              <a:t>16% back · 24 portal adds</a:t>
             </a:r>
           </a:p>
         </p:txBody>
@@ -11140,13 +11140,13 @@
           <a:p>
             <a:pPr algn="l"/>
             <a:r>
-              <a:rPr sz="1050" b="0" i="0">
+              <a:rPr sz="1500" b="1" i="0">
                 <a:solidFill>
                   <a:srgbClr val="16273D"/>
                 </a:solidFill>
                 <a:latin typeface="Arial"/>
               </a:rPr>
-              <a:t>Elko, year 3 — two NEW coordinators (Wiggins OC, Hemphill DC)</a:t>
+              <a:t>Elko, year 3 · two new coordinators</a:t>
             </a:r>
           </a:p>
         </p:txBody>
@@ -11210,13 +11210,13 @@
           <a:p>
             <a:pPr algn="l"/>
             <a:r>
-              <a:rPr sz="1050" b="0" i="0">
+              <a:rPr sz="1500" b="1" i="0">
                 <a:solidFill>
                   <a:srgbClr val="16273D"/>
                 </a:solidFill>
                 <a:latin typeface="Arial"/>
               </a:rPr>
-              <a:t>RETURNS — Marcel Reed: 3,000 pass / 550 rush in 2025, and 12 interceptions</a:t>
+              <a:t>Reed returns</a:t>
             </a:r>
           </a:p>
         </p:txBody>
@@ -11280,13 +11280,13 @@
           <a:p>
             <a:pPr algn="l"/>
             <a:r>
-              <a:rPr sz="1050" b="0" i="0">
+              <a:rPr sz="1500" b="1" i="0">
                 <a:solidFill>
                   <a:srgbClr val="16273D"/>
                 </a:solidFill>
                 <a:latin typeface="Arial"/>
               </a:rPr>
-              <a:t>73% back · 19 portal adds — skill talent kept, both trenches rebuilt</a:t>
+              <a:t>73% back · both lines rebuilt</a:t>
             </a:r>
           </a:p>
         </p:txBody>
@@ -13061,13 +13061,13 @@
           <a:p>
             <a:pPr algn="l"/>
             <a:r>
-              <a:rPr sz="1050" b="0" i="0">
+              <a:rPr sz="1500" b="1" i="0">
                 <a:solidFill>
                   <a:srgbClr val="16273D"/>
                 </a:solidFill>
                 <a:latin typeface="Arial"/>
               </a:rPr>
-              <a:t>Brennan, year 3 — DC Danny Gonzales returns eleven 2025 starters</a:t>
+              <a:t>Brennan, year 3</a:t>
             </a:r>
           </a:p>
         </p:txBody>
@@ -13131,13 +13131,13 @@
           <a:p>
             <a:pPr algn="l"/>
             <a:r>
-              <a:rPr sz="1050" b="0" i="0">
+              <a:rPr sz="1500" b="1" i="0">
                 <a:solidFill>
                   <a:srgbClr val="16273D"/>
                 </a:solidFill>
                 <a:latin typeface="Arial"/>
               </a:rPr>
-              <a:t>RETURNS — Noah Fifita, year four as the starter: 9,183 yards, 73 TDs</a:t>
+              <a:t>Fifita returns, year four</a:t>
             </a:r>
           </a:p>
         </p:txBody>
@@ -13201,13 +13201,13 @@
           <a:p>
             <a:pPr algn="l"/>
             <a:r>
-              <a:rPr sz="1050" b="0" i="0">
+              <a:rPr sz="1500" b="1" i="0">
                 <a:solidFill>
                   <a:srgbClr val="16273D"/>
                 </a:solidFill>
                 <a:latin typeface="Arial"/>
               </a:rPr>
-              <a:t>65% back · 22 portal adds — leading rusher and top two receivers gone</a:t>
+              <a:t>65% back · 22 portal adds</a:t>
             </a:r>
           </a:p>
         </p:txBody>
@@ -13786,13 +13786,13 @@
           <a:p>
             <a:pPr algn="l"/>
             <a:r>
-              <a:rPr sz="1050" b="0" i="0">
+              <a:rPr sz="1500" b="1" i="0">
                 <a:solidFill>
                   <a:srgbClr val="16273D"/>
                 </a:solidFill>
                 <a:latin typeface="Arial"/>
               </a:rPr>
-              <a:t>Sitake, year 11 — NEW DC Kelly Poppinga (Hill left for Michigan)</a:t>
+              <a:t>Sitake, year 11 · new DC Poppinga</a:t>
             </a:r>
           </a:p>
         </p:txBody>
@@ -13856,13 +13856,13 @@
           <a:p>
             <a:pPr algn="l"/>
             <a:r>
-              <a:rPr sz="1050" b="0" i="0">
+              <a:rPr sz="1500" b="1" i="0">
                 <a:solidFill>
                   <a:srgbClr val="16273D"/>
                 </a:solidFill>
                 <a:latin typeface="Arial"/>
               </a:rPr>
-              <a:t>RETURNS — Bear Bachmeier, year two: the Big 12's safest QB bet</a:t>
+              <a:t>Bachmeier, year two</a:t>
             </a:r>
           </a:p>
         </p:txBody>
@@ -13926,13 +13926,13 @@
           <a:p>
             <a:pPr algn="l"/>
             <a:r>
-              <a:rPr sz="1050" b="0" i="0">
+              <a:rPr sz="1500" b="1" i="0">
                 <a:solidFill>
                   <a:srgbClr val="16273D"/>
                 </a:solidFill>
                 <a:latin typeface="Arial"/>
               </a:rPr>
-              <a:t>79% back — most on the card · 9 portal adds · 177 returning starts</a:t>
+              <a:t>79% back · most on the card</a:t>
             </a:r>
           </a:p>
         </p:txBody>
@@ -15707,13 +15707,13 @@
           <a:p>
             <a:pPr algn="l"/>
             <a:r>
-              <a:rPr sz="1050" b="0" i="0">
+              <a:rPr sz="1500" b="1" i="0">
                 <a:solidFill>
                   <a:srgbClr val="16273D"/>
                 </a:solidFill>
                 <a:latin typeface="Arial"/>
               </a:rPr>
-              <a:t>DeBoer, year 3 — the referendum season; Wommack year 3 on defense</a:t>
+              <a:t>DeBoer, year 3 · the referendum</a:t>
             </a:r>
           </a:p>
         </p:txBody>
@@ -15777,13 +15777,13 @@
           <a:p>
             <a:pPr algn="l"/>
             <a:r>
-              <a:rPr sz="1050" b="0" i="0">
+              <a:rPr sz="1500" b="1" i="0">
                 <a:solidFill>
                   <a:srgbClr val="16273D"/>
                 </a:solidFill>
                 <a:latin typeface="Arial"/>
               </a:rPr>
-              <a:t>NEW — Keelon Russell, RS freshman, the No. 2 recruit in the 2025 class</a:t>
+              <a:t>NEW — Keelon Russell, RS freshman</a:t>
             </a:r>
           </a:p>
         </p:txBody>
@@ -15847,13 +15847,13 @@
           <a:p>
             <a:pPr algn="l"/>
             <a:r>
-              <a:rPr sz="1050" b="0" i="0">
+              <a:rPr sz="1500" b="1" i="0">
                 <a:solidFill>
                   <a:srgbClr val="16273D"/>
                 </a:solidFill>
                 <a:latin typeface="Arial"/>
               </a:rPr>
-              <a:t>26% back · 17 portal adds — six of the top seven OL gone, QB gone</a:t>
+              <a:t>26% back · 17 portal adds</a:t>
             </a:r>
           </a:p>
         </p:txBody>
@@ -16432,13 +16432,13 @@
           <a:p>
             <a:pPr algn="l"/>
             <a:r>
-              <a:rPr sz="1050" b="0" i="0">
+              <a:rPr sz="1500" b="1" i="0">
                 <a:solidFill>
                   <a:srgbClr val="16273D"/>
                 </a:solidFill>
                 <a:latin typeface="Arial"/>
               </a:rPr>
-              <a:t>NEW — Will Stein (Oregon OC) after the Stoops era ended at 5–7</a:t>
+              <a:t>NEW — Will Stein (Oregon OC)</a:t>
             </a:r>
           </a:p>
         </p:txBody>
@@ -16502,13 +16502,13 @@
           <a:p>
             <a:pPr algn="l"/>
             <a:r>
-              <a:rPr sz="1050" b="0" i="0">
+              <a:rPr sz="1500" b="1" i="0">
                 <a:solidFill>
                   <a:srgbClr val="16273D"/>
                 </a:solidFill>
                 <a:latin typeface="Arial"/>
               </a:rPr>
-              <a:t>NEW — Kenny Minchey (Notre Dame): accurate, mobile, one start of proof</a:t>
+              <a:t>NEW — Kenny Minchey</a:t>
             </a:r>
           </a:p>
         </p:txBody>
@@ -16572,13 +16572,13 @@
           <a:p>
             <a:pPr algn="l"/>
             <a:r>
-              <a:rPr sz="1050" b="0" i="0">
+              <a:rPr sz="1500" b="1" i="0">
                 <a:solidFill>
                   <a:srgbClr val="16273D"/>
                 </a:solidFill>
                 <a:latin typeface="Arial"/>
               </a:rPr>
-              <a:t>19% back · 31 portal adds — most on the card; six transfer OL, ten defensive starters back</a:t>
+              <a:t>19% back · 31 portal adds</a:t>
             </a:r>
           </a:p>
         </p:txBody>
@@ -18353,13 +18353,13 @@
           <a:p>
             <a:pPr algn="l"/>
             <a:r>
-              <a:rPr sz="1050" b="0" i="0">
+              <a:rPr sz="1500" b="1" i="0">
                 <a:solidFill>
                   <a:srgbClr val="16273D"/>
                 </a:solidFill>
                 <a:latin typeface="Arial"/>
               </a:rPr>
-              <a:t>Day, year 8 — NEW OC Arthur Smith (ex-Falcons HC); Patricia year two on defense</a:t>
+              <a:t>Day, year 8 · new OC Arthur Smith</a:t>
             </a:r>
           </a:p>
         </p:txBody>
@@ -18423,13 +18423,13 @@
           <a:p>
             <a:pPr algn="l"/>
             <a:r>
-              <a:rPr sz="1050" b="0" i="0">
+              <a:rPr sz="1500" b="1" i="0">
                 <a:solidFill>
                   <a:srgbClr val="16273D"/>
                 </a:solidFill>
                 <a:latin typeface="Arial"/>
               </a:rPr>
-              <a:t>RETURNS — Julian Sayin, year two: No. 1 in success rate as a freshman</a:t>
+              <a:t>Sayin returns, year two</a:t>
             </a:r>
           </a:p>
         </p:txBody>
@@ -18493,13 +18493,13 @@
           <a:p>
             <a:pPr algn="l"/>
             <a:r>
-              <a:rPr sz="1050" b="0" i="0">
+              <a:rPr sz="1500" b="1" i="0">
                 <a:solidFill>
                   <a:srgbClr val="16273D"/>
                 </a:solidFill>
                 <a:latin typeface="Arial"/>
               </a:rPr>
-              <a:t>68% of offensive production back · 17 portal adds — but 2 of 9 defensive starters return</a:t>
+              <a:t>68% back · 2 of 9 D starters</a:t>
             </a:r>
           </a:p>
         </p:txBody>
@@ -24038,13 +24038,13 @@
           <a:p>
             <a:pPr algn="l"/>
             <a:r>
-              <a:rPr sz="1050" b="0" i="0">
+              <a:rPr sz="1500" b="1" i="0">
                 <a:solidFill>
                   <a:srgbClr val="16273D"/>
                 </a:solidFill>
                 <a:latin typeface="Arial"/>
               </a:rPr>
-              <a:t>Sarkisian, year 6 — NEW DC Will Muschamp (the league's riskiest coordinator swap)</a:t>
+              <a:t>Sarkisian, year 6 · new DC Muschamp</a:t>
             </a:r>
           </a:p>
         </p:txBody>
@@ -24108,13 +24108,13 @@
           <a:p>
             <a:pPr algn="l"/>
             <a:r>
-              <a:rPr sz="1050" b="0" i="0">
+              <a:rPr sz="1500" b="1" i="0">
                 <a:solidFill>
                   <a:srgbClr val="16273D"/>
                 </a:solidFill>
                 <a:latin typeface="Arial"/>
               </a:rPr>
-              <a:t>RETURNS — Arch Manning, year two as the starter; final season, Heisman favorite</a:t>
+              <a:t>Arch returns, final season</a:t>
             </a:r>
           </a:p>
         </p:txBody>
@@ -24178,13 +24178,13 @@
           <a:p>
             <a:pPr algn="l"/>
             <a:r>
-              <a:rPr sz="1050" b="0" i="0">
+              <a:rPr sz="1500" b="1" i="0">
                 <a:solidFill>
                   <a:srgbClr val="16273D"/>
                 </a:solidFill>
                 <a:latin typeface="Arial"/>
               </a:rPr>
-              <a:t>72% back · 22 portal adds — the headline portal class (Coleman, Smothers, Biles, Siani)</a:t>
+              <a:t>72% back · 22 portal adds</a:t>
             </a:r>
           </a:p>
         </p:txBody>
@@ -33827,13 +33827,13 @@
           <a:p>
             <a:pPr algn="l"/>
             <a:r>
-              <a:rPr sz="1050" b="0" i="0">
+              <a:rPr sz="1500" b="1" i="0">
                 <a:solidFill>
                   <a:srgbClr val="16273D"/>
                 </a:solidFill>
                 <a:latin typeface="Arial"/>
               </a:rPr>
-              <a:t>Venables, year 5 — calls the defense himself; OC Arbuckle year two</a:t>
+              <a:t>Venables, year 5</a:t>
             </a:r>
           </a:p>
         </p:txBody>
@@ -33897,13 +33897,13 @@
           <a:p>
             <a:pPr algn="l"/>
             <a:r>
-              <a:rPr sz="1050" b="0" i="0">
+              <a:rPr sz="1500" b="1" i="0">
                 <a:solidFill>
                   <a:srgbClr val="16273D"/>
                 </a:solidFill>
                 <a:latin typeface="Arial"/>
               </a:rPr>
-              <a:t>RETURNS — John Mateer, senior; new throwing motion after the 2025 thumb injury</a:t>
+              <a:t>Mateer returns, senior</a:t>
             </a:r>
           </a:p>
         </p:txBody>
@@ -33967,13 +33967,13 @@
           <a:p>
             <a:pPr algn="l"/>
             <a:r>
-              <a:rPr sz="1050" b="0" i="0">
+              <a:rPr sz="1500" b="1" i="0">
                 <a:solidFill>
                   <a:srgbClr val="16273D"/>
                 </a:solidFill>
                 <a:latin typeface="Arial"/>
               </a:rPr>
-              <a:t>63% back · 16 portal adds — five OL transfers, WR room rebuilt around Sategna</a:t>
+              <a:t>63% back · 16 portal adds</a:t>
             </a:r>
           </a:p>
         </p:txBody>
@@ -34552,13 +34552,13 @@
           <a:p>
             <a:pPr algn="l"/>
             <a:r>
-              <a:rPr sz="1050" b="0" i="0">
+              <a:rPr sz="1500" b="1" i="0">
                 <a:solidFill>
                   <a:srgbClr val="16273D"/>
                 </a:solidFill>
                 <a:latin typeface="Arial"/>
               </a:rPr>
-              <a:t>NEW — Kyle Whittingham (Utah, 177 wins) after Moore's December firing; Beck OC, Hill DC</a:t>
+              <a:t>NEW — Whittingham (Utah)</a:t>
             </a:r>
           </a:p>
         </p:txBody>
@@ -34622,13 +34622,13 @@
           <a:p>
             <a:pPr algn="l"/>
             <a:r>
-              <a:rPr sz="1050" b="0" i="0">
+              <a:rPr sz="1500" b="1" i="0">
                 <a:solidFill>
                   <a:srgbClr val="16273D"/>
                 </a:solidFill>
                 <a:latin typeface="Arial"/>
               </a:rPr>
-              <a:t>RETURNS — Bryce Underwood, year two: the No. 1 recruit's Heisman-track season</a:t>
+              <a:t>Underwood, year two</a:t>
             </a:r>
           </a:p>
         </p:txBody>
@@ -34692,13 +34692,13 @@
           <a:p>
             <a:pPr algn="l"/>
             <a:r>
-              <a:rPr sz="1050" b="0" i="0">
+              <a:rPr sz="1500" b="1" i="0">
                 <a:solidFill>
                   <a:srgbClr val="16273D"/>
                 </a:solidFill>
                 <a:latin typeface="Arial"/>
               </a:rPr>
-              <a:t>69% back · 17 portal adds — the Utah pipeline (Daley, Snowden, Lea'ea, Buchanan)</a:t>
+              <a:t>69% back · the Utah pipeline</a:t>
             </a:r>
           </a:p>
         </p:txBody>

</xml_diff>

<commit_message>
Deck template: honesty box in headline form (20pt bold) on every game slide
Co-Authored-By: Claude Fable 5.1 <noreply@anthropic.com>
</commit_message>
<xml_diff>
--- a/decks/2026_Week2_Episode3.pptx
+++ b/decks/2026_Week2_Episode3.pptx
@@ -12224,8 +12224,8 @@
         </p:nvSpPr>
         <p:spPr>
           <a:xfrm>
-            <a:off x="1051560" y="5202936"/>
-            <a:ext cx="6126480" cy="685800"/>
+            <a:off x="1051560" y="5276088"/>
+            <a:ext cx="6126480" cy="502920"/>
           </a:xfrm>
           <a:prstGeom prst="rect">
             <a:avLst/>
@@ -12240,13 +12240,13 @@
           <a:p>
             <a:pPr algn="l"/>
             <a:r>
-              <a:rPr sz="1300" b="0" i="1">
-                <a:solidFill>
-                  <a:srgbClr val="5C6B7E"/>
-                </a:solidFill>
-                <a:latin typeface="Arial"/>
-              </a:rPr>
-              <a:t>Machine 8.4, market 7.5, both still the July prior — no play.</a:t>
+              <a:rPr sz="2000" b="1" i="0">
+                <a:solidFill>
+                  <a:srgbClr val="0A2851"/>
+                </a:solidFill>
+                <a:latin typeface="Arial"/>
+              </a:rPr>
+              <a:t>Machine = market — no play</a:t>
             </a:r>
           </a:p>
         </p:txBody>
@@ -14870,8 +14870,8 @@
         </p:nvSpPr>
         <p:spPr>
           <a:xfrm>
-            <a:off x="1051560" y="5202936"/>
-            <a:ext cx="6126480" cy="685800"/>
+            <a:off x="1051560" y="5276088"/>
+            <a:ext cx="6126480" cy="502920"/>
           </a:xfrm>
           <a:prstGeom prst="rect">
             <a:avLst/>
@@ -14886,13 +14886,13 @@
           <a:p>
             <a:pPr algn="l"/>
             <a:r>
-              <a:rPr sz="1300" b="0" i="1">
-                <a:solidFill>
-                  <a:srgbClr val="5C6B7E"/>
-                </a:solidFill>
-                <a:latin typeface="Arial"/>
-              </a:rPr>
-              <a:t>2.7 to Alabama sits right at the noise line — quibble, not a position.</a:t>
+              <a:rPr sz="2000" b="1" i="0">
+                <a:solidFill>
+                  <a:srgbClr val="0A2851"/>
+                </a:solidFill>
+                <a:latin typeface="Arial"/>
+              </a:rPr>
+              <a:t>Quibble, not a position</a:t>
             </a:r>
           </a:p>
         </p:txBody>
@@ -17516,8 +17516,8 @@
         </p:nvSpPr>
         <p:spPr>
           <a:xfrm>
-            <a:off x="1051560" y="5202936"/>
-            <a:ext cx="6126480" cy="685800"/>
+            <a:off x="1051560" y="5276088"/>
+            <a:ext cx="6126480" cy="502920"/>
           </a:xfrm>
           <a:prstGeom prst="rect">
             <a:avLst/>
@@ -17532,13 +17532,13 @@
           <a:p>
             <a:pPr algn="l"/>
             <a:r>
-              <a:rPr sz="1300" b="0" i="1">
-                <a:solidFill>
-                  <a:srgbClr val="5C6B7E"/>
-                </a:solidFill>
-                <a:latin typeface="Arial"/>
-              </a:rPr>
-              <a:t>Machine 3.7, market 1.5, ESPN 0.7 — three points of ours is the cap artifact. No position.</a:t>
+              <a:rPr sz="2000" b="1" i="0">
+                <a:solidFill>
+                  <a:srgbClr val="0A2851"/>
+                </a:solidFill>
+                <a:latin typeface="Arial"/>
+              </a:rPr>
+              <a:t>Pick'em plus home field — no position</a:t>
             </a:r>
           </a:p>
         </p:txBody>
@@ -32990,8 +32990,8 @@
         </p:nvSpPr>
         <p:spPr>
           <a:xfrm>
-            <a:off x="1051560" y="5202936"/>
-            <a:ext cx="6126480" cy="685800"/>
+            <a:off x="1051560" y="5276088"/>
+            <a:ext cx="6126480" cy="502920"/>
           </a:xfrm>
           <a:prstGeom prst="rect">
             <a:avLst/>
@@ -33006,13 +33006,13 @@
           <a:p>
             <a:pPr algn="l"/>
             <a:r>
-              <a:rPr sz="1300" b="0" i="1">
-                <a:solidFill>
-                  <a:srgbClr val="5C6B7E"/>
-                </a:solidFill>
-                <a:latin typeface="Arial"/>
-              </a:rPr>
-              <a:t>The market moved 7, the machine moved 4.3 — lean Michigan +5.5 as research, not a position.</a:t>
+              <a:rPr sz="2000" b="1" i="0">
+                <a:solidFill>
+                  <a:srgbClr val="0A2851"/>
+                </a:solidFill>
+                <a:latin typeface="Arial"/>
+              </a:rPr>
+              <a:t>Lean Michigan +5.5 — research, not a position</a:t>
             </a:r>
           </a:p>
         </p:txBody>
@@ -35636,8 +35636,8 @@
         </p:nvSpPr>
         <p:spPr>
           <a:xfrm>
-            <a:off x="1051560" y="5202936"/>
-            <a:ext cx="6126480" cy="685800"/>
+            <a:off x="1051560" y="5276088"/>
+            <a:ext cx="6126480" cy="502920"/>
           </a:xfrm>
           <a:prstGeom prst="rect">
             <a:avLst/>
@@ -35652,13 +35652,13 @@
           <a:p>
             <a:pPr algn="l"/>
             <a:r>
-              <a:rPr sz="1300" b="0" i="1">
-                <a:solidFill>
-                  <a:srgbClr val="5C6B7E"/>
-                </a:solidFill>
-                <a:latin typeface="Arial"/>
-              </a:rPr>
-              <a:t>Two points apart on a 14-point spread is agreement — no play.</a:t>
+              <a:rPr sz="2000" b="1" i="0">
+                <a:solidFill>
+                  <a:srgbClr val="0A2851"/>
+                </a:solidFill>
+                <a:latin typeface="Arial"/>
+              </a:rPr>
+              <a:t>Agreement — no play</a:t>
             </a:r>
           </a:p>
         </p:txBody>

</xml_diff>

<commit_message>
Deck template: game sub line in headline form (kickoff + place, 14pt bold)
Co-Authored-By: Claude Fable 5.1 <noreply@anthropic.com>
</commit_message>
<xml_diff>
--- a/decks/2026_Week2_Episode3.pptx
+++ b/decks/2026_Week2_Episode3.pptx
@@ -11810,13 +11810,13 @@
           <a:p>
             <a:pPr algn="l"/>
             <a:r>
-              <a:rPr sz="1100" b="0" i="1">
+              <a:rPr sz="1400" b="1" i="0">
                 <a:solidFill>
                   <a:srgbClr val="5C6B7E"/>
                 </a:solidFill>
                 <a:latin typeface="Arial"/>
               </a:rPr>
-              <a:t>Sat Sep 12 · 3:30 ET · Big 12 opener · BYU has won three straight in the series (33–27 in Tucson last year) · Fifita's final tour</a:t>
+              <a:t>Sat Sep 12 · 3:30 ET · Provo · Big 12 opener</a:t>
             </a:r>
           </a:p>
         </p:txBody>
@@ -14456,13 +14456,13 @@
           <a:p>
             <a:pPr algn="l"/>
             <a:r>
-              <a:rPr sz="1100" b="0" i="1">
+              <a:rPr sz="1400" b="1" i="0">
                 <a:solidFill>
                   <a:srgbClr val="5C6B7E"/>
                 </a:solidFill>
                 <a:latin typeface="Arial"/>
               </a:rPr>
-              <a:t>Sat Sep 12 · 3:30 ET · SEC opener · Keelon Russell's first road start · Will Stein's first SEC game · Kentucky hasn't beaten Alabama since 1997</a:t>
+              <a:t>Sat Sep 12 · 3:30 ET · Lexington · SEC opener</a:t>
             </a:r>
           </a:p>
         </p:txBody>
@@ -17102,13 +17102,13 @@
           <a:p>
             <a:pPr algn="l"/>
             <a:r>
-              <a:rPr sz="1100" b="0" i="1">
+              <a:rPr sz="1400" b="1" i="0">
                 <a:solidFill>
                   <a:srgbClr val="5C6B7E"/>
                 </a:solidFill>
                 <a:latin typeface="Arial"/>
               </a:rPr>
-              <a:t>Sat Sep 12 · 7:30 ET · No. 1 at No. 4 · the 2025 opener rematch (OSU 14–7) · Arch's last tour vs Sayin-to-Smith</a:t>
+              <a:t>Sat Sep 12 · 7:30 ET · Austin · No. 1 at No. 4</a:t>
             </a:r>
           </a:p>
         </p:txBody>
@@ -32576,13 +32576,13 @@
           <a:p>
             <a:pPr algn="l"/>
             <a:r>
-              <a:rPr sz="1100" b="0" i="1">
+              <a:rPr sz="1400" b="1" i="0">
                 <a:solidFill>
                   <a:srgbClr val="5C6B7E"/>
                 </a:solidFill>
                 <a:latin typeface="Arial"/>
               </a:rPr>
-              <a:t>Sat Sep 12 · 12:00 ET · rematch of OU's 24–13 win in Norman · Whittingham's first Big House test · the card's biggest machine-market gap</a:t>
+              <a:t>Sat Sep 12 · 12:00 ET · Ann Arbor</a:t>
             </a:r>
           </a:p>
         </p:txBody>
@@ -35222,13 +35222,13 @@
           <a:p>
             <a:pPr algn="l"/>
             <a:r>
-              <a:rPr sz="1100" b="0" i="1">
+              <a:rPr sz="1400" b="1" i="0">
                 <a:solidFill>
                   <a:srgbClr val="5C6B7E"/>
                 </a:solidFill>
                 <a:latin typeface="Arial"/>
               </a:rPr>
-              <a:t>Sat Sep 12 · 12:00 ET · Boley's second start vs an SEC secondary · Elko's portal-built trenches get a tempo test</a:t>
+              <a:t>Sat Sep 12 · 12:00 ET · College Station</a:t>
             </a:r>
           </a:p>
         </p:txBody>

</xml_diff>

<commit_message>
Deck template: closer in headline form (bigger score calls, DK market line, short footer)
Co-Authored-By: Claude Fable 5.1 <noreply@anthropic.com>
</commit_message>
<xml_diff>
--- a/decks/2026_Week2_Episode3.pptx
+++ b/decks/2026_Week2_Episode3.pptx
@@ -24824,7 +24824,7 @@
         </p:nvSpPr>
         <p:spPr>
           <a:xfrm>
-            <a:off x="2286000" y="1956816"/>
+            <a:off x="2286000" y="1938528"/>
             <a:ext cx="4937760" cy="365760"/>
           </a:xfrm>
           <a:prstGeom prst="rect">
@@ -24840,7 +24840,7 @@
           <a:p>
             <a:pPr algn="l"/>
             <a:r>
-              <a:rPr sz="1400" b="1" i="0">
+              <a:rPr sz="1600" b="1" i="0">
                 <a:solidFill>
                   <a:srgbClr val="FFFFFF"/>
                 </a:solidFill>
@@ -24859,8 +24859,8 @@
         </p:nvSpPr>
         <p:spPr>
           <a:xfrm>
-            <a:off x="6400800" y="1865376"/>
-            <a:ext cx="4754880" cy="384048"/>
+            <a:off x="6400800" y="1837943"/>
+            <a:ext cx="4754880" cy="411480"/>
           </a:xfrm>
           <a:prstGeom prst="rect">
             <a:avLst/>
@@ -24875,7 +24875,7 @@
           <a:p>
             <a:pPr algn="r"/>
             <a:r>
-              <a:rPr sz="1550" b="1" i="0">
+              <a:rPr sz="1900" b="1" i="0">
                 <a:solidFill>
                   <a:srgbClr val="F47321"/>
                 </a:solidFill>
@@ -24910,13 +24910,13 @@
           <a:p>
             <a:pPr algn="r"/>
             <a:r>
-              <a:rPr sz="850" b="0" i="0">
-                <a:solidFill>
-                  <a:srgbClr val="8FA5C4"/>
-                </a:solidFill>
-                <a:latin typeface="Arial"/>
-              </a:rPr>
-              <a:t>market +5.5 / +5.5</a:t>
+              <a:rPr sz="950" b="0" i="0">
+                <a:solidFill>
+                  <a:srgbClr val="CADCFC"/>
+                </a:solidFill>
+                <a:latin typeface="Arial"/>
+              </a:rPr>
+              <a:t>market +5.5</a:t>
             </a:r>
           </a:p>
         </p:txBody>
@@ -25109,7 +25109,7 @@
         </p:nvSpPr>
         <p:spPr>
           <a:xfrm>
-            <a:off x="2286000" y="2688336"/>
+            <a:off x="2286000" y="2670048"/>
             <a:ext cx="4937760" cy="365760"/>
           </a:xfrm>
           <a:prstGeom prst="rect">
@@ -25125,7 +25125,7 @@
           <a:p>
             <a:pPr algn="l"/>
             <a:r>
-              <a:rPr sz="1400" b="1" i="0">
+              <a:rPr sz="1600" b="1" i="0">
                 <a:solidFill>
                   <a:srgbClr val="FFFFFF"/>
                 </a:solidFill>
@@ -25144,8 +25144,8 @@
         </p:nvSpPr>
         <p:spPr>
           <a:xfrm>
-            <a:off x="6400800" y="2596896"/>
-            <a:ext cx="4754880" cy="384048"/>
+            <a:off x="6400800" y="2569464"/>
+            <a:ext cx="4754880" cy="411480"/>
           </a:xfrm>
           <a:prstGeom prst="rect">
             <a:avLst/>
@@ -25160,7 +25160,7 @@
           <a:p>
             <a:pPr algn="r"/>
             <a:r>
-              <a:rPr sz="1550" b="1" i="0">
+              <a:rPr sz="1900" b="1" i="0">
                 <a:solidFill>
                   <a:srgbClr val="F47321"/>
                 </a:solidFill>
@@ -25195,13 +25195,13 @@
           <a:p>
             <a:pPr algn="r"/>
             <a:r>
-              <a:rPr sz="850" b="0" i="0">
-                <a:solidFill>
-                  <a:srgbClr val="8FA5C4"/>
-                </a:solidFill>
-                <a:latin typeface="Arial"/>
-              </a:rPr>
-              <a:t>market –14.5 / –14</a:t>
+              <a:rPr sz="950" b="0" i="0">
+                <a:solidFill>
+                  <a:srgbClr val="CADCFC"/>
+                </a:solidFill>
+                <a:latin typeface="Arial"/>
+              </a:rPr>
+              <a:t>market –14.5</a:t>
             </a:r>
           </a:p>
         </p:txBody>
@@ -25394,7 +25394,7 @@
         </p:nvSpPr>
         <p:spPr>
           <a:xfrm>
-            <a:off x="2286000" y="3419856"/>
+            <a:off x="2286000" y="3401568"/>
             <a:ext cx="4937760" cy="365760"/>
           </a:xfrm>
           <a:prstGeom prst="rect">
@@ -25410,7 +25410,7 @@
           <a:p>
             <a:pPr algn="l"/>
             <a:r>
-              <a:rPr sz="1400" b="1" i="0">
+              <a:rPr sz="1600" b="1" i="0">
                 <a:solidFill>
                   <a:srgbClr val="FFFFFF"/>
                 </a:solidFill>
@@ -25429,8 +25429,8 @@
         </p:nvSpPr>
         <p:spPr>
           <a:xfrm>
-            <a:off x="6400800" y="3328415"/>
-            <a:ext cx="4754880" cy="384048"/>
+            <a:off x="6400800" y="3300984"/>
+            <a:ext cx="4754880" cy="411480"/>
           </a:xfrm>
           <a:prstGeom prst="rect">
             <a:avLst/>
@@ -25445,7 +25445,7 @@
           <a:p>
             <a:pPr algn="r"/>
             <a:r>
-              <a:rPr sz="1550" b="1" i="0">
+              <a:rPr sz="1900" b="1" i="0">
                 <a:solidFill>
                   <a:srgbClr val="F47321"/>
                 </a:solidFill>
@@ -25480,13 +25480,13 @@
           <a:p>
             <a:pPr algn="r"/>
             <a:r>
-              <a:rPr sz="850" b="0" i="0">
-                <a:solidFill>
-                  <a:srgbClr val="8FA5C4"/>
-                </a:solidFill>
-                <a:latin typeface="Arial"/>
-              </a:rPr>
-              <a:t>market –7.5 / –7.5</a:t>
+              <a:rPr sz="950" b="0" i="0">
+                <a:solidFill>
+                  <a:srgbClr val="CADCFC"/>
+                </a:solidFill>
+                <a:latin typeface="Arial"/>
+              </a:rPr>
+              <a:t>market –7.5</a:t>
             </a:r>
           </a:p>
         </p:txBody>
@@ -25679,7 +25679,7 @@
         </p:nvSpPr>
         <p:spPr>
           <a:xfrm>
-            <a:off x="2286000" y="4151376"/>
+            <a:off x="2286000" y="4133087"/>
             <a:ext cx="4937760" cy="365760"/>
           </a:xfrm>
           <a:prstGeom prst="rect">
@@ -25695,7 +25695,7 @@
           <a:p>
             <a:pPr algn="l"/>
             <a:r>
-              <a:rPr sz="1400" b="1" i="0">
+              <a:rPr sz="1600" b="1" i="0">
                 <a:solidFill>
                   <a:srgbClr val="FFFFFF"/>
                 </a:solidFill>
@@ -25714,8 +25714,8 @@
         </p:nvSpPr>
         <p:spPr>
           <a:xfrm>
-            <a:off x="6400800" y="4059935"/>
-            <a:ext cx="4754880" cy="384048"/>
+            <a:off x="6400800" y="4032503"/>
+            <a:ext cx="4754880" cy="411480"/>
           </a:xfrm>
           <a:prstGeom prst="rect">
             <a:avLst/>
@@ -25730,7 +25730,7 @@
           <a:p>
             <a:pPr algn="r"/>
             <a:r>
-              <a:rPr sz="1550" b="1" i="0">
+              <a:rPr sz="1900" b="1" i="0">
                 <a:solidFill>
                   <a:srgbClr val="F47321"/>
                 </a:solidFill>
@@ -25765,13 +25765,13 @@
           <a:p>
             <a:pPr algn="r"/>
             <a:r>
-              <a:rPr sz="850" b="0" i="0">
-                <a:solidFill>
-                  <a:srgbClr val="8FA5C4"/>
-                </a:solidFill>
-                <a:latin typeface="Arial"/>
-              </a:rPr>
-              <a:t>market +10.5 / +10.5</a:t>
+              <a:rPr sz="950" b="0" i="0">
+                <a:solidFill>
+                  <a:srgbClr val="CADCFC"/>
+                </a:solidFill>
+                <a:latin typeface="Arial"/>
+              </a:rPr>
+              <a:t>market +10.5</a:t>
             </a:r>
           </a:p>
         </p:txBody>
@@ -25964,7 +25964,7 @@
         </p:nvSpPr>
         <p:spPr>
           <a:xfrm>
-            <a:off x="2286000" y="4882896"/>
+            <a:off x="2286000" y="4864607"/>
             <a:ext cx="4937760" cy="365760"/>
           </a:xfrm>
           <a:prstGeom prst="rect">
@@ -25980,7 +25980,7 @@
           <a:p>
             <a:pPr algn="l"/>
             <a:r>
-              <a:rPr sz="1400" b="1" i="0">
+              <a:rPr sz="1600" b="1" i="0">
                 <a:solidFill>
                   <a:srgbClr val="FFFFFF"/>
                 </a:solidFill>
@@ -25999,8 +25999,8 @@
         </p:nvSpPr>
         <p:spPr>
           <a:xfrm>
-            <a:off x="6400800" y="4791455"/>
-            <a:ext cx="4754880" cy="384048"/>
+            <a:off x="6400800" y="4764023"/>
+            <a:ext cx="4754880" cy="411480"/>
           </a:xfrm>
           <a:prstGeom prst="rect">
             <a:avLst/>
@@ -26015,7 +26015,7 @@
           <a:p>
             <a:pPr algn="r"/>
             <a:r>
-              <a:rPr sz="1550" b="1" i="0">
+              <a:rPr sz="1900" b="1" i="0">
                 <a:solidFill>
                   <a:srgbClr val="F47321"/>
                 </a:solidFill>
@@ -26050,13 +26050,13 @@
           <a:p>
             <a:pPr algn="r"/>
             <a:r>
-              <a:rPr sz="850" b="0" i="0">
-                <a:solidFill>
-                  <a:srgbClr val="8FA5C4"/>
-                </a:solidFill>
-                <a:latin typeface="Arial"/>
-              </a:rPr>
-              <a:t>market –1.5 / –2</a:t>
+              <a:rPr sz="950" b="0" i="0">
+                <a:solidFill>
+                  <a:srgbClr val="CADCFC"/>
+                </a:solidFill>
+                <a:latin typeface="Arial"/>
+              </a:rPr>
+              <a:t>market –1.5</a:t>
             </a:r>
           </a:p>
         </p:txBody>
@@ -26113,8 +26113,8 @@
         </p:nvSpPr>
         <p:spPr>
           <a:xfrm>
-            <a:off x="1097280" y="5596127"/>
-            <a:ext cx="2743200" cy="320040"/>
+            <a:off x="1097280" y="5577840"/>
+            <a:ext cx="2743200" cy="347472"/>
           </a:xfrm>
           <a:prstGeom prst="rect">
             <a:avLst/>
@@ -26129,7 +26129,7 @@
           <a:p>
             <a:pPr algn="l"/>
             <a:r>
-              <a:rPr sz="1300" b="1" i="0">
+              <a:rPr sz="1400" b="1" i="0">
                 <a:solidFill>
                   <a:srgbClr val="0A2851"/>
                 </a:solidFill>
@@ -26148,8 +26148,8 @@
         </p:nvSpPr>
         <p:spPr>
           <a:xfrm>
-            <a:off x="3291840" y="5596127"/>
-            <a:ext cx="7863840" cy="320040"/>
+            <a:off x="3291840" y="5577840"/>
+            <a:ext cx="7863840" cy="347472"/>
           </a:xfrm>
           <a:prstGeom prst="rect">
             <a:avLst/>
@@ -26164,7 +26164,7 @@
           <a:p>
             <a:pPr algn="l"/>
             <a:r>
-              <a:rPr sz="1350" b="1" i="0">
+              <a:rPr sz="1600" b="1" i="0">
                 <a:solidFill>
                   <a:srgbClr val="FFFFFF"/>
                 </a:solidFill>
@@ -26183,8 +26183,8 @@
         </p:nvSpPr>
         <p:spPr>
           <a:xfrm>
-            <a:off x="1097280" y="5998464"/>
-            <a:ext cx="2743200" cy="320040"/>
+            <a:off x="1097280" y="5980176"/>
+            <a:ext cx="2743200" cy="347472"/>
           </a:xfrm>
           <a:prstGeom prst="rect">
             <a:avLst/>
@@ -26199,7 +26199,7 @@
           <a:p>
             <a:pPr algn="l"/>
             <a:r>
-              <a:rPr sz="1300" b="1" i="0">
+              <a:rPr sz="1400" b="1" i="0">
                 <a:solidFill>
                   <a:srgbClr val="0A2851"/>
                 </a:solidFill>
@@ -26218,8 +26218,8 @@
         </p:nvSpPr>
         <p:spPr>
           <a:xfrm>
-            <a:off x="3291840" y="5998464"/>
-            <a:ext cx="7863840" cy="320040"/>
+            <a:off x="3291840" y="5980176"/>
+            <a:ext cx="7863840" cy="347472"/>
           </a:xfrm>
           <a:prstGeom prst="rect">
             <a:avLst/>
@@ -26234,7 +26234,7 @@
           <a:p>
             <a:pPr algn="l"/>
             <a:r>
-              <a:rPr sz="1350" b="1" i="0">
+              <a:rPr sz="1600" b="1" i="0">
                 <a:solidFill>
                   <a:srgbClr val="FFFFFF"/>
                 </a:solidFill>
@@ -26253,7 +26253,7 @@
         </p:nvSpPr>
         <p:spPr>
           <a:xfrm>
-            <a:off x="822960" y="6565392"/>
+            <a:off x="822960" y="6537960"/>
             <a:ext cx="10515600" cy="274320"/>
           </a:xfrm>
           <a:prstGeom prst="rect">
@@ -26269,13 +26269,13 @@
           <a:p>
             <a:pPr algn="l"/>
             <a:r>
-              <a:rPr sz="900" b="0" i="1">
-                <a:solidFill>
-                  <a:srgbClr val="8FA5C4"/>
-                </a:solidFill>
-                <a:latin typeface="Arial"/>
-              </a:rPr>
-              <a:t>projected scores = machine margin on the market total · superdogs = dog to win outright, points = the spread · graded vs first-seen lines · research, not picks</a:t>
+              <a:rPr sz="1100" b="0" i="1">
+                <a:solidFill>
+                  <a:srgbClr val="CADCFC"/>
+                </a:solidFill>
+                <a:latin typeface="Arial"/>
+              </a:rPr>
+              <a:t>Superdogs pay only on the win · research, not picks</a:t>
             </a:r>
           </a:p>
         </p:txBody>

</xml_diff>

<commit_message>
Deck template: headline form on the remaining slides (Top 25, Hot Seat, Heisman, card, receipts subtitles/footers/row notes)
Co-Authored-By: Claude Fable 5.1 <noreply@anthropic.com>
</commit_message>
<xml_diff>
--- a/decks/2026_Week2_Episode3.pptx
+++ b/decks/2026_Week2_Episode3.pptx
@@ -3210,13 +3210,13 @@
           <a:p>
             <a:pPr algn="l"/>
             <a:r>
-              <a:rPr sz="1100" b="0" i="1">
+              <a:rPr sz="1300" b="1" i="0">
                 <a:solidFill>
                   <a:srgbClr val="CADCFC"/>
                 </a:solidFill>
                 <a:latin typeface="Arial"/>
               </a:rPr>
-              <a:t>our in-season rating after 51 rated games · Δ = move vs ESPN's preseason FPI (0.0 = no rated game yet) · AP = week 2 poll · NR = not ranked</a:t>
+              <a:t>Machine rating · Δ vs preseason · AP week 2 poll</a:t>
             </a:r>
           </a:p>
         </p:txBody>
@@ -10130,7 +10130,7 @@
         </p:nvSpPr>
         <p:spPr>
           <a:xfrm>
-            <a:off x="1005840" y="6217920"/>
+            <a:off x="1005840" y="6208776"/>
             <a:ext cx="10241280" cy="256032"/>
           </a:xfrm>
           <a:prstGeom prst="rect">
@@ -10146,13 +10146,13 @@
           <a:p>
             <a:pPr algn="l"/>
             <a:r>
-              <a:rPr sz="950" b="1" i="0">
+              <a:rPr sz="1100" b="1" i="0">
                 <a:solidFill>
                   <a:srgbClr val="FFFFFF"/>
                 </a:solidFill>
                 <a:latin typeface="Arial"/>
               </a:rPr>
-              <a:t>Biggest splits with the voters: Virginia (machine #20, AP #25) · SMU (machine #22, AP #17) · Ole Miss (machine #13, AP #9) · Missouri (machine #19, AP #23)</a:t>
+              <a:t>Biggest splits: Virginia #20 vs AP #25 · SMU #22 vs AP #17 · Ole Miss #13 vs AP #9</a:t>
             </a:r>
           </a:p>
         </p:txBody>
@@ -10181,13 +10181,13 @@
           <a:p>
             <a:pPr algn="l"/>
             <a:r>
-              <a:rPr sz="950" b="0" i="0">
+              <a:rPr sz="1050" b="0" i="0">
                 <a:solidFill>
                   <a:srgbClr val="CADCFC"/>
                 </a:solidFill>
                 <a:latin typeface="Arial"/>
               </a:rPr>
-              <a:t>In our 25, not theirs: Florida, Michigan, Auburn, South Carolina   |   In theirs, not ours: Washington (AP 19), Utah (AP 20), Houston (AP 22), Louisville (AP 24)</a:t>
+              <a:t>Ours, not theirs: Florida, Michigan, Auburn, South Carolina   ·   Theirs, not ours: Washington, Utah, Houston, Louisville</a:t>
             </a:r>
           </a:p>
         </p:txBody>
@@ -18975,13 +18975,13 @@
           <a:p>
             <a:pPr algn="l"/>
             <a:r>
-              <a:rPr sz="1050" b="0" i="1">
+              <a:rPr sz="1300" b="1" i="0">
                 <a:solidFill>
                   <a:srgbClr val="CADCFC"/>
                 </a:solidFill>
                 <a:latin typeface="Arial"/>
               </a:rPr>
-              <a:t>seat score = 60% the man (CBS hot-seat rating 0–5, Aug 29) + 40% the machine (odds of missing the job-saving win total, from our season sim) · * = estimated</a:t>
+              <a:t>60% CBS rating + 40% machine odds of missing the bar</a:t>
             </a:r>
           </a:p>
         </p:txBody>
@@ -23769,13 +23769,13 @@
           <a:p>
             <a:pPr algn="l"/>
             <a:r>
-              <a:rPr sz="950" b="1" i="0">
+              <a:rPr sz="1100" b="1" i="0">
                 <a:solidFill>
                   <a:srgbClr val="FFFFFF"/>
                 </a:solidFill>
                 <a:latin typeface="Arial"/>
               </a:rPr>
-              <a:t>Next three: Kalen DeBoer (Alabama, 64) · Dave Doeren (NC State, 64) · Bryant Vincent (UL Monroe, 63)</a:t>
+              <a:t>Next three: Kalen DeBoer 64 · Dave Doeren 64 · Bryant Vincent 63</a:t>
             </a:r>
           </a:p>
         </p:txBody>
@@ -23804,13 +23804,13 @@
           <a:p>
             <a:pPr algn="l"/>
             <a:r>
-              <a:rPr sz="850" b="0" i="0">
+              <a:rPr sz="1050" b="0" i="0">
                 <a:solidFill>
                   <a:srgbClr val="CADCFC"/>
                 </a:solidFill>
                 <a:latin typeface="Arial"/>
               </a:rPr>
-              <a:t>NEEDS = the win total that keeps the job (from the deep-dive write-ups — a judgment call) · P(GETS IT) = the machine's odds of reaching it · MACHINE WINS = projected wins (10th–90th pct), 51 rated games in</a:t>
+              <a:t>NEEDS = wins that keep the job · P(GETS IT) = the machine's odds · MACHINE WINS = projected (10th–90th)</a:t>
             </a:r>
           </a:p>
         </p:txBody>
@@ -26400,13 +26400,13 @@
           <a:p>
             <a:pPr algn="l"/>
             <a:r>
-              <a:rPr sz="1050" b="0" i="1">
+              <a:rPr sz="1300" b="1" i="0">
                 <a:solidFill>
                   <a:srgbClr val="CADCFC"/>
                 </a:solidFill>
                 <a:latin typeface="Arial"/>
               </a:rPr>
-              <a:t>index = team factor (0.5 + half the odds of 10+ wins) × blended PPA per play (2026 + 150 plays of the 2025 line as prior) · market = DraftKings, Sep 8</a:t>
+              <a:t>Team factor × QB efficiency (PPA per play) · market = DraftKings</a:t>
             </a:r>
           </a:p>
         </p:txBody>
@@ -26881,8 +26881,8 @@
         </p:nvSpPr>
         <p:spPr>
           <a:xfrm>
-            <a:off x="1600200" y="2203704"/>
-            <a:ext cx="9692640" cy="256032"/>
+            <a:off x="1600200" y="2185416"/>
+            <a:ext cx="9692640" cy="274320"/>
           </a:xfrm>
           <a:prstGeom prst="rect">
             <a:avLst/>
@@ -26897,13 +26897,13 @@
           <a:p>
             <a:pPr algn="l"/>
             <a:r>
-              <a:rPr sz="950" b="0" i="0">
+              <a:rPr sz="1150" b="0" i="0">
                 <a:solidFill>
                   <a:srgbClr val="CADCFC"/>
                 </a:solidFill>
                 <a:latin typeface="Arial"/>
               </a:rPr>
-              <a:t>Best returning efficiency in the sport (0.545 in 2025, No. 1 in success rate) on a title favorite — the market has him 8th at +1400</a:t>
+              <a:t>Best returning efficiency in the sport · market has him 8th</a:t>
             </a:r>
           </a:p>
         </p:txBody>
@@ -27334,8 +27334,8 @@
         </p:nvSpPr>
         <p:spPr>
           <a:xfrm>
-            <a:off x="1600200" y="2770632"/>
-            <a:ext cx="9692640" cy="256032"/>
+            <a:off x="1600200" y="2752344"/>
+            <a:ext cx="9692640" cy="274320"/>
           </a:xfrm>
           <a:prstGeom prst="rect">
             <a:avLst/>
@@ -27350,13 +27350,13 @@
           <a:p>
             <a:pPr algn="l"/>
             <a:r>
-              <a:rPr sz="950" b="0" i="0">
+              <a:rPr sz="1150" b="0" i="0">
                 <a:solidFill>
                   <a:srgbClr val="CADCFC"/>
                 </a:solidFill>
                 <a:latin typeface="Arial"/>
               </a:rPr>
-              <a:t>401 yards, 5 TD, 90% at Stanford — but the prior is a Duke season (0.371); Miami's 74% P(10+) is the best team factor on the board</a:t>
+              <a:t>One huge game vs Stanford · Duke prior · best team factor</a:t>
             </a:r>
           </a:p>
         </p:txBody>
@@ -27831,8 +27831,8 @@
         </p:nvSpPr>
         <p:spPr>
           <a:xfrm>
-            <a:off x="1600200" y="3337560"/>
-            <a:ext cx="9692640" cy="256032"/>
+            <a:off x="1600200" y="3319272"/>
+            <a:ext cx="9692640" cy="274320"/>
           </a:xfrm>
           <a:prstGeom prst="rect">
             <a:avLst/>
@@ -27847,13 +27847,13 @@
           <a:p>
             <a:pPr algn="l"/>
             <a:r>
-              <a:rPr sz="950" b="0" i="0">
+              <a:rPr sz="1150" b="0" i="0">
                 <a:solidFill>
                   <a:srgbClr val="CADCFC"/>
                 </a:solidFill>
                 <a:latin typeface="Arial"/>
               </a:rPr>
-              <a:t>Carried by the team: Notre Dame's 91% P(10+) is the board's highest; the efficiency line is average so far (0.398 on 31 plays, 0.433 prior)</a:t>
+              <a:t>Carried by Notre Dame's 91% · average line so far</a:t>
             </a:r>
           </a:p>
         </p:txBody>
@@ -28284,8 +28284,8 @@
         </p:nvSpPr>
         <p:spPr>
           <a:xfrm>
-            <a:off x="1600200" y="3904487"/>
-            <a:ext cx="9692640" cy="256032"/>
+            <a:off x="1600200" y="3886200"/>
+            <a:ext cx="9692640" cy="274320"/>
           </a:xfrm>
           <a:prstGeom prst="rect">
             <a:avLst/>
@@ -28300,13 +28300,13 @@
           <a:p>
             <a:pPr algn="l"/>
             <a:r>
-              <a:rPr sz="950" b="0" i="0">
+              <a:rPr sz="1150" b="0" i="0">
                 <a:solidFill>
                   <a:srgbClr val="CADCFC"/>
                 </a:solidFill>
                 <a:latin typeface="Arial"/>
               </a:rPr>
-              <a:t>1.639 per play on 15 plays — a tiny sample — plus Indiana's 73% P(10+) and the offense that made a Heisman winner of a transfer last year</a:t>
+              <a:t>1.639 on 15 plays · Indiana's offense</a:t>
             </a:r>
           </a:p>
         </p:txBody>
@@ -28781,8 +28781,8 @@
         </p:nvSpPr>
         <p:spPr>
           <a:xfrm>
-            <a:off x="1600200" y="4471416"/>
-            <a:ext cx="9692640" cy="256032"/>
+            <a:off x="1600200" y="4453128"/>
+            <a:ext cx="9692640" cy="274320"/>
           </a:xfrm>
           <a:prstGeom prst="rect">
             <a:avLst/>
@@ -28797,13 +28797,13 @@
           <a:p>
             <a:pPr algn="l"/>
             <a:r>
-              <a:rPr sz="950" b="0" i="0">
+              <a:rPr sz="1150" b="0" i="0">
                 <a:solidFill>
                   <a:srgbClr val="CADCFC"/>
                 </a:solidFill>
                 <a:latin typeface="Arial"/>
               </a:rPr>
-              <a:t>Situation, not tape: Texas Tech's 80% P(10+) is 2nd on the board while his efficiency is 8th of 9 (0.384) — Houston in Lubbock is the first real test</a:t>
+              <a:t>Situation, not tape · Texas Tech's 80%</a:t>
             </a:r>
           </a:p>
         </p:txBody>
@@ -29261,13 +29261,13 @@
           <a:p>
             <a:pPr algn="l"/>
             <a:r>
-              <a:rPr sz="1700" b="1" i="0">
+              <a:rPr sz="1800" b="1" i="0">
                 <a:solidFill>
                   <a:srgbClr val="FFFFFF"/>
                 </a:solidFill>
                 <a:latin typeface="Arial"/>
               </a:rPr>
-              <a:t>Julian Sayin, Ohio State — index 44.7 · market +1400 (#8 on the board)</a:t>
+              <a:t>Julian Sayin, Ohio State · index 44.7 · market +1400</a:t>
             </a:r>
           </a:p>
         </p:txBody>
@@ -29296,13 +29296,13 @@
           <a:p>
             <a:pPr algn="l"/>
             <a:r>
-              <a:rPr sz="950" b="0" i="0">
+              <a:rPr sz="1100" b="0" i="0">
                 <a:solidFill>
                   <a:srgbClr val="CADCFC"/>
                 </a:solidFill>
                 <a:latin typeface="Arial"/>
               </a:rPr>
-              <a:t>Non-QB watch (own scale — PPA per target, not comparable to the QB column): Jeremiah Smith 1.62 (+1000) · Malachi Toney 1.40 (+1250) · Ryan Wingo 1.55 · Trent Mosley 1.30</a:t>
+              <a:t>Non-QB watch: Jeremiah Smith (+1000) · Malachi Toney (+1250) · Ryan Wingo · Trent Mosley</a:t>
             </a:r>
           </a:p>
         </p:txBody>
@@ -29331,13 +29331,13 @@
           <a:p>
             <a:pPr algn="l"/>
             <a:r>
-              <a:rPr sz="850" b="0" i="1">
+              <a:rPr sz="1000" b="0" i="1">
                 <a:solidFill>
                   <a:srgbClr val="CADCFC"/>
                 </a:solidFill>
                 <a:latin typeface="Arial"/>
               </a:rPr>
-              <a:t>PPA = CFBD predicted points added per play · a great QB on a 9-win team stays alive (team factor floor 0.5) · the board re-computes every rebuild</a:t>
+              <a:t>PPA = predicted points added per play · re-computes every rebuild</a:t>
             </a:r>
           </a:p>
         </p:txBody>
@@ -31062,13 +31062,13 @@
           <a:p>
             <a:pPr algn="l"/>
             <a:r>
-              <a:rPr sz="1050" b="0" i="0">
-                <a:solidFill>
-                  <a:srgbClr val="8FA5C4"/>
-                </a:solidFill>
-                <a:latin typeface="Arial"/>
-              </a:rPr>
-              <a:t>Machine = our in-season rating (ESPN preseason FPI prior + 2026 results, λ 3, cap ±28) + 2.5 HFA · empirical margin curve (σ 15.9) · lines as of Sep 9 · model plays graded vs first-seen lines</a:t>
+              <a:rPr sz="1150" b="0" i="0">
+                <a:solidFill>
+                  <a:srgbClr val="CADCFC"/>
+                </a:solidFill>
+                <a:latin typeface="Arial"/>
+              </a:rPr>
+              <a:t>Machine = our in-season rating + 2.5 home field · lines as of Sep 9</a:t>
             </a:r>
           </a:p>
         </p:txBody>
@@ -31158,13 +31158,13 @@
           <a:p>
             <a:pPr algn="l"/>
             <a:r>
-              <a:rPr sz="1100" b="0" i="1">
+              <a:rPr sz="1200" b="1" i="0">
                 <a:solidFill>
                   <a:srgbClr val="5C6B7E"/>
                 </a:solidFill>
                 <a:latin typeface="Arial"/>
               </a:rPr>
-              <a:t>Our call frozen at the Ep2 recording · closing line = last pre-kick pull (Fri 5 PM ET · Mon 9:25 AM ET) · “off by” = miss vs the final margin</a:t>
+              <a:t>Calls frozen at recording · closing line = last pre-kick pull · off by = miss vs the final margin</a:t>
             </a:r>
           </a:p>
         </p:txBody>
@@ -32381,8 +32381,8 @@
         </p:nvSpPr>
         <p:spPr>
           <a:xfrm>
-            <a:off x="1051560" y="5870448"/>
-            <a:ext cx="10058400" cy="594360"/>
+            <a:off x="1051560" y="5833872"/>
+            <a:ext cx="10058400" cy="320040"/>
           </a:xfrm>
           <a:prstGeom prst="rect">
             <a:avLst/>
@@ -32397,13 +32397,48 @@
           <a:p>
             <a:pPr algn="l"/>
             <a:r>
-              <a:rPr sz="1050" b="0" i="0">
+              <a:rPr sz="1500" b="1" i="0">
                 <a:solidFill>
                   <a:srgbClr val="FFFFFF"/>
                 </a:solidFill>
                 <a:latin typeface="Arial"/>
               </a:rPr>
-              <a:t>Total miss across 5 graded games: machine 50.5 points, closing market 49.0 — machine closer in 2, market in 2, 1 tie. Stated positions 2–0: Baylor +7.5 covered and the MONSTER UNDER on 59.5 cashed (33 total). Two weeks in: machine 120.5 vs market 119.0 across 10 games — still a coin flip with Vegas. Stated leans 3–2 on the season.</a:t>
+              <a:t>Machine 50.5 · market 49.0 · machine closer in 2, market 2, 1 tie</a:t>
+            </a:r>
+          </a:p>
+        </p:txBody>
+      </p:sp>
+      <p:sp>
+        <p:nvSpPr>
+          <p:cNvPr id="41" name="TextBox 40"/>
+          <p:cNvSpPr txBox="1"/>
+          <p:nvPr/>
+        </p:nvSpPr>
+        <p:spPr>
+          <a:xfrm>
+            <a:off x="1051560" y="6172200"/>
+            <a:ext cx="10058400" cy="274320"/>
+          </a:xfrm>
+          <a:prstGeom prst="rect">
+            <a:avLst/>
+          </a:prstGeom>
+          <a:noFill/>
+        </p:spPr>
+        <p:txBody>
+          <a:bodyPr wrap="square" lIns="0" rIns="0" tIns="0" bIns="0">
+            <a:spAutoFit/>
+          </a:bodyPr>
+          <a:lstStyle/>
+          <a:p>
+            <a:pPr algn="l"/>
+            <a:r>
+              <a:rPr sz="1150" b="0" i="0">
+                <a:solidFill>
+                  <a:srgbClr val="CADCFC"/>
+                </a:solidFill>
+                <a:latin typeface="Arial"/>
+              </a:rPr>
+              <a:t>Season: machine 120.5 vs market 119.0 · stated leans 3–2 · Monster Under cashed</a:t>
             </a:r>
           </a:p>
         </p:txBody>

</xml_diff>